<commit_message>
feat: edição inicial do template pptx
</commit_message>
<xml_diff>
--- a/docs/Template - Fase 2 - Apresentação Executiva - Projeto em Business Intelligence e Analytics.pptx
+++ b/docs/Template - Fase 2 - Apresentação Executiva - Projeto em Business Intelligence e Analytics.pptx
@@ -1350,7 +1350,7 @@
           <a:p>
             <a:fld id="{22D2343C-BD3C-4650-924C-40706B7DFBCE}" type="datetimeFigureOut">
               <a:rPr lang="pt-BR" smtClean="0"/>
-              <a:t>08/05/2025</a:t>
+              <a:t>03/09/2026</a:t>
             </a:fld>
             <a:endParaRPr lang="pt-BR"/>
           </a:p>
@@ -2321,13 +2321,13 @@
           <p:nvPr userDrawn="1"/>
         </p:nvPicPr>
         <p:blipFill>
-          <a:blip r:embed="rId2">
+          <a:blip>
             <a:extLst>
               <a:ext uri="{28A0092B-C50C-407E-A947-70E740481C1C}">
                 <a14:useLocalDpi xmlns:a14="http://schemas.microsoft.com/office/drawing/2010/main" val="0"/>
               </a:ext>
               <a:ext uri="{96DAC541-7B7A-43D3-8B79-37D633B846F1}">
-                <asvg:svgBlip xmlns:asvg="http://schemas.microsoft.com/office/drawing/2016/SVG/main" r:embed="rId3"/>
+                <asvg:svgBlip xmlns:asvg="http://schemas.microsoft.com/office/drawing/2016/SVG/main" r:embed="rId2"/>
               </a:ext>
             </a:extLst>
           </a:blip>
@@ -3296,7 +3296,10 @@
           <a:bodyPr/>
           <a:lstStyle/>
           <a:p>
-            <a:endParaRPr lang="pt-BR" dirty="0"/>
+            <a:r>
+              <a:rPr lang="pt-BR" dirty="0"/>
+              <a:t>Felipe Pinheiro Fossá</a:t>
+            </a:r>
           </a:p>
         </p:txBody>
       </p:sp>
@@ -3376,12 +3379,490 @@
             <p:ph type="body" sz="quarter" idx="10"/>
           </p:nvPr>
         </p:nvSpPr>
-        <p:spPr/>
+        <p:spPr>
+          <a:xfrm>
+            <a:off x="928689" y="1416050"/>
+            <a:ext cx="14544674" cy="625401"/>
+          </a:xfrm>
+        </p:spPr>
         <p:txBody>
           <a:bodyPr/>
           <a:lstStyle/>
           <a:p>
-            <a:endParaRPr lang="pt-BR" dirty="0"/>
+            <a:r>
+              <a:rPr lang="pt-BR" sz="3000" b="1" dirty="0">
+                <a:solidFill>
+                  <a:schemeClr val="accent1">
+                    <a:lumMod val="75000"/>
+                  </a:schemeClr>
+                </a:solidFill>
+                <a:latin typeface="Arial" panose="020B0604020202020204" pitchFamily="34" charset="0"/>
+                <a:cs typeface="Arial" panose="020B0604020202020204" pitchFamily="34" charset="0"/>
+              </a:rPr>
+              <a:t>Contexto e Objetivo do projeto</a:t>
+            </a:r>
+          </a:p>
+        </p:txBody>
+      </p:sp>
+      <p:sp>
+        <p:nvSpPr>
+          <p:cNvPr id="3" name="Espaço Reservado para Texto 1">
+            <a:extLst>
+              <a:ext uri="{FF2B5EF4-FFF2-40B4-BE49-F238E27FC236}">
+                <a16:creationId xmlns:a16="http://schemas.microsoft.com/office/drawing/2014/main" id="{F834370D-68EB-9495-487A-5EC0B0687029}"/>
+              </a:ext>
+            </a:extLst>
+          </p:cNvPr>
+          <p:cNvSpPr txBox="1">
+            <a:spLocks/>
+          </p:cNvSpPr>
+          <p:nvPr/>
+        </p:nvSpPr>
+        <p:spPr>
+          <a:xfrm>
+            <a:off x="928688" y="1858736"/>
+            <a:ext cx="14544674" cy="928007"/>
+          </a:xfrm>
+          <a:prstGeom prst="rect">
+            <a:avLst/>
+          </a:prstGeom>
+          <a:noFill/>
+        </p:spPr>
+        <p:txBody>
+          <a:bodyPr lIns="72000" tIns="72000" rIns="72000" bIns="72000"/>
+          <a:lstStyle>
+            <a:lvl1pPr marL="0" indent="0" algn="l" defTabSz="1280160" rtl="0" eaLnBrk="1" latinLnBrk="0" hangingPunct="1">
+              <a:lnSpc>
+                <a:spcPct val="100000"/>
+              </a:lnSpc>
+              <a:spcBef>
+                <a:spcPts val="0"/>
+              </a:spcBef>
+              <a:spcAft>
+                <a:spcPts val="1200"/>
+              </a:spcAft>
+              <a:buFont typeface="Arial" panose="020B0604020202020204" pitchFamily="34" charset="0"/>
+              <a:buNone/>
+              <a:defRPr sz="1800" kern="1200">
+                <a:solidFill>
+                  <a:schemeClr val="tx2">
+                    <a:lumMod val="75000"/>
+                  </a:schemeClr>
+                </a:solidFill>
+                <a:latin typeface="+mn-lt"/>
+                <a:ea typeface="+mn-ea"/>
+                <a:cs typeface="+mn-cs"/>
+              </a:defRPr>
+            </a:lvl1pPr>
+            <a:lvl2pPr marL="640080" indent="0" algn="l" defTabSz="1280160" rtl="0" eaLnBrk="1" latinLnBrk="0" hangingPunct="1">
+              <a:lnSpc>
+                <a:spcPct val="90000"/>
+              </a:lnSpc>
+              <a:spcBef>
+                <a:spcPts val="700"/>
+              </a:spcBef>
+              <a:buFont typeface="Arial" panose="020B0604020202020204" pitchFamily="34" charset="0"/>
+              <a:buNone/>
+              <a:defRPr sz="1400" kern="1200">
+                <a:solidFill>
+                  <a:schemeClr val="tx1"/>
+                </a:solidFill>
+                <a:latin typeface="+mn-lt"/>
+                <a:ea typeface="+mn-ea"/>
+                <a:cs typeface="+mn-cs"/>
+              </a:defRPr>
+            </a:lvl2pPr>
+            <a:lvl3pPr marL="1280160" indent="0" algn="l" defTabSz="1280160" rtl="0" eaLnBrk="1" latinLnBrk="0" hangingPunct="1">
+              <a:lnSpc>
+                <a:spcPct val="90000"/>
+              </a:lnSpc>
+              <a:spcBef>
+                <a:spcPts val="700"/>
+              </a:spcBef>
+              <a:buFont typeface="Arial" panose="020B0604020202020204" pitchFamily="34" charset="0"/>
+              <a:buNone/>
+              <a:defRPr sz="1400" kern="1200">
+                <a:solidFill>
+                  <a:schemeClr val="tx1"/>
+                </a:solidFill>
+                <a:latin typeface="+mn-lt"/>
+                <a:ea typeface="+mn-ea"/>
+                <a:cs typeface="+mn-cs"/>
+              </a:defRPr>
+            </a:lvl3pPr>
+            <a:lvl4pPr marL="1920240" indent="0" algn="l" defTabSz="1280160" rtl="0" eaLnBrk="1" latinLnBrk="0" hangingPunct="1">
+              <a:lnSpc>
+                <a:spcPct val="90000"/>
+              </a:lnSpc>
+              <a:spcBef>
+                <a:spcPts val="700"/>
+              </a:spcBef>
+              <a:buFont typeface="Arial" panose="020B0604020202020204" pitchFamily="34" charset="0"/>
+              <a:buNone/>
+              <a:defRPr sz="1400" kern="1200">
+                <a:solidFill>
+                  <a:schemeClr val="tx1"/>
+                </a:solidFill>
+                <a:latin typeface="+mn-lt"/>
+                <a:ea typeface="+mn-ea"/>
+                <a:cs typeface="+mn-cs"/>
+              </a:defRPr>
+            </a:lvl4pPr>
+            <a:lvl5pPr marL="2560320" indent="0" algn="l" defTabSz="1280160" rtl="0" eaLnBrk="1" latinLnBrk="0" hangingPunct="1">
+              <a:lnSpc>
+                <a:spcPct val="90000"/>
+              </a:lnSpc>
+              <a:spcBef>
+                <a:spcPts val="700"/>
+              </a:spcBef>
+              <a:buFont typeface="Arial" panose="020B0604020202020204" pitchFamily="34" charset="0"/>
+              <a:buNone/>
+              <a:defRPr sz="1400" kern="1200">
+                <a:solidFill>
+                  <a:schemeClr val="tx1"/>
+                </a:solidFill>
+                <a:latin typeface="+mn-lt"/>
+                <a:ea typeface="+mn-ea"/>
+                <a:cs typeface="+mn-cs"/>
+              </a:defRPr>
+            </a:lvl5pPr>
+            <a:lvl6pPr marL="3520440" indent="-320040" algn="l" defTabSz="1280160" rtl="0" eaLnBrk="1" latinLnBrk="0" hangingPunct="1">
+              <a:lnSpc>
+                <a:spcPct val="90000"/>
+              </a:lnSpc>
+              <a:spcBef>
+                <a:spcPts val="700"/>
+              </a:spcBef>
+              <a:buFont typeface="Arial" panose="020B0604020202020204" pitchFamily="34" charset="0"/>
+              <a:buChar char="•"/>
+              <a:defRPr sz="2520" kern="1200">
+                <a:solidFill>
+                  <a:schemeClr val="tx1"/>
+                </a:solidFill>
+                <a:latin typeface="+mn-lt"/>
+                <a:ea typeface="+mn-ea"/>
+                <a:cs typeface="+mn-cs"/>
+              </a:defRPr>
+            </a:lvl6pPr>
+            <a:lvl7pPr marL="4160520" indent="-320040" algn="l" defTabSz="1280160" rtl="0" eaLnBrk="1" latinLnBrk="0" hangingPunct="1">
+              <a:lnSpc>
+                <a:spcPct val="90000"/>
+              </a:lnSpc>
+              <a:spcBef>
+                <a:spcPts val="700"/>
+              </a:spcBef>
+              <a:buFont typeface="Arial" panose="020B0604020202020204" pitchFamily="34" charset="0"/>
+              <a:buChar char="•"/>
+              <a:defRPr sz="2520" kern="1200">
+                <a:solidFill>
+                  <a:schemeClr val="tx1"/>
+                </a:solidFill>
+                <a:latin typeface="+mn-lt"/>
+                <a:ea typeface="+mn-ea"/>
+                <a:cs typeface="+mn-cs"/>
+              </a:defRPr>
+            </a:lvl7pPr>
+            <a:lvl8pPr marL="4800600" indent="-320040" algn="l" defTabSz="1280160" rtl="0" eaLnBrk="1" latinLnBrk="0" hangingPunct="1">
+              <a:lnSpc>
+                <a:spcPct val="90000"/>
+              </a:lnSpc>
+              <a:spcBef>
+                <a:spcPts val="700"/>
+              </a:spcBef>
+              <a:buFont typeface="Arial" panose="020B0604020202020204" pitchFamily="34" charset="0"/>
+              <a:buChar char="•"/>
+              <a:defRPr sz="2520" kern="1200">
+                <a:solidFill>
+                  <a:schemeClr val="tx1"/>
+                </a:solidFill>
+                <a:latin typeface="+mn-lt"/>
+                <a:ea typeface="+mn-ea"/>
+                <a:cs typeface="+mn-cs"/>
+              </a:defRPr>
+            </a:lvl8pPr>
+            <a:lvl9pPr marL="5440680" indent="-320040" algn="l" defTabSz="1280160" rtl="0" eaLnBrk="1" latinLnBrk="0" hangingPunct="1">
+              <a:lnSpc>
+                <a:spcPct val="90000"/>
+              </a:lnSpc>
+              <a:spcBef>
+                <a:spcPts val="700"/>
+              </a:spcBef>
+              <a:buFont typeface="Arial" panose="020B0604020202020204" pitchFamily="34" charset="0"/>
+              <a:buChar char="•"/>
+              <a:defRPr sz="2520" kern="1200">
+                <a:solidFill>
+                  <a:schemeClr val="tx1"/>
+                </a:solidFill>
+                <a:latin typeface="+mn-lt"/>
+                <a:ea typeface="+mn-ea"/>
+                <a:cs typeface="+mn-cs"/>
+              </a:defRPr>
+            </a:lvl9pPr>
+          </a:lstStyle>
+          <a:p>
+            <a:r>
+              <a:rPr lang="pt-BR" sz="1600" b="1" dirty="0">
+                <a:solidFill>
+                  <a:schemeClr val="accent1">
+                    <a:lumMod val="75000"/>
+                  </a:schemeClr>
+                </a:solidFill>
+                <a:latin typeface="Arial" panose="020B0604020202020204" pitchFamily="34" charset="0"/>
+                <a:cs typeface="Arial" panose="020B0604020202020204" pitchFamily="34" charset="0"/>
+              </a:rPr>
+              <a:t>Problema de negócio</a:t>
+            </a:r>
+          </a:p>
+          <a:p>
+            <a:r>
+              <a:rPr lang="pt-BR" sz="1200" dirty="0">
+                <a:solidFill>
+                  <a:schemeClr val="tx1"/>
+                </a:solidFill>
+                <a:latin typeface="Arial" panose="020B0604020202020204" pitchFamily="34" charset="0"/>
+                <a:cs typeface="Arial" panose="020B0604020202020204" pitchFamily="34" charset="0"/>
+              </a:rPr>
+              <a:t>O campeonato brasileiro Serie A rebaixa 4 clubes a cada temporada, com forte impacto financeiro e esportivo para os clubes envolvidos. O projeto usa dados históricos de desempenho (2006 – 2025) para estimar de formar antecipada, o risco de rebaixamento de cada clube.</a:t>
+            </a:r>
+          </a:p>
+          <a:p>
+            <a:endParaRPr lang="pt-BR" sz="3000" dirty="0">
+              <a:solidFill>
+                <a:schemeClr val="tx1"/>
+              </a:solidFill>
+              <a:latin typeface="Arial" panose="020B0604020202020204" pitchFamily="34" charset="0"/>
+              <a:cs typeface="Arial" panose="020B0604020202020204" pitchFamily="34" charset="0"/>
+            </a:endParaRPr>
+          </a:p>
+        </p:txBody>
+      </p:sp>
+      <p:sp>
+        <p:nvSpPr>
+          <p:cNvPr id="4" name="Espaço Reservado para Texto 1">
+            <a:extLst>
+              <a:ext uri="{FF2B5EF4-FFF2-40B4-BE49-F238E27FC236}">
+                <a16:creationId xmlns:a16="http://schemas.microsoft.com/office/drawing/2014/main" id="{E7B9B9ED-1583-657A-D390-7826F2B5CA73}"/>
+              </a:ext>
+            </a:extLst>
+          </p:cNvPr>
+          <p:cNvSpPr txBox="1">
+            <a:spLocks/>
+          </p:cNvSpPr>
+          <p:nvPr/>
+        </p:nvSpPr>
+        <p:spPr>
+          <a:xfrm>
+            <a:off x="928688" y="2916728"/>
+            <a:ext cx="14544674" cy="625401"/>
+          </a:xfrm>
+          <a:prstGeom prst="rect">
+            <a:avLst/>
+          </a:prstGeom>
+          <a:noFill/>
+        </p:spPr>
+        <p:txBody>
+          <a:bodyPr lIns="72000" tIns="72000" rIns="72000" bIns="72000"/>
+          <a:lstStyle>
+            <a:lvl1pPr marL="0" indent="0" algn="l" defTabSz="1280160" rtl="0" eaLnBrk="1" latinLnBrk="0" hangingPunct="1">
+              <a:lnSpc>
+                <a:spcPct val="100000"/>
+              </a:lnSpc>
+              <a:spcBef>
+                <a:spcPts val="0"/>
+              </a:spcBef>
+              <a:spcAft>
+                <a:spcPts val="1200"/>
+              </a:spcAft>
+              <a:buFont typeface="Arial" panose="020B0604020202020204" pitchFamily="34" charset="0"/>
+              <a:buNone/>
+              <a:defRPr sz="1800" kern="1200">
+                <a:solidFill>
+                  <a:schemeClr val="tx2">
+                    <a:lumMod val="75000"/>
+                  </a:schemeClr>
+                </a:solidFill>
+                <a:latin typeface="+mn-lt"/>
+                <a:ea typeface="+mn-ea"/>
+                <a:cs typeface="+mn-cs"/>
+              </a:defRPr>
+            </a:lvl1pPr>
+            <a:lvl2pPr marL="640080" indent="0" algn="l" defTabSz="1280160" rtl="0" eaLnBrk="1" latinLnBrk="0" hangingPunct="1">
+              <a:lnSpc>
+                <a:spcPct val="90000"/>
+              </a:lnSpc>
+              <a:spcBef>
+                <a:spcPts val="700"/>
+              </a:spcBef>
+              <a:buFont typeface="Arial" panose="020B0604020202020204" pitchFamily="34" charset="0"/>
+              <a:buNone/>
+              <a:defRPr sz="1400" kern="1200">
+                <a:solidFill>
+                  <a:schemeClr val="tx1"/>
+                </a:solidFill>
+                <a:latin typeface="+mn-lt"/>
+                <a:ea typeface="+mn-ea"/>
+                <a:cs typeface="+mn-cs"/>
+              </a:defRPr>
+            </a:lvl2pPr>
+            <a:lvl3pPr marL="1280160" indent="0" algn="l" defTabSz="1280160" rtl="0" eaLnBrk="1" latinLnBrk="0" hangingPunct="1">
+              <a:lnSpc>
+                <a:spcPct val="90000"/>
+              </a:lnSpc>
+              <a:spcBef>
+                <a:spcPts val="700"/>
+              </a:spcBef>
+              <a:buFont typeface="Arial" panose="020B0604020202020204" pitchFamily="34" charset="0"/>
+              <a:buNone/>
+              <a:defRPr sz="1400" kern="1200">
+                <a:solidFill>
+                  <a:schemeClr val="tx1"/>
+                </a:solidFill>
+                <a:latin typeface="+mn-lt"/>
+                <a:ea typeface="+mn-ea"/>
+                <a:cs typeface="+mn-cs"/>
+              </a:defRPr>
+            </a:lvl3pPr>
+            <a:lvl4pPr marL="1920240" indent="0" algn="l" defTabSz="1280160" rtl="0" eaLnBrk="1" latinLnBrk="0" hangingPunct="1">
+              <a:lnSpc>
+                <a:spcPct val="90000"/>
+              </a:lnSpc>
+              <a:spcBef>
+                <a:spcPts val="700"/>
+              </a:spcBef>
+              <a:buFont typeface="Arial" panose="020B0604020202020204" pitchFamily="34" charset="0"/>
+              <a:buNone/>
+              <a:defRPr sz="1400" kern="1200">
+                <a:solidFill>
+                  <a:schemeClr val="tx1"/>
+                </a:solidFill>
+                <a:latin typeface="+mn-lt"/>
+                <a:ea typeface="+mn-ea"/>
+                <a:cs typeface="+mn-cs"/>
+              </a:defRPr>
+            </a:lvl4pPr>
+            <a:lvl5pPr marL="2560320" indent="0" algn="l" defTabSz="1280160" rtl="0" eaLnBrk="1" latinLnBrk="0" hangingPunct="1">
+              <a:lnSpc>
+                <a:spcPct val="90000"/>
+              </a:lnSpc>
+              <a:spcBef>
+                <a:spcPts val="700"/>
+              </a:spcBef>
+              <a:buFont typeface="Arial" panose="020B0604020202020204" pitchFamily="34" charset="0"/>
+              <a:buNone/>
+              <a:defRPr sz="1400" kern="1200">
+                <a:solidFill>
+                  <a:schemeClr val="tx1"/>
+                </a:solidFill>
+                <a:latin typeface="+mn-lt"/>
+                <a:ea typeface="+mn-ea"/>
+                <a:cs typeface="+mn-cs"/>
+              </a:defRPr>
+            </a:lvl5pPr>
+            <a:lvl6pPr marL="3520440" indent="-320040" algn="l" defTabSz="1280160" rtl="0" eaLnBrk="1" latinLnBrk="0" hangingPunct="1">
+              <a:lnSpc>
+                <a:spcPct val="90000"/>
+              </a:lnSpc>
+              <a:spcBef>
+                <a:spcPts val="700"/>
+              </a:spcBef>
+              <a:buFont typeface="Arial" panose="020B0604020202020204" pitchFamily="34" charset="0"/>
+              <a:buChar char="•"/>
+              <a:defRPr sz="2520" kern="1200">
+                <a:solidFill>
+                  <a:schemeClr val="tx1"/>
+                </a:solidFill>
+                <a:latin typeface="+mn-lt"/>
+                <a:ea typeface="+mn-ea"/>
+                <a:cs typeface="+mn-cs"/>
+              </a:defRPr>
+            </a:lvl6pPr>
+            <a:lvl7pPr marL="4160520" indent="-320040" algn="l" defTabSz="1280160" rtl="0" eaLnBrk="1" latinLnBrk="0" hangingPunct="1">
+              <a:lnSpc>
+                <a:spcPct val="90000"/>
+              </a:lnSpc>
+              <a:spcBef>
+                <a:spcPts val="700"/>
+              </a:spcBef>
+              <a:buFont typeface="Arial" panose="020B0604020202020204" pitchFamily="34" charset="0"/>
+              <a:buChar char="•"/>
+              <a:defRPr sz="2520" kern="1200">
+                <a:solidFill>
+                  <a:schemeClr val="tx1"/>
+                </a:solidFill>
+                <a:latin typeface="+mn-lt"/>
+                <a:ea typeface="+mn-ea"/>
+                <a:cs typeface="+mn-cs"/>
+              </a:defRPr>
+            </a:lvl7pPr>
+            <a:lvl8pPr marL="4800600" indent="-320040" algn="l" defTabSz="1280160" rtl="0" eaLnBrk="1" latinLnBrk="0" hangingPunct="1">
+              <a:lnSpc>
+                <a:spcPct val="90000"/>
+              </a:lnSpc>
+              <a:spcBef>
+                <a:spcPts val="700"/>
+              </a:spcBef>
+              <a:buFont typeface="Arial" panose="020B0604020202020204" pitchFamily="34" charset="0"/>
+              <a:buChar char="•"/>
+              <a:defRPr sz="2520" kern="1200">
+                <a:solidFill>
+                  <a:schemeClr val="tx1"/>
+                </a:solidFill>
+                <a:latin typeface="+mn-lt"/>
+                <a:ea typeface="+mn-ea"/>
+                <a:cs typeface="+mn-cs"/>
+              </a:defRPr>
+            </a:lvl8pPr>
+            <a:lvl9pPr marL="5440680" indent="-320040" algn="l" defTabSz="1280160" rtl="0" eaLnBrk="1" latinLnBrk="0" hangingPunct="1">
+              <a:lnSpc>
+                <a:spcPct val="90000"/>
+              </a:lnSpc>
+              <a:spcBef>
+                <a:spcPts val="700"/>
+              </a:spcBef>
+              <a:buFont typeface="Arial" panose="020B0604020202020204" pitchFamily="34" charset="0"/>
+              <a:buChar char="•"/>
+              <a:defRPr sz="2520" kern="1200">
+                <a:solidFill>
+                  <a:schemeClr val="tx1"/>
+                </a:solidFill>
+                <a:latin typeface="+mn-lt"/>
+                <a:ea typeface="+mn-ea"/>
+                <a:cs typeface="+mn-cs"/>
+              </a:defRPr>
+            </a:lvl9pPr>
+          </a:lstStyle>
+          <a:p>
+            <a:r>
+              <a:rPr lang="pt-BR" sz="1600" b="1" dirty="0">
+                <a:solidFill>
+                  <a:schemeClr val="accent1">
+                    <a:lumMod val="75000"/>
+                  </a:schemeClr>
+                </a:solidFill>
+                <a:latin typeface="Arial" panose="020B0604020202020204" pitchFamily="34" charset="0"/>
+                <a:cs typeface="Arial" panose="020B0604020202020204" pitchFamily="34" charset="0"/>
+              </a:rPr>
+              <a:t>Objetivo geral</a:t>
+            </a:r>
+            <a:endParaRPr lang="pt-BR" sz="1600" b="1" dirty="0">
+              <a:solidFill>
+                <a:schemeClr val="tx1"/>
+              </a:solidFill>
+              <a:latin typeface="Arial" panose="020B0604020202020204" pitchFamily="34" charset="0"/>
+              <a:cs typeface="Arial" panose="020B0604020202020204" pitchFamily="34" charset="0"/>
+            </a:endParaRPr>
+          </a:p>
+          <a:p>
+            <a:r>
+              <a:rPr lang="pt-BR" sz="1200" dirty="0">
+                <a:solidFill>
+                  <a:schemeClr val="tx1"/>
+                </a:solidFill>
+                <a:latin typeface="Arial" panose="020B0604020202020204" pitchFamily="34" charset="0"/>
+                <a:cs typeface="Arial" panose="020B0604020202020204" pitchFamily="34" charset="0"/>
+              </a:rPr>
+              <a:t>Transformar dados de desempenho clube-temporada em um indicador preditivo de risco de rebaixamento , apresentado por meio de uma solução de BI e Analytics.</a:t>
+            </a:r>
           </a:p>
         </p:txBody>
       </p:sp>
@@ -4052,23 +4533,6 @@
 </file>
 
 <file path=customXml/item1.xml><?xml version="1.0" encoding="utf-8"?>
-<p:properties xmlns:p="http://schemas.microsoft.com/office/2006/metadata/properties" xmlns:xsi="http://www.w3.org/2001/XMLSchema-instance" xmlns:pc="http://schemas.microsoft.com/office/infopath/2007/PartnerControls">
-  <documentManagement>
-    <_activity xmlns="6439f31e-650a-4110-90ce-dedea4761958" xsi:nil="true"/>
-  </documentManagement>
-</p:properties>
-</file>
-
-<file path=customXml/item2.xml><?xml version="1.0" encoding="utf-8"?>
-<?mso-contentType ?>
-<FormTemplates xmlns="http://schemas.microsoft.com/sharepoint/v3/contenttype/forms">
-  <Display>DocumentLibraryForm</Display>
-  <Edit>DocumentLibraryForm</Edit>
-  <New>DocumentLibraryForm</New>
-</FormTemplates>
-</file>
-
-<file path=customXml/item3.xml><?xml version="1.0" encoding="utf-8"?>
 <ct:contentTypeSchema xmlns:ct="http://schemas.microsoft.com/office/2006/metadata/contentType" xmlns:ma="http://schemas.microsoft.com/office/2006/metadata/properties/metaAttributes" ct:_="" ma:_="" ma:contentTypeName="Documento" ma:contentTypeID="0x010100D0B80C79D672AC42A1970465DFBE826F" ma:contentTypeVersion="15" ma:contentTypeDescription="Crie um novo documento." ma:contentTypeScope="" ma:versionID="2eefaa1e6d6c44dc16da2b9d163c9050">
   <xsd:schema xmlns:xsd="http://www.w3.org/2001/XMLSchema" xmlns:xs="http://www.w3.org/2001/XMLSchema" xmlns:p="http://schemas.microsoft.com/office/2006/metadata/properties" xmlns:ns3="6439f31e-650a-4110-90ce-dedea4761958" xmlns:ns4="0c1d693f-504f-4903-8fa4-fc4240ce4f11" targetNamespace="http://schemas.microsoft.com/office/2006/metadata/properties" ma:root="true" ma:fieldsID="0d3e9c37c1323d55a0c2b9c866021e93" ns3:_="" ns4:_="">
     <xsd:import namespace="6439f31e-650a-4110-90ce-dedea4761958"/>
@@ -4301,32 +4765,24 @@
 </ct:contentTypeSchema>
 </file>
 
-<file path=customXml/itemProps1.xml><?xml version="1.0" encoding="utf-8"?>
-<ds:datastoreItem xmlns:ds="http://schemas.openxmlformats.org/officeDocument/2006/customXml" ds:itemID="{0C5DC577-20A1-4512-B4E1-28F0CC21B7A7}">
-  <ds:schemaRefs>
-    <ds:schemaRef ds:uri="http://schemas.microsoft.com/office/2006/documentManagement/types"/>
-    <ds:schemaRef ds:uri="http://purl.org/dc/elements/1.1/"/>
-    <ds:schemaRef ds:uri="http://schemas.microsoft.com/office/2006/metadata/properties"/>
-    <ds:schemaRef ds:uri="6439f31e-650a-4110-90ce-dedea4761958"/>
-    <ds:schemaRef ds:uri="http://purl.org/dc/terms/"/>
-    <ds:schemaRef ds:uri="http://schemas.openxmlformats.org/package/2006/metadata/core-properties"/>
-    <ds:schemaRef ds:uri="http://purl.org/dc/dcmitype/"/>
-    <ds:schemaRef ds:uri="0c1d693f-504f-4903-8fa4-fc4240ce4f11"/>
-    <ds:schemaRef ds:uri="http://schemas.microsoft.com/office/infopath/2007/PartnerControls"/>
-    <ds:schemaRef ds:uri="http://www.w3.org/XML/1998/namespace"/>
-  </ds:schemaRefs>
-</ds:datastoreItem>
+<file path=customXml/item2.xml><?xml version="1.0" encoding="utf-8"?>
+<?mso-contentType ?>
+<FormTemplates xmlns="http://schemas.microsoft.com/sharepoint/v3/contenttype/forms">
+  <Display>DocumentLibraryForm</Display>
+  <Edit>DocumentLibraryForm</Edit>
+  <New>DocumentLibraryForm</New>
+</FormTemplates>
 </file>
 
-<file path=customXml/itemProps2.xml><?xml version="1.0" encoding="utf-8"?>
-<ds:datastoreItem xmlns:ds="http://schemas.openxmlformats.org/officeDocument/2006/customXml" ds:itemID="{F16D510D-55C7-43E2-BA4A-72786699A122}">
-  <ds:schemaRefs>
-    <ds:schemaRef ds:uri="http://schemas.microsoft.com/sharepoint/v3/contenttype/forms"/>
-  </ds:schemaRefs>
-</ds:datastoreItem>
+<file path=customXml/item3.xml><?xml version="1.0" encoding="utf-8"?>
+<p:properties xmlns:p="http://schemas.microsoft.com/office/2006/metadata/properties" xmlns:xsi="http://www.w3.org/2001/XMLSchema-instance" xmlns:pc="http://schemas.microsoft.com/office/infopath/2007/PartnerControls">
+  <documentManagement>
+    <_activity xmlns="6439f31e-650a-4110-90ce-dedea4761958" xsi:nil="true"/>
+  </documentManagement>
+</p:properties>
 </file>
 
-<file path=customXml/itemProps3.xml><?xml version="1.0" encoding="utf-8"?>
+<file path=customXml/itemProps1.xml><?xml version="1.0" encoding="utf-8"?>
 <ds:datastoreItem xmlns:ds="http://schemas.openxmlformats.org/officeDocument/2006/customXml" ds:itemID="{D4840938-E05E-4C2F-BC8B-C9AED83822C2}">
   <ds:schemaRefs>
     <ds:schemaRef ds:uri="http://schemas.microsoft.com/office/2006/metadata/contentType"/>
@@ -4343,4 +4799,29 @@
     <ds:schemaRef ds:uri="http://schemas.microsoft.com/internal/obd"/>
   </ds:schemaRefs>
 </ds:datastoreItem>
+</file>
+
+<file path=customXml/itemProps2.xml><?xml version="1.0" encoding="utf-8"?>
+<ds:datastoreItem xmlns:ds="http://schemas.openxmlformats.org/officeDocument/2006/customXml" ds:itemID="{F16D510D-55C7-43E2-BA4A-72786699A122}">
+  <ds:schemaRefs>
+    <ds:schemaRef ds:uri="http://schemas.microsoft.com/sharepoint/v3/contenttype/forms"/>
+  </ds:schemaRefs>
+</ds:datastoreItem>
+</file>
+
+<file path=customXml/itemProps3.xml><?xml version="1.0" encoding="utf-8"?>
+<ds:datastoreItem xmlns:ds="http://schemas.openxmlformats.org/officeDocument/2006/customXml" ds:itemID="{0C5DC577-20A1-4512-B4E1-28F0CC21B7A7}">
+  <ds:schemaRefs>
+    <ds:schemaRef ds:uri="http://schemas.microsoft.com/office/2006/documentManagement/types"/>
+    <ds:schemaRef ds:uri="http://purl.org/dc/elements/1.1/"/>
+    <ds:schemaRef ds:uri="http://schemas.microsoft.com/office/2006/metadata/properties"/>
+    <ds:schemaRef ds:uri="6439f31e-650a-4110-90ce-dedea4761958"/>
+    <ds:schemaRef ds:uri="http://purl.org/dc/terms/"/>
+    <ds:schemaRef ds:uri="http://schemas.openxmlformats.org/package/2006/metadata/core-properties"/>
+    <ds:schemaRef ds:uri="http://purl.org/dc/dcmitype/"/>
+    <ds:schemaRef ds:uri="0c1d693f-504f-4903-8fa4-fc4240ce4f11"/>
+    <ds:schemaRef ds:uri="http://schemas.microsoft.com/office/infopath/2007/PartnerControls"/>
+    <ds:schemaRef ds:uri="http://www.w3.org/XML/1998/namespace"/>
+  </ds:schemaRefs>
+</ds:datastoreItem>
 </file>
</xml_diff>

<commit_message>
feat: Algumas descrições do projeto
</commit_message>
<xml_diff>
--- a/docs/Template - Fase 2 - Apresentação Executiva - Projeto em Business Intelligence e Analytics.pptx
+++ b/docs/Template - Fase 2 - Apresentação Executiva - Projeto em Business Intelligence e Analytics.pptx
@@ -3861,7 +3861,676 @@
                 <a:latin typeface="Arial" panose="020B0604020202020204" pitchFamily="34" charset="0"/>
                 <a:cs typeface="Arial" panose="020B0604020202020204" pitchFamily="34" charset="0"/>
               </a:rPr>
-              <a:t>Transformar dados de desempenho clube-temporada em um indicador preditivo de risco de rebaixamento , apresentado por meio de uma solução de BI e Analytics.</a:t>
+              <a:t>Transformar dados de desempenho clube-temporada em um indicador preditivo de risco de rebaixamento, apresentado por meio de uma solução de BI e Analytics.</a:t>
+            </a:r>
+          </a:p>
+        </p:txBody>
+      </p:sp>
+      <p:sp>
+        <p:nvSpPr>
+          <p:cNvPr id="6" name="Espaço Reservado para Texto 1">
+            <a:extLst>
+              <a:ext uri="{FF2B5EF4-FFF2-40B4-BE49-F238E27FC236}">
+                <a16:creationId xmlns:a16="http://schemas.microsoft.com/office/drawing/2014/main" id="{5AA023C6-56D6-F152-8B49-4085D087A29F}"/>
+              </a:ext>
+            </a:extLst>
+          </p:cNvPr>
+          <p:cNvSpPr txBox="1">
+            <a:spLocks/>
+          </p:cNvSpPr>
+          <p:nvPr/>
+        </p:nvSpPr>
+        <p:spPr>
+          <a:xfrm>
+            <a:off x="928688" y="4857750"/>
+            <a:ext cx="4386262" cy="3384550"/>
+          </a:xfrm>
+          <a:prstGeom prst="rect">
+            <a:avLst/>
+          </a:prstGeom>
+          <a:noFill/>
+        </p:spPr>
+        <p:txBody>
+          <a:bodyPr lIns="72000" tIns="72000" rIns="72000" bIns="72000"/>
+          <a:lstStyle>
+            <a:lvl1pPr marL="0" indent="0" algn="l" defTabSz="1280160" rtl="0" eaLnBrk="1" latinLnBrk="0" hangingPunct="1">
+              <a:lnSpc>
+                <a:spcPct val="100000"/>
+              </a:lnSpc>
+              <a:spcBef>
+                <a:spcPts val="0"/>
+              </a:spcBef>
+              <a:spcAft>
+                <a:spcPts val="1200"/>
+              </a:spcAft>
+              <a:buFont typeface="Arial" panose="020B0604020202020204" pitchFamily="34" charset="0"/>
+              <a:buNone/>
+              <a:defRPr sz="1800" kern="1200">
+                <a:solidFill>
+                  <a:schemeClr val="tx2">
+                    <a:lumMod val="75000"/>
+                  </a:schemeClr>
+                </a:solidFill>
+                <a:latin typeface="+mn-lt"/>
+                <a:ea typeface="+mn-ea"/>
+                <a:cs typeface="+mn-cs"/>
+              </a:defRPr>
+            </a:lvl1pPr>
+            <a:lvl2pPr marL="640080" indent="0" algn="l" defTabSz="1280160" rtl="0" eaLnBrk="1" latinLnBrk="0" hangingPunct="1">
+              <a:lnSpc>
+                <a:spcPct val="90000"/>
+              </a:lnSpc>
+              <a:spcBef>
+                <a:spcPts val="700"/>
+              </a:spcBef>
+              <a:buFont typeface="Arial" panose="020B0604020202020204" pitchFamily="34" charset="0"/>
+              <a:buNone/>
+              <a:defRPr sz="1400" kern="1200">
+                <a:solidFill>
+                  <a:schemeClr val="tx1"/>
+                </a:solidFill>
+                <a:latin typeface="+mn-lt"/>
+                <a:ea typeface="+mn-ea"/>
+                <a:cs typeface="+mn-cs"/>
+              </a:defRPr>
+            </a:lvl2pPr>
+            <a:lvl3pPr marL="1280160" indent="0" algn="l" defTabSz="1280160" rtl="0" eaLnBrk="1" latinLnBrk="0" hangingPunct="1">
+              <a:lnSpc>
+                <a:spcPct val="90000"/>
+              </a:lnSpc>
+              <a:spcBef>
+                <a:spcPts val="700"/>
+              </a:spcBef>
+              <a:buFont typeface="Arial" panose="020B0604020202020204" pitchFamily="34" charset="0"/>
+              <a:buNone/>
+              <a:defRPr sz="1400" kern="1200">
+                <a:solidFill>
+                  <a:schemeClr val="tx1"/>
+                </a:solidFill>
+                <a:latin typeface="+mn-lt"/>
+                <a:ea typeface="+mn-ea"/>
+                <a:cs typeface="+mn-cs"/>
+              </a:defRPr>
+            </a:lvl3pPr>
+            <a:lvl4pPr marL="1920240" indent="0" algn="l" defTabSz="1280160" rtl="0" eaLnBrk="1" latinLnBrk="0" hangingPunct="1">
+              <a:lnSpc>
+                <a:spcPct val="90000"/>
+              </a:lnSpc>
+              <a:spcBef>
+                <a:spcPts val="700"/>
+              </a:spcBef>
+              <a:buFont typeface="Arial" panose="020B0604020202020204" pitchFamily="34" charset="0"/>
+              <a:buNone/>
+              <a:defRPr sz="1400" kern="1200">
+                <a:solidFill>
+                  <a:schemeClr val="tx1"/>
+                </a:solidFill>
+                <a:latin typeface="+mn-lt"/>
+                <a:ea typeface="+mn-ea"/>
+                <a:cs typeface="+mn-cs"/>
+              </a:defRPr>
+            </a:lvl4pPr>
+            <a:lvl5pPr marL="2560320" indent="0" algn="l" defTabSz="1280160" rtl="0" eaLnBrk="1" latinLnBrk="0" hangingPunct="1">
+              <a:lnSpc>
+                <a:spcPct val="90000"/>
+              </a:lnSpc>
+              <a:spcBef>
+                <a:spcPts val="700"/>
+              </a:spcBef>
+              <a:buFont typeface="Arial" panose="020B0604020202020204" pitchFamily="34" charset="0"/>
+              <a:buNone/>
+              <a:defRPr sz="1400" kern="1200">
+                <a:solidFill>
+                  <a:schemeClr val="tx1"/>
+                </a:solidFill>
+                <a:latin typeface="+mn-lt"/>
+                <a:ea typeface="+mn-ea"/>
+                <a:cs typeface="+mn-cs"/>
+              </a:defRPr>
+            </a:lvl5pPr>
+            <a:lvl6pPr marL="3520440" indent="-320040" algn="l" defTabSz="1280160" rtl="0" eaLnBrk="1" latinLnBrk="0" hangingPunct="1">
+              <a:lnSpc>
+                <a:spcPct val="90000"/>
+              </a:lnSpc>
+              <a:spcBef>
+                <a:spcPts val="700"/>
+              </a:spcBef>
+              <a:buFont typeface="Arial" panose="020B0604020202020204" pitchFamily="34" charset="0"/>
+              <a:buChar char="•"/>
+              <a:defRPr sz="2520" kern="1200">
+                <a:solidFill>
+                  <a:schemeClr val="tx1"/>
+                </a:solidFill>
+                <a:latin typeface="+mn-lt"/>
+                <a:ea typeface="+mn-ea"/>
+                <a:cs typeface="+mn-cs"/>
+              </a:defRPr>
+            </a:lvl6pPr>
+            <a:lvl7pPr marL="4160520" indent="-320040" algn="l" defTabSz="1280160" rtl="0" eaLnBrk="1" latinLnBrk="0" hangingPunct="1">
+              <a:lnSpc>
+                <a:spcPct val="90000"/>
+              </a:lnSpc>
+              <a:spcBef>
+                <a:spcPts val="700"/>
+              </a:spcBef>
+              <a:buFont typeface="Arial" panose="020B0604020202020204" pitchFamily="34" charset="0"/>
+              <a:buChar char="•"/>
+              <a:defRPr sz="2520" kern="1200">
+                <a:solidFill>
+                  <a:schemeClr val="tx1"/>
+                </a:solidFill>
+                <a:latin typeface="+mn-lt"/>
+                <a:ea typeface="+mn-ea"/>
+                <a:cs typeface="+mn-cs"/>
+              </a:defRPr>
+            </a:lvl7pPr>
+            <a:lvl8pPr marL="4800600" indent="-320040" algn="l" defTabSz="1280160" rtl="0" eaLnBrk="1" latinLnBrk="0" hangingPunct="1">
+              <a:lnSpc>
+                <a:spcPct val="90000"/>
+              </a:lnSpc>
+              <a:spcBef>
+                <a:spcPts val="700"/>
+              </a:spcBef>
+              <a:buFont typeface="Arial" panose="020B0604020202020204" pitchFamily="34" charset="0"/>
+              <a:buChar char="•"/>
+              <a:defRPr sz="2520" kern="1200">
+                <a:solidFill>
+                  <a:schemeClr val="tx1"/>
+                </a:solidFill>
+                <a:latin typeface="+mn-lt"/>
+                <a:ea typeface="+mn-ea"/>
+                <a:cs typeface="+mn-cs"/>
+              </a:defRPr>
+            </a:lvl8pPr>
+            <a:lvl9pPr marL="5440680" indent="-320040" algn="l" defTabSz="1280160" rtl="0" eaLnBrk="1" latinLnBrk="0" hangingPunct="1">
+              <a:lnSpc>
+                <a:spcPct val="90000"/>
+              </a:lnSpc>
+              <a:spcBef>
+                <a:spcPts val="700"/>
+              </a:spcBef>
+              <a:buFont typeface="Arial" panose="020B0604020202020204" pitchFamily="34" charset="0"/>
+              <a:buChar char="•"/>
+              <a:defRPr sz="2520" kern="1200">
+                <a:solidFill>
+                  <a:schemeClr val="tx1"/>
+                </a:solidFill>
+                <a:latin typeface="+mn-lt"/>
+                <a:ea typeface="+mn-ea"/>
+                <a:cs typeface="+mn-cs"/>
+              </a:defRPr>
+            </a:lvl9pPr>
+          </a:lstStyle>
+          <a:p>
+            <a:r>
+              <a:rPr lang="pt-BR" sz="1600" b="1" dirty="0">
+                <a:solidFill>
+                  <a:schemeClr val="accent1">
+                    <a:lumMod val="75000"/>
+                  </a:schemeClr>
+                </a:solidFill>
+                <a:latin typeface="Arial" panose="020B0604020202020204" pitchFamily="34" charset="0"/>
+                <a:cs typeface="Arial" panose="020B0604020202020204" pitchFamily="34" charset="0"/>
+              </a:rPr>
+              <a:t>Indicador de risco por clube</a:t>
+            </a:r>
+          </a:p>
+          <a:p>
+            <a:r>
+              <a:rPr lang="pt-BR" sz="1200" dirty="0">
+                <a:solidFill>
+                  <a:schemeClr val="tx1"/>
+                </a:solidFill>
+                <a:latin typeface="Arial" panose="020B0604020202020204" pitchFamily="34" charset="0"/>
+                <a:cs typeface="Arial" panose="020B0604020202020204" pitchFamily="34" charset="0"/>
+              </a:rPr>
+              <a:t>Probabilidade de rebaixamente calculada para cada um dos 20 clubes de Série A na temporada 2025</a:t>
+            </a:r>
+          </a:p>
+        </p:txBody>
+      </p:sp>
+      <p:sp>
+        <p:nvSpPr>
+          <p:cNvPr id="8" name="Espaço Reservado para Texto 1">
+            <a:extLst>
+              <a:ext uri="{FF2B5EF4-FFF2-40B4-BE49-F238E27FC236}">
+                <a16:creationId xmlns:a16="http://schemas.microsoft.com/office/drawing/2014/main" id="{FE5BDC7B-EF69-B6F8-0C32-8ED6164BA7FB}"/>
+              </a:ext>
+            </a:extLst>
+          </p:cNvPr>
+          <p:cNvSpPr txBox="1">
+            <a:spLocks/>
+          </p:cNvSpPr>
+          <p:nvPr/>
+        </p:nvSpPr>
+        <p:spPr>
+          <a:xfrm>
+            <a:off x="6007894" y="4857750"/>
+            <a:ext cx="4386262" cy="3384550"/>
+          </a:xfrm>
+          <a:prstGeom prst="rect">
+            <a:avLst/>
+          </a:prstGeom>
+          <a:noFill/>
+        </p:spPr>
+        <p:txBody>
+          <a:bodyPr lIns="72000" tIns="72000" rIns="72000" bIns="72000"/>
+          <a:lstStyle>
+            <a:lvl1pPr marL="0" indent="0" algn="l" defTabSz="1280160" rtl="0" eaLnBrk="1" latinLnBrk="0" hangingPunct="1">
+              <a:lnSpc>
+                <a:spcPct val="100000"/>
+              </a:lnSpc>
+              <a:spcBef>
+                <a:spcPts val="0"/>
+              </a:spcBef>
+              <a:spcAft>
+                <a:spcPts val="1200"/>
+              </a:spcAft>
+              <a:buFont typeface="Arial" panose="020B0604020202020204" pitchFamily="34" charset="0"/>
+              <a:buNone/>
+              <a:defRPr sz="1800" kern="1200">
+                <a:solidFill>
+                  <a:schemeClr val="tx2">
+                    <a:lumMod val="75000"/>
+                  </a:schemeClr>
+                </a:solidFill>
+                <a:latin typeface="+mn-lt"/>
+                <a:ea typeface="+mn-ea"/>
+                <a:cs typeface="+mn-cs"/>
+              </a:defRPr>
+            </a:lvl1pPr>
+            <a:lvl2pPr marL="640080" indent="0" algn="l" defTabSz="1280160" rtl="0" eaLnBrk="1" latinLnBrk="0" hangingPunct="1">
+              <a:lnSpc>
+                <a:spcPct val="90000"/>
+              </a:lnSpc>
+              <a:spcBef>
+                <a:spcPts val="700"/>
+              </a:spcBef>
+              <a:buFont typeface="Arial" panose="020B0604020202020204" pitchFamily="34" charset="0"/>
+              <a:buNone/>
+              <a:defRPr sz="1400" kern="1200">
+                <a:solidFill>
+                  <a:schemeClr val="tx1"/>
+                </a:solidFill>
+                <a:latin typeface="+mn-lt"/>
+                <a:ea typeface="+mn-ea"/>
+                <a:cs typeface="+mn-cs"/>
+              </a:defRPr>
+            </a:lvl2pPr>
+            <a:lvl3pPr marL="1280160" indent="0" algn="l" defTabSz="1280160" rtl="0" eaLnBrk="1" latinLnBrk="0" hangingPunct="1">
+              <a:lnSpc>
+                <a:spcPct val="90000"/>
+              </a:lnSpc>
+              <a:spcBef>
+                <a:spcPts val="700"/>
+              </a:spcBef>
+              <a:buFont typeface="Arial" panose="020B0604020202020204" pitchFamily="34" charset="0"/>
+              <a:buNone/>
+              <a:defRPr sz="1400" kern="1200">
+                <a:solidFill>
+                  <a:schemeClr val="tx1"/>
+                </a:solidFill>
+                <a:latin typeface="+mn-lt"/>
+                <a:ea typeface="+mn-ea"/>
+                <a:cs typeface="+mn-cs"/>
+              </a:defRPr>
+            </a:lvl3pPr>
+            <a:lvl4pPr marL="1920240" indent="0" algn="l" defTabSz="1280160" rtl="0" eaLnBrk="1" latinLnBrk="0" hangingPunct="1">
+              <a:lnSpc>
+                <a:spcPct val="90000"/>
+              </a:lnSpc>
+              <a:spcBef>
+                <a:spcPts val="700"/>
+              </a:spcBef>
+              <a:buFont typeface="Arial" panose="020B0604020202020204" pitchFamily="34" charset="0"/>
+              <a:buNone/>
+              <a:defRPr sz="1400" kern="1200">
+                <a:solidFill>
+                  <a:schemeClr val="tx1"/>
+                </a:solidFill>
+                <a:latin typeface="+mn-lt"/>
+                <a:ea typeface="+mn-ea"/>
+                <a:cs typeface="+mn-cs"/>
+              </a:defRPr>
+            </a:lvl4pPr>
+            <a:lvl5pPr marL="2560320" indent="0" algn="l" defTabSz="1280160" rtl="0" eaLnBrk="1" latinLnBrk="0" hangingPunct="1">
+              <a:lnSpc>
+                <a:spcPct val="90000"/>
+              </a:lnSpc>
+              <a:spcBef>
+                <a:spcPts val="700"/>
+              </a:spcBef>
+              <a:buFont typeface="Arial" panose="020B0604020202020204" pitchFamily="34" charset="0"/>
+              <a:buNone/>
+              <a:defRPr sz="1400" kern="1200">
+                <a:solidFill>
+                  <a:schemeClr val="tx1"/>
+                </a:solidFill>
+                <a:latin typeface="+mn-lt"/>
+                <a:ea typeface="+mn-ea"/>
+                <a:cs typeface="+mn-cs"/>
+              </a:defRPr>
+            </a:lvl5pPr>
+            <a:lvl6pPr marL="3520440" indent="-320040" algn="l" defTabSz="1280160" rtl="0" eaLnBrk="1" latinLnBrk="0" hangingPunct="1">
+              <a:lnSpc>
+                <a:spcPct val="90000"/>
+              </a:lnSpc>
+              <a:spcBef>
+                <a:spcPts val="700"/>
+              </a:spcBef>
+              <a:buFont typeface="Arial" panose="020B0604020202020204" pitchFamily="34" charset="0"/>
+              <a:buChar char="•"/>
+              <a:defRPr sz="2520" kern="1200">
+                <a:solidFill>
+                  <a:schemeClr val="tx1"/>
+                </a:solidFill>
+                <a:latin typeface="+mn-lt"/>
+                <a:ea typeface="+mn-ea"/>
+                <a:cs typeface="+mn-cs"/>
+              </a:defRPr>
+            </a:lvl6pPr>
+            <a:lvl7pPr marL="4160520" indent="-320040" algn="l" defTabSz="1280160" rtl="0" eaLnBrk="1" latinLnBrk="0" hangingPunct="1">
+              <a:lnSpc>
+                <a:spcPct val="90000"/>
+              </a:lnSpc>
+              <a:spcBef>
+                <a:spcPts val="700"/>
+              </a:spcBef>
+              <a:buFont typeface="Arial" panose="020B0604020202020204" pitchFamily="34" charset="0"/>
+              <a:buChar char="•"/>
+              <a:defRPr sz="2520" kern="1200">
+                <a:solidFill>
+                  <a:schemeClr val="tx1"/>
+                </a:solidFill>
+                <a:latin typeface="+mn-lt"/>
+                <a:ea typeface="+mn-ea"/>
+                <a:cs typeface="+mn-cs"/>
+              </a:defRPr>
+            </a:lvl7pPr>
+            <a:lvl8pPr marL="4800600" indent="-320040" algn="l" defTabSz="1280160" rtl="0" eaLnBrk="1" latinLnBrk="0" hangingPunct="1">
+              <a:lnSpc>
+                <a:spcPct val="90000"/>
+              </a:lnSpc>
+              <a:spcBef>
+                <a:spcPts val="700"/>
+              </a:spcBef>
+              <a:buFont typeface="Arial" panose="020B0604020202020204" pitchFamily="34" charset="0"/>
+              <a:buChar char="•"/>
+              <a:defRPr sz="2520" kern="1200">
+                <a:solidFill>
+                  <a:schemeClr val="tx1"/>
+                </a:solidFill>
+                <a:latin typeface="+mn-lt"/>
+                <a:ea typeface="+mn-ea"/>
+                <a:cs typeface="+mn-cs"/>
+              </a:defRPr>
+            </a:lvl8pPr>
+            <a:lvl9pPr marL="5440680" indent="-320040" algn="l" defTabSz="1280160" rtl="0" eaLnBrk="1" latinLnBrk="0" hangingPunct="1">
+              <a:lnSpc>
+                <a:spcPct val="90000"/>
+              </a:lnSpc>
+              <a:spcBef>
+                <a:spcPts val="700"/>
+              </a:spcBef>
+              <a:buFont typeface="Arial" panose="020B0604020202020204" pitchFamily="34" charset="0"/>
+              <a:buChar char="•"/>
+              <a:defRPr sz="2520" kern="1200">
+                <a:solidFill>
+                  <a:schemeClr val="tx1"/>
+                </a:solidFill>
+                <a:latin typeface="+mn-lt"/>
+                <a:ea typeface="+mn-ea"/>
+                <a:cs typeface="+mn-cs"/>
+              </a:defRPr>
+            </a:lvl9pPr>
+          </a:lstStyle>
+          <a:p>
+            <a:r>
+              <a:rPr lang="pt-BR" sz="1600" b="1" dirty="0">
+                <a:solidFill>
+                  <a:schemeClr val="accent1">
+                    <a:lumMod val="75000"/>
+                  </a:schemeClr>
+                </a:solidFill>
+                <a:latin typeface="Arial" panose="020B0604020202020204" pitchFamily="34" charset="0"/>
+                <a:cs typeface="Arial" panose="020B0604020202020204" pitchFamily="34" charset="0"/>
+              </a:rPr>
+              <a:t>Modelo preditivo</a:t>
+            </a:r>
+          </a:p>
+          <a:p>
+            <a:r>
+              <a:rPr lang="pt-BR" sz="1200" dirty="0">
+                <a:solidFill>
+                  <a:schemeClr val="tx1"/>
+                </a:solidFill>
+                <a:latin typeface="Arial" panose="020B0604020202020204" pitchFamily="34" charset="0"/>
+                <a:cs typeface="Arial" panose="020B0604020202020204" pitchFamily="34" charset="0"/>
+              </a:rPr>
+              <a:t>Regressão Logística treinada com dados de 2006 a 2024, usando a posição final como variavel preditiva.</a:t>
+            </a:r>
+          </a:p>
+        </p:txBody>
+      </p:sp>
+      <p:sp>
+        <p:nvSpPr>
+          <p:cNvPr id="10" name="Espaço Reservado para Texto 1">
+            <a:extLst>
+              <a:ext uri="{FF2B5EF4-FFF2-40B4-BE49-F238E27FC236}">
+                <a16:creationId xmlns:a16="http://schemas.microsoft.com/office/drawing/2014/main" id="{98FCB85E-93B7-1FC3-3C47-C54599E4A6F4}"/>
+              </a:ext>
+            </a:extLst>
+          </p:cNvPr>
+          <p:cNvSpPr txBox="1">
+            <a:spLocks/>
+          </p:cNvSpPr>
+          <p:nvPr/>
+        </p:nvSpPr>
+        <p:spPr>
+          <a:xfrm>
+            <a:off x="11087100" y="4857750"/>
+            <a:ext cx="4386262" cy="3384550"/>
+          </a:xfrm>
+          <a:prstGeom prst="rect">
+            <a:avLst/>
+          </a:prstGeom>
+          <a:noFill/>
+        </p:spPr>
+        <p:txBody>
+          <a:bodyPr lIns="72000" tIns="72000" rIns="72000" bIns="72000"/>
+          <a:lstStyle>
+            <a:lvl1pPr marL="0" indent="0" algn="l" defTabSz="1280160" rtl="0" eaLnBrk="1" latinLnBrk="0" hangingPunct="1">
+              <a:lnSpc>
+                <a:spcPct val="100000"/>
+              </a:lnSpc>
+              <a:spcBef>
+                <a:spcPts val="0"/>
+              </a:spcBef>
+              <a:spcAft>
+                <a:spcPts val="1200"/>
+              </a:spcAft>
+              <a:buFont typeface="Arial" panose="020B0604020202020204" pitchFamily="34" charset="0"/>
+              <a:buNone/>
+              <a:defRPr sz="1800" kern="1200">
+                <a:solidFill>
+                  <a:schemeClr val="tx2">
+                    <a:lumMod val="75000"/>
+                  </a:schemeClr>
+                </a:solidFill>
+                <a:latin typeface="+mn-lt"/>
+                <a:ea typeface="+mn-ea"/>
+                <a:cs typeface="+mn-cs"/>
+              </a:defRPr>
+            </a:lvl1pPr>
+            <a:lvl2pPr marL="640080" indent="0" algn="l" defTabSz="1280160" rtl="0" eaLnBrk="1" latinLnBrk="0" hangingPunct="1">
+              <a:lnSpc>
+                <a:spcPct val="90000"/>
+              </a:lnSpc>
+              <a:spcBef>
+                <a:spcPts val="700"/>
+              </a:spcBef>
+              <a:buFont typeface="Arial" panose="020B0604020202020204" pitchFamily="34" charset="0"/>
+              <a:buNone/>
+              <a:defRPr sz="1400" kern="1200">
+                <a:solidFill>
+                  <a:schemeClr val="tx1"/>
+                </a:solidFill>
+                <a:latin typeface="+mn-lt"/>
+                <a:ea typeface="+mn-ea"/>
+                <a:cs typeface="+mn-cs"/>
+              </a:defRPr>
+            </a:lvl2pPr>
+            <a:lvl3pPr marL="1280160" indent="0" algn="l" defTabSz="1280160" rtl="0" eaLnBrk="1" latinLnBrk="0" hangingPunct="1">
+              <a:lnSpc>
+                <a:spcPct val="90000"/>
+              </a:lnSpc>
+              <a:spcBef>
+                <a:spcPts val="700"/>
+              </a:spcBef>
+              <a:buFont typeface="Arial" panose="020B0604020202020204" pitchFamily="34" charset="0"/>
+              <a:buNone/>
+              <a:defRPr sz="1400" kern="1200">
+                <a:solidFill>
+                  <a:schemeClr val="tx1"/>
+                </a:solidFill>
+                <a:latin typeface="+mn-lt"/>
+                <a:ea typeface="+mn-ea"/>
+                <a:cs typeface="+mn-cs"/>
+              </a:defRPr>
+            </a:lvl3pPr>
+            <a:lvl4pPr marL="1920240" indent="0" algn="l" defTabSz="1280160" rtl="0" eaLnBrk="1" latinLnBrk="0" hangingPunct="1">
+              <a:lnSpc>
+                <a:spcPct val="90000"/>
+              </a:lnSpc>
+              <a:spcBef>
+                <a:spcPts val="700"/>
+              </a:spcBef>
+              <a:buFont typeface="Arial" panose="020B0604020202020204" pitchFamily="34" charset="0"/>
+              <a:buNone/>
+              <a:defRPr sz="1400" kern="1200">
+                <a:solidFill>
+                  <a:schemeClr val="tx1"/>
+                </a:solidFill>
+                <a:latin typeface="+mn-lt"/>
+                <a:ea typeface="+mn-ea"/>
+                <a:cs typeface="+mn-cs"/>
+              </a:defRPr>
+            </a:lvl4pPr>
+            <a:lvl5pPr marL="2560320" indent="0" algn="l" defTabSz="1280160" rtl="0" eaLnBrk="1" latinLnBrk="0" hangingPunct="1">
+              <a:lnSpc>
+                <a:spcPct val="90000"/>
+              </a:lnSpc>
+              <a:spcBef>
+                <a:spcPts val="700"/>
+              </a:spcBef>
+              <a:buFont typeface="Arial" panose="020B0604020202020204" pitchFamily="34" charset="0"/>
+              <a:buNone/>
+              <a:defRPr sz="1400" kern="1200">
+                <a:solidFill>
+                  <a:schemeClr val="tx1"/>
+                </a:solidFill>
+                <a:latin typeface="+mn-lt"/>
+                <a:ea typeface="+mn-ea"/>
+                <a:cs typeface="+mn-cs"/>
+              </a:defRPr>
+            </a:lvl5pPr>
+            <a:lvl6pPr marL="3520440" indent="-320040" algn="l" defTabSz="1280160" rtl="0" eaLnBrk="1" latinLnBrk="0" hangingPunct="1">
+              <a:lnSpc>
+                <a:spcPct val="90000"/>
+              </a:lnSpc>
+              <a:spcBef>
+                <a:spcPts val="700"/>
+              </a:spcBef>
+              <a:buFont typeface="Arial" panose="020B0604020202020204" pitchFamily="34" charset="0"/>
+              <a:buChar char="•"/>
+              <a:defRPr sz="2520" kern="1200">
+                <a:solidFill>
+                  <a:schemeClr val="tx1"/>
+                </a:solidFill>
+                <a:latin typeface="+mn-lt"/>
+                <a:ea typeface="+mn-ea"/>
+                <a:cs typeface="+mn-cs"/>
+              </a:defRPr>
+            </a:lvl6pPr>
+            <a:lvl7pPr marL="4160520" indent="-320040" algn="l" defTabSz="1280160" rtl="0" eaLnBrk="1" latinLnBrk="0" hangingPunct="1">
+              <a:lnSpc>
+                <a:spcPct val="90000"/>
+              </a:lnSpc>
+              <a:spcBef>
+                <a:spcPts val="700"/>
+              </a:spcBef>
+              <a:buFont typeface="Arial" panose="020B0604020202020204" pitchFamily="34" charset="0"/>
+              <a:buChar char="•"/>
+              <a:defRPr sz="2520" kern="1200">
+                <a:solidFill>
+                  <a:schemeClr val="tx1"/>
+                </a:solidFill>
+                <a:latin typeface="+mn-lt"/>
+                <a:ea typeface="+mn-ea"/>
+                <a:cs typeface="+mn-cs"/>
+              </a:defRPr>
+            </a:lvl7pPr>
+            <a:lvl8pPr marL="4800600" indent="-320040" algn="l" defTabSz="1280160" rtl="0" eaLnBrk="1" latinLnBrk="0" hangingPunct="1">
+              <a:lnSpc>
+                <a:spcPct val="90000"/>
+              </a:lnSpc>
+              <a:spcBef>
+                <a:spcPts val="700"/>
+              </a:spcBef>
+              <a:buFont typeface="Arial" panose="020B0604020202020204" pitchFamily="34" charset="0"/>
+              <a:buChar char="•"/>
+              <a:defRPr sz="2520" kern="1200">
+                <a:solidFill>
+                  <a:schemeClr val="tx1"/>
+                </a:solidFill>
+                <a:latin typeface="+mn-lt"/>
+                <a:ea typeface="+mn-ea"/>
+                <a:cs typeface="+mn-cs"/>
+              </a:defRPr>
+            </a:lvl8pPr>
+            <a:lvl9pPr marL="5440680" indent="-320040" algn="l" defTabSz="1280160" rtl="0" eaLnBrk="1" latinLnBrk="0" hangingPunct="1">
+              <a:lnSpc>
+                <a:spcPct val="90000"/>
+              </a:lnSpc>
+              <a:spcBef>
+                <a:spcPts val="700"/>
+              </a:spcBef>
+              <a:buFont typeface="Arial" panose="020B0604020202020204" pitchFamily="34" charset="0"/>
+              <a:buChar char="•"/>
+              <a:defRPr sz="2520" kern="1200">
+                <a:solidFill>
+                  <a:schemeClr val="tx1"/>
+                </a:solidFill>
+                <a:latin typeface="+mn-lt"/>
+                <a:ea typeface="+mn-ea"/>
+                <a:cs typeface="+mn-cs"/>
+              </a:defRPr>
+            </a:lvl9pPr>
+          </a:lstStyle>
+          <a:p>
+            <a:r>
+              <a:rPr lang="pt-BR" sz="1600" b="1" dirty="0">
+                <a:solidFill>
+                  <a:schemeClr val="accent1">
+                    <a:lumMod val="75000"/>
+                  </a:schemeClr>
+                </a:solidFill>
+                <a:latin typeface="Arial" panose="020B0604020202020204" pitchFamily="34" charset="0"/>
+                <a:cs typeface="Arial" panose="020B0604020202020204" pitchFamily="34" charset="0"/>
+              </a:rPr>
+              <a:t>Dashboard</a:t>
+            </a:r>
+          </a:p>
+          <a:p>
+            <a:r>
+              <a:rPr lang="pt-BR" sz="1200" dirty="0">
+                <a:solidFill>
+                  <a:schemeClr val="tx1"/>
+                </a:solidFill>
+                <a:latin typeface="Arial" panose="020B0604020202020204" pitchFamily="34" charset="0"/>
+                <a:cs typeface="Arial" panose="020B0604020202020204" pitchFamily="34" charset="0"/>
+              </a:rPr>
+              <a:t>KPIs e visualizações disponíveis no Tableu Public, alimentados pela base analítica do projeto.</a:t>
             </a:r>
           </a:p>
         </p:txBody>

</xml_diff>

<commit_message>
feat: ideia inicial do segundo slide
</commit_message>
<xml_diff>
--- a/docs/Template - Fase 2 - Apresentação Executiva - Projeto em Business Intelligence e Analytics.pptx
+++ b/docs/Template - Fase 2 - Apresentação Executiva - Projeto em Business Intelligence e Analytics.pptx
@@ -5,13 +5,14 @@
     <p:sldMasterId id="2147483665" r:id="rId4"/>
   </p:sldMasterIdLst>
   <p:handoutMasterIdLst>
-    <p:handoutMasterId r:id="rId9"/>
+    <p:handoutMasterId r:id="rId10"/>
   </p:handoutMasterIdLst>
   <p:sldIdLst>
     <p:sldId id="288" r:id="rId5"/>
     <p:sldId id="303" r:id="rId6"/>
     <p:sldId id="302" r:id="rId7"/>
-    <p:sldId id="300" r:id="rId8"/>
+    <p:sldId id="304" r:id="rId8"/>
+    <p:sldId id="300" r:id="rId9"/>
   </p:sldIdLst>
   <p:sldSz cx="16402050" cy="9601200"/>
   <p:notesSz cx="6858000" cy="9144000"/>
@@ -118,6 +119,7 @@
             <p14:sldId id="288"/>
             <p14:sldId id="303"/>
             <p14:sldId id="302"/>
+            <p14:sldId id="304"/>
             <p14:sldId id="300"/>
           </p14:sldIdLst>
         </p14:section>
@@ -3420,7 +3422,7 @@
         </p:nvSpPr>
         <p:spPr>
           <a:xfrm>
-            <a:off x="928688" y="1858736"/>
+            <a:off x="928688" y="2041451"/>
             <a:ext cx="14544674" cy="928007"/>
           </a:xfrm>
           <a:prstGeom prst="rect">
@@ -3652,7 +3654,7 @@
         </p:nvSpPr>
         <p:spPr>
           <a:xfrm>
-            <a:off x="928688" y="2916728"/>
+            <a:off x="928688" y="3099443"/>
             <a:ext cx="14544674" cy="625401"/>
           </a:xfrm>
           <a:prstGeom prst="rect">
@@ -4549,6 +4551,1262 @@
 </file>
 
 <file path=ppt/slides/slide4.xml><?xml version="1.0" encoding="utf-8"?>
+<p:sld xmlns:a="http://schemas.openxmlformats.org/drawingml/2006/main" xmlns:r="http://schemas.openxmlformats.org/officeDocument/2006/relationships" xmlns:p="http://schemas.openxmlformats.org/presentationml/2006/main">
+  <p:cSld>
+    <p:spTree>
+      <p:nvGrpSpPr>
+        <p:cNvPr id="1" name="">
+          <a:extLst>
+            <a:ext uri="{FF2B5EF4-FFF2-40B4-BE49-F238E27FC236}">
+              <a16:creationId xmlns:a16="http://schemas.microsoft.com/office/drawing/2014/main" id="{EF6D453A-9751-19EC-9464-641604180AD1}"/>
+            </a:ext>
+          </a:extLst>
+        </p:cNvPr>
+        <p:cNvGrpSpPr/>
+        <p:nvPr/>
+      </p:nvGrpSpPr>
+      <p:grpSpPr>
+        <a:xfrm>
+          <a:off x="0" y="0"/>
+          <a:ext cx="0" cy="0"/>
+          <a:chOff x="0" y="0"/>
+          <a:chExt cx="0" cy="0"/>
+        </a:xfrm>
+      </p:grpSpPr>
+      <p:sp>
+        <p:nvSpPr>
+          <p:cNvPr id="2" name="Espaço Reservado para Texto 1">
+            <a:extLst>
+              <a:ext uri="{FF2B5EF4-FFF2-40B4-BE49-F238E27FC236}">
+                <a16:creationId xmlns:a16="http://schemas.microsoft.com/office/drawing/2014/main" id="{18F062C9-E3AD-D14A-1BEB-4D891D061DFE}"/>
+              </a:ext>
+            </a:extLst>
+          </p:cNvPr>
+          <p:cNvSpPr>
+            <a:spLocks noGrp="1"/>
+          </p:cNvSpPr>
+          <p:nvPr>
+            <p:ph type="body" sz="quarter" idx="10"/>
+          </p:nvPr>
+        </p:nvSpPr>
+        <p:spPr>
+          <a:xfrm>
+            <a:off x="928689" y="1416050"/>
+            <a:ext cx="14544674" cy="625401"/>
+          </a:xfrm>
+        </p:spPr>
+        <p:txBody>
+          <a:bodyPr/>
+          <a:lstStyle/>
+          <a:p>
+            <a:r>
+              <a:rPr lang="pt-BR" sz="3000" b="1" dirty="0">
+                <a:solidFill>
+                  <a:schemeClr val="accent1">
+                    <a:lumMod val="75000"/>
+                  </a:schemeClr>
+                </a:solidFill>
+                <a:latin typeface="Arial" panose="020B0604020202020204" pitchFamily="34" charset="0"/>
+                <a:cs typeface="Arial" panose="020B0604020202020204" pitchFamily="34" charset="0"/>
+              </a:rPr>
+              <a:t>Arquitetura da Solução</a:t>
+            </a:r>
+          </a:p>
+        </p:txBody>
+      </p:sp>
+      <p:sp>
+        <p:nvSpPr>
+          <p:cNvPr id="3" name="Espaço Reservado para Texto 1">
+            <a:extLst>
+              <a:ext uri="{FF2B5EF4-FFF2-40B4-BE49-F238E27FC236}">
+                <a16:creationId xmlns:a16="http://schemas.microsoft.com/office/drawing/2014/main" id="{0C80FD07-592A-FC9C-6497-B84BC4628C24}"/>
+              </a:ext>
+            </a:extLst>
+          </p:cNvPr>
+          <p:cNvSpPr txBox="1">
+            <a:spLocks/>
+          </p:cNvSpPr>
+          <p:nvPr/>
+        </p:nvSpPr>
+        <p:spPr>
+          <a:xfrm>
+            <a:off x="928688" y="2041451"/>
+            <a:ext cx="14544674" cy="1703614"/>
+          </a:xfrm>
+          <a:prstGeom prst="rect">
+            <a:avLst/>
+          </a:prstGeom>
+          <a:noFill/>
+        </p:spPr>
+        <p:txBody>
+          <a:bodyPr lIns="72000" tIns="72000" rIns="72000" bIns="72000"/>
+          <a:lstStyle>
+            <a:lvl1pPr marL="0" indent="0" algn="l" defTabSz="1280160" rtl="0" eaLnBrk="1" latinLnBrk="0" hangingPunct="1">
+              <a:lnSpc>
+                <a:spcPct val="100000"/>
+              </a:lnSpc>
+              <a:spcBef>
+                <a:spcPts val="0"/>
+              </a:spcBef>
+              <a:spcAft>
+                <a:spcPts val="1200"/>
+              </a:spcAft>
+              <a:buFont typeface="Arial" panose="020B0604020202020204" pitchFamily="34" charset="0"/>
+              <a:buNone/>
+              <a:defRPr sz="1800" kern="1200">
+                <a:solidFill>
+                  <a:schemeClr val="tx2">
+                    <a:lumMod val="75000"/>
+                  </a:schemeClr>
+                </a:solidFill>
+                <a:latin typeface="+mn-lt"/>
+                <a:ea typeface="+mn-ea"/>
+                <a:cs typeface="+mn-cs"/>
+              </a:defRPr>
+            </a:lvl1pPr>
+            <a:lvl2pPr marL="640080" indent="0" algn="l" defTabSz="1280160" rtl="0" eaLnBrk="1" latinLnBrk="0" hangingPunct="1">
+              <a:lnSpc>
+                <a:spcPct val="90000"/>
+              </a:lnSpc>
+              <a:spcBef>
+                <a:spcPts val="700"/>
+              </a:spcBef>
+              <a:buFont typeface="Arial" panose="020B0604020202020204" pitchFamily="34" charset="0"/>
+              <a:buNone/>
+              <a:defRPr sz="1400" kern="1200">
+                <a:solidFill>
+                  <a:schemeClr val="tx1"/>
+                </a:solidFill>
+                <a:latin typeface="+mn-lt"/>
+                <a:ea typeface="+mn-ea"/>
+                <a:cs typeface="+mn-cs"/>
+              </a:defRPr>
+            </a:lvl2pPr>
+            <a:lvl3pPr marL="1280160" indent="0" algn="l" defTabSz="1280160" rtl="0" eaLnBrk="1" latinLnBrk="0" hangingPunct="1">
+              <a:lnSpc>
+                <a:spcPct val="90000"/>
+              </a:lnSpc>
+              <a:spcBef>
+                <a:spcPts val="700"/>
+              </a:spcBef>
+              <a:buFont typeface="Arial" panose="020B0604020202020204" pitchFamily="34" charset="0"/>
+              <a:buNone/>
+              <a:defRPr sz="1400" kern="1200">
+                <a:solidFill>
+                  <a:schemeClr val="tx1"/>
+                </a:solidFill>
+                <a:latin typeface="+mn-lt"/>
+                <a:ea typeface="+mn-ea"/>
+                <a:cs typeface="+mn-cs"/>
+              </a:defRPr>
+            </a:lvl3pPr>
+            <a:lvl4pPr marL="1920240" indent="0" algn="l" defTabSz="1280160" rtl="0" eaLnBrk="1" latinLnBrk="0" hangingPunct="1">
+              <a:lnSpc>
+                <a:spcPct val="90000"/>
+              </a:lnSpc>
+              <a:spcBef>
+                <a:spcPts val="700"/>
+              </a:spcBef>
+              <a:buFont typeface="Arial" panose="020B0604020202020204" pitchFamily="34" charset="0"/>
+              <a:buNone/>
+              <a:defRPr sz="1400" kern="1200">
+                <a:solidFill>
+                  <a:schemeClr val="tx1"/>
+                </a:solidFill>
+                <a:latin typeface="+mn-lt"/>
+                <a:ea typeface="+mn-ea"/>
+                <a:cs typeface="+mn-cs"/>
+              </a:defRPr>
+            </a:lvl4pPr>
+            <a:lvl5pPr marL="2560320" indent="0" algn="l" defTabSz="1280160" rtl="0" eaLnBrk="1" latinLnBrk="0" hangingPunct="1">
+              <a:lnSpc>
+                <a:spcPct val="90000"/>
+              </a:lnSpc>
+              <a:spcBef>
+                <a:spcPts val="700"/>
+              </a:spcBef>
+              <a:buFont typeface="Arial" panose="020B0604020202020204" pitchFamily="34" charset="0"/>
+              <a:buNone/>
+              <a:defRPr sz="1400" kern="1200">
+                <a:solidFill>
+                  <a:schemeClr val="tx1"/>
+                </a:solidFill>
+                <a:latin typeface="+mn-lt"/>
+                <a:ea typeface="+mn-ea"/>
+                <a:cs typeface="+mn-cs"/>
+              </a:defRPr>
+            </a:lvl5pPr>
+            <a:lvl6pPr marL="3520440" indent="-320040" algn="l" defTabSz="1280160" rtl="0" eaLnBrk="1" latinLnBrk="0" hangingPunct="1">
+              <a:lnSpc>
+                <a:spcPct val="90000"/>
+              </a:lnSpc>
+              <a:spcBef>
+                <a:spcPts val="700"/>
+              </a:spcBef>
+              <a:buFont typeface="Arial" panose="020B0604020202020204" pitchFamily="34" charset="0"/>
+              <a:buChar char="•"/>
+              <a:defRPr sz="2520" kern="1200">
+                <a:solidFill>
+                  <a:schemeClr val="tx1"/>
+                </a:solidFill>
+                <a:latin typeface="+mn-lt"/>
+                <a:ea typeface="+mn-ea"/>
+                <a:cs typeface="+mn-cs"/>
+              </a:defRPr>
+            </a:lvl6pPr>
+            <a:lvl7pPr marL="4160520" indent="-320040" algn="l" defTabSz="1280160" rtl="0" eaLnBrk="1" latinLnBrk="0" hangingPunct="1">
+              <a:lnSpc>
+                <a:spcPct val="90000"/>
+              </a:lnSpc>
+              <a:spcBef>
+                <a:spcPts val="700"/>
+              </a:spcBef>
+              <a:buFont typeface="Arial" panose="020B0604020202020204" pitchFamily="34" charset="0"/>
+              <a:buChar char="•"/>
+              <a:defRPr sz="2520" kern="1200">
+                <a:solidFill>
+                  <a:schemeClr val="tx1"/>
+                </a:solidFill>
+                <a:latin typeface="+mn-lt"/>
+                <a:ea typeface="+mn-ea"/>
+                <a:cs typeface="+mn-cs"/>
+              </a:defRPr>
+            </a:lvl7pPr>
+            <a:lvl8pPr marL="4800600" indent="-320040" algn="l" defTabSz="1280160" rtl="0" eaLnBrk="1" latinLnBrk="0" hangingPunct="1">
+              <a:lnSpc>
+                <a:spcPct val="90000"/>
+              </a:lnSpc>
+              <a:spcBef>
+                <a:spcPts val="700"/>
+              </a:spcBef>
+              <a:buFont typeface="Arial" panose="020B0604020202020204" pitchFamily="34" charset="0"/>
+              <a:buChar char="•"/>
+              <a:defRPr sz="2520" kern="1200">
+                <a:solidFill>
+                  <a:schemeClr val="tx1"/>
+                </a:solidFill>
+                <a:latin typeface="+mn-lt"/>
+                <a:ea typeface="+mn-ea"/>
+                <a:cs typeface="+mn-cs"/>
+              </a:defRPr>
+            </a:lvl8pPr>
+            <a:lvl9pPr marL="5440680" indent="-320040" algn="l" defTabSz="1280160" rtl="0" eaLnBrk="1" latinLnBrk="0" hangingPunct="1">
+              <a:lnSpc>
+                <a:spcPct val="90000"/>
+              </a:lnSpc>
+              <a:spcBef>
+                <a:spcPts val="700"/>
+              </a:spcBef>
+              <a:buFont typeface="Arial" panose="020B0604020202020204" pitchFamily="34" charset="0"/>
+              <a:buChar char="•"/>
+              <a:defRPr sz="2520" kern="1200">
+                <a:solidFill>
+                  <a:schemeClr val="tx1"/>
+                </a:solidFill>
+                <a:latin typeface="+mn-lt"/>
+                <a:ea typeface="+mn-ea"/>
+                <a:cs typeface="+mn-cs"/>
+              </a:defRPr>
+            </a:lvl9pPr>
+          </a:lstStyle>
+          <a:p>
+            <a:r>
+              <a:rPr lang="pt-BR" sz="1600" b="1" dirty="0">
+                <a:solidFill>
+                  <a:schemeClr val="accent1">
+                    <a:lumMod val="75000"/>
+                  </a:schemeClr>
+                </a:solidFill>
+                <a:latin typeface="Arial" panose="020B0604020202020204" pitchFamily="34" charset="0"/>
+                <a:cs typeface="Arial" panose="020B0604020202020204" pitchFamily="34" charset="0"/>
+              </a:rPr>
+              <a:t>Ferramentas utilizadas</a:t>
+            </a:r>
+          </a:p>
+          <a:p>
+            <a:r>
+              <a:rPr lang="pt-BR" sz="1200" dirty="0">
+                <a:solidFill>
+                  <a:schemeClr val="tx1"/>
+                </a:solidFill>
+                <a:latin typeface="Arial" panose="020B0604020202020204" pitchFamily="34" charset="0"/>
+                <a:cs typeface="Arial" panose="020B0604020202020204" pitchFamily="34" charset="0"/>
+              </a:rPr>
+              <a:t> - Python</a:t>
+            </a:r>
+          </a:p>
+          <a:p>
+            <a:pPr marL="171450" indent="-171450">
+              <a:buFontTx/>
+              <a:buChar char="-"/>
+            </a:pPr>
+            <a:r>
+              <a:rPr lang="pt-BR" sz="1200" dirty="0">
+                <a:solidFill>
+                  <a:schemeClr val="tx1"/>
+                </a:solidFill>
+                <a:latin typeface="Arial" panose="020B0604020202020204" pitchFamily="34" charset="0"/>
+                <a:cs typeface="Arial" panose="020B0604020202020204" pitchFamily="34" charset="0"/>
+              </a:rPr>
+              <a:t>Jupyter notebook</a:t>
+            </a:r>
+          </a:p>
+          <a:p>
+            <a:pPr marL="171450" indent="-171450">
+              <a:buFontTx/>
+              <a:buChar char="-"/>
+            </a:pPr>
+            <a:r>
+              <a:rPr lang="pt-BR" sz="1200" dirty="0">
+                <a:solidFill>
+                  <a:schemeClr val="tx1"/>
+                </a:solidFill>
+                <a:latin typeface="Arial" panose="020B0604020202020204" pitchFamily="34" charset="0"/>
+                <a:cs typeface="Arial" panose="020B0604020202020204" pitchFamily="34" charset="0"/>
+              </a:rPr>
+              <a:t>Tableau Public</a:t>
+            </a:r>
+          </a:p>
+          <a:p>
+            <a:pPr marL="171450" indent="-171450">
+              <a:buFontTx/>
+              <a:buChar char="-"/>
+            </a:pPr>
+            <a:r>
+              <a:rPr lang="pt-BR" sz="1200" dirty="0">
+                <a:solidFill>
+                  <a:schemeClr val="tx1"/>
+                </a:solidFill>
+                <a:latin typeface="Arial" panose="020B0604020202020204" pitchFamily="34" charset="0"/>
+                <a:cs typeface="Arial" panose="020B0604020202020204" pitchFamily="34" charset="0"/>
+              </a:rPr>
+              <a:t> Git/Github</a:t>
+            </a:r>
+          </a:p>
+          <a:p>
+            <a:endParaRPr lang="pt-BR" sz="3000" dirty="0">
+              <a:solidFill>
+                <a:schemeClr val="tx1"/>
+              </a:solidFill>
+              <a:latin typeface="Arial" panose="020B0604020202020204" pitchFamily="34" charset="0"/>
+              <a:cs typeface="Arial" panose="020B0604020202020204" pitchFamily="34" charset="0"/>
+            </a:endParaRPr>
+          </a:p>
+        </p:txBody>
+      </p:sp>
+      <p:sp>
+        <p:nvSpPr>
+          <p:cNvPr id="4" name="Espaço Reservado para Texto 1">
+            <a:extLst>
+              <a:ext uri="{FF2B5EF4-FFF2-40B4-BE49-F238E27FC236}">
+                <a16:creationId xmlns:a16="http://schemas.microsoft.com/office/drawing/2014/main" id="{2034A440-FCF4-6B33-6585-66297D8FA9F0}"/>
+              </a:ext>
+            </a:extLst>
+          </p:cNvPr>
+          <p:cNvSpPr txBox="1">
+            <a:spLocks/>
+          </p:cNvSpPr>
+          <p:nvPr/>
+        </p:nvSpPr>
+        <p:spPr>
+          <a:xfrm>
+            <a:off x="928688" y="3799757"/>
+            <a:ext cx="14544674" cy="625401"/>
+          </a:xfrm>
+          <a:prstGeom prst="rect">
+            <a:avLst/>
+          </a:prstGeom>
+          <a:noFill/>
+        </p:spPr>
+        <p:txBody>
+          <a:bodyPr lIns="72000" tIns="72000" rIns="72000" bIns="72000"/>
+          <a:lstStyle>
+            <a:lvl1pPr marL="0" indent="0" algn="l" defTabSz="1280160" rtl="0" eaLnBrk="1" latinLnBrk="0" hangingPunct="1">
+              <a:lnSpc>
+                <a:spcPct val="100000"/>
+              </a:lnSpc>
+              <a:spcBef>
+                <a:spcPts val="0"/>
+              </a:spcBef>
+              <a:spcAft>
+                <a:spcPts val="1200"/>
+              </a:spcAft>
+              <a:buFont typeface="Arial" panose="020B0604020202020204" pitchFamily="34" charset="0"/>
+              <a:buNone/>
+              <a:defRPr sz="1800" kern="1200">
+                <a:solidFill>
+                  <a:schemeClr val="tx2">
+                    <a:lumMod val="75000"/>
+                  </a:schemeClr>
+                </a:solidFill>
+                <a:latin typeface="+mn-lt"/>
+                <a:ea typeface="+mn-ea"/>
+                <a:cs typeface="+mn-cs"/>
+              </a:defRPr>
+            </a:lvl1pPr>
+            <a:lvl2pPr marL="640080" indent="0" algn="l" defTabSz="1280160" rtl="0" eaLnBrk="1" latinLnBrk="0" hangingPunct="1">
+              <a:lnSpc>
+                <a:spcPct val="90000"/>
+              </a:lnSpc>
+              <a:spcBef>
+                <a:spcPts val="700"/>
+              </a:spcBef>
+              <a:buFont typeface="Arial" panose="020B0604020202020204" pitchFamily="34" charset="0"/>
+              <a:buNone/>
+              <a:defRPr sz="1400" kern="1200">
+                <a:solidFill>
+                  <a:schemeClr val="tx1"/>
+                </a:solidFill>
+                <a:latin typeface="+mn-lt"/>
+                <a:ea typeface="+mn-ea"/>
+                <a:cs typeface="+mn-cs"/>
+              </a:defRPr>
+            </a:lvl2pPr>
+            <a:lvl3pPr marL="1280160" indent="0" algn="l" defTabSz="1280160" rtl="0" eaLnBrk="1" latinLnBrk="0" hangingPunct="1">
+              <a:lnSpc>
+                <a:spcPct val="90000"/>
+              </a:lnSpc>
+              <a:spcBef>
+                <a:spcPts val="700"/>
+              </a:spcBef>
+              <a:buFont typeface="Arial" panose="020B0604020202020204" pitchFamily="34" charset="0"/>
+              <a:buNone/>
+              <a:defRPr sz="1400" kern="1200">
+                <a:solidFill>
+                  <a:schemeClr val="tx1"/>
+                </a:solidFill>
+                <a:latin typeface="+mn-lt"/>
+                <a:ea typeface="+mn-ea"/>
+                <a:cs typeface="+mn-cs"/>
+              </a:defRPr>
+            </a:lvl3pPr>
+            <a:lvl4pPr marL="1920240" indent="0" algn="l" defTabSz="1280160" rtl="0" eaLnBrk="1" latinLnBrk="0" hangingPunct="1">
+              <a:lnSpc>
+                <a:spcPct val="90000"/>
+              </a:lnSpc>
+              <a:spcBef>
+                <a:spcPts val="700"/>
+              </a:spcBef>
+              <a:buFont typeface="Arial" panose="020B0604020202020204" pitchFamily="34" charset="0"/>
+              <a:buNone/>
+              <a:defRPr sz="1400" kern="1200">
+                <a:solidFill>
+                  <a:schemeClr val="tx1"/>
+                </a:solidFill>
+                <a:latin typeface="+mn-lt"/>
+                <a:ea typeface="+mn-ea"/>
+                <a:cs typeface="+mn-cs"/>
+              </a:defRPr>
+            </a:lvl4pPr>
+            <a:lvl5pPr marL="2560320" indent="0" algn="l" defTabSz="1280160" rtl="0" eaLnBrk="1" latinLnBrk="0" hangingPunct="1">
+              <a:lnSpc>
+                <a:spcPct val="90000"/>
+              </a:lnSpc>
+              <a:spcBef>
+                <a:spcPts val="700"/>
+              </a:spcBef>
+              <a:buFont typeface="Arial" panose="020B0604020202020204" pitchFamily="34" charset="0"/>
+              <a:buNone/>
+              <a:defRPr sz="1400" kern="1200">
+                <a:solidFill>
+                  <a:schemeClr val="tx1"/>
+                </a:solidFill>
+                <a:latin typeface="+mn-lt"/>
+                <a:ea typeface="+mn-ea"/>
+                <a:cs typeface="+mn-cs"/>
+              </a:defRPr>
+            </a:lvl5pPr>
+            <a:lvl6pPr marL="3520440" indent="-320040" algn="l" defTabSz="1280160" rtl="0" eaLnBrk="1" latinLnBrk="0" hangingPunct="1">
+              <a:lnSpc>
+                <a:spcPct val="90000"/>
+              </a:lnSpc>
+              <a:spcBef>
+                <a:spcPts val="700"/>
+              </a:spcBef>
+              <a:buFont typeface="Arial" panose="020B0604020202020204" pitchFamily="34" charset="0"/>
+              <a:buChar char="•"/>
+              <a:defRPr sz="2520" kern="1200">
+                <a:solidFill>
+                  <a:schemeClr val="tx1"/>
+                </a:solidFill>
+                <a:latin typeface="+mn-lt"/>
+                <a:ea typeface="+mn-ea"/>
+                <a:cs typeface="+mn-cs"/>
+              </a:defRPr>
+            </a:lvl6pPr>
+            <a:lvl7pPr marL="4160520" indent="-320040" algn="l" defTabSz="1280160" rtl="0" eaLnBrk="1" latinLnBrk="0" hangingPunct="1">
+              <a:lnSpc>
+                <a:spcPct val="90000"/>
+              </a:lnSpc>
+              <a:spcBef>
+                <a:spcPts val="700"/>
+              </a:spcBef>
+              <a:buFont typeface="Arial" panose="020B0604020202020204" pitchFamily="34" charset="0"/>
+              <a:buChar char="•"/>
+              <a:defRPr sz="2520" kern="1200">
+                <a:solidFill>
+                  <a:schemeClr val="tx1"/>
+                </a:solidFill>
+                <a:latin typeface="+mn-lt"/>
+                <a:ea typeface="+mn-ea"/>
+                <a:cs typeface="+mn-cs"/>
+              </a:defRPr>
+            </a:lvl7pPr>
+            <a:lvl8pPr marL="4800600" indent="-320040" algn="l" defTabSz="1280160" rtl="0" eaLnBrk="1" latinLnBrk="0" hangingPunct="1">
+              <a:lnSpc>
+                <a:spcPct val="90000"/>
+              </a:lnSpc>
+              <a:spcBef>
+                <a:spcPts val="700"/>
+              </a:spcBef>
+              <a:buFont typeface="Arial" panose="020B0604020202020204" pitchFamily="34" charset="0"/>
+              <a:buChar char="•"/>
+              <a:defRPr sz="2520" kern="1200">
+                <a:solidFill>
+                  <a:schemeClr val="tx1"/>
+                </a:solidFill>
+                <a:latin typeface="+mn-lt"/>
+                <a:ea typeface="+mn-ea"/>
+                <a:cs typeface="+mn-cs"/>
+              </a:defRPr>
+            </a:lvl8pPr>
+            <a:lvl9pPr marL="5440680" indent="-320040" algn="l" defTabSz="1280160" rtl="0" eaLnBrk="1" latinLnBrk="0" hangingPunct="1">
+              <a:lnSpc>
+                <a:spcPct val="90000"/>
+              </a:lnSpc>
+              <a:spcBef>
+                <a:spcPts val="700"/>
+              </a:spcBef>
+              <a:buFont typeface="Arial" panose="020B0604020202020204" pitchFamily="34" charset="0"/>
+              <a:buChar char="•"/>
+              <a:defRPr sz="2520" kern="1200">
+                <a:solidFill>
+                  <a:schemeClr val="tx1"/>
+                </a:solidFill>
+                <a:latin typeface="+mn-lt"/>
+                <a:ea typeface="+mn-ea"/>
+                <a:cs typeface="+mn-cs"/>
+              </a:defRPr>
+            </a:lvl9pPr>
+          </a:lstStyle>
+          <a:p>
+            <a:r>
+              <a:rPr lang="pt-BR" sz="1600" b="1" dirty="0">
+                <a:solidFill>
+                  <a:schemeClr val="accent1">
+                    <a:lumMod val="75000"/>
+                  </a:schemeClr>
+                </a:solidFill>
+                <a:latin typeface="Arial" panose="020B0604020202020204" pitchFamily="34" charset="0"/>
+                <a:cs typeface="Arial" panose="020B0604020202020204" pitchFamily="34" charset="0"/>
+              </a:rPr>
+              <a:t>Objetivo geral</a:t>
+            </a:r>
+            <a:endParaRPr lang="pt-BR" sz="1600" b="1" dirty="0">
+              <a:solidFill>
+                <a:schemeClr val="tx1"/>
+              </a:solidFill>
+              <a:latin typeface="Arial" panose="020B0604020202020204" pitchFamily="34" charset="0"/>
+              <a:cs typeface="Arial" panose="020B0604020202020204" pitchFamily="34" charset="0"/>
+            </a:endParaRPr>
+          </a:p>
+          <a:p>
+            <a:r>
+              <a:rPr lang="pt-BR" sz="1200" dirty="0">
+                <a:solidFill>
+                  <a:schemeClr val="tx1"/>
+                </a:solidFill>
+                <a:latin typeface="Arial" panose="020B0604020202020204" pitchFamily="34" charset="0"/>
+                <a:cs typeface="Arial" panose="020B0604020202020204" pitchFamily="34" charset="0"/>
+              </a:rPr>
+              <a:t>Transformar dados de desempenho clube-temporada em um indicador preditivo de risco de rebaixamento, apresentado por meio de uma solução de BI e Analytics.</a:t>
+            </a:r>
+          </a:p>
+        </p:txBody>
+      </p:sp>
+      <p:sp>
+        <p:nvSpPr>
+          <p:cNvPr id="6" name="Espaço Reservado para Texto 1">
+            <a:extLst>
+              <a:ext uri="{FF2B5EF4-FFF2-40B4-BE49-F238E27FC236}">
+                <a16:creationId xmlns:a16="http://schemas.microsoft.com/office/drawing/2014/main" id="{739AE78C-57B9-A849-E87A-6F48116B96F1}"/>
+              </a:ext>
+            </a:extLst>
+          </p:cNvPr>
+          <p:cNvSpPr txBox="1">
+            <a:spLocks/>
+          </p:cNvSpPr>
+          <p:nvPr/>
+        </p:nvSpPr>
+        <p:spPr>
+          <a:xfrm>
+            <a:off x="928688" y="4857750"/>
+            <a:ext cx="4386262" cy="3384550"/>
+          </a:xfrm>
+          <a:prstGeom prst="rect">
+            <a:avLst/>
+          </a:prstGeom>
+          <a:noFill/>
+        </p:spPr>
+        <p:txBody>
+          <a:bodyPr lIns="72000" tIns="72000" rIns="72000" bIns="72000"/>
+          <a:lstStyle>
+            <a:lvl1pPr marL="0" indent="0" algn="l" defTabSz="1280160" rtl="0" eaLnBrk="1" latinLnBrk="0" hangingPunct="1">
+              <a:lnSpc>
+                <a:spcPct val="100000"/>
+              </a:lnSpc>
+              <a:spcBef>
+                <a:spcPts val="0"/>
+              </a:spcBef>
+              <a:spcAft>
+                <a:spcPts val="1200"/>
+              </a:spcAft>
+              <a:buFont typeface="Arial" panose="020B0604020202020204" pitchFamily="34" charset="0"/>
+              <a:buNone/>
+              <a:defRPr sz="1800" kern="1200">
+                <a:solidFill>
+                  <a:schemeClr val="tx2">
+                    <a:lumMod val="75000"/>
+                  </a:schemeClr>
+                </a:solidFill>
+                <a:latin typeface="+mn-lt"/>
+                <a:ea typeface="+mn-ea"/>
+                <a:cs typeface="+mn-cs"/>
+              </a:defRPr>
+            </a:lvl1pPr>
+            <a:lvl2pPr marL="640080" indent="0" algn="l" defTabSz="1280160" rtl="0" eaLnBrk="1" latinLnBrk="0" hangingPunct="1">
+              <a:lnSpc>
+                <a:spcPct val="90000"/>
+              </a:lnSpc>
+              <a:spcBef>
+                <a:spcPts val="700"/>
+              </a:spcBef>
+              <a:buFont typeface="Arial" panose="020B0604020202020204" pitchFamily="34" charset="0"/>
+              <a:buNone/>
+              <a:defRPr sz="1400" kern="1200">
+                <a:solidFill>
+                  <a:schemeClr val="tx1"/>
+                </a:solidFill>
+                <a:latin typeface="+mn-lt"/>
+                <a:ea typeface="+mn-ea"/>
+                <a:cs typeface="+mn-cs"/>
+              </a:defRPr>
+            </a:lvl2pPr>
+            <a:lvl3pPr marL="1280160" indent="0" algn="l" defTabSz="1280160" rtl="0" eaLnBrk="1" latinLnBrk="0" hangingPunct="1">
+              <a:lnSpc>
+                <a:spcPct val="90000"/>
+              </a:lnSpc>
+              <a:spcBef>
+                <a:spcPts val="700"/>
+              </a:spcBef>
+              <a:buFont typeface="Arial" panose="020B0604020202020204" pitchFamily="34" charset="0"/>
+              <a:buNone/>
+              <a:defRPr sz="1400" kern="1200">
+                <a:solidFill>
+                  <a:schemeClr val="tx1"/>
+                </a:solidFill>
+                <a:latin typeface="+mn-lt"/>
+                <a:ea typeface="+mn-ea"/>
+                <a:cs typeface="+mn-cs"/>
+              </a:defRPr>
+            </a:lvl3pPr>
+            <a:lvl4pPr marL="1920240" indent="0" algn="l" defTabSz="1280160" rtl="0" eaLnBrk="1" latinLnBrk="0" hangingPunct="1">
+              <a:lnSpc>
+                <a:spcPct val="90000"/>
+              </a:lnSpc>
+              <a:spcBef>
+                <a:spcPts val="700"/>
+              </a:spcBef>
+              <a:buFont typeface="Arial" panose="020B0604020202020204" pitchFamily="34" charset="0"/>
+              <a:buNone/>
+              <a:defRPr sz="1400" kern="1200">
+                <a:solidFill>
+                  <a:schemeClr val="tx1"/>
+                </a:solidFill>
+                <a:latin typeface="+mn-lt"/>
+                <a:ea typeface="+mn-ea"/>
+                <a:cs typeface="+mn-cs"/>
+              </a:defRPr>
+            </a:lvl4pPr>
+            <a:lvl5pPr marL="2560320" indent="0" algn="l" defTabSz="1280160" rtl="0" eaLnBrk="1" latinLnBrk="0" hangingPunct="1">
+              <a:lnSpc>
+                <a:spcPct val="90000"/>
+              </a:lnSpc>
+              <a:spcBef>
+                <a:spcPts val="700"/>
+              </a:spcBef>
+              <a:buFont typeface="Arial" panose="020B0604020202020204" pitchFamily="34" charset="0"/>
+              <a:buNone/>
+              <a:defRPr sz="1400" kern="1200">
+                <a:solidFill>
+                  <a:schemeClr val="tx1"/>
+                </a:solidFill>
+                <a:latin typeface="+mn-lt"/>
+                <a:ea typeface="+mn-ea"/>
+                <a:cs typeface="+mn-cs"/>
+              </a:defRPr>
+            </a:lvl5pPr>
+            <a:lvl6pPr marL="3520440" indent="-320040" algn="l" defTabSz="1280160" rtl="0" eaLnBrk="1" latinLnBrk="0" hangingPunct="1">
+              <a:lnSpc>
+                <a:spcPct val="90000"/>
+              </a:lnSpc>
+              <a:spcBef>
+                <a:spcPts val="700"/>
+              </a:spcBef>
+              <a:buFont typeface="Arial" panose="020B0604020202020204" pitchFamily="34" charset="0"/>
+              <a:buChar char="•"/>
+              <a:defRPr sz="2520" kern="1200">
+                <a:solidFill>
+                  <a:schemeClr val="tx1"/>
+                </a:solidFill>
+                <a:latin typeface="+mn-lt"/>
+                <a:ea typeface="+mn-ea"/>
+                <a:cs typeface="+mn-cs"/>
+              </a:defRPr>
+            </a:lvl6pPr>
+            <a:lvl7pPr marL="4160520" indent="-320040" algn="l" defTabSz="1280160" rtl="0" eaLnBrk="1" latinLnBrk="0" hangingPunct="1">
+              <a:lnSpc>
+                <a:spcPct val="90000"/>
+              </a:lnSpc>
+              <a:spcBef>
+                <a:spcPts val="700"/>
+              </a:spcBef>
+              <a:buFont typeface="Arial" panose="020B0604020202020204" pitchFamily="34" charset="0"/>
+              <a:buChar char="•"/>
+              <a:defRPr sz="2520" kern="1200">
+                <a:solidFill>
+                  <a:schemeClr val="tx1"/>
+                </a:solidFill>
+                <a:latin typeface="+mn-lt"/>
+                <a:ea typeface="+mn-ea"/>
+                <a:cs typeface="+mn-cs"/>
+              </a:defRPr>
+            </a:lvl7pPr>
+            <a:lvl8pPr marL="4800600" indent="-320040" algn="l" defTabSz="1280160" rtl="0" eaLnBrk="1" latinLnBrk="0" hangingPunct="1">
+              <a:lnSpc>
+                <a:spcPct val="90000"/>
+              </a:lnSpc>
+              <a:spcBef>
+                <a:spcPts val="700"/>
+              </a:spcBef>
+              <a:buFont typeface="Arial" panose="020B0604020202020204" pitchFamily="34" charset="0"/>
+              <a:buChar char="•"/>
+              <a:defRPr sz="2520" kern="1200">
+                <a:solidFill>
+                  <a:schemeClr val="tx1"/>
+                </a:solidFill>
+                <a:latin typeface="+mn-lt"/>
+                <a:ea typeface="+mn-ea"/>
+                <a:cs typeface="+mn-cs"/>
+              </a:defRPr>
+            </a:lvl8pPr>
+            <a:lvl9pPr marL="5440680" indent="-320040" algn="l" defTabSz="1280160" rtl="0" eaLnBrk="1" latinLnBrk="0" hangingPunct="1">
+              <a:lnSpc>
+                <a:spcPct val="90000"/>
+              </a:lnSpc>
+              <a:spcBef>
+                <a:spcPts val="700"/>
+              </a:spcBef>
+              <a:buFont typeface="Arial" panose="020B0604020202020204" pitchFamily="34" charset="0"/>
+              <a:buChar char="•"/>
+              <a:defRPr sz="2520" kern="1200">
+                <a:solidFill>
+                  <a:schemeClr val="tx1"/>
+                </a:solidFill>
+                <a:latin typeface="+mn-lt"/>
+                <a:ea typeface="+mn-ea"/>
+                <a:cs typeface="+mn-cs"/>
+              </a:defRPr>
+            </a:lvl9pPr>
+          </a:lstStyle>
+          <a:p>
+            <a:r>
+              <a:rPr lang="pt-BR" sz="1600" b="1" dirty="0">
+                <a:solidFill>
+                  <a:schemeClr val="accent1">
+                    <a:lumMod val="75000"/>
+                  </a:schemeClr>
+                </a:solidFill>
+                <a:latin typeface="Arial" panose="020B0604020202020204" pitchFamily="34" charset="0"/>
+                <a:cs typeface="Arial" panose="020B0604020202020204" pitchFamily="34" charset="0"/>
+              </a:rPr>
+              <a:t>Indicador de risco por clube</a:t>
+            </a:r>
+          </a:p>
+          <a:p>
+            <a:r>
+              <a:rPr lang="pt-BR" sz="1200" dirty="0">
+                <a:solidFill>
+                  <a:schemeClr val="tx1"/>
+                </a:solidFill>
+                <a:latin typeface="Arial" panose="020B0604020202020204" pitchFamily="34" charset="0"/>
+                <a:cs typeface="Arial" panose="020B0604020202020204" pitchFamily="34" charset="0"/>
+              </a:rPr>
+              <a:t>Probabilidade de rebaixamente calculada para cada um dos 20 clubes de Série A na temporada 2025</a:t>
+            </a:r>
+          </a:p>
+        </p:txBody>
+      </p:sp>
+      <p:sp>
+        <p:nvSpPr>
+          <p:cNvPr id="8" name="Espaço Reservado para Texto 1">
+            <a:extLst>
+              <a:ext uri="{FF2B5EF4-FFF2-40B4-BE49-F238E27FC236}">
+                <a16:creationId xmlns:a16="http://schemas.microsoft.com/office/drawing/2014/main" id="{61F207CE-E01C-6EED-159C-D03B17C8D0A6}"/>
+              </a:ext>
+            </a:extLst>
+          </p:cNvPr>
+          <p:cNvSpPr txBox="1">
+            <a:spLocks/>
+          </p:cNvSpPr>
+          <p:nvPr/>
+        </p:nvSpPr>
+        <p:spPr>
+          <a:xfrm>
+            <a:off x="6007894" y="4857750"/>
+            <a:ext cx="4386262" cy="3384550"/>
+          </a:xfrm>
+          <a:prstGeom prst="rect">
+            <a:avLst/>
+          </a:prstGeom>
+          <a:noFill/>
+        </p:spPr>
+        <p:txBody>
+          <a:bodyPr lIns="72000" tIns="72000" rIns="72000" bIns="72000"/>
+          <a:lstStyle>
+            <a:lvl1pPr marL="0" indent="0" algn="l" defTabSz="1280160" rtl="0" eaLnBrk="1" latinLnBrk="0" hangingPunct="1">
+              <a:lnSpc>
+                <a:spcPct val="100000"/>
+              </a:lnSpc>
+              <a:spcBef>
+                <a:spcPts val="0"/>
+              </a:spcBef>
+              <a:spcAft>
+                <a:spcPts val="1200"/>
+              </a:spcAft>
+              <a:buFont typeface="Arial" panose="020B0604020202020204" pitchFamily="34" charset="0"/>
+              <a:buNone/>
+              <a:defRPr sz="1800" kern="1200">
+                <a:solidFill>
+                  <a:schemeClr val="tx2">
+                    <a:lumMod val="75000"/>
+                  </a:schemeClr>
+                </a:solidFill>
+                <a:latin typeface="+mn-lt"/>
+                <a:ea typeface="+mn-ea"/>
+                <a:cs typeface="+mn-cs"/>
+              </a:defRPr>
+            </a:lvl1pPr>
+            <a:lvl2pPr marL="640080" indent="0" algn="l" defTabSz="1280160" rtl="0" eaLnBrk="1" latinLnBrk="0" hangingPunct="1">
+              <a:lnSpc>
+                <a:spcPct val="90000"/>
+              </a:lnSpc>
+              <a:spcBef>
+                <a:spcPts val="700"/>
+              </a:spcBef>
+              <a:buFont typeface="Arial" panose="020B0604020202020204" pitchFamily="34" charset="0"/>
+              <a:buNone/>
+              <a:defRPr sz="1400" kern="1200">
+                <a:solidFill>
+                  <a:schemeClr val="tx1"/>
+                </a:solidFill>
+                <a:latin typeface="+mn-lt"/>
+                <a:ea typeface="+mn-ea"/>
+                <a:cs typeface="+mn-cs"/>
+              </a:defRPr>
+            </a:lvl2pPr>
+            <a:lvl3pPr marL="1280160" indent="0" algn="l" defTabSz="1280160" rtl="0" eaLnBrk="1" latinLnBrk="0" hangingPunct="1">
+              <a:lnSpc>
+                <a:spcPct val="90000"/>
+              </a:lnSpc>
+              <a:spcBef>
+                <a:spcPts val="700"/>
+              </a:spcBef>
+              <a:buFont typeface="Arial" panose="020B0604020202020204" pitchFamily="34" charset="0"/>
+              <a:buNone/>
+              <a:defRPr sz="1400" kern="1200">
+                <a:solidFill>
+                  <a:schemeClr val="tx1"/>
+                </a:solidFill>
+                <a:latin typeface="+mn-lt"/>
+                <a:ea typeface="+mn-ea"/>
+                <a:cs typeface="+mn-cs"/>
+              </a:defRPr>
+            </a:lvl3pPr>
+            <a:lvl4pPr marL="1920240" indent="0" algn="l" defTabSz="1280160" rtl="0" eaLnBrk="1" latinLnBrk="0" hangingPunct="1">
+              <a:lnSpc>
+                <a:spcPct val="90000"/>
+              </a:lnSpc>
+              <a:spcBef>
+                <a:spcPts val="700"/>
+              </a:spcBef>
+              <a:buFont typeface="Arial" panose="020B0604020202020204" pitchFamily="34" charset="0"/>
+              <a:buNone/>
+              <a:defRPr sz="1400" kern="1200">
+                <a:solidFill>
+                  <a:schemeClr val="tx1"/>
+                </a:solidFill>
+                <a:latin typeface="+mn-lt"/>
+                <a:ea typeface="+mn-ea"/>
+                <a:cs typeface="+mn-cs"/>
+              </a:defRPr>
+            </a:lvl4pPr>
+            <a:lvl5pPr marL="2560320" indent="0" algn="l" defTabSz="1280160" rtl="0" eaLnBrk="1" latinLnBrk="0" hangingPunct="1">
+              <a:lnSpc>
+                <a:spcPct val="90000"/>
+              </a:lnSpc>
+              <a:spcBef>
+                <a:spcPts val="700"/>
+              </a:spcBef>
+              <a:buFont typeface="Arial" panose="020B0604020202020204" pitchFamily="34" charset="0"/>
+              <a:buNone/>
+              <a:defRPr sz="1400" kern="1200">
+                <a:solidFill>
+                  <a:schemeClr val="tx1"/>
+                </a:solidFill>
+                <a:latin typeface="+mn-lt"/>
+                <a:ea typeface="+mn-ea"/>
+                <a:cs typeface="+mn-cs"/>
+              </a:defRPr>
+            </a:lvl5pPr>
+            <a:lvl6pPr marL="3520440" indent="-320040" algn="l" defTabSz="1280160" rtl="0" eaLnBrk="1" latinLnBrk="0" hangingPunct="1">
+              <a:lnSpc>
+                <a:spcPct val="90000"/>
+              </a:lnSpc>
+              <a:spcBef>
+                <a:spcPts val="700"/>
+              </a:spcBef>
+              <a:buFont typeface="Arial" panose="020B0604020202020204" pitchFamily="34" charset="0"/>
+              <a:buChar char="•"/>
+              <a:defRPr sz="2520" kern="1200">
+                <a:solidFill>
+                  <a:schemeClr val="tx1"/>
+                </a:solidFill>
+                <a:latin typeface="+mn-lt"/>
+                <a:ea typeface="+mn-ea"/>
+                <a:cs typeface="+mn-cs"/>
+              </a:defRPr>
+            </a:lvl6pPr>
+            <a:lvl7pPr marL="4160520" indent="-320040" algn="l" defTabSz="1280160" rtl="0" eaLnBrk="1" latinLnBrk="0" hangingPunct="1">
+              <a:lnSpc>
+                <a:spcPct val="90000"/>
+              </a:lnSpc>
+              <a:spcBef>
+                <a:spcPts val="700"/>
+              </a:spcBef>
+              <a:buFont typeface="Arial" panose="020B0604020202020204" pitchFamily="34" charset="0"/>
+              <a:buChar char="•"/>
+              <a:defRPr sz="2520" kern="1200">
+                <a:solidFill>
+                  <a:schemeClr val="tx1"/>
+                </a:solidFill>
+                <a:latin typeface="+mn-lt"/>
+                <a:ea typeface="+mn-ea"/>
+                <a:cs typeface="+mn-cs"/>
+              </a:defRPr>
+            </a:lvl7pPr>
+            <a:lvl8pPr marL="4800600" indent="-320040" algn="l" defTabSz="1280160" rtl="0" eaLnBrk="1" latinLnBrk="0" hangingPunct="1">
+              <a:lnSpc>
+                <a:spcPct val="90000"/>
+              </a:lnSpc>
+              <a:spcBef>
+                <a:spcPts val="700"/>
+              </a:spcBef>
+              <a:buFont typeface="Arial" panose="020B0604020202020204" pitchFamily="34" charset="0"/>
+              <a:buChar char="•"/>
+              <a:defRPr sz="2520" kern="1200">
+                <a:solidFill>
+                  <a:schemeClr val="tx1"/>
+                </a:solidFill>
+                <a:latin typeface="+mn-lt"/>
+                <a:ea typeface="+mn-ea"/>
+                <a:cs typeface="+mn-cs"/>
+              </a:defRPr>
+            </a:lvl8pPr>
+            <a:lvl9pPr marL="5440680" indent="-320040" algn="l" defTabSz="1280160" rtl="0" eaLnBrk="1" latinLnBrk="0" hangingPunct="1">
+              <a:lnSpc>
+                <a:spcPct val="90000"/>
+              </a:lnSpc>
+              <a:spcBef>
+                <a:spcPts val="700"/>
+              </a:spcBef>
+              <a:buFont typeface="Arial" panose="020B0604020202020204" pitchFamily="34" charset="0"/>
+              <a:buChar char="•"/>
+              <a:defRPr sz="2520" kern="1200">
+                <a:solidFill>
+                  <a:schemeClr val="tx1"/>
+                </a:solidFill>
+                <a:latin typeface="+mn-lt"/>
+                <a:ea typeface="+mn-ea"/>
+                <a:cs typeface="+mn-cs"/>
+              </a:defRPr>
+            </a:lvl9pPr>
+          </a:lstStyle>
+          <a:p>
+            <a:r>
+              <a:rPr lang="pt-BR" sz="1600" b="1" dirty="0">
+                <a:solidFill>
+                  <a:schemeClr val="accent1">
+                    <a:lumMod val="75000"/>
+                  </a:schemeClr>
+                </a:solidFill>
+                <a:latin typeface="Arial" panose="020B0604020202020204" pitchFamily="34" charset="0"/>
+                <a:cs typeface="Arial" panose="020B0604020202020204" pitchFamily="34" charset="0"/>
+              </a:rPr>
+              <a:t>Modelo preditivo</a:t>
+            </a:r>
+          </a:p>
+          <a:p>
+            <a:r>
+              <a:rPr lang="pt-BR" sz="1200" dirty="0">
+                <a:solidFill>
+                  <a:schemeClr val="tx1"/>
+                </a:solidFill>
+                <a:latin typeface="Arial" panose="020B0604020202020204" pitchFamily="34" charset="0"/>
+                <a:cs typeface="Arial" panose="020B0604020202020204" pitchFamily="34" charset="0"/>
+              </a:rPr>
+              <a:t>Regressão Logística treinada com dados de 2006 a 2024, usando a posição final como variavel preditiva.</a:t>
+            </a:r>
+          </a:p>
+        </p:txBody>
+      </p:sp>
+      <p:sp>
+        <p:nvSpPr>
+          <p:cNvPr id="10" name="Espaço Reservado para Texto 1">
+            <a:extLst>
+              <a:ext uri="{FF2B5EF4-FFF2-40B4-BE49-F238E27FC236}">
+                <a16:creationId xmlns:a16="http://schemas.microsoft.com/office/drawing/2014/main" id="{0A70C441-77D9-7936-1F04-CB6B04935D29}"/>
+              </a:ext>
+            </a:extLst>
+          </p:cNvPr>
+          <p:cNvSpPr txBox="1">
+            <a:spLocks/>
+          </p:cNvSpPr>
+          <p:nvPr/>
+        </p:nvSpPr>
+        <p:spPr>
+          <a:xfrm>
+            <a:off x="11087100" y="4857750"/>
+            <a:ext cx="4386262" cy="3384550"/>
+          </a:xfrm>
+          <a:prstGeom prst="rect">
+            <a:avLst/>
+          </a:prstGeom>
+          <a:noFill/>
+        </p:spPr>
+        <p:txBody>
+          <a:bodyPr lIns="72000" tIns="72000" rIns="72000" bIns="72000"/>
+          <a:lstStyle>
+            <a:lvl1pPr marL="0" indent="0" algn="l" defTabSz="1280160" rtl="0" eaLnBrk="1" latinLnBrk="0" hangingPunct="1">
+              <a:lnSpc>
+                <a:spcPct val="100000"/>
+              </a:lnSpc>
+              <a:spcBef>
+                <a:spcPts val="0"/>
+              </a:spcBef>
+              <a:spcAft>
+                <a:spcPts val="1200"/>
+              </a:spcAft>
+              <a:buFont typeface="Arial" panose="020B0604020202020204" pitchFamily="34" charset="0"/>
+              <a:buNone/>
+              <a:defRPr sz="1800" kern="1200">
+                <a:solidFill>
+                  <a:schemeClr val="tx2">
+                    <a:lumMod val="75000"/>
+                  </a:schemeClr>
+                </a:solidFill>
+                <a:latin typeface="+mn-lt"/>
+                <a:ea typeface="+mn-ea"/>
+                <a:cs typeface="+mn-cs"/>
+              </a:defRPr>
+            </a:lvl1pPr>
+            <a:lvl2pPr marL="640080" indent="0" algn="l" defTabSz="1280160" rtl="0" eaLnBrk="1" latinLnBrk="0" hangingPunct="1">
+              <a:lnSpc>
+                <a:spcPct val="90000"/>
+              </a:lnSpc>
+              <a:spcBef>
+                <a:spcPts val="700"/>
+              </a:spcBef>
+              <a:buFont typeface="Arial" panose="020B0604020202020204" pitchFamily="34" charset="0"/>
+              <a:buNone/>
+              <a:defRPr sz="1400" kern="1200">
+                <a:solidFill>
+                  <a:schemeClr val="tx1"/>
+                </a:solidFill>
+                <a:latin typeface="+mn-lt"/>
+                <a:ea typeface="+mn-ea"/>
+                <a:cs typeface="+mn-cs"/>
+              </a:defRPr>
+            </a:lvl2pPr>
+            <a:lvl3pPr marL="1280160" indent="0" algn="l" defTabSz="1280160" rtl="0" eaLnBrk="1" latinLnBrk="0" hangingPunct="1">
+              <a:lnSpc>
+                <a:spcPct val="90000"/>
+              </a:lnSpc>
+              <a:spcBef>
+                <a:spcPts val="700"/>
+              </a:spcBef>
+              <a:buFont typeface="Arial" panose="020B0604020202020204" pitchFamily="34" charset="0"/>
+              <a:buNone/>
+              <a:defRPr sz="1400" kern="1200">
+                <a:solidFill>
+                  <a:schemeClr val="tx1"/>
+                </a:solidFill>
+                <a:latin typeface="+mn-lt"/>
+                <a:ea typeface="+mn-ea"/>
+                <a:cs typeface="+mn-cs"/>
+              </a:defRPr>
+            </a:lvl3pPr>
+            <a:lvl4pPr marL="1920240" indent="0" algn="l" defTabSz="1280160" rtl="0" eaLnBrk="1" latinLnBrk="0" hangingPunct="1">
+              <a:lnSpc>
+                <a:spcPct val="90000"/>
+              </a:lnSpc>
+              <a:spcBef>
+                <a:spcPts val="700"/>
+              </a:spcBef>
+              <a:buFont typeface="Arial" panose="020B0604020202020204" pitchFamily="34" charset="0"/>
+              <a:buNone/>
+              <a:defRPr sz="1400" kern="1200">
+                <a:solidFill>
+                  <a:schemeClr val="tx1"/>
+                </a:solidFill>
+                <a:latin typeface="+mn-lt"/>
+                <a:ea typeface="+mn-ea"/>
+                <a:cs typeface="+mn-cs"/>
+              </a:defRPr>
+            </a:lvl4pPr>
+            <a:lvl5pPr marL="2560320" indent="0" algn="l" defTabSz="1280160" rtl="0" eaLnBrk="1" latinLnBrk="0" hangingPunct="1">
+              <a:lnSpc>
+                <a:spcPct val="90000"/>
+              </a:lnSpc>
+              <a:spcBef>
+                <a:spcPts val="700"/>
+              </a:spcBef>
+              <a:buFont typeface="Arial" panose="020B0604020202020204" pitchFamily="34" charset="0"/>
+              <a:buNone/>
+              <a:defRPr sz="1400" kern="1200">
+                <a:solidFill>
+                  <a:schemeClr val="tx1"/>
+                </a:solidFill>
+                <a:latin typeface="+mn-lt"/>
+                <a:ea typeface="+mn-ea"/>
+                <a:cs typeface="+mn-cs"/>
+              </a:defRPr>
+            </a:lvl5pPr>
+            <a:lvl6pPr marL="3520440" indent="-320040" algn="l" defTabSz="1280160" rtl="0" eaLnBrk="1" latinLnBrk="0" hangingPunct="1">
+              <a:lnSpc>
+                <a:spcPct val="90000"/>
+              </a:lnSpc>
+              <a:spcBef>
+                <a:spcPts val="700"/>
+              </a:spcBef>
+              <a:buFont typeface="Arial" panose="020B0604020202020204" pitchFamily="34" charset="0"/>
+              <a:buChar char="•"/>
+              <a:defRPr sz="2520" kern="1200">
+                <a:solidFill>
+                  <a:schemeClr val="tx1"/>
+                </a:solidFill>
+                <a:latin typeface="+mn-lt"/>
+                <a:ea typeface="+mn-ea"/>
+                <a:cs typeface="+mn-cs"/>
+              </a:defRPr>
+            </a:lvl6pPr>
+            <a:lvl7pPr marL="4160520" indent="-320040" algn="l" defTabSz="1280160" rtl="0" eaLnBrk="1" latinLnBrk="0" hangingPunct="1">
+              <a:lnSpc>
+                <a:spcPct val="90000"/>
+              </a:lnSpc>
+              <a:spcBef>
+                <a:spcPts val="700"/>
+              </a:spcBef>
+              <a:buFont typeface="Arial" panose="020B0604020202020204" pitchFamily="34" charset="0"/>
+              <a:buChar char="•"/>
+              <a:defRPr sz="2520" kern="1200">
+                <a:solidFill>
+                  <a:schemeClr val="tx1"/>
+                </a:solidFill>
+                <a:latin typeface="+mn-lt"/>
+                <a:ea typeface="+mn-ea"/>
+                <a:cs typeface="+mn-cs"/>
+              </a:defRPr>
+            </a:lvl7pPr>
+            <a:lvl8pPr marL="4800600" indent="-320040" algn="l" defTabSz="1280160" rtl="0" eaLnBrk="1" latinLnBrk="0" hangingPunct="1">
+              <a:lnSpc>
+                <a:spcPct val="90000"/>
+              </a:lnSpc>
+              <a:spcBef>
+                <a:spcPts val="700"/>
+              </a:spcBef>
+              <a:buFont typeface="Arial" panose="020B0604020202020204" pitchFamily="34" charset="0"/>
+              <a:buChar char="•"/>
+              <a:defRPr sz="2520" kern="1200">
+                <a:solidFill>
+                  <a:schemeClr val="tx1"/>
+                </a:solidFill>
+                <a:latin typeface="+mn-lt"/>
+                <a:ea typeface="+mn-ea"/>
+                <a:cs typeface="+mn-cs"/>
+              </a:defRPr>
+            </a:lvl8pPr>
+            <a:lvl9pPr marL="5440680" indent="-320040" algn="l" defTabSz="1280160" rtl="0" eaLnBrk="1" latinLnBrk="0" hangingPunct="1">
+              <a:lnSpc>
+                <a:spcPct val="90000"/>
+              </a:lnSpc>
+              <a:spcBef>
+                <a:spcPts val="700"/>
+              </a:spcBef>
+              <a:buFont typeface="Arial" panose="020B0604020202020204" pitchFamily="34" charset="0"/>
+              <a:buChar char="•"/>
+              <a:defRPr sz="2520" kern="1200">
+                <a:solidFill>
+                  <a:schemeClr val="tx1"/>
+                </a:solidFill>
+                <a:latin typeface="+mn-lt"/>
+                <a:ea typeface="+mn-ea"/>
+                <a:cs typeface="+mn-cs"/>
+              </a:defRPr>
+            </a:lvl9pPr>
+          </a:lstStyle>
+          <a:p>
+            <a:r>
+              <a:rPr lang="pt-BR" sz="1600" b="1" dirty="0">
+                <a:solidFill>
+                  <a:schemeClr val="accent1">
+                    <a:lumMod val="75000"/>
+                  </a:schemeClr>
+                </a:solidFill>
+                <a:latin typeface="Arial" panose="020B0604020202020204" pitchFamily="34" charset="0"/>
+                <a:cs typeface="Arial" panose="020B0604020202020204" pitchFamily="34" charset="0"/>
+              </a:rPr>
+              <a:t>Dashboard</a:t>
+            </a:r>
+          </a:p>
+          <a:p>
+            <a:r>
+              <a:rPr lang="pt-BR" sz="1200" dirty="0">
+                <a:solidFill>
+                  <a:schemeClr val="tx1"/>
+                </a:solidFill>
+                <a:latin typeface="Arial" panose="020B0604020202020204" pitchFamily="34" charset="0"/>
+                <a:cs typeface="Arial" panose="020B0604020202020204" pitchFamily="34" charset="0"/>
+              </a:rPr>
+              <a:t>KPIs e visualizações disponíveis no Tableu Public, alimentados pela base analítica do projeto.</a:t>
+            </a:r>
+          </a:p>
+        </p:txBody>
+      </p:sp>
+    </p:spTree>
+    <p:extLst>
+      <p:ext uri="{BB962C8B-B14F-4D97-AF65-F5344CB8AC3E}">
+        <p14:creationId xmlns:p14="http://schemas.microsoft.com/office/powerpoint/2010/main" val="1254710555"/>
+      </p:ext>
+    </p:extLst>
+  </p:cSld>
+  <p:clrMapOvr>
+    <a:masterClrMapping/>
+  </p:clrMapOvr>
+</p:sld>
+</file>
+
+<file path=ppt/slides/slide5.xml><?xml version="1.0" encoding="utf-8"?>
 <p:sld xmlns:a="http://schemas.openxmlformats.org/drawingml/2006/main" xmlns:r="http://schemas.openxmlformats.org/officeDocument/2006/relationships" xmlns:p="http://schemas.openxmlformats.org/presentationml/2006/main">
   <p:cSld>
     <p:spTree>

</xml_diff>

<commit_message>
feat: ideia de 'card' no template
</commit_message>
<xml_diff>
--- a/docs/Template - Fase 2 - Apresentação Executiva - Projeto em Business Intelligence e Analytics.pptx
+++ b/docs/Template - Fase 2 - Apresentação Executiva - Projeto em Business Intelligence e Analytics.pptx
@@ -4,8 +4,11 @@
   <p:sldMasterIdLst>
     <p:sldMasterId id="2147483665" r:id="rId4"/>
   </p:sldMasterIdLst>
+  <p:notesMasterIdLst>
+    <p:notesMasterId r:id="rId10"/>
+  </p:notesMasterIdLst>
   <p:handoutMasterIdLst>
-    <p:handoutMasterId r:id="rId10"/>
+    <p:handoutMasterId r:id="rId11"/>
   </p:handoutMasterIdLst>
   <p:sldIdLst>
     <p:sldId id="288" r:id="rId5"/>
@@ -1445,6 +1448,440 @@
   </p:cSld>
   <p:clrMap bg1="lt1" tx1="dk1" bg2="lt2" tx2="dk2" accent1="accent1" accent2="accent2" accent3="accent3" accent4="accent4" accent5="accent5" accent6="accent6" hlink="hlink" folHlink="folHlink"/>
 </p:handoutMaster>
+</file>
+
+<file path=ppt/notesMasters/notesMaster1.xml><?xml version="1.0" encoding="utf-8"?>
+<p:notesMaster xmlns:a="http://schemas.openxmlformats.org/drawingml/2006/main" xmlns:r="http://schemas.openxmlformats.org/officeDocument/2006/relationships" xmlns:p="http://schemas.openxmlformats.org/presentationml/2006/main">
+  <p:cSld>
+    <p:bg>
+      <p:bgRef idx="1001">
+        <a:schemeClr val="bg1"/>
+      </p:bgRef>
+    </p:bg>
+    <p:spTree>
+      <p:nvGrpSpPr>
+        <p:cNvPr id="1" name=""/>
+        <p:cNvGrpSpPr/>
+        <p:nvPr/>
+      </p:nvGrpSpPr>
+      <p:grpSpPr>
+        <a:xfrm>
+          <a:off x="0" y="0"/>
+          <a:ext cx="0" cy="0"/>
+          <a:chOff x="0" y="0"/>
+          <a:chExt cx="0" cy="0"/>
+        </a:xfrm>
+      </p:grpSpPr>
+      <p:sp>
+        <p:nvSpPr>
+          <p:cNvPr id="2" name="Marcador de Posição do Cabeçalho 1"/>
+          <p:cNvSpPr>
+            <a:spLocks noGrp="1"/>
+          </p:cNvSpPr>
+          <p:nvPr>
+            <p:ph type="hdr" sz="quarter"/>
+          </p:nvPr>
+        </p:nvSpPr>
+        <p:spPr>
+          <a:xfrm>
+            <a:off x="0" y="0"/>
+            <a:ext cx="2971800" cy="458788"/>
+          </a:xfrm>
+          <a:prstGeom prst="rect">
+            <a:avLst/>
+          </a:prstGeom>
+        </p:spPr>
+        <p:txBody>
+          <a:bodyPr vert="horz" lIns="91440" tIns="45720" rIns="91440" bIns="45720" rtlCol="0"/>
+          <a:lstStyle>
+            <a:lvl1pPr algn="l">
+              <a:defRPr sz="1200"/>
+            </a:lvl1pPr>
+          </a:lstStyle>
+          <a:p>
+            <a:endParaRPr lang="pt-BR"/>
+          </a:p>
+        </p:txBody>
+      </p:sp>
+      <p:sp>
+        <p:nvSpPr>
+          <p:cNvPr id="3" name="Marcador de Posição da Data 2"/>
+          <p:cNvSpPr>
+            <a:spLocks noGrp="1"/>
+          </p:cNvSpPr>
+          <p:nvPr>
+            <p:ph type="dt" idx="1"/>
+          </p:nvPr>
+        </p:nvSpPr>
+        <p:spPr>
+          <a:xfrm>
+            <a:off x="3884613" y="0"/>
+            <a:ext cx="2971800" cy="458788"/>
+          </a:xfrm>
+          <a:prstGeom prst="rect">
+            <a:avLst/>
+          </a:prstGeom>
+        </p:spPr>
+        <p:txBody>
+          <a:bodyPr vert="horz" lIns="91440" tIns="45720" rIns="91440" bIns="45720" rtlCol="0"/>
+          <a:lstStyle>
+            <a:lvl1pPr algn="r">
+              <a:defRPr sz="1200"/>
+            </a:lvl1pPr>
+          </a:lstStyle>
+          <a:p>
+            <a:fld id="{35FDBEBC-B96E-46E8-8EEF-3A4138A33DC3}" type="datetimeFigureOut">
+              <a:rPr lang="pt-BR" smtClean="0"/>
+              <a:t>03/09/2026</a:t>
+            </a:fld>
+            <a:endParaRPr lang="pt-BR"/>
+          </a:p>
+        </p:txBody>
+      </p:sp>
+      <p:sp>
+        <p:nvSpPr>
+          <p:cNvPr id="4" name="Marcador de Posição da Imagem do Diapositivo 3"/>
+          <p:cNvSpPr>
+            <a:spLocks noGrp="1" noRot="1" noChangeAspect="1"/>
+          </p:cNvSpPr>
+          <p:nvPr>
+            <p:ph type="sldImg" idx="2"/>
+          </p:nvPr>
+        </p:nvSpPr>
+        <p:spPr>
+          <a:xfrm>
+            <a:off x="792163" y="1143000"/>
+            <a:ext cx="5273675" cy="3086100"/>
+          </a:xfrm>
+          <a:prstGeom prst="rect">
+            <a:avLst/>
+          </a:prstGeom>
+          <a:noFill/>
+          <a:ln w="12700">
+            <a:solidFill>
+              <a:prstClr val="black"/>
+            </a:solidFill>
+          </a:ln>
+        </p:spPr>
+        <p:txBody>
+          <a:bodyPr vert="horz" lIns="91440" tIns="45720" rIns="91440" bIns="45720" rtlCol="0" anchor="ctr"/>
+          <a:lstStyle/>
+          <a:p>
+            <a:endParaRPr lang="pt-BR"/>
+          </a:p>
+        </p:txBody>
+      </p:sp>
+      <p:sp>
+        <p:nvSpPr>
+          <p:cNvPr id="5" name="Marcador de Posição de Notas 4"/>
+          <p:cNvSpPr>
+            <a:spLocks noGrp="1"/>
+          </p:cNvSpPr>
+          <p:nvPr>
+            <p:ph type="body" sz="quarter" idx="3"/>
+          </p:nvPr>
+        </p:nvSpPr>
+        <p:spPr>
+          <a:xfrm>
+            <a:off x="685800" y="4400550"/>
+            <a:ext cx="5486400" cy="3600450"/>
+          </a:xfrm>
+          <a:prstGeom prst="rect">
+            <a:avLst/>
+          </a:prstGeom>
+        </p:spPr>
+        <p:txBody>
+          <a:bodyPr vert="horz" lIns="91440" tIns="45720" rIns="91440" bIns="45720" rtlCol="0"/>
+          <a:lstStyle/>
+          <a:p>
+            <a:pPr lvl="0"/>
+            <a:r>
+              <a:rPr lang="pt-PT"/>
+              <a:t>Clique para editar os estilos do texto de Modelo Global</a:t>
+            </a:r>
+          </a:p>
+          <a:p>
+            <a:pPr lvl="1"/>
+            <a:r>
+              <a:rPr lang="pt-PT"/>
+              <a:t>Segundo nível</a:t>
+            </a:r>
+          </a:p>
+          <a:p>
+            <a:pPr lvl="2"/>
+            <a:r>
+              <a:rPr lang="pt-PT"/>
+              <a:t>Terceiro nível</a:t>
+            </a:r>
+          </a:p>
+          <a:p>
+            <a:pPr lvl="3"/>
+            <a:r>
+              <a:rPr lang="pt-PT"/>
+              <a:t>Quarto nível</a:t>
+            </a:r>
+          </a:p>
+          <a:p>
+            <a:pPr lvl="4"/>
+            <a:r>
+              <a:rPr lang="pt-PT"/>
+              <a:t>Quinto nível</a:t>
+            </a:r>
+            <a:endParaRPr lang="pt-BR"/>
+          </a:p>
+        </p:txBody>
+      </p:sp>
+      <p:sp>
+        <p:nvSpPr>
+          <p:cNvPr id="6" name="Marcador de Posição do Rodapé 5"/>
+          <p:cNvSpPr>
+            <a:spLocks noGrp="1"/>
+          </p:cNvSpPr>
+          <p:nvPr>
+            <p:ph type="ftr" sz="quarter" idx="4"/>
+          </p:nvPr>
+        </p:nvSpPr>
+        <p:spPr>
+          <a:xfrm>
+            <a:off x="0" y="8685213"/>
+            <a:ext cx="2971800" cy="458787"/>
+          </a:xfrm>
+          <a:prstGeom prst="rect">
+            <a:avLst/>
+          </a:prstGeom>
+        </p:spPr>
+        <p:txBody>
+          <a:bodyPr vert="horz" lIns="91440" tIns="45720" rIns="91440" bIns="45720" rtlCol="0" anchor="b"/>
+          <a:lstStyle>
+            <a:lvl1pPr algn="l">
+              <a:defRPr sz="1200"/>
+            </a:lvl1pPr>
+          </a:lstStyle>
+          <a:p>
+            <a:endParaRPr lang="pt-BR"/>
+          </a:p>
+        </p:txBody>
+      </p:sp>
+      <p:sp>
+        <p:nvSpPr>
+          <p:cNvPr id="7" name="Marcador de Posição do Número do Diapositivo 6"/>
+          <p:cNvSpPr>
+            <a:spLocks noGrp="1"/>
+          </p:cNvSpPr>
+          <p:nvPr>
+            <p:ph type="sldNum" sz="quarter" idx="5"/>
+          </p:nvPr>
+        </p:nvSpPr>
+        <p:spPr>
+          <a:xfrm>
+            <a:off x="3884613" y="8685213"/>
+            <a:ext cx="2971800" cy="458787"/>
+          </a:xfrm>
+          <a:prstGeom prst="rect">
+            <a:avLst/>
+          </a:prstGeom>
+        </p:spPr>
+        <p:txBody>
+          <a:bodyPr vert="horz" lIns="91440" tIns="45720" rIns="91440" bIns="45720" rtlCol="0" anchor="b"/>
+          <a:lstStyle>
+            <a:lvl1pPr algn="r">
+              <a:defRPr sz="1200"/>
+            </a:lvl1pPr>
+          </a:lstStyle>
+          <a:p>
+            <a:fld id="{4EC3EDC0-8BE0-4B53-981B-0D2AEC565C43}" type="slidenum">
+              <a:rPr lang="pt-BR" smtClean="0"/>
+              <a:t>‹nº›</a:t>
+            </a:fld>
+            <a:endParaRPr lang="pt-BR"/>
+          </a:p>
+        </p:txBody>
+      </p:sp>
+    </p:spTree>
+    <p:extLst>
+      <p:ext uri="{BB962C8B-B14F-4D97-AF65-F5344CB8AC3E}">
+        <p14:creationId xmlns:p14="http://schemas.microsoft.com/office/powerpoint/2010/main" val="3624359233"/>
+      </p:ext>
+    </p:extLst>
+  </p:cSld>
+  <p:clrMap bg1="lt1" tx1="dk1" bg2="lt2" tx2="dk2" accent1="accent1" accent2="accent2" accent3="accent3" accent4="accent4" accent5="accent5" accent6="accent6" hlink="hlink" folHlink="folHlink"/>
+  <p:notesStyle>
+    <a:lvl1pPr marL="0" algn="l" defTabSz="914400" rtl="0" eaLnBrk="1" latinLnBrk="0" hangingPunct="1">
+      <a:defRPr sz="1200" kern="1200">
+        <a:solidFill>
+          <a:schemeClr val="tx1"/>
+        </a:solidFill>
+        <a:latin typeface="+mn-lt"/>
+        <a:ea typeface="+mn-ea"/>
+        <a:cs typeface="+mn-cs"/>
+      </a:defRPr>
+    </a:lvl1pPr>
+    <a:lvl2pPr marL="457200" algn="l" defTabSz="914400" rtl="0" eaLnBrk="1" latinLnBrk="0" hangingPunct="1">
+      <a:defRPr sz="1200" kern="1200">
+        <a:solidFill>
+          <a:schemeClr val="tx1"/>
+        </a:solidFill>
+        <a:latin typeface="+mn-lt"/>
+        <a:ea typeface="+mn-ea"/>
+        <a:cs typeface="+mn-cs"/>
+      </a:defRPr>
+    </a:lvl2pPr>
+    <a:lvl3pPr marL="914400" algn="l" defTabSz="914400" rtl="0" eaLnBrk="1" latinLnBrk="0" hangingPunct="1">
+      <a:defRPr sz="1200" kern="1200">
+        <a:solidFill>
+          <a:schemeClr val="tx1"/>
+        </a:solidFill>
+        <a:latin typeface="+mn-lt"/>
+        <a:ea typeface="+mn-ea"/>
+        <a:cs typeface="+mn-cs"/>
+      </a:defRPr>
+    </a:lvl3pPr>
+    <a:lvl4pPr marL="1371600" algn="l" defTabSz="914400" rtl="0" eaLnBrk="1" latinLnBrk="0" hangingPunct="1">
+      <a:defRPr sz="1200" kern="1200">
+        <a:solidFill>
+          <a:schemeClr val="tx1"/>
+        </a:solidFill>
+        <a:latin typeface="+mn-lt"/>
+        <a:ea typeface="+mn-ea"/>
+        <a:cs typeface="+mn-cs"/>
+      </a:defRPr>
+    </a:lvl4pPr>
+    <a:lvl5pPr marL="1828800" algn="l" defTabSz="914400" rtl="0" eaLnBrk="1" latinLnBrk="0" hangingPunct="1">
+      <a:defRPr sz="1200" kern="1200">
+        <a:solidFill>
+          <a:schemeClr val="tx1"/>
+        </a:solidFill>
+        <a:latin typeface="+mn-lt"/>
+        <a:ea typeface="+mn-ea"/>
+        <a:cs typeface="+mn-cs"/>
+      </a:defRPr>
+    </a:lvl5pPr>
+    <a:lvl6pPr marL="2286000" algn="l" defTabSz="914400" rtl="0" eaLnBrk="1" latinLnBrk="0" hangingPunct="1">
+      <a:defRPr sz="1200" kern="1200">
+        <a:solidFill>
+          <a:schemeClr val="tx1"/>
+        </a:solidFill>
+        <a:latin typeface="+mn-lt"/>
+        <a:ea typeface="+mn-ea"/>
+        <a:cs typeface="+mn-cs"/>
+      </a:defRPr>
+    </a:lvl6pPr>
+    <a:lvl7pPr marL="2743200" algn="l" defTabSz="914400" rtl="0" eaLnBrk="1" latinLnBrk="0" hangingPunct="1">
+      <a:defRPr sz="1200" kern="1200">
+        <a:solidFill>
+          <a:schemeClr val="tx1"/>
+        </a:solidFill>
+        <a:latin typeface="+mn-lt"/>
+        <a:ea typeface="+mn-ea"/>
+        <a:cs typeface="+mn-cs"/>
+      </a:defRPr>
+    </a:lvl7pPr>
+    <a:lvl8pPr marL="3200400" algn="l" defTabSz="914400" rtl="0" eaLnBrk="1" latinLnBrk="0" hangingPunct="1">
+      <a:defRPr sz="1200" kern="1200">
+        <a:solidFill>
+          <a:schemeClr val="tx1"/>
+        </a:solidFill>
+        <a:latin typeface="+mn-lt"/>
+        <a:ea typeface="+mn-ea"/>
+        <a:cs typeface="+mn-cs"/>
+      </a:defRPr>
+    </a:lvl8pPr>
+    <a:lvl9pPr marL="3657600" algn="l" defTabSz="914400" rtl="0" eaLnBrk="1" latinLnBrk="0" hangingPunct="1">
+      <a:defRPr sz="1200" kern="1200">
+        <a:solidFill>
+          <a:schemeClr val="tx1"/>
+        </a:solidFill>
+        <a:latin typeface="+mn-lt"/>
+        <a:ea typeface="+mn-ea"/>
+        <a:cs typeface="+mn-cs"/>
+      </a:defRPr>
+    </a:lvl9pPr>
+  </p:notesStyle>
+</p:notesMaster>
+</file>
+
+<file path=ppt/notesSlides/notesSlide1.xml><?xml version="1.0" encoding="utf-8"?>
+<p:notes xmlns:a="http://schemas.openxmlformats.org/drawingml/2006/main" xmlns:r="http://schemas.openxmlformats.org/officeDocument/2006/relationships" xmlns:p="http://schemas.openxmlformats.org/presentationml/2006/main">
+  <p:cSld>
+    <p:spTree>
+      <p:nvGrpSpPr>
+        <p:cNvPr id="1" name=""/>
+        <p:cNvGrpSpPr/>
+        <p:nvPr/>
+      </p:nvGrpSpPr>
+      <p:grpSpPr>
+        <a:xfrm>
+          <a:off x="0" y="0"/>
+          <a:ext cx="0" cy="0"/>
+          <a:chOff x="0" y="0"/>
+          <a:chExt cx="0" cy="0"/>
+        </a:xfrm>
+      </p:grpSpPr>
+      <p:sp>
+        <p:nvSpPr>
+          <p:cNvPr id="2" name="Marcador de Posição da Imagem do Diapositivo 1"/>
+          <p:cNvSpPr>
+            <a:spLocks noGrp="1" noRot="1" noChangeAspect="1"/>
+          </p:cNvSpPr>
+          <p:nvPr>
+            <p:ph type="sldImg"/>
+          </p:nvPr>
+        </p:nvSpPr>
+        <p:spPr/>
+      </p:sp>
+      <p:sp>
+        <p:nvSpPr>
+          <p:cNvPr id="3" name="Marcador de Posição de Notas 2"/>
+          <p:cNvSpPr>
+            <a:spLocks noGrp="1"/>
+          </p:cNvSpPr>
+          <p:nvPr>
+            <p:ph type="body" idx="1"/>
+          </p:nvPr>
+        </p:nvSpPr>
+        <p:spPr/>
+        <p:txBody>
+          <a:bodyPr/>
+          <a:lstStyle/>
+          <a:p>
+            <a:endParaRPr lang="pt-BR" dirty="0"/>
+          </a:p>
+        </p:txBody>
+      </p:sp>
+      <p:sp>
+        <p:nvSpPr>
+          <p:cNvPr id="4" name="Marcador de Posição do Número do Diapositivo 3"/>
+          <p:cNvSpPr>
+            <a:spLocks noGrp="1"/>
+          </p:cNvSpPr>
+          <p:nvPr>
+            <p:ph type="sldNum" sz="quarter" idx="5"/>
+          </p:nvPr>
+        </p:nvSpPr>
+        <p:spPr/>
+        <p:txBody>
+          <a:bodyPr/>
+          <a:lstStyle/>
+          <a:p>
+            <a:fld id="{4EC3EDC0-8BE0-4B53-981B-0D2AEC565C43}" type="slidenum">
+              <a:rPr lang="pt-BR" smtClean="0"/>
+              <a:t>4</a:t>
+            </a:fld>
+            <a:endParaRPr lang="pt-BR"/>
+          </a:p>
+        </p:txBody>
+      </p:sp>
+    </p:spTree>
+    <p:extLst>
+      <p:ext uri="{BB962C8B-B14F-4D97-AF65-F5344CB8AC3E}">
+        <p14:creationId xmlns:p14="http://schemas.microsoft.com/office/powerpoint/2010/main" val="1758493627"/>
+      </p:ext>
+    </p:extLst>
+  </p:cSld>
+  <p:clrMapOvr>
+    <a:masterClrMapping/>
+  </p:clrMapOvr>
+</p:notes>
 </file>
 
 <file path=ppt/slideLayouts/slideLayout1.xml><?xml version="1.0" encoding="utf-8"?>
@@ -5146,7 +5583,17 @@
           <a:prstGeom prst="rect">
             <a:avLst/>
           </a:prstGeom>
-          <a:noFill/>
+          <a:solidFill>
+            <a:schemeClr val="bg2"/>
+          </a:solidFill>
+          <a:effectLst>
+            <a:outerShdw blurRad="215900" dist="114300" dir="2700000" algn="tl" rotWithShape="0">
+              <a:prstClr val="black">
+                <a:alpha val="76000"/>
+              </a:prstClr>
+            </a:outerShdw>
+            <a:softEdge rad="38100"/>
+          </a:effectLst>
         </p:spPr>
         <p:txBody>
           <a:bodyPr lIns="72000" tIns="72000" rIns="72000" bIns="72000"/>
@@ -5369,7 +5816,17 @@
           <a:prstGeom prst="rect">
             <a:avLst/>
           </a:prstGeom>
-          <a:noFill/>
+          <a:solidFill>
+            <a:srgbClr val="E7E6E6"/>
+          </a:solidFill>
+          <a:effectLst>
+            <a:outerShdw blurRad="215900" dist="114300" dir="2700000" algn="ctr" rotWithShape="0">
+              <a:srgbClr val="000000">
+                <a:alpha val="76000"/>
+              </a:srgbClr>
+            </a:outerShdw>
+            <a:softEdge rad="38100"/>
+          </a:effectLst>
         </p:spPr>
         <p:txBody>
           <a:bodyPr lIns="72000" tIns="72000" rIns="72000" bIns="72000"/>
@@ -5592,7 +6049,17 @@
           <a:prstGeom prst="rect">
             <a:avLst/>
           </a:prstGeom>
-          <a:noFill/>
+          <a:solidFill>
+            <a:srgbClr val="E7E6E6"/>
+          </a:solidFill>
+          <a:effectLst>
+            <a:outerShdw blurRad="215900" dist="114300" dir="2700000" algn="tl" rotWithShape="0">
+              <a:prstClr val="black">
+                <a:alpha val="76000"/>
+              </a:prstClr>
+            </a:outerShdw>
+            <a:softEdge rad="38100"/>
+          </a:effectLst>
         </p:spPr>
         <p:txBody>
           <a:bodyPr lIns="72000" tIns="72000" rIns="72000" bIns="72000"/>
@@ -6459,6 +6926,301 @@
 </a:theme>
 </file>
 
+<file path=ppt/theme/theme3.xml><?xml version="1.0" encoding="utf-8"?>
+<a:theme xmlns:a="http://schemas.openxmlformats.org/drawingml/2006/main" name="Tema do Office">
+  <a:themeElements>
+    <a:clrScheme name="Office">
+      <a:dk1>
+        <a:sysClr val="windowText" lastClr="000000"/>
+      </a:dk1>
+      <a:lt1>
+        <a:sysClr val="window" lastClr="FFFFFF"/>
+      </a:lt1>
+      <a:dk2>
+        <a:srgbClr val="44546A"/>
+      </a:dk2>
+      <a:lt2>
+        <a:srgbClr val="E7E6E6"/>
+      </a:lt2>
+      <a:accent1>
+        <a:srgbClr val="4472C4"/>
+      </a:accent1>
+      <a:accent2>
+        <a:srgbClr val="ED7D31"/>
+      </a:accent2>
+      <a:accent3>
+        <a:srgbClr val="A5A5A5"/>
+      </a:accent3>
+      <a:accent4>
+        <a:srgbClr val="FFC000"/>
+      </a:accent4>
+      <a:accent5>
+        <a:srgbClr val="5B9BD5"/>
+      </a:accent5>
+      <a:accent6>
+        <a:srgbClr val="70AD47"/>
+      </a:accent6>
+      <a:hlink>
+        <a:srgbClr val="0563C1"/>
+      </a:hlink>
+      <a:folHlink>
+        <a:srgbClr val="954F72"/>
+      </a:folHlink>
+    </a:clrScheme>
+    <a:fontScheme name="Office">
+      <a:majorFont>
+        <a:latin typeface="Calibri Light" panose="020F0302020204030204"/>
+        <a:ea typeface=""/>
+        <a:cs typeface=""/>
+        <a:font script="Jpan" typeface="游ゴシック Light"/>
+        <a:font script="Hang" typeface="맑은 고딕"/>
+        <a:font script="Hans" typeface="等线 Light"/>
+        <a:font script="Hant" typeface="新細明體"/>
+        <a:font script="Arab" typeface="Times New Roman"/>
+        <a:font script="Hebr" typeface="Times New Roman"/>
+        <a:font script="Thai" typeface="Angsana New"/>
+        <a:font script="Ethi" typeface="Nyala"/>
+        <a:font script="Beng" typeface="Vrinda"/>
+        <a:font script="Gujr" typeface="Shruti"/>
+        <a:font script="Khmr" typeface="MoolBoran"/>
+        <a:font script="Knda" typeface="Tunga"/>
+        <a:font script="Guru" typeface="Raavi"/>
+        <a:font script="Cans" typeface="Euphemia"/>
+        <a:font script="Cher" typeface="Plantagenet Cherokee"/>
+        <a:font script="Yiii" typeface="Microsoft Yi Baiti"/>
+        <a:font script="Tibt" typeface="Microsoft Himalaya"/>
+        <a:font script="Thaa" typeface="MV Boli"/>
+        <a:font script="Deva" typeface="Mangal"/>
+        <a:font script="Telu" typeface="Gautami"/>
+        <a:font script="Taml" typeface="Latha"/>
+        <a:font script="Syrc" typeface="Estrangelo Edessa"/>
+        <a:font script="Orya" typeface="Kalinga"/>
+        <a:font script="Mlym" typeface="Kartika"/>
+        <a:font script="Laoo" typeface="DokChampa"/>
+        <a:font script="Sinh" typeface="Iskoola Pota"/>
+        <a:font script="Mong" typeface="Mongolian Baiti"/>
+        <a:font script="Viet" typeface="Times New Roman"/>
+        <a:font script="Uigh" typeface="Microsoft Uighur"/>
+        <a:font script="Geor" typeface="Sylfaen"/>
+        <a:font script="Armn" typeface="Arial"/>
+        <a:font script="Bugi" typeface="Leelawadee UI"/>
+        <a:font script="Bopo" typeface="Microsoft JhengHei"/>
+        <a:font script="Java" typeface="Javanese Text"/>
+        <a:font script="Lisu" typeface="Segoe UI"/>
+        <a:font script="Mymr" typeface="Myanmar Text"/>
+        <a:font script="Nkoo" typeface="Ebrima"/>
+        <a:font script="Olck" typeface="Nirmala UI"/>
+        <a:font script="Osma" typeface="Ebrima"/>
+        <a:font script="Phag" typeface="Phagspa"/>
+        <a:font script="Syrn" typeface="Estrangelo Edessa"/>
+        <a:font script="Syrj" typeface="Estrangelo Edessa"/>
+        <a:font script="Syre" typeface="Estrangelo Edessa"/>
+        <a:font script="Sora" typeface="Nirmala UI"/>
+        <a:font script="Tale" typeface="Microsoft Tai Le"/>
+        <a:font script="Talu" typeface="Microsoft New Tai Lue"/>
+        <a:font script="Tfng" typeface="Ebrima"/>
+      </a:majorFont>
+      <a:minorFont>
+        <a:latin typeface="Calibri" panose="020F0502020204030204"/>
+        <a:ea typeface=""/>
+        <a:cs typeface=""/>
+        <a:font script="Jpan" typeface="游ゴシック"/>
+        <a:font script="Hang" typeface="맑은 고딕"/>
+        <a:font script="Hans" typeface="等线"/>
+        <a:font script="Hant" typeface="新細明體"/>
+        <a:font script="Arab" typeface="Arial"/>
+        <a:font script="Hebr" typeface="Arial"/>
+        <a:font script="Thai" typeface="Cordia New"/>
+        <a:font script="Ethi" typeface="Nyala"/>
+        <a:font script="Beng" typeface="Vrinda"/>
+        <a:font script="Gujr" typeface="Shruti"/>
+        <a:font script="Khmr" typeface="DaunPenh"/>
+        <a:font script="Knda" typeface="Tunga"/>
+        <a:font script="Guru" typeface="Raavi"/>
+        <a:font script="Cans" typeface="Euphemia"/>
+        <a:font script="Cher" typeface="Plantagenet Cherokee"/>
+        <a:font script="Yiii" typeface="Microsoft Yi Baiti"/>
+        <a:font script="Tibt" typeface="Microsoft Himalaya"/>
+        <a:font script="Thaa" typeface="MV Boli"/>
+        <a:font script="Deva" typeface="Mangal"/>
+        <a:font script="Telu" typeface="Gautami"/>
+        <a:font script="Taml" typeface="Latha"/>
+        <a:font script="Syrc" typeface="Estrangelo Edessa"/>
+        <a:font script="Orya" typeface="Kalinga"/>
+        <a:font script="Mlym" typeface="Kartika"/>
+        <a:font script="Laoo" typeface="DokChampa"/>
+        <a:font script="Sinh" typeface="Iskoola Pota"/>
+        <a:font script="Mong" typeface="Mongolian Baiti"/>
+        <a:font script="Viet" typeface="Arial"/>
+        <a:font script="Uigh" typeface="Microsoft Uighur"/>
+        <a:font script="Geor" typeface="Sylfaen"/>
+        <a:font script="Armn" typeface="Arial"/>
+        <a:font script="Bugi" typeface="Leelawadee UI"/>
+        <a:font script="Bopo" typeface="Microsoft JhengHei"/>
+        <a:font script="Java" typeface="Javanese Text"/>
+        <a:font script="Lisu" typeface="Segoe UI"/>
+        <a:font script="Mymr" typeface="Myanmar Text"/>
+        <a:font script="Nkoo" typeface="Ebrima"/>
+        <a:font script="Olck" typeface="Nirmala UI"/>
+        <a:font script="Osma" typeface="Ebrima"/>
+        <a:font script="Phag" typeface="Phagspa"/>
+        <a:font script="Syrn" typeface="Estrangelo Edessa"/>
+        <a:font script="Syrj" typeface="Estrangelo Edessa"/>
+        <a:font script="Syre" typeface="Estrangelo Edessa"/>
+        <a:font script="Sora" typeface="Nirmala UI"/>
+        <a:font script="Tale" typeface="Microsoft Tai Le"/>
+        <a:font script="Talu" typeface="Microsoft New Tai Lue"/>
+        <a:font script="Tfng" typeface="Ebrima"/>
+      </a:minorFont>
+    </a:fontScheme>
+    <a:fmtScheme name="Office">
+      <a:fillStyleLst>
+        <a:solidFill>
+          <a:schemeClr val="phClr"/>
+        </a:solidFill>
+        <a:gradFill rotWithShape="1">
+          <a:gsLst>
+            <a:gs pos="0">
+              <a:schemeClr val="phClr">
+                <a:lumMod val="110000"/>
+                <a:satMod val="105000"/>
+                <a:tint val="67000"/>
+              </a:schemeClr>
+            </a:gs>
+            <a:gs pos="50000">
+              <a:schemeClr val="phClr">
+                <a:lumMod val="105000"/>
+                <a:satMod val="103000"/>
+                <a:tint val="73000"/>
+              </a:schemeClr>
+            </a:gs>
+            <a:gs pos="100000">
+              <a:schemeClr val="phClr">
+                <a:lumMod val="105000"/>
+                <a:satMod val="109000"/>
+                <a:tint val="81000"/>
+              </a:schemeClr>
+            </a:gs>
+          </a:gsLst>
+          <a:lin ang="5400000" scaled="0"/>
+        </a:gradFill>
+        <a:gradFill rotWithShape="1">
+          <a:gsLst>
+            <a:gs pos="0">
+              <a:schemeClr val="phClr">
+                <a:satMod val="103000"/>
+                <a:lumMod val="102000"/>
+                <a:tint val="94000"/>
+              </a:schemeClr>
+            </a:gs>
+            <a:gs pos="50000">
+              <a:schemeClr val="phClr">
+                <a:satMod val="110000"/>
+                <a:lumMod val="100000"/>
+                <a:shade val="100000"/>
+              </a:schemeClr>
+            </a:gs>
+            <a:gs pos="100000">
+              <a:schemeClr val="phClr">
+                <a:lumMod val="99000"/>
+                <a:satMod val="120000"/>
+                <a:shade val="78000"/>
+              </a:schemeClr>
+            </a:gs>
+          </a:gsLst>
+          <a:lin ang="5400000" scaled="0"/>
+        </a:gradFill>
+      </a:fillStyleLst>
+      <a:lnStyleLst>
+        <a:ln w="6350" cap="flat" cmpd="sng" algn="ctr">
+          <a:solidFill>
+            <a:schemeClr val="phClr"/>
+          </a:solidFill>
+          <a:prstDash val="solid"/>
+          <a:miter lim="800000"/>
+        </a:ln>
+        <a:ln w="12700" cap="flat" cmpd="sng" algn="ctr">
+          <a:solidFill>
+            <a:schemeClr val="phClr"/>
+          </a:solidFill>
+          <a:prstDash val="solid"/>
+          <a:miter lim="800000"/>
+        </a:ln>
+        <a:ln w="19050" cap="flat" cmpd="sng" algn="ctr">
+          <a:solidFill>
+            <a:schemeClr val="phClr"/>
+          </a:solidFill>
+          <a:prstDash val="solid"/>
+          <a:miter lim="800000"/>
+        </a:ln>
+      </a:lnStyleLst>
+      <a:effectStyleLst>
+        <a:effectStyle>
+          <a:effectLst/>
+        </a:effectStyle>
+        <a:effectStyle>
+          <a:effectLst/>
+        </a:effectStyle>
+        <a:effectStyle>
+          <a:effectLst>
+            <a:outerShdw blurRad="57150" dist="19050" dir="5400000" algn="ctr" rotWithShape="0">
+              <a:srgbClr val="000000">
+                <a:alpha val="63000"/>
+              </a:srgbClr>
+            </a:outerShdw>
+          </a:effectLst>
+        </a:effectStyle>
+      </a:effectStyleLst>
+      <a:bgFillStyleLst>
+        <a:solidFill>
+          <a:schemeClr val="phClr"/>
+        </a:solidFill>
+        <a:solidFill>
+          <a:schemeClr val="phClr">
+            <a:tint val="95000"/>
+            <a:satMod val="170000"/>
+          </a:schemeClr>
+        </a:solidFill>
+        <a:gradFill rotWithShape="1">
+          <a:gsLst>
+            <a:gs pos="0">
+              <a:schemeClr val="phClr">
+                <a:tint val="93000"/>
+                <a:satMod val="150000"/>
+                <a:shade val="98000"/>
+                <a:lumMod val="102000"/>
+              </a:schemeClr>
+            </a:gs>
+            <a:gs pos="50000">
+              <a:schemeClr val="phClr">
+                <a:tint val="98000"/>
+                <a:satMod val="130000"/>
+                <a:shade val="90000"/>
+                <a:lumMod val="103000"/>
+              </a:schemeClr>
+            </a:gs>
+            <a:gs pos="100000">
+              <a:schemeClr val="phClr">
+                <a:shade val="63000"/>
+                <a:satMod val="120000"/>
+              </a:schemeClr>
+            </a:gs>
+          </a:gsLst>
+          <a:lin ang="5400000" scaled="0"/>
+        </a:gradFill>
+      </a:bgFillStyleLst>
+    </a:fmtScheme>
+  </a:themeElements>
+  <a:objectDefaults/>
+  <a:extraClrSchemeLst/>
+  <a:extLst>
+    <a:ext uri="{05A4C25C-085E-4340-85A3-A5531E510DB2}">
+      <thm15:themeFamily xmlns:thm15="http://schemas.microsoft.com/office/thememl/2012/main" name="Office Theme" id="{62F939B6-93AF-4DB8-9C6B-D6C7DFDC589F}" vid="{4A3C46E8-61CC-4603-A589-7422A47A8E4A}"/>
+    </a:ext>
+  </a:extLst>
+</a:theme>
+</file>
+
 <file path=customXml/item1.xml><?xml version="1.0" encoding="utf-8"?>
 <ct:contentTypeSchema xmlns:ct="http://schemas.microsoft.com/office/2006/metadata/contentType" xmlns:ma="http://schemas.microsoft.com/office/2006/metadata/properties/metaAttributes" ct:_="" ma:_="" ma:contentTypeName="Documento" ma:contentTypeID="0x010100D0B80C79D672AC42A1970465DFBE826F" ma:contentTypeVersion="15" ma:contentTypeDescription="Crie um novo documento." ma:contentTypeScope="" ma:versionID="2eefaa1e6d6c44dc16da2b9d163c9050">
   <xsd:schema xmlns:xsd="http://www.w3.org/2001/XMLSchema" xmlns:xs="http://www.w3.org/2001/XMLSchema" xmlns:p="http://schemas.microsoft.com/office/2006/metadata/properties" xmlns:ns3="6439f31e-650a-4110-90ce-dedea4761958" xmlns:ns4="0c1d693f-504f-4903-8fa4-fc4240ce4f11" targetNamespace="http://schemas.microsoft.com/office/2006/metadata/properties" ma:root="true" ma:fieldsID="0d3e9c37c1323d55a0c2b9c866021e93" ns3:_="" ns4:_="">

</xml_diff>

<commit_message>
fix: cards no slide errado
</commit_message>
<xml_diff>
--- a/docs/Template - Fase 2 - Apresentação Executiva - Projeto em Business Intelligence e Analytics.pptx
+++ b/docs/Template - Fase 2 - Apresentação Executiva - Projeto em Business Intelligence e Analytics.pptx
@@ -4307,10 +4307,10 @@
       </p:sp>
       <p:sp>
         <p:nvSpPr>
-          <p:cNvPr id="6" name="Espaço Reservado para Texto 1">
+          <p:cNvPr id="12" name="Espaço Reservado para Texto 1">
             <a:extLst>
               <a:ext uri="{FF2B5EF4-FFF2-40B4-BE49-F238E27FC236}">
-                <a16:creationId xmlns:a16="http://schemas.microsoft.com/office/drawing/2014/main" id="{5AA023C6-56D6-F152-8B49-4085D087A29F}"/>
+                <a16:creationId xmlns:a16="http://schemas.microsoft.com/office/drawing/2014/main" id="{E2A04869-DECF-FE40-5AF3-003ED549D9FE}"/>
               </a:ext>
             </a:extLst>
           </p:cNvPr>
@@ -4327,7 +4327,17 @@
           <a:prstGeom prst="rect">
             <a:avLst/>
           </a:prstGeom>
-          <a:noFill/>
+          <a:solidFill>
+            <a:schemeClr val="bg2"/>
+          </a:solidFill>
+          <a:effectLst>
+            <a:outerShdw blurRad="215900" dist="114300" dir="2700000" algn="tl" rotWithShape="0">
+              <a:prstClr val="black">
+                <a:alpha val="76000"/>
+              </a:prstClr>
+            </a:outerShdw>
+            <a:softEdge rad="38100"/>
+          </a:effectLst>
         </p:spPr>
         <p:txBody>
           <a:bodyPr lIns="72000" tIns="72000" rIns="72000" bIns="72000"/>
@@ -4530,10 +4540,10 @@
       </p:sp>
       <p:sp>
         <p:nvSpPr>
-          <p:cNvPr id="8" name="Espaço Reservado para Texto 1">
+          <p:cNvPr id="14" name="Espaço Reservado para Texto 1">
             <a:extLst>
               <a:ext uri="{FF2B5EF4-FFF2-40B4-BE49-F238E27FC236}">
-                <a16:creationId xmlns:a16="http://schemas.microsoft.com/office/drawing/2014/main" id="{FE5BDC7B-EF69-B6F8-0C32-8ED6164BA7FB}"/>
+                <a16:creationId xmlns:a16="http://schemas.microsoft.com/office/drawing/2014/main" id="{DB4D9200-5628-6FBA-5821-660DD3FEC148}"/>
               </a:ext>
             </a:extLst>
           </p:cNvPr>
@@ -4550,7 +4560,17 @@
           <a:prstGeom prst="rect">
             <a:avLst/>
           </a:prstGeom>
-          <a:noFill/>
+          <a:solidFill>
+            <a:srgbClr val="E7E6E6"/>
+          </a:solidFill>
+          <a:effectLst>
+            <a:outerShdw blurRad="215900" dist="114300" dir="2700000" algn="ctr" rotWithShape="0">
+              <a:srgbClr val="000000">
+                <a:alpha val="76000"/>
+              </a:srgbClr>
+            </a:outerShdw>
+            <a:softEdge rad="38100"/>
+          </a:effectLst>
         </p:spPr>
         <p:txBody>
           <a:bodyPr lIns="72000" tIns="72000" rIns="72000" bIns="72000"/>
@@ -4753,10 +4773,10 @@
       </p:sp>
       <p:sp>
         <p:nvSpPr>
-          <p:cNvPr id="10" name="Espaço Reservado para Texto 1">
+          <p:cNvPr id="16" name="Espaço Reservado para Texto 1">
             <a:extLst>
               <a:ext uri="{FF2B5EF4-FFF2-40B4-BE49-F238E27FC236}">
-                <a16:creationId xmlns:a16="http://schemas.microsoft.com/office/drawing/2014/main" id="{98FCB85E-93B7-1FC3-3C47-C54599E4A6F4}"/>
+                <a16:creationId xmlns:a16="http://schemas.microsoft.com/office/drawing/2014/main" id="{845B4D45-0372-7978-3BC3-CE4D168D1777}"/>
               </a:ext>
             </a:extLst>
           </p:cNvPr>
@@ -4773,7 +4793,17 @@
           <a:prstGeom prst="rect">
             <a:avLst/>
           </a:prstGeom>
-          <a:noFill/>
+          <a:solidFill>
+            <a:srgbClr val="E7E6E6"/>
+          </a:solidFill>
+          <a:effectLst>
+            <a:outerShdw blurRad="215900" dist="114300" dir="2700000" algn="tl" rotWithShape="0">
+              <a:prstClr val="black">
+                <a:alpha val="76000"/>
+              </a:prstClr>
+            </a:outerShdw>
+            <a:softEdge rad="38100"/>
+          </a:effectLst>
         </p:spPr>
         <p:txBody>
           <a:bodyPr lIns="72000" tIns="72000" rIns="72000" bIns="72000"/>
@@ -5557,705 +5587,6 @@
                 <a:cs typeface="Arial" panose="020B0604020202020204" pitchFamily="34" charset="0"/>
               </a:rPr>
               <a:t>Transformar dados de desempenho clube-temporada em um indicador preditivo de risco de rebaixamento, apresentado por meio de uma solução de BI e Analytics.</a:t>
-            </a:r>
-          </a:p>
-        </p:txBody>
-      </p:sp>
-      <p:sp>
-        <p:nvSpPr>
-          <p:cNvPr id="6" name="Espaço Reservado para Texto 1">
-            <a:extLst>
-              <a:ext uri="{FF2B5EF4-FFF2-40B4-BE49-F238E27FC236}">
-                <a16:creationId xmlns:a16="http://schemas.microsoft.com/office/drawing/2014/main" id="{739AE78C-57B9-A849-E87A-6F48116B96F1}"/>
-              </a:ext>
-            </a:extLst>
-          </p:cNvPr>
-          <p:cNvSpPr txBox="1">
-            <a:spLocks/>
-          </p:cNvSpPr>
-          <p:nvPr/>
-        </p:nvSpPr>
-        <p:spPr>
-          <a:xfrm>
-            <a:off x="928688" y="4857750"/>
-            <a:ext cx="4386262" cy="3384550"/>
-          </a:xfrm>
-          <a:prstGeom prst="rect">
-            <a:avLst/>
-          </a:prstGeom>
-          <a:solidFill>
-            <a:schemeClr val="bg2"/>
-          </a:solidFill>
-          <a:effectLst>
-            <a:outerShdw blurRad="215900" dist="114300" dir="2700000" algn="tl" rotWithShape="0">
-              <a:prstClr val="black">
-                <a:alpha val="76000"/>
-              </a:prstClr>
-            </a:outerShdw>
-            <a:softEdge rad="38100"/>
-          </a:effectLst>
-        </p:spPr>
-        <p:txBody>
-          <a:bodyPr lIns="72000" tIns="72000" rIns="72000" bIns="72000"/>
-          <a:lstStyle>
-            <a:lvl1pPr marL="0" indent="0" algn="l" defTabSz="1280160" rtl="0" eaLnBrk="1" latinLnBrk="0" hangingPunct="1">
-              <a:lnSpc>
-                <a:spcPct val="100000"/>
-              </a:lnSpc>
-              <a:spcBef>
-                <a:spcPts val="0"/>
-              </a:spcBef>
-              <a:spcAft>
-                <a:spcPts val="1200"/>
-              </a:spcAft>
-              <a:buFont typeface="Arial" panose="020B0604020202020204" pitchFamily="34" charset="0"/>
-              <a:buNone/>
-              <a:defRPr sz="1800" kern="1200">
-                <a:solidFill>
-                  <a:schemeClr val="tx2">
-                    <a:lumMod val="75000"/>
-                  </a:schemeClr>
-                </a:solidFill>
-                <a:latin typeface="+mn-lt"/>
-                <a:ea typeface="+mn-ea"/>
-                <a:cs typeface="+mn-cs"/>
-              </a:defRPr>
-            </a:lvl1pPr>
-            <a:lvl2pPr marL="640080" indent="0" algn="l" defTabSz="1280160" rtl="0" eaLnBrk="1" latinLnBrk="0" hangingPunct="1">
-              <a:lnSpc>
-                <a:spcPct val="90000"/>
-              </a:lnSpc>
-              <a:spcBef>
-                <a:spcPts val="700"/>
-              </a:spcBef>
-              <a:buFont typeface="Arial" panose="020B0604020202020204" pitchFamily="34" charset="0"/>
-              <a:buNone/>
-              <a:defRPr sz="1400" kern="1200">
-                <a:solidFill>
-                  <a:schemeClr val="tx1"/>
-                </a:solidFill>
-                <a:latin typeface="+mn-lt"/>
-                <a:ea typeface="+mn-ea"/>
-                <a:cs typeface="+mn-cs"/>
-              </a:defRPr>
-            </a:lvl2pPr>
-            <a:lvl3pPr marL="1280160" indent="0" algn="l" defTabSz="1280160" rtl="0" eaLnBrk="1" latinLnBrk="0" hangingPunct="1">
-              <a:lnSpc>
-                <a:spcPct val="90000"/>
-              </a:lnSpc>
-              <a:spcBef>
-                <a:spcPts val="700"/>
-              </a:spcBef>
-              <a:buFont typeface="Arial" panose="020B0604020202020204" pitchFamily="34" charset="0"/>
-              <a:buNone/>
-              <a:defRPr sz="1400" kern="1200">
-                <a:solidFill>
-                  <a:schemeClr val="tx1"/>
-                </a:solidFill>
-                <a:latin typeface="+mn-lt"/>
-                <a:ea typeface="+mn-ea"/>
-                <a:cs typeface="+mn-cs"/>
-              </a:defRPr>
-            </a:lvl3pPr>
-            <a:lvl4pPr marL="1920240" indent="0" algn="l" defTabSz="1280160" rtl="0" eaLnBrk="1" latinLnBrk="0" hangingPunct="1">
-              <a:lnSpc>
-                <a:spcPct val="90000"/>
-              </a:lnSpc>
-              <a:spcBef>
-                <a:spcPts val="700"/>
-              </a:spcBef>
-              <a:buFont typeface="Arial" panose="020B0604020202020204" pitchFamily="34" charset="0"/>
-              <a:buNone/>
-              <a:defRPr sz="1400" kern="1200">
-                <a:solidFill>
-                  <a:schemeClr val="tx1"/>
-                </a:solidFill>
-                <a:latin typeface="+mn-lt"/>
-                <a:ea typeface="+mn-ea"/>
-                <a:cs typeface="+mn-cs"/>
-              </a:defRPr>
-            </a:lvl4pPr>
-            <a:lvl5pPr marL="2560320" indent="0" algn="l" defTabSz="1280160" rtl="0" eaLnBrk="1" latinLnBrk="0" hangingPunct="1">
-              <a:lnSpc>
-                <a:spcPct val="90000"/>
-              </a:lnSpc>
-              <a:spcBef>
-                <a:spcPts val="700"/>
-              </a:spcBef>
-              <a:buFont typeface="Arial" panose="020B0604020202020204" pitchFamily="34" charset="0"/>
-              <a:buNone/>
-              <a:defRPr sz="1400" kern="1200">
-                <a:solidFill>
-                  <a:schemeClr val="tx1"/>
-                </a:solidFill>
-                <a:latin typeface="+mn-lt"/>
-                <a:ea typeface="+mn-ea"/>
-                <a:cs typeface="+mn-cs"/>
-              </a:defRPr>
-            </a:lvl5pPr>
-            <a:lvl6pPr marL="3520440" indent="-320040" algn="l" defTabSz="1280160" rtl="0" eaLnBrk="1" latinLnBrk="0" hangingPunct="1">
-              <a:lnSpc>
-                <a:spcPct val="90000"/>
-              </a:lnSpc>
-              <a:spcBef>
-                <a:spcPts val="700"/>
-              </a:spcBef>
-              <a:buFont typeface="Arial" panose="020B0604020202020204" pitchFamily="34" charset="0"/>
-              <a:buChar char="•"/>
-              <a:defRPr sz="2520" kern="1200">
-                <a:solidFill>
-                  <a:schemeClr val="tx1"/>
-                </a:solidFill>
-                <a:latin typeface="+mn-lt"/>
-                <a:ea typeface="+mn-ea"/>
-                <a:cs typeface="+mn-cs"/>
-              </a:defRPr>
-            </a:lvl6pPr>
-            <a:lvl7pPr marL="4160520" indent="-320040" algn="l" defTabSz="1280160" rtl="0" eaLnBrk="1" latinLnBrk="0" hangingPunct="1">
-              <a:lnSpc>
-                <a:spcPct val="90000"/>
-              </a:lnSpc>
-              <a:spcBef>
-                <a:spcPts val="700"/>
-              </a:spcBef>
-              <a:buFont typeface="Arial" panose="020B0604020202020204" pitchFamily="34" charset="0"/>
-              <a:buChar char="•"/>
-              <a:defRPr sz="2520" kern="1200">
-                <a:solidFill>
-                  <a:schemeClr val="tx1"/>
-                </a:solidFill>
-                <a:latin typeface="+mn-lt"/>
-                <a:ea typeface="+mn-ea"/>
-                <a:cs typeface="+mn-cs"/>
-              </a:defRPr>
-            </a:lvl7pPr>
-            <a:lvl8pPr marL="4800600" indent="-320040" algn="l" defTabSz="1280160" rtl="0" eaLnBrk="1" latinLnBrk="0" hangingPunct="1">
-              <a:lnSpc>
-                <a:spcPct val="90000"/>
-              </a:lnSpc>
-              <a:spcBef>
-                <a:spcPts val="700"/>
-              </a:spcBef>
-              <a:buFont typeface="Arial" panose="020B0604020202020204" pitchFamily="34" charset="0"/>
-              <a:buChar char="•"/>
-              <a:defRPr sz="2520" kern="1200">
-                <a:solidFill>
-                  <a:schemeClr val="tx1"/>
-                </a:solidFill>
-                <a:latin typeface="+mn-lt"/>
-                <a:ea typeface="+mn-ea"/>
-                <a:cs typeface="+mn-cs"/>
-              </a:defRPr>
-            </a:lvl8pPr>
-            <a:lvl9pPr marL="5440680" indent="-320040" algn="l" defTabSz="1280160" rtl="0" eaLnBrk="1" latinLnBrk="0" hangingPunct="1">
-              <a:lnSpc>
-                <a:spcPct val="90000"/>
-              </a:lnSpc>
-              <a:spcBef>
-                <a:spcPts val="700"/>
-              </a:spcBef>
-              <a:buFont typeface="Arial" panose="020B0604020202020204" pitchFamily="34" charset="0"/>
-              <a:buChar char="•"/>
-              <a:defRPr sz="2520" kern="1200">
-                <a:solidFill>
-                  <a:schemeClr val="tx1"/>
-                </a:solidFill>
-                <a:latin typeface="+mn-lt"/>
-                <a:ea typeface="+mn-ea"/>
-                <a:cs typeface="+mn-cs"/>
-              </a:defRPr>
-            </a:lvl9pPr>
-          </a:lstStyle>
-          <a:p>
-            <a:r>
-              <a:rPr lang="pt-BR" sz="1600" b="1" dirty="0">
-                <a:solidFill>
-                  <a:schemeClr val="accent1">
-                    <a:lumMod val="75000"/>
-                  </a:schemeClr>
-                </a:solidFill>
-                <a:latin typeface="Arial" panose="020B0604020202020204" pitchFamily="34" charset="0"/>
-                <a:cs typeface="Arial" panose="020B0604020202020204" pitchFamily="34" charset="0"/>
-              </a:rPr>
-              <a:t>Indicador de risco por clube</a:t>
-            </a:r>
-          </a:p>
-          <a:p>
-            <a:r>
-              <a:rPr lang="pt-BR" sz="1200" dirty="0">
-                <a:solidFill>
-                  <a:schemeClr val="tx1"/>
-                </a:solidFill>
-                <a:latin typeface="Arial" panose="020B0604020202020204" pitchFamily="34" charset="0"/>
-                <a:cs typeface="Arial" panose="020B0604020202020204" pitchFamily="34" charset="0"/>
-              </a:rPr>
-              <a:t>Probabilidade de rebaixamente calculada para cada um dos 20 clubes de Série A na temporada 2025</a:t>
-            </a:r>
-          </a:p>
-        </p:txBody>
-      </p:sp>
-      <p:sp>
-        <p:nvSpPr>
-          <p:cNvPr id="8" name="Espaço Reservado para Texto 1">
-            <a:extLst>
-              <a:ext uri="{FF2B5EF4-FFF2-40B4-BE49-F238E27FC236}">
-                <a16:creationId xmlns:a16="http://schemas.microsoft.com/office/drawing/2014/main" id="{61F207CE-E01C-6EED-159C-D03B17C8D0A6}"/>
-              </a:ext>
-            </a:extLst>
-          </p:cNvPr>
-          <p:cNvSpPr txBox="1">
-            <a:spLocks/>
-          </p:cNvSpPr>
-          <p:nvPr/>
-        </p:nvSpPr>
-        <p:spPr>
-          <a:xfrm>
-            <a:off x="6007894" y="4857750"/>
-            <a:ext cx="4386262" cy="3384550"/>
-          </a:xfrm>
-          <a:prstGeom prst="rect">
-            <a:avLst/>
-          </a:prstGeom>
-          <a:solidFill>
-            <a:srgbClr val="E7E6E6"/>
-          </a:solidFill>
-          <a:effectLst>
-            <a:outerShdw blurRad="215900" dist="114300" dir="2700000" algn="ctr" rotWithShape="0">
-              <a:srgbClr val="000000">
-                <a:alpha val="76000"/>
-              </a:srgbClr>
-            </a:outerShdw>
-            <a:softEdge rad="38100"/>
-          </a:effectLst>
-        </p:spPr>
-        <p:txBody>
-          <a:bodyPr lIns="72000" tIns="72000" rIns="72000" bIns="72000"/>
-          <a:lstStyle>
-            <a:lvl1pPr marL="0" indent="0" algn="l" defTabSz="1280160" rtl="0" eaLnBrk="1" latinLnBrk="0" hangingPunct="1">
-              <a:lnSpc>
-                <a:spcPct val="100000"/>
-              </a:lnSpc>
-              <a:spcBef>
-                <a:spcPts val="0"/>
-              </a:spcBef>
-              <a:spcAft>
-                <a:spcPts val="1200"/>
-              </a:spcAft>
-              <a:buFont typeface="Arial" panose="020B0604020202020204" pitchFamily="34" charset="0"/>
-              <a:buNone/>
-              <a:defRPr sz="1800" kern="1200">
-                <a:solidFill>
-                  <a:schemeClr val="tx2">
-                    <a:lumMod val="75000"/>
-                  </a:schemeClr>
-                </a:solidFill>
-                <a:latin typeface="+mn-lt"/>
-                <a:ea typeface="+mn-ea"/>
-                <a:cs typeface="+mn-cs"/>
-              </a:defRPr>
-            </a:lvl1pPr>
-            <a:lvl2pPr marL="640080" indent="0" algn="l" defTabSz="1280160" rtl="0" eaLnBrk="1" latinLnBrk="0" hangingPunct="1">
-              <a:lnSpc>
-                <a:spcPct val="90000"/>
-              </a:lnSpc>
-              <a:spcBef>
-                <a:spcPts val="700"/>
-              </a:spcBef>
-              <a:buFont typeface="Arial" panose="020B0604020202020204" pitchFamily="34" charset="0"/>
-              <a:buNone/>
-              <a:defRPr sz="1400" kern="1200">
-                <a:solidFill>
-                  <a:schemeClr val="tx1"/>
-                </a:solidFill>
-                <a:latin typeface="+mn-lt"/>
-                <a:ea typeface="+mn-ea"/>
-                <a:cs typeface="+mn-cs"/>
-              </a:defRPr>
-            </a:lvl2pPr>
-            <a:lvl3pPr marL="1280160" indent="0" algn="l" defTabSz="1280160" rtl="0" eaLnBrk="1" latinLnBrk="0" hangingPunct="1">
-              <a:lnSpc>
-                <a:spcPct val="90000"/>
-              </a:lnSpc>
-              <a:spcBef>
-                <a:spcPts val="700"/>
-              </a:spcBef>
-              <a:buFont typeface="Arial" panose="020B0604020202020204" pitchFamily="34" charset="0"/>
-              <a:buNone/>
-              <a:defRPr sz="1400" kern="1200">
-                <a:solidFill>
-                  <a:schemeClr val="tx1"/>
-                </a:solidFill>
-                <a:latin typeface="+mn-lt"/>
-                <a:ea typeface="+mn-ea"/>
-                <a:cs typeface="+mn-cs"/>
-              </a:defRPr>
-            </a:lvl3pPr>
-            <a:lvl4pPr marL="1920240" indent="0" algn="l" defTabSz="1280160" rtl="0" eaLnBrk="1" latinLnBrk="0" hangingPunct="1">
-              <a:lnSpc>
-                <a:spcPct val="90000"/>
-              </a:lnSpc>
-              <a:spcBef>
-                <a:spcPts val="700"/>
-              </a:spcBef>
-              <a:buFont typeface="Arial" panose="020B0604020202020204" pitchFamily="34" charset="0"/>
-              <a:buNone/>
-              <a:defRPr sz="1400" kern="1200">
-                <a:solidFill>
-                  <a:schemeClr val="tx1"/>
-                </a:solidFill>
-                <a:latin typeface="+mn-lt"/>
-                <a:ea typeface="+mn-ea"/>
-                <a:cs typeface="+mn-cs"/>
-              </a:defRPr>
-            </a:lvl4pPr>
-            <a:lvl5pPr marL="2560320" indent="0" algn="l" defTabSz="1280160" rtl="0" eaLnBrk="1" latinLnBrk="0" hangingPunct="1">
-              <a:lnSpc>
-                <a:spcPct val="90000"/>
-              </a:lnSpc>
-              <a:spcBef>
-                <a:spcPts val="700"/>
-              </a:spcBef>
-              <a:buFont typeface="Arial" panose="020B0604020202020204" pitchFamily="34" charset="0"/>
-              <a:buNone/>
-              <a:defRPr sz="1400" kern="1200">
-                <a:solidFill>
-                  <a:schemeClr val="tx1"/>
-                </a:solidFill>
-                <a:latin typeface="+mn-lt"/>
-                <a:ea typeface="+mn-ea"/>
-                <a:cs typeface="+mn-cs"/>
-              </a:defRPr>
-            </a:lvl5pPr>
-            <a:lvl6pPr marL="3520440" indent="-320040" algn="l" defTabSz="1280160" rtl="0" eaLnBrk="1" latinLnBrk="0" hangingPunct="1">
-              <a:lnSpc>
-                <a:spcPct val="90000"/>
-              </a:lnSpc>
-              <a:spcBef>
-                <a:spcPts val="700"/>
-              </a:spcBef>
-              <a:buFont typeface="Arial" panose="020B0604020202020204" pitchFamily="34" charset="0"/>
-              <a:buChar char="•"/>
-              <a:defRPr sz="2520" kern="1200">
-                <a:solidFill>
-                  <a:schemeClr val="tx1"/>
-                </a:solidFill>
-                <a:latin typeface="+mn-lt"/>
-                <a:ea typeface="+mn-ea"/>
-                <a:cs typeface="+mn-cs"/>
-              </a:defRPr>
-            </a:lvl6pPr>
-            <a:lvl7pPr marL="4160520" indent="-320040" algn="l" defTabSz="1280160" rtl="0" eaLnBrk="1" latinLnBrk="0" hangingPunct="1">
-              <a:lnSpc>
-                <a:spcPct val="90000"/>
-              </a:lnSpc>
-              <a:spcBef>
-                <a:spcPts val="700"/>
-              </a:spcBef>
-              <a:buFont typeface="Arial" panose="020B0604020202020204" pitchFamily="34" charset="0"/>
-              <a:buChar char="•"/>
-              <a:defRPr sz="2520" kern="1200">
-                <a:solidFill>
-                  <a:schemeClr val="tx1"/>
-                </a:solidFill>
-                <a:latin typeface="+mn-lt"/>
-                <a:ea typeface="+mn-ea"/>
-                <a:cs typeface="+mn-cs"/>
-              </a:defRPr>
-            </a:lvl7pPr>
-            <a:lvl8pPr marL="4800600" indent="-320040" algn="l" defTabSz="1280160" rtl="0" eaLnBrk="1" latinLnBrk="0" hangingPunct="1">
-              <a:lnSpc>
-                <a:spcPct val="90000"/>
-              </a:lnSpc>
-              <a:spcBef>
-                <a:spcPts val="700"/>
-              </a:spcBef>
-              <a:buFont typeface="Arial" panose="020B0604020202020204" pitchFamily="34" charset="0"/>
-              <a:buChar char="•"/>
-              <a:defRPr sz="2520" kern="1200">
-                <a:solidFill>
-                  <a:schemeClr val="tx1"/>
-                </a:solidFill>
-                <a:latin typeface="+mn-lt"/>
-                <a:ea typeface="+mn-ea"/>
-                <a:cs typeface="+mn-cs"/>
-              </a:defRPr>
-            </a:lvl8pPr>
-            <a:lvl9pPr marL="5440680" indent="-320040" algn="l" defTabSz="1280160" rtl="0" eaLnBrk="1" latinLnBrk="0" hangingPunct="1">
-              <a:lnSpc>
-                <a:spcPct val="90000"/>
-              </a:lnSpc>
-              <a:spcBef>
-                <a:spcPts val="700"/>
-              </a:spcBef>
-              <a:buFont typeface="Arial" panose="020B0604020202020204" pitchFamily="34" charset="0"/>
-              <a:buChar char="•"/>
-              <a:defRPr sz="2520" kern="1200">
-                <a:solidFill>
-                  <a:schemeClr val="tx1"/>
-                </a:solidFill>
-                <a:latin typeface="+mn-lt"/>
-                <a:ea typeface="+mn-ea"/>
-                <a:cs typeface="+mn-cs"/>
-              </a:defRPr>
-            </a:lvl9pPr>
-          </a:lstStyle>
-          <a:p>
-            <a:r>
-              <a:rPr lang="pt-BR" sz="1600" b="1" dirty="0">
-                <a:solidFill>
-                  <a:schemeClr val="accent1">
-                    <a:lumMod val="75000"/>
-                  </a:schemeClr>
-                </a:solidFill>
-                <a:latin typeface="Arial" panose="020B0604020202020204" pitchFamily="34" charset="0"/>
-                <a:cs typeface="Arial" panose="020B0604020202020204" pitchFamily="34" charset="0"/>
-              </a:rPr>
-              <a:t>Modelo preditivo</a:t>
-            </a:r>
-          </a:p>
-          <a:p>
-            <a:r>
-              <a:rPr lang="pt-BR" sz="1200" dirty="0">
-                <a:solidFill>
-                  <a:schemeClr val="tx1"/>
-                </a:solidFill>
-                <a:latin typeface="Arial" panose="020B0604020202020204" pitchFamily="34" charset="0"/>
-                <a:cs typeface="Arial" panose="020B0604020202020204" pitchFamily="34" charset="0"/>
-              </a:rPr>
-              <a:t>Regressão Logística treinada com dados de 2006 a 2024, usando a posição final como variavel preditiva.</a:t>
-            </a:r>
-          </a:p>
-        </p:txBody>
-      </p:sp>
-      <p:sp>
-        <p:nvSpPr>
-          <p:cNvPr id="10" name="Espaço Reservado para Texto 1">
-            <a:extLst>
-              <a:ext uri="{FF2B5EF4-FFF2-40B4-BE49-F238E27FC236}">
-                <a16:creationId xmlns:a16="http://schemas.microsoft.com/office/drawing/2014/main" id="{0A70C441-77D9-7936-1F04-CB6B04935D29}"/>
-              </a:ext>
-            </a:extLst>
-          </p:cNvPr>
-          <p:cNvSpPr txBox="1">
-            <a:spLocks/>
-          </p:cNvSpPr>
-          <p:nvPr/>
-        </p:nvSpPr>
-        <p:spPr>
-          <a:xfrm>
-            <a:off x="11087100" y="4857750"/>
-            <a:ext cx="4386262" cy="3384550"/>
-          </a:xfrm>
-          <a:prstGeom prst="rect">
-            <a:avLst/>
-          </a:prstGeom>
-          <a:solidFill>
-            <a:srgbClr val="E7E6E6"/>
-          </a:solidFill>
-          <a:effectLst>
-            <a:outerShdw blurRad="215900" dist="114300" dir="2700000" algn="tl" rotWithShape="0">
-              <a:prstClr val="black">
-                <a:alpha val="76000"/>
-              </a:prstClr>
-            </a:outerShdw>
-            <a:softEdge rad="38100"/>
-          </a:effectLst>
-        </p:spPr>
-        <p:txBody>
-          <a:bodyPr lIns="72000" tIns="72000" rIns="72000" bIns="72000"/>
-          <a:lstStyle>
-            <a:lvl1pPr marL="0" indent="0" algn="l" defTabSz="1280160" rtl="0" eaLnBrk="1" latinLnBrk="0" hangingPunct="1">
-              <a:lnSpc>
-                <a:spcPct val="100000"/>
-              </a:lnSpc>
-              <a:spcBef>
-                <a:spcPts val="0"/>
-              </a:spcBef>
-              <a:spcAft>
-                <a:spcPts val="1200"/>
-              </a:spcAft>
-              <a:buFont typeface="Arial" panose="020B0604020202020204" pitchFamily="34" charset="0"/>
-              <a:buNone/>
-              <a:defRPr sz="1800" kern="1200">
-                <a:solidFill>
-                  <a:schemeClr val="tx2">
-                    <a:lumMod val="75000"/>
-                  </a:schemeClr>
-                </a:solidFill>
-                <a:latin typeface="+mn-lt"/>
-                <a:ea typeface="+mn-ea"/>
-                <a:cs typeface="+mn-cs"/>
-              </a:defRPr>
-            </a:lvl1pPr>
-            <a:lvl2pPr marL="640080" indent="0" algn="l" defTabSz="1280160" rtl="0" eaLnBrk="1" latinLnBrk="0" hangingPunct="1">
-              <a:lnSpc>
-                <a:spcPct val="90000"/>
-              </a:lnSpc>
-              <a:spcBef>
-                <a:spcPts val="700"/>
-              </a:spcBef>
-              <a:buFont typeface="Arial" panose="020B0604020202020204" pitchFamily="34" charset="0"/>
-              <a:buNone/>
-              <a:defRPr sz="1400" kern="1200">
-                <a:solidFill>
-                  <a:schemeClr val="tx1"/>
-                </a:solidFill>
-                <a:latin typeface="+mn-lt"/>
-                <a:ea typeface="+mn-ea"/>
-                <a:cs typeface="+mn-cs"/>
-              </a:defRPr>
-            </a:lvl2pPr>
-            <a:lvl3pPr marL="1280160" indent="0" algn="l" defTabSz="1280160" rtl="0" eaLnBrk="1" latinLnBrk="0" hangingPunct="1">
-              <a:lnSpc>
-                <a:spcPct val="90000"/>
-              </a:lnSpc>
-              <a:spcBef>
-                <a:spcPts val="700"/>
-              </a:spcBef>
-              <a:buFont typeface="Arial" panose="020B0604020202020204" pitchFamily="34" charset="0"/>
-              <a:buNone/>
-              <a:defRPr sz="1400" kern="1200">
-                <a:solidFill>
-                  <a:schemeClr val="tx1"/>
-                </a:solidFill>
-                <a:latin typeface="+mn-lt"/>
-                <a:ea typeface="+mn-ea"/>
-                <a:cs typeface="+mn-cs"/>
-              </a:defRPr>
-            </a:lvl3pPr>
-            <a:lvl4pPr marL="1920240" indent="0" algn="l" defTabSz="1280160" rtl="0" eaLnBrk="1" latinLnBrk="0" hangingPunct="1">
-              <a:lnSpc>
-                <a:spcPct val="90000"/>
-              </a:lnSpc>
-              <a:spcBef>
-                <a:spcPts val="700"/>
-              </a:spcBef>
-              <a:buFont typeface="Arial" panose="020B0604020202020204" pitchFamily="34" charset="0"/>
-              <a:buNone/>
-              <a:defRPr sz="1400" kern="1200">
-                <a:solidFill>
-                  <a:schemeClr val="tx1"/>
-                </a:solidFill>
-                <a:latin typeface="+mn-lt"/>
-                <a:ea typeface="+mn-ea"/>
-                <a:cs typeface="+mn-cs"/>
-              </a:defRPr>
-            </a:lvl4pPr>
-            <a:lvl5pPr marL="2560320" indent="0" algn="l" defTabSz="1280160" rtl="0" eaLnBrk="1" latinLnBrk="0" hangingPunct="1">
-              <a:lnSpc>
-                <a:spcPct val="90000"/>
-              </a:lnSpc>
-              <a:spcBef>
-                <a:spcPts val="700"/>
-              </a:spcBef>
-              <a:buFont typeface="Arial" panose="020B0604020202020204" pitchFamily="34" charset="0"/>
-              <a:buNone/>
-              <a:defRPr sz="1400" kern="1200">
-                <a:solidFill>
-                  <a:schemeClr val="tx1"/>
-                </a:solidFill>
-                <a:latin typeface="+mn-lt"/>
-                <a:ea typeface="+mn-ea"/>
-                <a:cs typeface="+mn-cs"/>
-              </a:defRPr>
-            </a:lvl5pPr>
-            <a:lvl6pPr marL="3520440" indent="-320040" algn="l" defTabSz="1280160" rtl="0" eaLnBrk="1" latinLnBrk="0" hangingPunct="1">
-              <a:lnSpc>
-                <a:spcPct val="90000"/>
-              </a:lnSpc>
-              <a:spcBef>
-                <a:spcPts val="700"/>
-              </a:spcBef>
-              <a:buFont typeface="Arial" panose="020B0604020202020204" pitchFamily="34" charset="0"/>
-              <a:buChar char="•"/>
-              <a:defRPr sz="2520" kern="1200">
-                <a:solidFill>
-                  <a:schemeClr val="tx1"/>
-                </a:solidFill>
-                <a:latin typeface="+mn-lt"/>
-                <a:ea typeface="+mn-ea"/>
-                <a:cs typeface="+mn-cs"/>
-              </a:defRPr>
-            </a:lvl6pPr>
-            <a:lvl7pPr marL="4160520" indent="-320040" algn="l" defTabSz="1280160" rtl="0" eaLnBrk="1" latinLnBrk="0" hangingPunct="1">
-              <a:lnSpc>
-                <a:spcPct val="90000"/>
-              </a:lnSpc>
-              <a:spcBef>
-                <a:spcPts val="700"/>
-              </a:spcBef>
-              <a:buFont typeface="Arial" panose="020B0604020202020204" pitchFamily="34" charset="0"/>
-              <a:buChar char="•"/>
-              <a:defRPr sz="2520" kern="1200">
-                <a:solidFill>
-                  <a:schemeClr val="tx1"/>
-                </a:solidFill>
-                <a:latin typeface="+mn-lt"/>
-                <a:ea typeface="+mn-ea"/>
-                <a:cs typeface="+mn-cs"/>
-              </a:defRPr>
-            </a:lvl7pPr>
-            <a:lvl8pPr marL="4800600" indent="-320040" algn="l" defTabSz="1280160" rtl="0" eaLnBrk="1" latinLnBrk="0" hangingPunct="1">
-              <a:lnSpc>
-                <a:spcPct val="90000"/>
-              </a:lnSpc>
-              <a:spcBef>
-                <a:spcPts val="700"/>
-              </a:spcBef>
-              <a:buFont typeface="Arial" panose="020B0604020202020204" pitchFamily="34" charset="0"/>
-              <a:buChar char="•"/>
-              <a:defRPr sz="2520" kern="1200">
-                <a:solidFill>
-                  <a:schemeClr val="tx1"/>
-                </a:solidFill>
-                <a:latin typeface="+mn-lt"/>
-                <a:ea typeface="+mn-ea"/>
-                <a:cs typeface="+mn-cs"/>
-              </a:defRPr>
-            </a:lvl8pPr>
-            <a:lvl9pPr marL="5440680" indent="-320040" algn="l" defTabSz="1280160" rtl="0" eaLnBrk="1" latinLnBrk="0" hangingPunct="1">
-              <a:lnSpc>
-                <a:spcPct val="90000"/>
-              </a:lnSpc>
-              <a:spcBef>
-                <a:spcPts val="700"/>
-              </a:spcBef>
-              <a:buFont typeface="Arial" panose="020B0604020202020204" pitchFamily="34" charset="0"/>
-              <a:buChar char="•"/>
-              <a:defRPr sz="2520" kern="1200">
-                <a:solidFill>
-                  <a:schemeClr val="tx1"/>
-                </a:solidFill>
-                <a:latin typeface="+mn-lt"/>
-                <a:ea typeface="+mn-ea"/>
-                <a:cs typeface="+mn-cs"/>
-              </a:defRPr>
-            </a:lvl9pPr>
-          </a:lstStyle>
-          <a:p>
-            <a:r>
-              <a:rPr lang="pt-BR" sz="1600" b="1" dirty="0">
-                <a:solidFill>
-                  <a:schemeClr val="accent1">
-                    <a:lumMod val="75000"/>
-                  </a:schemeClr>
-                </a:solidFill>
-                <a:latin typeface="Arial" panose="020B0604020202020204" pitchFamily="34" charset="0"/>
-                <a:cs typeface="Arial" panose="020B0604020202020204" pitchFamily="34" charset="0"/>
-              </a:rPr>
-              <a:t>Dashboard</a:t>
-            </a:r>
-          </a:p>
-          <a:p>
-            <a:r>
-              <a:rPr lang="pt-BR" sz="1200" dirty="0">
-                <a:solidFill>
-                  <a:schemeClr val="tx1"/>
-                </a:solidFill>
-                <a:latin typeface="Arial" panose="020B0604020202020204" pitchFamily="34" charset="0"/>
-                <a:cs typeface="Arial" panose="020B0604020202020204" pitchFamily="34" charset="0"/>
-              </a:rPr>
-              <a:t>KPIs e visualizações disponíveis no Tableu Public, alimentados pela base analítica do projeto.</a:t>
             </a:r>
           </a:p>
         </p:txBody>

</xml_diff>

<commit_message>
feat: esboçõs dos slides
</commit_message>
<xml_diff>
--- a/docs/Template - Fase 2 - Apresentação Executiva - Projeto em Business Intelligence e Analytics.pptx
+++ b/docs/Template - Fase 2 - Apresentação Executiva - Projeto em Business Intelligence e Analytics.pptx
@@ -5567,7 +5567,7 @@
                 <a:latin typeface="Arial" panose="020B0604020202020204" pitchFamily="34" charset="0"/>
                 <a:cs typeface="Arial" panose="020B0604020202020204" pitchFamily="34" charset="0"/>
               </a:rPr>
-              <a:t>Objetivo geral</a:t>
+              <a:t>Pipeline da solução</a:t>
             </a:r>
             <a:endParaRPr lang="pt-BR" sz="1600" b="1" dirty="0">
               <a:solidFill>
@@ -5578,15 +5578,263 @@
             </a:endParaRPr>
           </a:p>
           <a:p>
+            <a:endParaRPr lang="pt-BR" sz="1200" dirty="0">
+              <a:solidFill>
+                <a:schemeClr val="tx1"/>
+              </a:solidFill>
+              <a:latin typeface="Arial" panose="020B0604020202020204" pitchFamily="34" charset="0"/>
+              <a:cs typeface="Arial" panose="020B0604020202020204" pitchFamily="34" charset="0"/>
+            </a:endParaRPr>
+          </a:p>
+        </p:txBody>
+      </p:sp>
+      <p:pic>
+        <p:nvPicPr>
+          <p:cNvPr id="7" name="Imagem 6">
+            <a:extLst>
+              <a:ext uri="{FF2B5EF4-FFF2-40B4-BE49-F238E27FC236}">
+                <a16:creationId xmlns:a16="http://schemas.microsoft.com/office/drawing/2014/main" id="{D5840391-6E96-1BF7-34E3-A17387148677}"/>
+              </a:ext>
+            </a:extLst>
+          </p:cNvPr>
+          <p:cNvPicPr>
+            <a:picLocks noChangeAspect="1"/>
+          </p:cNvPicPr>
+          <p:nvPr/>
+        </p:nvPicPr>
+        <p:blipFill>
+          <a:blip r:embed="rId3"/>
+          <a:stretch>
+            <a:fillRect/>
+          </a:stretch>
+        </p:blipFill>
+        <p:spPr>
+          <a:xfrm>
+            <a:off x="928688" y="4370466"/>
+            <a:ext cx="3430905" cy="4288631"/>
+          </a:xfrm>
+          <a:prstGeom prst="rect">
+            <a:avLst/>
+          </a:prstGeom>
+        </p:spPr>
+      </p:pic>
+      <p:sp>
+        <p:nvSpPr>
+          <p:cNvPr id="11" name="Espaço Reservado para Texto 1">
+            <a:extLst>
+              <a:ext uri="{FF2B5EF4-FFF2-40B4-BE49-F238E27FC236}">
+                <a16:creationId xmlns:a16="http://schemas.microsoft.com/office/drawing/2014/main" id="{2A37608E-33FB-922F-A7A3-B4F0D3B99BEF}"/>
+              </a:ext>
+            </a:extLst>
+          </p:cNvPr>
+          <p:cNvSpPr txBox="1">
+            <a:spLocks/>
+          </p:cNvSpPr>
+          <p:nvPr/>
+        </p:nvSpPr>
+        <p:spPr>
+          <a:xfrm>
+            <a:off x="4535487" y="4425157"/>
+            <a:ext cx="7506971" cy="4233939"/>
+          </a:xfrm>
+          <a:prstGeom prst="rect">
+            <a:avLst/>
+          </a:prstGeom>
+          <a:solidFill>
+            <a:schemeClr val="bg2"/>
+          </a:solidFill>
+          <a:effectLst>
+            <a:outerShdw blurRad="215900" dist="114300" dir="2700000" algn="tl" rotWithShape="0">
+              <a:prstClr val="black">
+                <a:alpha val="76000"/>
+              </a:prstClr>
+            </a:outerShdw>
+            <a:softEdge rad="38100"/>
+          </a:effectLst>
+        </p:spPr>
+        <p:txBody>
+          <a:bodyPr lIns="72000" tIns="72000" rIns="72000" bIns="72000"/>
+          <a:lstStyle>
+            <a:lvl1pPr marL="0" indent="0" algn="l" defTabSz="1280160" rtl="0" eaLnBrk="1" latinLnBrk="0" hangingPunct="1">
+              <a:lnSpc>
+                <a:spcPct val="100000"/>
+              </a:lnSpc>
+              <a:spcBef>
+                <a:spcPts val="0"/>
+              </a:spcBef>
+              <a:spcAft>
+                <a:spcPts val="1200"/>
+              </a:spcAft>
+              <a:buFont typeface="Arial" panose="020B0604020202020204" pitchFamily="34" charset="0"/>
+              <a:buNone/>
+              <a:defRPr sz="1800" kern="1200">
+                <a:solidFill>
+                  <a:schemeClr val="tx2">
+                    <a:lumMod val="75000"/>
+                  </a:schemeClr>
+                </a:solidFill>
+                <a:latin typeface="+mn-lt"/>
+                <a:ea typeface="+mn-ea"/>
+                <a:cs typeface="+mn-cs"/>
+              </a:defRPr>
+            </a:lvl1pPr>
+            <a:lvl2pPr marL="640080" indent="0" algn="l" defTabSz="1280160" rtl="0" eaLnBrk="1" latinLnBrk="0" hangingPunct="1">
+              <a:lnSpc>
+                <a:spcPct val="90000"/>
+              </a:lnSpc>
+              <a:spcBef>
+                <a:spcPts val="700"/>
+              </a:spcBef>
+              <a:buFont typeface="Arial" panose="020B0604020202020204" pitchFamily="34" charset="0"/>
+              <a:buNone/>
+              <a:defRPr sz="1400" kern="1200">
+                <a:solidFill>
+                  <a:schemeClr val="tx1"/>
+                </a:solidFill>
+                <a:latin typeface="+mn-lt"/>
+                <a:ea typeface="+mn-ea"/>
+                <a:cs typeface="+mn-cs"/>
+              </a:defRPr>
+            </a:lvl2pPr>
+            <a:lvl3pPr marL="1280160" indent="0" algn="l" defTabSz="1280160" rtl="0" eaLnBrk="1" latinLnBrk="0" hangingPunct="1">
+              <a:lnSpc>
+                <a:spcPct val="90000"/>
+              </a:lnSpc>
+              <a:spcBef>
+                <a:spcPts val="700"/>
+              </a:spcBef>
+              <a:buFont typeface="Arial" panose="020B0604020202020204" pitchFamily="34" charset="0"/>
+              <a:buNone/>
+              <a:defRPr sz="1400" kern="1200">
+                <a:solidFill>
+                  <a:schemeClr val="tx1"/>
+                </a:solidFill>
+                <a:latin typeface="+mn-lt"/>
+                <a:ea typeface="+mn-ea"/>
+                <a:cs typeface="+mn-cs"/>
+              </a:defRPr>
+            </a:lvl3pPr>
+            <a:lvl4pPr marL="1920240" indent="0" algn="l" defTabSz="1280160" rtl="0" eaLnBrk="1" latinLnBrk="0" hangingPunct="1">
+              <a:lnSpc>
+                <a:spcPct val="90000"/>
+              </a:lnSpc>
+              <a:spcBef>
+                <a:spcPts val="700"/>
+              </a:spcBef>
+              <a:buFont typeface="Arial" panose="020B0604020202020204" pitchFamily="34" charset="0"/>
+              <a:buNone/>
+              <a:defRPr sz="1400" kern="1200">
+                <a:solidFill>
+                  <a:schemeClr val="tx1"/>
+                </a:solidFill>
+                <a:latin typeface="+mn-lt"/>
+                <a:ea typeface="+mn-ea"/>
+                <a:cs typeface="+mn-cs"/>
+              </a:defRPr>
+            </a:lvl4pPr>
+            <a:lvl5pPr marL="2560320" indent="0" algn="l" defTabSz="1280160" rtl="0" eaLnBrk="1" latinLnBrk="0" hangingPunct="1">
+              <a:lnSpc>
+                <a:spcPct val="90000"/>
+              </a:lnSpc>
+              <a:spcBef>
+                <a:spcPts val="700"/>
+              </a:spcBef>
+              <a:buFont typeface="Arial" panose="020B0604020202020204" pitchFamily="34" charset="0"/>
+              <a:buNone/>
+              <a:defRPr sz="1400" kern="1200">
+                <a:solidFill>
+                  <a:schemeClr val="tx1"/>
+                </a:solidFill>
+                <a:latin typeface="+mn-lt"/>
+                <a:ea typeface="+mn-ea"/>
+                <a:cs typeface="+mn-cs"/>
+              </a:defRPr>
+            </a:lvl5pPr>
+            <a:lvl6pPr marL="3520440" indent="-320040" algn="l" defTabSz="1280160" rtl="0" eaLnBrk="1" latinLnBrk="0" hangingPunct="1">
+              <a:lnSpc>
+                <a:spcPct val="90000"/>
+              </a:lnSpc>
+              <a:spcBef>
+                <a:spcPts val="700"/>
+              </a:spcBef>
+              <a:buFont typeface="Arial" panose="020B0604020202020204" pitchFamily="34" charset="0"/>
+              <a:buChar char="•"/>
+              <a:defRPr sz="2520" kern="1200">
+                <a:solidFill>
+                  <a:schemeClr val="tx1"/>
+                </a:solidFill>
+                <a:latin typeface="+mn-lt"/>
+                <a:ea typeface="+mn-ea"/>
+                <a:cs typeface="+mn-cs"/>
+              </a:defRPr>
+            </a:lvl6pPr>
+            <a:lvl7pPr marL="4160520" indent="-320040" algn="l" defTabSz="1280160" rtl="0" eaLnBrk="1" latinLnBrk="0" hangingPunct="1">
+              <a:lnSpc>
+                <a:spcPct val="90000"/>
+              </a:lnSpc>
+              <a:spcBef>
+                <a:spcPts val="700"/>
+              </a:spcBef>
+              <a:buFont typeface="Arial" panose="020B0604020202020204" pitchFamily="34" charset="0"/>
+              <a:buChar char="•"/>
+              <a:defRPr sz="2520" kern="1200">
+                <a:solidFill>
+                  <a:schemeClr val="tx1"/>
+                </a:solidFill>
+                <a:latin typeface="+mn-lt"/>
+                <a:ea typeface="+mn-ea"/>
+                <a:cs typeface="+mn-cs"/>
+              </a:defRPr>
+            </a:lvl7pPr>
+            <a:lvl8pPr marL="4800600" indent="-320040" algn="l" defTabSz="1280160" rtl="0" eaLnBrk="1" latinLnBrk="0" hangingPunct="1">
+              <a:lnSpc>
+                <a:spcPct val="90000"/>
+              </a:lnSpc>
+              <a:spcBef>
+                <a:spcPts val="700"/>
+              </a:spcBef>
+              <a:buFont typeface="Arial" panose="020B0604020202020204" pitchFamily="34" charset="0"/>
+              <a:buChar char="•"/>
+              <a:defRPr sz="2520" kern="1200">
+                <a:solidFill>
+                  <a:schemeClr val="tx1"/>
+                </a:solidFill>
+                <a:latin typeface="+mn-lt"/>
+                <a:ea typeface="+mn-ea"/>
+                <a:cs typeface="+mn-cs"/>
+              </a:defRPr>
+            </a:lvl8pPr>
+            <a:lvl9pPr marL="5440680" indent="-320040" algn="l" defTabSz="1280160" rtl="0" eaLnBrk="1" latinLnBrk="0" hangingPunct="1">
+              <a:lnSpc>
+                <a:spcPct val="90000"/>
+              </a:lnSpc>
+              <a:spcBef>
+                <a:spcPts val="700"/>
+              </a:spcBef>
+              <a:buFont typeface="Arial" panose="020B0604020202020204" pitchFamily="34" charset="0"/>
+              <a:buChar char="•"/>
+              <a:defRPr sz="2520" kern="1200">
+                <a:solidFill>
+                  <a:schemeClr val="tx1"/>
+                </a:solidFill>
+                <a:latin typeface="+mn-lt"/>
+                <a:ea typeface="+mn-ea"/>
+                <a:cs typeface="+mn-cs"/>
+              </a:defRPr>
+            </a:lvl9pPr>
+          </a:lstStyle>
+          <a:p>
             <a:r>
-              <a:rPr lang="pt-BR" sz="1200" dirty="0">
-                <a:solidFill>
-                  <a:schemeClr val="tx1"/>
+              <a:rPr lang="pt-BR" sz="1600" b="1" dirty="0">
+                <a:solidFill>
+                  <a:schemeClr val="accent1">
+                    <a:lumMod val="75000"/>
+                  </a:schemeClr>
                 </a:solidFill>
                 <a:latin typeface="Arial" panose="020B0604020202020204" pitchFamily="34" charset="0"/>
                 <a:cs typeface="Arial" panose="020B0604020202020204" pitchFamily="34" charset="0"/>
               </a:rPr>
-              <a:t>Transformar dados de desempenho clube-temporada em um indicador preditivo de risco de rebaixamento, apresentado por meio de uma solução de BI e Analytics.</a:t>
+              <a:t>Algum texto vai vir aqui</a:t>
             </a:r>
           </a:p>
         </p:txBody>

</xml_diff>

<commit_message>
feat: melhorias no primeiro slide, fonte a definir
</commit_message>
<xml_diff>
--- a/docs/Template - Fase 2 - Apresentação Executiva - Projeto em Business Intelligence e Analytics.pptx
+++ b/docs/Template - Fase 2 - Apresentação Executiva - Projeto em Business Intelligence e Analytics.pptx
@@ -1355,7 +1355,7 @@
           <a:p>
             <a:fld id="{22D2343C-BD3C-4650-924C-40706B7DFBCE}" type="datetimeFigureOut">
               <a:rPr lang="pt-BR" smtClean="0"/>
-              <a:t>03/09/2026</a:t>
+              <a:t>04/09/2026</a:t>
             </a:fld>
             <a:endParaRPr lang="pt-BR"/>
           </a:p>
@@ -1532,7 +1532,7 @@
           <a:p>
             <a:fld id="{35FDBEBC-B96E-46E8-8EEF-3A4138A33DC3}" type="datetimeFigureOut">
               <a:rPr lang="pt-BR" smtClean="0"/>
-              <a:t>03/09/2026</a:t>
+              <a:t>04/09/2026</a:t>
             </a:fld>
             <a:endParaRPr lang="pt-BR"/>
           </a:p>
@@ -3859,7 +3859,7 @@
         </p:nvSpPr>
         <p:spPr>
           <a:xfrm>
-            <a:off x="928688" y="2041451"/>
+            <a:off x="928688" y="2666852"/>
             <a:ext cx="14544674" cy="928007"/>
           </a:xfrm>
           <a:prstGeom prst="rect">
@@ -4039,6 +4039,7 @@
             </a:lvl9pPr>
           </a:lstStyle>
           <a:p>
+            <a:pPr algn="ctr"/>
             <a:r>
               <a:rPr lang="pt-BR" sz="1600" b="1" dirty="0">
                 <a:solidFill>
@@ -4053,6 +4054,7 @@
             </a:r>
           </a:p>
           <a:p>
+            <a:pPr algn="ctr"/>
             <a:r>
               <a:rPr lang="pt-BR" sz="1200" dirty="0">
                 <a:solidFill>
@@ -4091,7 +4093,7 @@
         </p:nvSpPr>
         <p:spPr>
           <a:xfrm>
-            <a:off x="928688" y="3099443"/>
+            <a:off x="928688" y="4463258"/>
             <a:ext cx="14544674" cy="625401"/>
           </a:xfrm>
           <a:prstGeom prst="rect">
@@ -4271,6 +4273,7 @@
             </a:lvl9pPr>
           </a:lstStyle>
           <a:p>
+            <a:pPr algn="ctr"/>
             <a:r>
               <a:rPr lang="pt-BR" sz="1600" b="1" dirty="0">
                 <a:solidFill>
@@ -4292,6 +4295,7 @@
             </a:endParaRPr>
           </a:p>
           <a:p>
+            <a:pPr algn="ctr"/>
             <a:r>
               <a:rPr lang="pt-BR" sz="1200" dirty="0">
                 <a:solidFill>
@@ -4321,8 +4325,8 @@
         </p:nvSpPr>
         <p:spPr>
           <a:xfrm>
-            <a:off x="928688" y="4857750"/>
-            <a:ext cx="4386262" cy="3384550"/>
+            <a:off x="928688" y="6076043"/>
+            <a:ext cx="4386262" cy="2109107"/>
           </a:xfrm>
           <a:prstGeom prst="rect">
             <a:avLst/>
@@ -4511,39 +4515,24 @@
             </a:lvl9pPr>
           </a:lstStyle>
           <a:p>
-            <a:r>
-              <a:rPr lang="pt-BR" sz="1600" b="1" dirty="0">
-                <a:solidFill>
-                  <a:schemeClr val="accent1">
-                    <a:lumMod val="75000"/>
-                  </a:schemeClr>
-                </a:solidFill>
-                <a:latin typeface="Arial" panose="020B0604020202020204" pitchFamily="34" charset="0"/>
-                <a:cs typeface="Arial" panose="020B0604020202020204" pitchFamily="34" charset="0"/>
-              </a:rPr>
-              <a:t>Indicador de risco por clube</a:t>
-            </a:r>
-          </a:p>
-          <a:p>
-            <a:r>
-              <a:rPr lang="pt-BR" sz="1200" dirty="0">
-                <a:solidFill>
-                  <a:schemeClr val="tx1"/>
-                </a:solidFill>
-                <a:latin typeface="Arial" panose="020B0604020202020204" pitchFamily="34" charset="0"/>
-                <a:cs typeface="Arial" panose="020B0604020202020204" pitchFamily="34" charset="0"/>
-              </a:rPr>
-              <a:t>Probabilidade de rebaixamente calculada para cada um dos 20 clubes de Série A na temporada 2025</a:t>
-            </a:r>
+            <a:endParaRPr lang="pt-BR" sz="1600" b="1" dirty="0">
+              <a:solidFill>
+                <a:schemeClr val="accent1">
+                  <a:lumMod val="75000"/>
+                </a:schemeClr>
+              </a:solidFill>
+              <a:latin typeface="Arial" panose="020B0604020202020204" pitchFamily="34" charset="0"/>
+              <a:cs typeface="Arial" panose="020B0604020202020204" pitchFamily="34" charset="0"/>
+            </a:endParaRPr>
           </a:p>
         </p:txBody>
       </p:sp>
       <p:sp>
         <p:nvSpPr>
-          <p:cNvPr id="14" name="Espaço Reservado para Texto 1">
+          <p:cNvPr id="6" name="Espaço Reservado para Texto 1">
             <a:extLst>
               <a:ext uri="{FF2B5EF4-FFF2-40B4-BE49-F238E27FC236}">
-                <a16:creationId xmlns:a16="http://schemas.microsoft.com/office/drawing/2014/main" id="{DB4D9200-5628-6FBA-5821-660DD3FEC148}"/>
+                <a16:creationId xmlns:a16="http://schemas.microsoft.com/office/drawing/2014/main" id="{EBDC9E87-DD7A-4D29-92DA-F418FD785941}"/>
               </a:ext>
             </a:extLst>
           </p:cNvPr>
@@ -4554,23 +4543,13 @@
         </p:nvSpPr>
         <p:spPr>
           <a:xfrm>
-            <a:off x="6007894" y="4857750"/>
-            <a:ext cx="4386262" cy="3384550"/>
+            <a:off x="1680487" y="6305840"/>
+            <a:ext cx="2882664" cy="421714"/>
           </a:xfrm>
           <a:prstGeom prst="rect">
             <a:avLst/>
           </a:prstGeom>
-          <a:solidFill>
-            <a:srgbClr val="E7E6E6"/>
-          </a:solidFill>
-          <a:effectLst>
-            <a:outerShdw blurRad="215900" dist="114300" dir="2700000" algn="ctr" rotWithShape="0">
-              <a:srgbClr val="000000">
-                <a:alpha val="76000"/>
-              </a:srgbClr>
-            </a:outerShdw>
-            <a:softEdge rad="38100"/>
-          </a:effectLst>
+          <a:noFill/>
         </p:spPr>
         <p:txBody>
           <a:bodyPr lIns="72000" tIns="72000" rIns="72000" bIns="72000"/>
@@ -4754,29 +4733,17 @@
                 <a:latin typeface="Arial" panose="020B0604020202020204" pitchFamily="34" charset="0"/>
                 <a:cs typeface="Arial" panose="020B0604020202020204" pitchFamily="34" charset="0"/>
               </a:rPr>
-              <a:t>Modelo preditivo</a:t>
-            </a:r>
-          </a:p>
-          <a:p>
-            <a:r>
-              <a:rPr lang="pt-BR" sz="1200" dirty="0">
-                <a:solidFill>
-                  <a:schemeClr val="tx1"/>
-                </a:solidFill>
-                <a:latin typeface="Arial" panose="020B0604020202020204" pitchFamily="34" charset="0"/>
-                <a:cs typeface="Arial" panose="020B0604020202020204" pitchFamily="34" charset="0"/>
-              </a:rPr>
-              <a:t>Regressão Logística treinada com dados de 2006 a 2024, usando a posição final como variavel preditiva.</a:t>
+              <a:t>Indicador de risco por clube</a:t>
             </a:r>
           </a:p>
         </p:txBody>
       </p:sp>
       <p:sp>
         <p:nvSpPr>
-          <p:cNvPr id="16" name="Espaço Reservado para Texto 1">
+          <p:cNvPr id="8" name="Espaço Reservado para Texto 1">
             <a:extLst>
               <a:ext uri="{FF2B5EF4-FFF2-40B4-BE49-F238E27FC236}">
-                <a16:creationId xmlns:a16="http://schemas.microsoft.com/office/drawing/2014/main" id="{845B4D45-0372-7978-3BC3-CE4D168D1777}"/>
+                <a16:creationId xmlns:a16="http://schemas.microsoft.com/office/drawing/2014/main" id="{569BB56C-4C80-B1BD-0E6E-2B88BCBB3208}"/>
               </a:ext>
             </a:extLst>
           </p:cNvPr>
@@ -4787,14 +4754,224 @@
         </p:nvSpPr>
         <p:spPr>
           <a:xfrm>
-            <a:off x="11087100" y="4857750"/>
-            <a:ext cx="4386262" cy="3384550"/>
+            <a:off x="1680487" y="6854571"/>
+            <a:ext cx="2882664" cy="759206"/>
+          </a:xfrm>
+          <a:prstGeom prst="rect">
+            <a:avLst/>
+          </a:prstGeom>
+          <a:noFill/>
+        </p:spPr>
+        <p:txBody>
+          <a:bodyPr lIns="72000" tIns="72000" rIns="72000" bIns="72000"/>
+          <a:lstStyle>
+            <a:lvl1pPr marL="0" indent="0" algn="l" defTabSz="1280160" rtl="0" eaLnBrk="1" latinLnBrk="0" hangingPunct="1">
+              <a:lnSpc>
+                <a:spcPct val="100000"/>
+              </a:lnSpc>
+              <a:spcBef>
+                <a:spcPts val="0"/>
+              </a:spcBef>
+              <a:spcAft>
+                <a:spcPts val="1200"/>
+              </a:spcAft>
+              <a:buFont typeface="Arial" panose="020B0604020202020204" pitchFamily="34" charset="0"/>
+              <a:buNone/>
+              <a:defRPr sz="1800" kern="1200">
+                <a:solidFill>
+                  <a:schemeClr val="tx2">
+                    <a:lumMod val="75000"/>
+                  </a:schemeClr>
+                </a:solidFill>
+                <a:latin typeface="+mn-lt"/>
+                <a:ea typeface="+mn-ea"/>
+                <a:cs typeface="+mn-cs"/>
+              </a:defRPr>
+            </a:lvl1pPr>
+            <a:lvl2pPr marL="640080" indent="0" algn="l" defTabSz="1280160" rtl="0" eaLnBrk="1" latinLnBrk="0" hangingPunct="1">
+              <a:lnSpc>
+                <a:spcPct val="90000"/>
+              </a:lnSpc>
+              <a:spcBef>
+                <a:spcPts val="700"/>
+              </a:spcBef>
+              <a:buFont typeface="Arial" panose="020B0604020202020204" pitchFamily="34" charset="0"/>
+              <a:buNone/>
+              <a:defRPr sz="1400" kern="1200">
+                <a:solidFill>
+                  <a:schemeClr val="tx1"/>
+                </a:solidFill>
+                <a:latin typeface="+mn-lt"/>
+                <a:ea typeface="+mn-ea"/>
+                <a:cs typeface="+mn-cs"/>
+              </a:defRPr>
+            </a:lvl2pPr>
+            <a:lvl3pPr marL="1280160" indent="0" algn="l" defTabSz="1280160" rtl="0" eaLnBrk="1" latinLnBrk="0" hangingPunct="1">
+              <a:lnSpc>
+                <a:spcPct val="90000"/>
+              </a:lnSpc>
+              <a:spcBef>
+                <a:spcPts val="700"/>
+              </a:spcBef>
+              <a:buFont typeface="Arial" panose="020B0604020202020204" pitchFamily="34" charset="0"/>
+              <a:buNone/>
+              <a:defRPr sz="1400" kern="1200">
+                <a:solidFill>
+                  <a:schemeClr val="tx1"/>
+                </a:solidFill>
+                <a:latin typeface="+mn-lt"/>
+                <a:ea typeface="+mn-ea"/>
+                <a:cs typeface="+mn-cs"/>
+              </a:defRPr>
+            </a:lvl3pPr>
+            <a:lvl4pPr marL="1920240" indent="0" algn="l" defTabSz="1280160" rtl="0" eaLnBrk="1" latinLnBrk="0" hangingPunct="1">
+              <a:lnSpc>
+                <a:spcPct val="90000"/>
+              </a:lnSpc>
+              <a:spcBef>
+                <a:spcPts val="700"/>
+              </a:spcBef>
+              <a:buFont typeface="Arial" panose="020B0604020202020204" pitchFamily="34" charset="0"/>
+              <a:buNone/>
+              <a:defRPr sz="1400" kern="1200">
+                <a:solidFill>
+                  <a:schemeClr val="tx1"/>
+                </a:solidFill>
+                <a:latin typeface="+mn-lt"/>
+                <a:ea typeface="+mn-ea"/>
+                <a:cs typeface="+mn-cs"/>
+              </a:defRPr>
+            </a:lvl4pPr>
+            <a:lvl5pPr marL="2560320" indent="0" algn="l" defTabSz="1280160" rtl="0" eaLnBrk="1" latinLnBrk="0" hangingPunct="1">
+              <a:lnSpc>
+                <a:spcPct val="90000"/>
+              </a:lnSpc>
+              <a:spcBef>
+                <a:spcPts val="700"/>
+              </a:spcBef>
+              <a:buFont typeface="Arial" panose="020B0604020202020204" pitchFamily="34" charset="0"/>
+              <a:buNone/>
+              <a:defRPr sz="1400" kern="1200">
+                <a:solidFill>
+                  <a:schemeClr val="tx1"/>
+                </a:solidFill>
+                <a:latin typeface="+mn-lt"/>
+                <a:ea typeface="+mn-ea"/>
+                <a:cs typeface="+mn-cs"/>
+              </a:defRPr>
+            </a:lvl5pPr>
+            <a:lvl6pPr marL="3520440" indent="-320040" algn="l" defTabSz="1280160" rtl="0" eaLnBrk="1" latinLnBrk="0" hangingPunct="1">
+              <a:lnSpc>
+                <a:spcPct val="90000"/>
+              </a:lnSpc>
+              <a:spcBef>
+                <a:spcPts val="700"/>
+              </a:spcBef>
+              <a:buFont typeface="Arial" panose="020B0604020202020204" pitchFamily="34" charset="0"/>
+              <a:buChar char="•"/>
+              <a:defRPr sz="2520" kern="1200">
+                <a:solidFill>
+                  <a:schemeClr val="tx1"/>
+                </a:solidFill>
+                <a:latin typeface="+mn-lt"/>
+                <a:ea typeface="+mn-ea"/>
+                <a:cs typeface="+mn-cs"/>
+              </a:defRPr>
+            </a:lvl6pPr>
+            <a:lvl7pPr marL="4160520" indent="-320040" algn="l" defTabSz="1280160" rtl="0" eaLnBrk="1" latinLnBrk="0" hangingPunct="1">
+              <a:lnSpc>
+                <a:spcPct val="90000"/>
+              </a:lnSpc>
+              <a:spcBef>
+                <a:spcPts val="700"/>
+              </a:spcBef>
+              <a:buFont typeface="Arial" panose="020B0604020202020204" pitchFamily="34" charset="0"/>
+              <a:buChar char="•"/>
+              <a:defRPr sz="2520" kern="1200">
+                <a:solidFill>
+                  <a:schemeClr val="tx1"/>
+                </a:solidFill>
+                <a:latin typeface="+mn-lt"/>
+                <a:ea typeface="+mn-ea"/>
+                <a:cs typeface="+mn-cs"/>
+              </a:defRPr>
+            </a:lvl7pPr>
+            <a:lvl8pPr marL="4800600" indent="-320040" algn="l" defTabSz="1280160" rtl="0" eaLnBrk="1" latinLnBrk="0" hangingPunct="1">
+              <a:lnSpc>
+                <a:spcPct val="90000"/>
+              </a:lnSpc>
+              <a:spcBef>
+                <a:spcPts val="700"/>
+              </a:spcBef>
+              <a:buFont typeface="Arial" panose="020B0604020202020204" pitchFamily="34" charset="0"/>
+              <a:buChar char="•"/>
+              <a:defRPr sz="2520" kern="1200">
+                <a:solidFill>
+                  <a:schemeClr val="tx1"/>
+                </a:solidFill>
+                <a:latin typeface="+mn-lt"/>
+                <a:ea typeface="+mn-ea"/>
+                <a:cs typeface="+mn-cs"/>
+              </a:defRPr>
+            </a:lvl8pPr>
+            <a:lvl9pPr marL="5440680" indent="-320040" algn="l" defTabSz="1280160" rtl="0" eaLnBrk="1" latinLnBrk="0" hangingPunct="1">
+              <a:lnSpc>
+                <a:spcPct val="90000"/>
+              </a:lnSpc>
+              <a:spcBef>
+                <a:spcPts val="700"/>
+              </a:spcBef>
+              <a:buFont typeface="Arial" panose="020B0604020202020204" pitchFamily="34" charset="0"/>
+              <a:buChar char="•"/>
+              <a:defRPr sz="2520" kern="1200">
+                <a:solidFill>
+                  <a:schemeClr val="tx1"/>
+                </a:solidFill>
+                <a:latin typeface="+mn-lt"/>
+                <a:ea typeface="+mn-ea"/>
+                <a:cs typeface="+mn-cs"/>
+              </a:defRPr>
+            </a:lvl9pPr>
+          </a:lstStyle>
+          <a:p>
+            <a:pPr algn="ctr"/>
+            <a:r>
+              <a:rPr lang="pt-BR" sz="1200" dirty="0">
+                <a:solidFill>
+                  <a:schemeClr val="tx1"/>
+                </a:solidFill>
+                <a:latin typeface="Arial" panose="020B0604020202020204" pitchFamily="34" charset="0"/>
+                <a:cs typeface="Arial" panose="020B0604020202020204" pitchFamily="34" charset="0"/>
+              </a:rPr>
+              <a:t>Probabilidade de rebaixamento calculada para cada um dos 20 clubes da Série A na temporada de 2025</a:t>
+            </a:r>
+          </a:p>
+        </p:txBody>
+      </p:sp>
+      <p:sp>
+        <p:nvSpPr>
+          <p:cNvPr id="13" name="Espaço Reservado para Texto 1">
+            <a:extLst>
+              <a:ext uri="{FF2B5EF4-FFF2-40B4-BE49-F238E27FC236}">
+                <a16:creationId xmlns:a16="http://schemas.microsoft.com/office/drawing/2014/main" id="{4F9DD5DE-18D1-0B86-2969-4C3E8ABC928B}"/>
+              </a:ext>
+            </a:extLst>
+          </p:cNvPr>
+          <p:cNvSpPr txBox="1">
+            <a:spLocks/>
+          </p:cNvSpPr>
+          <p:nvPr/>
+        </p:nvSpPr>
+        <p:spPr>
+          <a:xfrm>
+            <a:off x="6007894" y="6076043"/>
+            <a:ext cx="4386262" cy="2109107"/>
           </a:xfrm>
           <a:prstGeom prst="rect">
             <a:avLst/>
           </a:prstGeom>
           <a:solidFill>
-            <a:srgbClr val="E7E6E6"/>
+            <a:schemeClr val="bg2"/>
           </a:solidFill>
           <a:effectLst>
             <a:outerShdw blurRad="215900" dist="114300" dir="2700000" algn="tl" rotWithShape="0">
@@ -4977,6 +5154,645 @@
             </a:lvl9pPr>
           </a:lstStyle>
           <a:p>
+            <a:endParaRPr lang="pt-BR" sz="1600" b="1" dirty="0">
+              <a:solidFill>
+                <a:schemeClr val="accent1">
+                  <a:lumMod val="75000"/>
+                </a:schemeClr>
+              </a:solidFill>
+              <a:latin typeface="Arial" panose="020B0604020202020204" pitchFamily="34" charset="0"/>
+              <a:cs typeface="Arial" panose="020B0604020202020204" pitchFamily="34" charset="0"/>
+            </a:endParaRPr>
+          </a:p>
+        </p:txBody>
+      </p:sp>
+      <p:sp>
+        <p:nvSpPr>
+          <p:cNvPr id="17" name="Espaço Reservado para Texto 1">
+            <a:extLst>
+              <a:ext uri="{FF2B5EF4-FFF2-40B4-BE49-F238E27FC236}">
+                <a16:creationId xmlns:a16="http://schemas.microsoft.com/office/drawing/2014/main" id="{F23F6F5F-9970-72F5-152A-8E786A5DAC62}"/>
+              </a:ext>
+            </a:extLst>
+          </p:cNvPr>
+          <p:cNvSpPr txBox="1">
+            <a:spLocks/>
+          </p:cNvSpPr>
+          <p:nvPr/>
+        </p:nvSpPr>
+        <p:spPr>
+          <a:xfrm>
+            <a:off x="6759693" y="6305840"/>
+            <a:ext cx="2882664" cy="421714"/>
+          </a:xfrm>
+          <a:prstGeom prst="rect">
+            <a:avLst/>
+          </a:prstGeom>
+          <a:noFill/>
+        </p:spPr>
+        <p:txBody>
+          <a:bodyPr lIns="72000" tIns="72000" rIns="72000" bIns="72000"/>
+          <a:lstStyle>
+            <a:lvl1pPr marL="0" indent="0" algn="l" defTabSz="1280160" rtl="0" eaLnBrk="1" latinLnBrk="0" hangingPunct="1">
+              <a:lnSpc>
+                <a:spcPct val="100000"/>
+              </a:lnSpc>
+              <a:spcBef>
+                <a:spcPts val="0"/>
+              </a:spcBef>
+              <a:spcAft>
+                <a:spcPts val="1200"/>
+              </a:spcAft>
+              <a:buFont typeface="Arial" panose="020B0604020202020204" pitchFamily="34" charset="0"/>
+              <a:buNone/>
+              <a:defRPr sz="1800" kern="1200">
+                <a:solidFill>
+                  <a:schemeClr val="tx2">
+                    <a:lumMod val="75000"/>
+                  </a:schemeClr>
+                </a:solidFill>
+                <a:latin typeface="+mn-lt"/>
+                <a:ea typeface="+mn-ea"/>
+                <a:cs typeface="+mn-cs"/>
+              </a:defRPr>
+            </a:lvl1pPr>
+            <a:lvl2pPr marL="640080" indent="0" algn="l" defTabSz="1280160" rtl="0" eaLnBrk="1" latinLnBrk="0" hangingPunct="1">
+              <a:lnSpc>
+                <a:spcPct val="90000"/>
+              </a:lnSpc>
+              <a:spcBef>
+                <a:spcPts val="700"/>
+              </a:spcBef>
+              <a:buFont typeface="Arial" panose="020B0604020202020204" pitchFamily="34" charset="0"/>
+              <a:buNone/>
+              <a:defRPr sz="1400" kern="1200">
+                <a:solidFill>
+                  <a:schemeClr val="tx1"/>
+                </a:solidFill>
+                <a:latin typeface="+mn-lt"/>
+                <a:ea typeface="+mn-ea"/>
+                <a:cs typeface="+mn-cs"/>
+              </a:defRPr>
+            </a:lvl2pPr>
+            <a:lvl3pPr marL="1280160" indent="0" algn="l" defTabSz="1280160" rtl="0" eaLnBrk="1" latinLnBrk="0" hangingPunct="1">
+              <a:lnSpc>
+                <a:spcPct val="90000"/>
+              </a:lnSpc>
+              <a:spcBef>
+                <a:spcPts val="700"/>
+              </a:spcBef>
+              <a:buFont typeface="Arial" panose="020B0604020202020204" pitchFamily="34" charset="0"/>
+              <a:buNone/>
+              <a:defRPr sz="1400" kern="1200">
+                <a:solidFill>
+                  <a:schemeClr val="tx1"/>
+                </a:solidFill>
+                <a:latin typeface="+mn-lt"/>
+                <a:ea typeface="+mn-ea"/>
+                <a:cs typeface="+mn-cs"/>
+              </a:defRPr>
+            </a:lvl3pPr>
+            <a:lvl4pPr marL="1920240" indent="0" algn="l" defTabSz="1280160" rtl="0" eaLnBrk="1" latinLnBrk="0" hangingPunct="1">
+              <a:lnSpc>
+                <a:spcPct val="90000"/>
+              </a:lnSpc>
+              <a:spcBef>
+                <a:spcPts val="700"/>
+              </a:spcBef>
+              <a:buFont typeface="Arial" panose="020B0604020202020204" pitchFamily="34" charset="0"/>
+              <a:buNone/>
+              <a:defRPr sz="1400" kern="1200">
+                <a:solidFill>
+                  <a:schemeClr val="tx1"/>
+                </a:solidFill>
+                <a:latin typeface="+mn-lt"/>
+                <a:ea typeface="+mn-ea"/>
+                <a:cs typeface="+mn-cs"/>
+              </a:defRPr>
+            </a:lvl4pPr>
+            <a:lvl5pPr marL="2560320" indent="0" algn="l" defTabSz="1280160" rtl="0" eaLnBrk="1" latinLnBrk="0" hangingPunct="1">
+              <a:lnSpc>
+                <a:spcPct val="90000"/>
+              </a:lnSpc>
+              <a:spcBef>
+                <a:spcPts val="700"/>
+              </a:spcBef>
+              <a:buFont typeface="Arial" panose="020B0604020202020204" pitchFamily="34" charset="0"/>
+              <a:buNone/>
+              <a:defRPr sz="1400" kern="1200">
+                <a:solidFill>
+                  <a:schemeClr val="tx1"/>
+                </a:solidFill>
+                <a:latin typeface="+mn-lt"/>
+                <a:ea typeface="+mn-ea"/>
+                <a:cs typeface="+mn-cs"/>
+              </a:defRPr>
+            </a:lvl5pPr>
+            <a:lvl6pPr marL="3520440" indent="-320040" algn="l" defTabSz="1280160" rtl="0" eaLnBrk="1" latinLnBrk="0" hangingPunct="1">
+              <a:lnSpc>
+                <a:spcPct val="90000"/>
+              </a:lnSpc>
+              <a:spcBef>
+                <a:spcPts val="700"/>
+              </a:spcBef>
+              <a:buFont typeface="Arial" panose="020B0604020202020204" pitchFamily="34" charset="0"/>
+              <a:buChar char="•"/>
+              <a:defRPr sz="2520" kern="1200">
+                <a:solidFill>
+                  <a:schemeClr val="tx1"/>
+                </a:solidFill>
+                <a:latin typeface="+mn-lt"/>
+                <a:ea typeface="+mn-ea"/>
+                <a:cs typeface="+mn-cs"/>
+              </a:defRPr>
+            </a:lvl6pPr>
+            <a:lvl7pPr marL="4160520" indent="-320040" algn="l" defTabSz="1280160" rtl="0" eaLnBrk="1" latinLnBrk="0" hangingPunct="1">
+              <a:lnSpc>
+                <a:spcPct val="90000"/>
+              </a:lnSpc>
+              <a:spcBef>
+                <a:spcPts val="700"/>
+              </a:spcBef>
+              <a:buFont typeface="Arial" panose="020B0604020202020204" pitchFamily="34" charset="0"/>
+              <a:buChar char="•"/>
+              <a:defRPr sz="2520" kern="1200">
+                <a:solidFill>
+                  <a:schemeClr val="tx1"/>
+                </a:solidFill>
+                <a:latin typeface="+mn-lt"/>
+                <a:ea typeface="+mn-ea"/>
+                <a:cs typeface="+mn-cs"/>
+              </a:defRPr>
+            </a:lvl7pPr>
+            <a:lvl8pPr marL="4800600" indent="-320040" algn="l" defTabSz="1280160" rtl="0" eaLnBrk="1" latinLnBrk="0" hangingPunct="1">
+              <a:lnSpc>
+                <a:spcPct val="90000"/>
+              </a:lnSpc>
+              <a:spcBef>
+                <a:spcPts val="700"/>
+              </a:spcBef>
+              <a:buFont typeface="Arial" panose="020B0604020202020204" pitchFamily="34" charset="0"/>
+              <a:buChar char="•"/>
+              <a:defRPr sz="2520" kern="1200">
+                <a:solidFill>
+                  <a:schemeClr val="tx1"/>
+                </a:solidFill>
+                <a:latin typeface="+mn-lt"/>
+                <a:ea typeface="+mn-ea"/>
+                <a:cs typeface="+mn-cs"/>
+              </a:defRPr>
+            </a:lvl8pPr>
+            <a:lvl9pPr marL="5440680" indent="-320040" algn="l" defTabSz="1280160" rtl="0" eaLnBrk="1" latinLnBrk="0" hangingPunct="1">
+              <a:lnSpc>
+                <a:spcPct val="90000"/>
+              </a:lnSpc>
+              <a:spcBef>
+                <a:spcPts val="700"/>
+              </a:spcBef>
+              <a:buFont typeface="Arial" panose="020B0604020202020204" pitchFamily="34" charset="0"/>
+              <a:buChar char="•"/>
+              <a:defRPr sz="2520" kern="1200">
+                <a:solidFill>
+                  <a:schemeClr val="tx1"/>
+                </a:solidFill>
+                <a:latin typeface="+mn-lt"/>
+                <a:ea typeface="+mn-ea"/>
+                <a:cs typeface="+mn-cs"/>
+              </a:defRPr>
+            </a:lvl9pPr>
+          </a:lstStyle>
+          <a:p>
+            <a:pPr algn="ctr"/>
+            <a:r>
+              <a:rPr lang="pt-BR" sz="1600" b="1" dirty="0">
+                <a:solidFill>
+                  <a:schemeClr val="accent1">
+                    <a:lumMod val="75000"/>
+                  </a:schemeClr>
+                </a:solidFill>
+                <a:latin typeface="Arial" panose="020B0604020202020204" pitchFamily="34" charset="0"/>
+                <a:cs typeface="Arial" panose="020B0604020202020204" pitchFamily="34" charset="0"/>
+              </a:rPr>
+              <a:t>Modelo preditivo</a:t>
+            </a:r>
+          </a:p>
+        </p:txBody>
+      </p:sp>
+      <p:sp>
+        <p:nvSpPr>
+          <p:cNvPr id="21" name="Espaço Reservado para Texto 1">
+            <a:extLst>
+              <a:ext uri="{FF2B5EF4-FFF2-40B4-BE49-F238E27FC236}">
+                <a16:creationId xmlns:a16="http://schemas.microsoft.com/office/drawing/2014/main" id="{8A49E1DA-82AC-08C6-0A73-773474DD29F6}"/>
+              </a:ext>
+            </a:extLst>
+          </p:cNvPr>
+          <p:cNvSpPr txBox="1">
+            <a:spLocks/>
+          </p:cNvSpPr>
+          <p:nvPr/>
+        </p:nvSpPr>
+        <p:spPr>
+          <a:xfrm>
+            <a:off x="11087100" y="6076043"/>
+            <a:ext cx="4386262" cy="2109107"/>
+          </a:xfrm>
+          <a:prstGeom prst="rect">
+            <a:avLst/>
+          </a:prstGeom>
+          <a:solidFill>
+            <a:schemeClr val="bg2"/>
+          </a:solidFill>
+          <a:effectLst>
+            <a:outerShdw blurRad="215900" dist="114300" dir="2700000" algn="tl" rotWithShape="0">
+              <a:prstClr val="black">
+                <a:alpha val="76000"/>
+              </a:prstClr>
+            </a:outerShdw>
+            <a:softEdge rad="38100"/>
+          </a:effectLst>
+        </p:spPr>
+        <p:txBody>
+          <a:bodyPr lIns="72000" tIns="72000" rIns="72000" bIns="72000"/>
+          <a:lstStyle>
+            <a:lvl1pPr marL="0" indent="0" algn="l" defTabSz="1280160" rtl="0" eaLnBrk="1" latinLnBrk="0" hangingPunct="1">
+              <a:lnSpc>
+                <a:spcPct val="100000"/>
+              </a:lnSpc>
+              <a:spcBef>
+                <a:spcPts val="0"/>
+              </a:spcBef>
+              <a:spcAft>
+                <a:spcPts val="1200"/>
+              </a:spcAft>
+              <a:buFont typeface="Arial" panose="020B0604020202020204" pitchFamily="34" charset="0"/>
+              <a:buNone/>
+              <a:defRPr sz="1800" kern="1200">
+                <a:solidFill>
+                  <a:schemeClr val="tx2">
+                    <a:lumMod val="75000"/>
+                  </a:schemeClr>
+                </a:solidFill>
+                <a:latin typeface="+mn-lt"/>
+                <a:ea typeface="+mn-ea"/>
+                <a:cs typeface="+mn-cs"/>
+              </a:defRPr>
+            </a:lvl1pPr>
+            <a:lvl2pPr marL="640080" indent="0" algn="l" defTabSz="1280160" rtl="0" eaLnBrk="1" latinLnBrk="0" hangingPunct="1">
+              <a:lnSpc>
+                <a:spcPct val="90000"/>
+              </a:lnSpc>
+              <a:spcBef>
+                <a:spcPts val="700"/>
+              </a:spcBef>
+              <a:buFont typeface="Arial" panose="020B0604020202020204" pitchFamily="34" charset="0"/>
+              <a:buNone/>
+              <a:defRPr sz="1400" kern="1200">
+                <a:solidFill>
+                  <a:schemeClr val="tx1"/>
+                </a:solidFill>
+                <a:latin typeface="+mn-lt"/>
+                <a:ea typeface="+mn-ea"/>
+                <a:cs typeface="+mn-cs"/>
+              </a:defRPr>
+            </a:lvl2pPr>
+            <a:lvl3pPr marL="1280160" indent="0" algn="l" defTabSz="1280160" rtl="0" eaLnBrk="1" latinLnBrk="0" hangingPunct="1">
+              <a:lnSpc>
+                <a:spcPct val="90000"/>
+              </a:lnSpc>
+              <a:spcBef>
+                <a:spcPts val="700"/>
+              </a:spcBef>
+              <a:buFont typeface="Arial" panose="020B0604020202020204" pitchFamily="34" charset="0"/>
+              <a:buNone/>
+              <a:defRPr sz="1400" kern="1200">
+                <a:solidFill>
+                  <a:schemeClr val="tx1"/>
+                </a:solidFill>
+                <a:latin typeface="+mn-lt"/>
+                <a:ea typeface="+mn-ea"/>
+                <a:cs typeface="+mn-cs"/>
+              </a:defRPr>
+            </a:lvl3pPr>
+            <a:lvl4pPr marL="1920240" indent="0" algn="l" defTabSz="1280160" rtl="0" eaLnBrk="1" latinLnBrk="0" hangingPunct="1">
+              <a:lnSpc>
+                <a:spcPct val="90000"/>
+              </a:lnSpc>
+              <a:spcBef>
+                <a:spcPts val="700"/>
+              </a:spcBef>
+              <a:buFont typeface="Arial" panose="020B0604020202020204" pitchFamily="34" charset="0"/>
+              <a:buNone/>
+              <a:defRPr sz="1400" kern="1200">
+                <a:solidFill>
+                  <a:schemeClr val="tx1"/>
+                </a:solidFill>
+                <a:latin typeface="+mn-lt"/>
+                <a:ea typeface="+mn-ea"/>
+                <a:cs typeface="+mn-cs"/>
+              </a:defRPr>
+            </a:lvl4pPr>
+            <a:lvl5pPr marL="2560320" indent="0" algn="l" defTabSz="1280160" rtl="0" eaLnBrk="1" latinLnBrk="0" hangingPunct="1">
+              <a:lnSpc>
+                <a:spcPct val="90000"/>
+              </a:lnSpc>
+              <a:spcBef>
+                <a:spcPts val="700"/>
+              </a:spcBef>
+              <a:buFont typeface="Arial" panose="020B0604020202020204" pitchFamily="34" charset="0"/>
+              <a:buNone/>
+              <a:defRPr sz="1400" kern="1200">
+                <a:solidFill>
+                  <a:schemeClr val="tx1"/>
+                </a:solidFill>
+                <a:latin typeface="+mn-lt"/>
+                <a:ea typeface="+mn-ea"/>
+                <a:cs typeface="+mn-cs"/>
+              </a:defRPr>
+            </a:lvl5pPr>
+            <a:lvl6pPr marL="3520440" indent="-320040" algn="l" defTabSz="1280160" rtl="0" eaLnBrk="1" latinLnBrk="0" hangingPunct="1">
+              <a:lnSpc>
+                <a:spcPct val="90000"/>
+              </a:lnSpc>
+              <a:spcBef>
+                <a:spcPts val="700"/>
+              </a:spcBef>
+              <a:buFont typeface="Arial" panose="020B0604020202020204" pitchFamily="34" charset="0"/>
+              <a:buChar char="•"/>
+              <a:defRPr sz="2520" kern="1200">
+                <a:solidFill>
+                  <a:schemeClr val="tx1"/>
+                </a:solidFill>
+                <a:latin typeface="+mn-lt"/>
+                <a:ea typeface="+mn-ea"/>
+                <a:cs typeface="+mn-cs"/>
+              </a:defRPr>
+            </a:lvl6pPr>
+            <a:lvl7pPr marL="4160520" indent="-320040" algn="l" defTabSz="1280160" rtl="0" eaLnBrk="1" latinLnBrk="0" hangingPunct="1">
+              <a:lnSpc>
+                <a:spcPct val="90000"/>
+              </a:lnSpc>
+              <a:spcBef>
+                <a:spcPts val="700"/>
+              </a:spcBef>
+              <a:buFont typeface="Arial" panose="020B0604020202020204" pitchFamily="34" charset="0"/>
+              <a:buChar char="•"/>
+              <a:defRPr sz="2520" kern="1200">
+                <a:solidFill>
+                  <a:schemeClr val="tx1"/>
+                </a:solidFill>
+                <a:latin typeface="+mn-lt"/>
+                <a:ea typeface="+mn-ea"/>
+                <a:cs typeface="+mn-cs"/>
+              </a:defRPr>
+            </a:lvl7pPr>
+            <a:lvl8pPr marL="4800600" indent="-320040" algn="l" defTabSz="1280160" rtl="0" eaLnBrk="1" latinLnBrk="0" hangingPunct="1">
+              <a:lnSpc>
+                <a:spcPct val="90000"/>
+              </a:lnSpc>
+              <a:spcBef>
+                <a:spcPts val="700"/>
+              </a:spcBef>
+              <a:buFont typeface="Arial" panose="020B0604020202020204" pitchFamily="34" charset="0"/>
+              <a:buChar char="•"/>
+              <a:defRPr sz="2520" kern="1200">
+                <a:solidFill>
+                  <a:schemeClr val="tx1"/>
+                </a:solidFill>
+                <a:latin typeface="+mn-lt"/>
+                <a:ea typeface="+mn-ea"/>
+                <a:cs typeface="+mn-cs"/>
+              </a:defRPr>
+            </a:lvl8pPr>
+            <a:lvl9pPr marL="5440680" indent="-320040" algn="l" defTabSz="1280160" rtl="0" eaLnBrk="1" latinLnBrk="0" hangingPunct="1">
+              <a:lnSpc>
+                <a:spcPct val="90000"/>
+              </a:lnSpc>
+              <a:spcBef>
+                <a:spcPts val="700"/>
+              </a:spcBef>
+              <a:buFont typeface="Arial" panose="020B0604020202020204" pitchFamily="34" charset="0"/>
+              <a:buChar char="•"/>
+              <a:defRPr sz="2520" kern="1200">
+                <a:solidFill>
+                  <a:schemeClr val="tx1"/>
+                </a:solidFill>
+                <a:latin typeface="+mn-lt"/>
+                <a:ea typeface="+mn-ea"/>
+                <a:cs typeface="+mn-cs"/>
+              </a:defRPr>
+            </a:lvl9pPr>
+          </a:lstStyle>
+          <a:p>
+            <a:endParaRPr lang="pt-BR" sz="1600" b="1" dirty="0">
+              <a:solidFill>
+                <a:schemeClr val="accent1">
+                  <a:lumMod val="75000"/>
+                </a:schemeClr>
+              </a:solidFill>
+              <a:latin typeface="Arial" panose="020B0604020202020204" pitchFamily="34" charset="0"/>
+              <a:cs typeface="Arial" panose="020B0604020202020204" pitchFamily="34" charset="0"/>
+            </a:endParaRPr>
+          </a:p>
+        </p:txBody>
+      </p:sp>
+      <p:sp>
+        <p:nvSpPr>
+          <p:cNvPr id="23" name="Espaço Reservado para Texto 1">
+            <a:extLst>
+              <a:ext uri="{FF2B5EF4-FFF2-40B4-BE49-F238E27FC236}">
+                <a16:creationId xmlns:a16="http://schemas.microsoft.com/office/drawing/2014/main" id="{731D9D1B-7803-2595-ADB0-46EB27F42EB5}"/>
+              </a:ext>
+            </a:extLst>
+          </p:cNvPr>
+          <p:cNvSpPr txBox="1">
+            <a:spLocks/>
+          </p:cNvSpPr>
+          <p:nvPr/>
+        </p:nvSpPr>
+        <p:spPr>
+          <a:xfrm>
+            <a:off x="11838899" y="6305840"/>
+            <a:ext cx="2882664" cy="421714"/>
+          </a:xfrm>
+          <a:prstGeom prst="rect">
+            <a:avLst/>
+          </a:prstGeom>
+          <a:noFill/>
+        </p:spPr>
+        <p:txBody>
+          <a:bodyPr lIns="72000" tIns="72000" rIns="72000" bIns="72000"/>
+          <a:lstStyle>
+            <a:lvl1pPr marL="0" indent="0" algn="l" defTabSz="1280160" rtl="0" eaLnBrk="1" latinLnBrk="0" hangingPunct="1">
+              <a:lnSpc>
+                <a:spcPct val="100000"/>
+              </a:lnSpc>
+              <a:spcBef>
+                <a:spcPts val="0"/>
+              </a:spcBef>
+              <a:spcAft>
+                <a:spcPts val="1200"/>
+              </a:spcAft>
+              <a:buFont typeface="Arial" panose="020B0604020202020204" pitchFamily="34" charset="0"/>
+              <a:buNone/>
+              <a:defRPr sz="1800" kern="1200">
+                <a:solidFill>
+                  <a:schemeClr val="tx2">
+                    <a:lumMod val="75000"/>
+                  </a:schemeClr>
+                </a:solidFill>
+                <a:latin typeface="+mn-lt"/>
+                <a:ea typeface="+mn-ea"/>
+                <a:cs typeface="+mn-cs"/>
+              </a:defRPr>
+            </a:lvl1pPr>
+            <a:lvl2pPr marL="640080" indent="0" algn="l" defTabSz="1280160" rtl="0" eaLnBrk="1" latinLnBrk="0" hangingPunct="1">
+              <a:lnSpc>
+                <a:spcPct val="90000"/>
+              </a:lnSpc>
+              <a:spcBef>
+                <a:spcPts val="700"/>
+              </a:spcBef>
+              <a:buFont typeface="Arial" panose="020B0604020202020204" pitchFamily="34" charset="0"/>
+              <a:buNone/>
+              <a:defRPr sz="1400" kern="1200">
+                <a:solidFill>
+                  <a:schemeClr val="tx1"/>
+                </a:solidFill>
+                <a:latin typeface="+mn-lt"/>
+                <a:ea typeface="+mn-ea"/>
+                <a:cs typeface="+mn-cs"/>
+              </a:defRPr>
+            </a:lvl2pPr>
+            <a:lvl3pPr marL="1280160" indent="0" algn="l" defTabSz="1280160" rtl="0" eaLnBrk="1" latinLnBrk="0" hangingPunct="1">
+              <a:lnSpc>
+                <a:spcPct val="90000"/>
+              </a:lnSpc>
+              <a:spcBef>
+                <a:spcPts val="700"/>
+              </a:spcBef>
+              <a:buFont typeface="Arial" panose="020B0604020202020204" pitchFamily="34" charset="0"/>
+              <a:buNone/>
+              <a:defRPr sz="1400" kern="1200">
+                <a:solidFill>
+                  <a:schemeClr val="tx1"/>
+                </a:solidFill>
+                <a:latin typeface="+mn-lt"/>
+                <a:ea typeface="+mn-ea"/>
+                <a:cs typeface="+mn-cs"/>
+              </a:defRPr>
+            </a:lvl3pPr>
+            <a:lvl4pPr marL="1920240" indent="0" algn="l" defTabSz="1280160" rtl="0" eaLnBrk="1" latinLnBrk="0" hangingPunct="1">
+              <a:lnSpc>
+                <a:spcPct val="90000"/>
+              </a:lnSpc>
+              <a:spcBef>
+                <a:spcPts val="700"/>
+              </a:spcBef>
+              <a:buFont typeface="Arial" panose="020B0604020202020204" pitchFamily="34" charset="0"/>
+              <a:buNone/>
+              <a:defRPr sz="1400" kern="1200">
+                <a:solidFill>
+                  <a:schemeClr val="tx1"/>
+                </a:solidFill>
+                <a:latin typeface="+mn-lt"/>
+                <a:ea typeface="+mn-ea"/>
+                <a:cs typeface="+mn-cs"/>
+              </a:defRPr>
+            </a:lvl4pPr>
+            <a:lvl5pPr marL="2560320" indent="0" algn="l" defTabSz="1280160" rtl="0" eaLnBrk="1" latinLnBrk="0" hangingPunct="1">
+              <a:lnSpc>
+                <a:spcPct val="90000"/>
+              </a:lnSpc>
+              <a:spcBef>
+                <a:spcPts val="700"/>
+              </a:spcBef>
+              <a:buFont typeface="Arial" panose="020B0604020202020204" pitchFamily="34" charset="0"/>
+              <a:buNone/>
+              <a:defRPr sz="1400" kern="1200">
+                <a:solidFill>
+                  <a:schemeClr val="tx1"/>
+                </a:solidFill>
+                <a:latin typeface="+mn-lt"/>
+                <a:ea typeface="+mn-ea"/>
+                <a:cs typeface="+mn-cs"/>
+              </a:defRPr>
+            </a:lvl5pPr>
+            <a:lvl6pPr marL="3520440" indent="-320040" algn="l" defTabSz="1280160" rtl="0" eaLnBrk="1" latinLnBrk="0" hangingPunct="1">
+              <a:lnSpc>
+                <a:spcPct val="90000"/>
+              </a:lnSpc>
+              <a:spcBef>
+                <a:spcPts val="700"/>
+              </a:spcBef>
+              <a:buFont typeface="Arial" panose="020B0604020202020204" pitchFamily="34" charset="0"/>
+              <a:buChar char="•"/>
+              <a:defRPr sz="2520" kern="1200">
+                <a:solidFill>
+                  <a:schemeClr val="tx1"/>
+                </a:solidFill>
+                <a:latin typeface="+mn-lt"/>
+                <a:ea typeface="+mn-ea"/>
+                <a:cs typeface="+mn-cs"/>
+              </a:defRPr>
+            </a:lvl6pPr>
+            <a:lvl7pPr marL="4160520" indent="-320040" algn="l" defTabSz="1280160" rtl="0" eaLnBrk="1" latinLnBrk="0" hangingPunct="1">
+              <a:lnSpc>
+                <a:spcPct val="90000"/>
+              </a:lnSpc>
+              <a:spcBef>
+                <a:spcPts val="700"/>
+              </a:spcBef>
+              <a:buFont typeface="Arial" panose="020B0604020202020204" pitchFamily="34" charset="0"/>
+              <a:buChar char="•"/>
+              <a:defRPr sz="2520" kern="1200">
+                <a:solidFill>
+                  <a:schemeClr val="tx1"/>
+                </a:solidFill>
+                <a:latin typeface="+mn-lt"/>
+                <a:ea typeface="+mn-ea"/>
+                <a:cs typeface="+mn-cs"/>
+              </a:defRPr>
+            </a:lvl7pPr>
+            <a:lvl8pPr marL="4800600" indent="-320040" algn="l" defTabSz="1280160" rtl="0" eaLnBrk="1" latinLnBrk="0" hangingPunct="1">
+              <a:lnSpc>
+                <a:spcPct val="90000"/>
+              </a:lnSpc>
+              <a:spcBef>
+                <a:spcPts val="700"/>
+              </a:spcBef>
+              <a:buFont typeface="Arial" panose="020B0604020202020204" pitchFamily="34" charset="0"/>
+              <a:buChar char="•"/>
+              <a:defRPr sz="2520" kern="1200">
+                <a:solidFill>
+                  <a:schemeClr val="tx1"/>
+                </a:solidFill>
+                <a:latin typeface="+mn-lt"/>
+                <a:ea typeface="+mn-ea"/>
+                <a:cs typeface="+mn-cs"/>
+              </a:defRPr>
+            </a:lvl8pPr>
+            <a:lvl9pPr marL="5440680" indent="-320040" algn="l" defTabSz="1280160" rtl="0" eaLnBrk="1" latinLnBrk="0" hangingPunct="1">
+              <a:lnSpc>
+                <a:spcPct val="90000"/>
+              </a:lnSpc>
+              <a:spcBef>
+                <a:spcPts val="700"/>
+              </a:spcBef>
+              <a:buFont typeface="Arial" panose="020B0604020202020204" pitchFamily="34" charset="0"/>
+              <a:buChar char="•"/>
+              <a:defRPr sz="2520" kern="1200">
+                <a:solidFill>
+                  <a:schemeClr val="tx1"/>
+                </a:solidFill>
+                <a:latin typeface="+mn-lt"/>
+                <a:ea typeface="+mn-ea"/>
+                <a:cs typeface="+mn-cs"/>
+              </a:defRPr>
+            </a:lvl9pPr>
+          </a:lstStyle>
+          <a:p>
+            <a:pPr algn="ctr"/>
             <a:r>
               <a:rPr lang="pt-BR" sz="1600" b="1" dirty="0">
                 <a:solidFill>
@@ -4990,7 +5806,285 @@
               <a:t>Dashboard</a:t>
             </a:r>
           </a:p>
+        </p:txBody>
+      </p:sp>
+      <p:cxnSp>
+        <p:nvCxnSpPr>
+          <p:cNvPr id="27" name="Conexão reta 26">
+            <a:extLst>
+              <a:ext uri="{FF2B5EF4-FFF2-40B4-BE49-F238E27FC236}">
+                <a16:creationId xmlns:a16="http://schemas.microsoft.com/office/drawing/2014/main" id="{0A8C47B2-4CFE-1289-FC3F-F7025F5EB329}"/>
+              </a:ext>
+            </a:extLst>
+          </p:cNvPr>
+          <p:cNvCxnSpPr>
+            <a:cxnSpLocks/>
+          </p:cNvCxnSpPr>
+          <p:nvPr/>
+        </p:nvCxnSpPr>
+        <p:spPr>
+          <a:xfrm flipV="1">
+            <a:off x="997744" y="4088550"/>
+            <a:ext cx="14406562" cy="1"/>
+          </a:xfrm>
+          <a:prstGeom prst="line">
+            <a:avLst/>
+          </a:prstGeom>
+        </p:spPr>
+        <p:style>
+          <a:lnRef idx="1">
+            <a:schemeClr val="accent1"/>
+          </a:lnRef>
+          <a:fillRef idx="0">
+            <a:schemeClr val="accent1"/>
+          </a:fillRef>
+          <a:effectRef idx="0">
+            <a:schemeClr val="accent1"/>
+          </a:effectRef>
+          <a:fontRef idx="minor">
+            <a:schemeClr val="tx1"/>
+          </a:fontRef>
+        </p:style>
+      </p:cxnSp>
+      <p:cxnSp>
+        <p:nvCxnSpPr>
+          <p:cNvPr id="28" name="Conexão reta 27">
+            <a:extLst>
+              <a:ext uri="{FF2B5EF4-FFF2-40B4-BE49-F238E27FC236}">
+                <a16:creationId xmlns:a16="http://schemas.microsoft.com/office/drawing/2014/main" id="{C6B4D194-B3B8-27A4-D371-D795AF40E102}"/>
+              </a:ext>
+            </a:extLst>
+          </p:cNvPr>
+          <p:cNvCxnSpPr>
+            <a:cxnSpLocks/>
+          </p:cNvCxnSpPr>
+          <p:nvPr/>
+        </p:nvCxnSpPr>
+        <p:spPr>
+          <a:xfrm flipV="1">
+            <a:off x="997744" y="2271248"/>
+            <a:ext cx="14406562" cy="1"/>
+          </a:xfrm>
+          <a:prstGeom prst="line">
+            <a:avLst/>
+          </a:prstGeom>
+        </p:spPr>
+        <p:style>
+          <a:lnRef idx="1">
+            <a:schemeClr val="accent1"/>
+          </a:lnRef>
+          <a:fillRef idx="0">
+            <a:schemeClr val="accent1"/>
+          </a:fillRef>
+          <a:effectRef idx="0">
+            <a:schemeClr val="accent1"/>
+          </a:effectRef>
+          <a:fontRef idx="minor">
+            <a:schemeClr val="tx1"/>
+          </a:fontRef>
+        </p:style>
+      </p:cxnSp>
+      <p:sp>
+        <p:nvSpPr>
+          <p:cNvPr id="30" name="Espaço Reservado para Texto 1">
+            <a:extLst>
+              <a:ext uri="{FF2B5EF4-FFF2-40B4-BE49-F238E27FC236}">
+                <a16:creationId xmlns:a16="http://schemas.microsoft.com/office/drawing/2014/main" id="{A9032A32-8494-E1D9-E2C3-627CEC1EC8C3}"/>
+              </a:ext>
+            </a:extLst>
+          </p:cNvPr>
+          <p:cNvSpPr txBox="1">
+            <a:spLocks/>
+          </p:cNvSpPr>
+          <p:nvPr/>
+        </p:nvSpPr>
+        <p:spPr>
+          <a:xfrm>
+            <a:off x="6759693" y="6854571"/>
+            <a:ext cx="2882664" cy="759206"/>
+          </a:xfrm>
+          <a:prstGeom prst="rect">
+            <a:avLst/>
+          </a:prstGeom>
+          <a:noFill/>
+        </p:spPr>
+        <p:txBody>
+          <a:bodyPr lIns="72000" tIns="72000" rIns="72000" bIns="72000"/>
+          <a:lstStyle>
+            <a:lvl1pPr marL="0" indent="0" algn="l" defTabSz="1280160" rtl="0" eaLnBrk="1" latinLnBrk="0" hangingPunct="1">
+              <a:lnSpc>
+                <a:spcPct val="100000"/>
+              </a:lnSpc>
+              <a:spcBef>
+                <a:spcPts val="0"/>
+              </a:spcBef>
+              <a:spcAft>
+                <a:spcPts val="1200"/>
+              </a:spcAft>
+              <a:buFont typeface="Arial" panose="020B0604020202020204" pitchFamily="34" charset="0"/>
+              <a:buNone/>
+              <a:defRPr sz="1800" kern="1200">
+                <a:solidFill>
+                  <a:schemeClr val="tx2">
+                    <a:lumMod val="75000"/>
+                  </a:schemeClr>
+                </a:solidFill>
+                <a:latin typeface="+mn-lt"/>
+                <a:ea typeface="+mn-ea"/>
+                <a:cs typeface="+mn-cs"/>
+              </a:defRPr>
+            </a:lvl1pPr>
+            <a:lvl2pPr marL="640080" indent="0" algn="l" defTabSz="1280160" rtl="0" eaLnBrk="1" latinLnBrk="0" hangingPunct="1">
+              <a:lnSpc>
+                <a:spcPct val="90000"/>
+              </a:lnSpc>
+              <a:spcBef>
+                <a:spcPts val="700"/>
+              </a:spcBef>
+              <a:buFont typeface="Arial" panose="020B0604020202020204" pitchFamily="34" charset="0"/>
+              <a:buNone/>
+              <a:defRPr sz="1400" kern="1200">
+                <a:solidFill>
+                  <a:schemeClr val="tx1"/>
+                </a:solidFill>
+                <a:latin typeface="+mn-lt"/>
+                <a:ea typeface="+mn-ea"/>
+                <a:cs typeface="+mn-cs"/>
+              </a:defRPr>
+            </a:lvl2pPr>
+            <a:lvl3pPr marL="1280160" indent="0" algn="l" defTabSz="1280160" rtl="0" eaLnBrk="1" latinLnBrk="0" hangingPunct="1">
+              <a:lnSpc>
+                <a:spcPct val="90000"/>
+              </a:lnSpc>
+              <a:spcBef>
+                <a:spcPts val="700"/>
+              </a:spcBef>
+              <a:buFont typeface="Arial" panose="020B0604020202020204" pitchFamily="34" charset="0"/>
+              <a:buNone/>
+              <a:defRPr sz="1400" kern="1200">
+                <a:solidFill>
+                  <a:schemeClr val="tx1"/>
+                </a:solidFill>
+                <a:latin typeface="+mn-lt"/>
+                <a:ea typeface="+mn-ea"/>
+                <a:cs typeface="+mn-cs"/>
+              </a:defRPr>
+            </a:lvl3pPr>
+            <a:lvl4pPr marL="1920240" indent="0" algn="l" defTabSz="1280160" rtl="0" eaLnBrk="1" latinLnBrk="0" hangingPunct="1">
+              <a:lnSpc>
+                <a:spcPct val="90000"/>
+              </a:lnSpc>
+              <a:spcBef>
+                <a:spcPts val="700"/>
+              </a:spcBef>
+              <a:buFont typeface="Arial" panose="020B0604020202020204" pitchFamily="34" charset="0"/>
+              <a:buNone/>
+              <a:defRPr sz="1400" kern="1200">
+                <a:solidFill>
+                  <a:schemeClr val="tx1"/>
+                </a:solidFill>
+                <a:latin typeface="+mn-lt"/>
+                <a:ea typeface="+mn-ea"/>
+                <a:cs typeface="+mn-cs"/>
+              </a:defRPr>
+            </a:lvl4pPr>
+            <a:lvl5pPr marL="2560320" indent="0" algn="l" defTabSz="1280160" rtl="0" eaLnBrk="1" latinLnBrk="0" hangingPunct="1">
+              <a:lnSpc>
+                <a:spcPct val="90000"/>
+              </a:lnSpc>
+              <a:spcBef>
+                <a:spcPts val="700"/>
+              </a:spcBef>
+              <a:buFont typeface="Arial" panose="020B0604020202020204" pitchFamily="34" charset="0"/>
+              <a:buNone/>
+              <a:defRPr sz="1400" kern="1200">
+                <a:solidFill>
+                  <a:schemeClr val="tx1"/>
+                </a:solidFill>
+                <a:latin typeface="+mn-lt"/>
+                <a:ea typeface="+mn-ea"/>
+                <a:cs typeface="+mn-cs"/>
+              </a:defRPr>
+            </a:lvl5pPr>
+            <a:lvl6pPr marL="3520440" indent="-320040" algn="l" defTabSz="1280160" rtl="0" eaLnBrk="1" latinLnBrk="0" hangingPunct="1">
+              <a:lnSpc>
+                <a:spcPct val="90000"/>
+              </a:lnSpc>
+              <a:spcBef>
+                <a:spcPts val="700"/>
+              </a:spcBef>
+              <a:buFont typeface="Arial" panose="020B0604020202020204" pitchFamily="34" charset="0"/>
+              <a:buChar char="•"/>
+              <a:defRPr sz="2520" kern="1200">
+                <a:solidFill>
+                  <a:schemeClr val="tx1"/>
+                </a:solidFill>
+                <a:latin typeface="+mn-lt"/>
+                <a:ea typeface="+mn-ea"/>
+                <a:cs typeface="+mn-cs"/>
+              </a:defRPr>
+            </a:lvl6pPr>
+            <a:lvl7pPr marL="4160520" indent="-320040" algn="l" defTabSz="1280160" rtl="0" eaLnBrk="1" latinLnBrk="0" hangingPunct="1">
+              <a:lnSpc>
+                <a:spcPct val="90000"/>
+              </a:lnSpc>
+              <a:spcBef>
+                <a:spcPts val="700"/>
+              </a:spcBef>
+              <a:buFont typeface="Arial" panose="020B0604020202020204" pitchFamily="34" charset="0"/>
+              <a:buChar char="•"/>
+              <a:defRPr sz="2520" kern="1200">
+                <a:solidFill>
+                  <a:schemeClr val="tx1"/>
+                </a:solidFill>
+                <a:latin typeface="+mn-lt"/>
+                <a:ea typeface="+mn-ea"/>
+                <a:cs typeface="+mn-cs"/>
+              </a:defRPr>
+            </a:lvl7pPr>
+            <a:lvl8pPr marL="4800600" indent="-320040" algn="l" defTabSz="1280160" rtl="0" eaLnBrk="1" latinLnBrk="0" hangingPunct="1">
+              <a:lnSpc>
+                <a:spcPct val="90000"/>
+              </a:lnSpc>
+              <a:spcBef>
+                <a:spcPts val="700"/>
+              </a:spcBef>
+              <a:buFont typeface="Arial" panose="020B0604020202020204" pitchFamily="34" charset="0"/>
+              <a:buChar char="•"/>
+              <a:defRPr sz="2520" kern="1200">
+                <a:solidFill>
+                  <a:schemeClr val="tx1"/>
+                </a:solidFill>
+                <a:latin typeface="+mn-lt"/>
+                <a:ea typeface="+mn-ea"/>
+                <a:cs typeface="+mn-cs"/>
+              </a:defRPr>
+            </a:lvl8pPr>
+            <a:lvl9pPr marL="5440680" indent="-320040" algn="l" defTabSz="1280160" rtl="0" eaLnBrk="1" latinLnBrk="0" hangingPunct="1">
+              <a:lnSpc>
+                <a:spcPct val="90000"/>
+              </a:lnSpc>
+              <a:spcBef>
+                <a:spcPts val="700"/>
+              </a:spcBef>
+              <a:buFont typeface="Arial" panose="020B0604020202020204" pitchFamily="34" charset="0"/>
+              <a:buChar char="•"/>
+              <a:defRPr sz="2520" kern="1200">
+                <a:solidFill>
+                  <a:schemeClr val="tx1"/>
+                </a:solidFill>
+                <a:latin typeface="+mn-lt"/>
+                <a:ea typeface="+mn-ea"/>
+                <a:cs typeface="+mn-cs"/>
+              </a:defRPr>
+            </a:lvl9pPr>
+          </a:lstStyle>
           <a:p>
+            <a:pPr algn="ctr">
+              <a:spcAft>
+                <a:spcPts val="0"/>
+              </a:spcAft>
+            </a:pPr>
             <a:r>
               <a:rPr lang="pt-BR" sz="1200" dirty="0">
                 <a:solidFill>
@@ -4999,7 +6093,221 @@
                 <a:latin typeface="Arial" panose="020B0604020202020204" pitchFamily="34" charset="0"/>
                 <a:cs typeface="Arial" panose="020B0604020202020204" pitchFamily="34" charset="0"/>
               </a:rPr>
-              <a:t>KPIs e visualizações disponíveis no Tableu Public, alimentados pela base analítica do projeto.</a:t>
+              <a:t>Regressão Logística treinada com dados de 2006 a 2024, usando a posição final como variável preditiva.</a:t>
+            </a:r>
+          </a:p>
+        </p:txBody>
+      </p:sp>
+      <p:sp>
+        <p:nvSpPr>
+          <p:cNvPr id="32" name="Espaço Reservado para Texto 1">
+            <a:extLst>
+              <a:ext uri="{FF2B5EF4-FFF2-40B4-BE49-F238E27FC236}">
+                <a16:creationId xmlns:a16="http://schemas.microsoft.com/office/drawing/2014/main" id="{67737EF5-677D-2BFC-E9E9-856CC0993796}"/>
+              </a:ext>
+            </a:extLst>
+          </p:cNvPr>
+          <p:cNvSpPr txBox="1">
+            <a:spLocks/>
+          </p:cNvSpPr>
+          <p:nvPr/>
+        </p:nvSpPr>
+        <p:spPr>
+          <a:xfrm>
+            <a:off x="11838899" y="6854571"/>
+            <a:ext cx="2882664" cy="759206"/>
+          </a:xfrm>
+          <a:prstGeom prst="rect">
+            <a:avLst/>
+          </a:prstGeom>
+          <a:noFill/>
+        </p:spPr>
+        <p:txBody>
+          <a:bodyPr lIns="72000" tIns="72000" rIns="72000" bIns="72000"/>
+          <a:lstStyle>
+            <a:lvl1pPr marL="0" indent="0" algn="l" defTabSz="1280160" rtl="0" eaLnBrk="1" latinLnBrk="0" hangingPunct="1">
+              <a:lnSpc>
+                <a:spcPct val="100000"/>
+              </a:lnSpc>
+              <a:spcBef>
+                <a:spcPts val="0"/>
+              </a:spcBef>
+              <a:spcAft>
+                <a:spcPts val="1200"/>
+              </a:spcAft>
+              <a:buFont typeface="Arial" panose="020B0604020202020204" pitchFamily="34" charset="0"/>
+              <a:buNone/>
+              <a:defRPr sz="1800" kern="1200">
+                <a:solidFill>
+                  <a:schemeClr val="tx2">
+                    <a:lumMod val="75000"/>
+                  </a:schemeClr>
+                </a:solidFill>
+                <a:latin typeface="+mn-lt"/>
+                <a:ea typeface="+mn-ea"/>
+                <a:cs typeface="+mn-cs"/>
+              </a:defRPr>
+            </a:lvl1pPr>
+            <a:lvl2pPr marL="640080" indent="0" algn="l" defTabSz="1280160" rtl="0" eaLnBrk="1" latinLnBrk="0" hangingPunct="1">
+              <a:lnSpc>
+                <a:spcPct val="90000"/>
+              </a:lnSpc>
+              <a:spcBef>
+                <a:spcPts val="700"/>
+              </a:spcBef>
+              <a:buFont typeface="Arial" panose="020B0604020202020204" pitchFamily="34" charset="0"/>
+              <a:buNone/>
+              <a:defRPr sz="1400" kern="1200">
+                <a:solidFill>
+                  <a:schemeClr val="tx1"/>
+                </a:solidFill>
+                <a:latin typeface="+mn-lt"/>
+                <a:ea typeface="+mn-ea"/>
+                <a:cs typeface="+mn-cs"/>
+              </a:defRPr>
+            </a:lvl2pPr>
+            <a:lvl3pPr marL="1280160" indent="0" algn="l" defTabSz="1280160" rtl="0" eaLnBrk="1" latinLnBrk="0" hangingPunct="1">
+              <a:lnSpc>
+                <a:spcPct val="90000"/>
+              </a:lnSpc>
+              <a:spcBef>
+                <a:spcPts val="700"/>
+              </a:spcBef>
+              <a:buFont typeface="Arial" panose="020B0604020202020204" pitchFamily="34" charset="0"/>
+              <a:buNone/>
+              <a:defRPr sz="1400" kern="1200">
+                <a:solidFill>
+                  <a:schemeClr val="tx1"/>
+                </a:solidFill>
+                <a:latin typeface="+mn-lt"/>
+                <a:ea typeface="+mn-ea"/>
+                <a:cs typeface="+mn-cs"/>
+              </a:defRPr>
+            </a:lvl3pPr>
+            <a:lvl4pPr marL="1920240" indent="0" algn="l" defTabSz="1280160" rtl="0" eaLnBrk="1" latinLnBrk="0" hangingPunct="1">
+              <a:lnSpc>
+                <a:spcPct val="90000"/>
+              </a:lnSpc>
+              <a:spcBef>
+                <a:spcPts val="700"/>
+              </a:spcBef>
+              <a:buFont typeface="Arial" panose="020B0604020202020204" pitchFamily="34" charset="0"/>
+              <a:buNone/>
+              <a:defRPr sz="1400" kern="1200">
+                <a:solidFill>
+                  <a:schemeClr val="tx1"/>
+                </a:solidFill>
+                <a:latin typeface="+mn-lt"/>
+                <a:ea typeface="+mn-ea"/>
+                <a:cs typeface="+mn-cs"/>
+              </a:defRPr>
+            </a:lvl4pPr>
+            <a:lvl5pPr marL="2560320" indent="0" algn="l" defTabSz="1280160" rtl="0" eaLnBrk="1" latinLnBrk="0" hangingPunct="1">
+              <a:lnSpc>
+                <a:spcPct val="90000"/>
+              </a:lnSpc>
+              <a:spcBef>
+                <a:spcPts val="700"/>
+              </a:spcBef>
+              <a:buFont typeface="Arial" panose="020B0604020202020204" pitchFamily="34" charset="0"/>
+              <a:buNone/>
+              <a:defRPr sz="1400" kern="1200">
+                <a:solidFill>
+                  <a:schemeClr val="tx1"/>
+                </a:solidFill>
+                <a:latin typeface="+mn-lt"/>
+                <a:ea typeface="+mn-ea"/>
+                <a:cs typeface="+mn-cs"/>
+              </a:defRPr>
+            </a:lvl5pPr>
+            <a:lvl6pPr marL="3520440" indent="-320040" algn="l" defTabSz="1280160" rtl="0" eaLnBrk="1" latinLnBrk="0" hangingPunct="1">
+              <a:lnSpc>
+                <a:spcPct val="90000"/>
+              </a:lnSpc>
+              <a:spcBef>
+                <a:spcPts val="700"/>
+              </a:spcBef>
+              <a:buFont typeface="Arial" panose="020B0604020202020204" pitchFamily="34" charset="0"/>
+              <a:buChar char="•"/>
+              <a:defRPr sz="2520" kern="1200">
+                <a:solidFill>
+                  <a:schemeClr val="tx1"/>
+                </a:solidFill>
+                <a:latin typeface="+mn-lt"/>
+                <a:ea typeface="+mn-ea"/>
+                <a:cs typeface="+mn-cs"/>
+              </a:defRPr>
+            </a:lvl6pPr>
+            <a:lvl7pPr marL="4160520" indent="-320040" algn="l" defTabSz="1280160" rtl="0" eaLnBrk="1" latinLnBrk="0" hangingPunct="1">
+              <a:lnSpc>
+                <a:spcPct val="90000"/>
+              </a:lnSpc>
+              <a:spcBef>
+                <a:spcPts val="700"/>
+              </a:spcBef>
+              <a:buFont typeface="Arial" panose="020B0604020202020204" pitchFamily="34" charset="0"/>
+              <a:buChar char="•"/>
+              <a:defRPr sz="2520" kern="1200">
+                <a:solidFill>
+                  <a:schemeClr val="tx1"/>
+                </a:solidFill>
+                <a:latin typeface="+mn-lt"/>
+                <a:ea typeface="+mn-ea"/>
+                <a:cs typeface="+mn-cs"/>
+              </a:defRPr>
+            </a:lvl7pPr>
+            <a:lvl8pPr marL="4800600" indent="-320040" algn="l" defTabSz="1280160" rtl="0" eaLnBrk="1" latinLnBrk="0" hangingPunct="1">
+              <a:lnSpc>
+                <a:spcPct val="90000"/>
+              </a:lnSpc>
+              <a:spcBef>
+                <a:spcPts val="700"/>
+              </a:spcBef>
+              <a:buFont typeface="Arial" panose="020B0604020202020204" pitchFamily="34" charset="0"/>
+              <a:buChar char="•"/>
+              <a:defRPr sz="2520" kern="1200">
+                <a:solidFill>
+                  <a:schemeClr val="tx1"/>
+                </a:solidFill>
+                <a:latin typeface="+mn-lt"/>
+                <a:ea typeface="+mn-ea"/>
+                <a:cs typeface="+mn-cs"/>
+              </a:defRPr>
+            </a:lvl8pPr>
+            <a:lvl9pPr marL="5440680" indent="-320040" algn="l" defTabSz="1280160" rtl="0" eaLnBrk="1" latinLnBrk="0" hangingPunct="1">
+              <a:lnSpc>
+                <a:spcPct val="90000"/>
+              </a:lnSpc>
+              <a:spcBef>
+                <a:spcPts val="700"/>
+              </a:spcBef>
+              <a:buFont typeface="Arial" panose="020B0604020202020204" pitchFamily="34" charset="0"/>
+              <a:buChar char="•"/>
+              <a:defRPr sz="2520" kern="1200">
+                <a:solidFill>
+                  <a:schemeClr val="tx1"/>
+                </a:solidFill>
+                <a:latin typeface="+mn-lt"/>
+                <a:ea typeface="+mn-ea"/>
+                <a:cs typeface="+mn-cs"/>
+              </a:defRPr>
+            </a:lvl9pPr>
+          </a:lstStyle>
+          <a:p>
+            <a:pPr algn="ctr">
+              <a:spcAft>
+                <a:spcPts val="0"/>
+              </a:spcAft>
+            </a:pPr>
+            <a:r>
+              <a:rPr lang="pt-BR" sz="1200" dirty="0">
+                <a:solidFill>
+                  <a:schemeClr val="tx1"/>
+                </a:solidFill>
+                <a:latin typeface="Arial" panose="020B0604020202020204" pitchFamily="34" charset="0"/>
+                <a:cs typeface="Arial" panose="020B0604020202020204" pitchFamily="34" charset="0"/>
+              </a:rPr>
+              <a:t>KPIs e visualizações disponíveis no Tableau Public, alimentados pela base analítica do projeto.</a:t>
             </a:r>
           </a:p>
         </p:txBody>
@@ -7034,20 +8342,20 @@
 </file>
 
 <file path=customXml/item2.xml><?xml version="1.0" encoding="utf-8"?>
+<p:properties xmlns:p="http://schemas.microsoft.com/office/2006/metadata/properties" xmlns:xsi="http://www.w3.org/2001/XMLSchema-instance" xmlns:pc="http://schemas.microsoft.com/office/infopath/2007/PartnerControls">
+  <documentManagement>
+    <_activity xmlns="6439f31e-650a-4110-90ce-dedea4761958" xsi:nil="true"/>
+  </documentManagement>
+</p:properties>
+</file>
+
+<file path=customXml/item3.xml><?xml version="1.0" encoding="utf-8"?>
 <?mso-contentType ?>
 <FormTemplates xmlns="http://schemas.microsoft.com/sharepoint/v3/contenttype/forms">
   <Display>DocumentLibraryForm</Display>
   <Edit>DocumentLibraryForm</Edit>
   <New>DocumentLibraryForm</New>
 </FormTemplates>
-</file>
-
-<file path=customXml/item3.xml><?xml version="1.0" encoding="utf-8"?>
-<p:properties xmlns:p="http://schemas.microsoft.com/office/2006/metadata/properties" xmlns:xsi="http://www.w3.org/2001/XMLSchema-instance" xmlns:pc="http://schemas.microsoft.com/office/infopath/2007/PartnerControls">
-  <documentManagement>
-    <_activity xmlns="6439f31e-650a-4110-90ce-dedea4761958" xsi:nil="true"/>
-  </documentManagement>
-</p:properties>
 </file>
 
 <file path=customXml/itemProps1.xml><?xml version="1.0" encoding="utf-8"?>
@@ -7070,14 +8378,6 @@
 </file>
 
 <file path=customXml/itemProps2.xml><?xml version="1.0" encoding="utf-8"?>
-<ds:datastoreItem xmlns:ds="http://schemas.openxmlformats.org/officeDocument/2006/customXml" ds:itemID="{F16D510D-55C7-43E2-BA4A-72786699A122}">
-  <ds:schemaRefs>
-    <ds:schemaRef ds:uri="http://schemas.microsoft.com/sharepoint/v3/contenttype/forms"/>
-  </ds:schemaRefs>
-</ds:datastoreItem>
-</file>
-
-<file path=customXml/itemProps3.xml><?xml version="1.0" encoding="utf-8"?>
 <ds:datastoreItem xmlns:ds="http://schemas.openxmlformats.org/officeDocument/2006/customXml" ds:itemID="{0C5DC577-20A1-4512-B4E1-28F0CC21B7A7}">
   <ds:schemaRefs>
     <ds:schemaRef ds:uri="http://schemas.microsoft.com/office/2006/documentManagement/types"/>
@@ -7092,4 +8392,12 @@
     <ds:schemaRef ds:uri="http://www.w3.org/XML/1998/namespace"/>
   </ds:schemaRefs>
 </ds:datastoreItem>
+</file>
+
+<file path=customXml/itemProps3.xml><?xml version="1.0" encoding="utf-8"?>
+<ds:datastoreItem xmlns:ds="http://schemas.openxmlformats.org/officeDocument/2006/customXml" ds:itemID="{F16D510D-55C7-43E2-BA4A-72786699A122}">
+  <ds:schemaRefs>
+    <ds:schemaRef ds:uri="http://schemas.microsoft.com/sharepoint/v3/contenttype/forms"/>
+  </ds:schemaRefs>
+</ds:datastoreItem>
 </file>
</xml_diff>

<commit_message>
feat: slide 2 - descrição das ferramentas
</commit_message>
<xml_diff>
--- a/docs/Template - Fase 2 - Apresentação Executiva - Projeto em Business Intelligence e Analytics.pptx
+++ b/docs/Template - Fase 2 - Apresentação Executiva - Projeto em Business Intelligence e Analytics.pptx
@@ -6405,8 +6405,8 @@
         </p:nvSpPr>
         <p:spPr>
           <a:xfrm>
-            <a:off x="928688" y="2041451"/>
-            <a:ext cx="14544674" cy="1703614"/>
+            <a:off x="6162992" y="2041451"/>
+            <a:ext cx="9310369" cy="1703614"/>
           </a:xfrm>
           <a:prstGeom prst="rect">
             <a:avLst/>
@@ -6607,7 +6607,7 @@
                 <a:latin typeface="Arial" panose="020B0604020202020204" pitchFamily="34" charset="0"/>
                 <a:cs typeface="Arial" panose="020B0604020202020204" pitchFamily="34" charset="0"/>
               </a:rPr>
-              <a:t> - Python</a:t>
+              <a:t>-   Python (pandas, scikit-learn): preparação de dados e modelagem preditiva;</a:t>
             </a:r>
           </a:p>
           <a:p>
@@ -6623,7 +6623,7 @@
                 <a:latin typeface="Arial" panose="020B0604020202020204" pitchFamily="34" charset="0"/>
                 <a:cs typeface="Arial" panose="020B0604020202020204" pitchFamily="34" charset="0"/>
               </a:rPr>
-              <a:t>Jupyter notebook</a:t>
+              <a:t>Jupyter notebook: desenvolvimento e documentação da análise;</a:t>
             </a:r>
           </a:p>
           <a:p>
@@ -6639,7 +6639,7 @@
                 <a:latin typeface="Arial" panose="020B0604020202020204" pitchFamily="34" charset="0"/>
                 <a:cs typeface="Arial" panose="020B0604020202020204" pitchFamily="34" charset="0"/>
               </a:rPr>
-              <a:t>Tableau Public</a:t>
+              <a:t>Tableau Public: construção e publicação do dashboard;</a:t>
             </a:r>
           </a:p>
           <a:p>
@@ -6655,10 +6655,8 @@
                 <a:latin typeface="Arial" panose="020B0604020202020204" pitchFamily="34" charset="0"/>
                 <a:cs typeface="Arial" panose="020B0604020202020204" pitchFamily="34" charset="0"/>
               </a:rPr>
-              <a:t> Git/Github</a:t>
+              <a:t> Git/Github: documentação e histórico do projeto.</a:t>
             </a:r>
-          </a:p>
-          <a:p>
             <a:endParaRPr lang="pt-BR" sz="3000" dirty="0">
               <a:solidFill>
                 <a:schemeClr val="tx1"/>
@@ -6685,8 +6683,8 @@
         </p:nvSpPr>
         <p:spPr>
           <a:xfrm>
-            <a:off x="928688" y="3799757"/>
-            <a:ext cx="14544674" cy="625401"/>
+            <a:off x="6162992" y="3857608"/>
+            <a:ext cx="2104798" cy="455006"/>
           </a:xfrm>
           <a:prstGeom prst="rect">
             <a:avLst/>
@@ -6918,12 +6916,20 @@
         </p:blipFill>
         <p:spPr>
           <a:xfrm>
-            <a:off x="928688" y="4370466"/>
-            <a:ext cx="3430905" cy="4288631"/>
+            <a:off x="566737" y="2041451"/>
+            <a:ext cx="5294117" cy="6617646"/>
           </a:xfrm>
           <a:prstGeom prst="rect">
             <a:avLst/>
           </a:prstGeom>
+          <a:effectLst>
+            <a:outerShdw blurRad="215900" dist="114300" dir="2700000" algn="tl" rotWithShape="0">
+              <a:prstClr val="black">
+                <a:alpha val="76000"/>
+              </a:prstClr>
+            </a:outerShdw>
+            <a:softEdge rad="38100"/>
+          </a:effectLst>
         </p:spPr>
       </p:pic>
       <p:sp>
@@ -6942,7 +6948,7 @@
         </p:nvSpPr>
         <p:spPr>
           <a:xfrm>
-            <a:off x="4535487" y="4425157"/>
+            <a:off x="6162992" y="4425158"/>
             <a:ext cx="7506971" cy="4233939"/>
           </a:xfrm>
           <a:prstGeom prst="rect">

</xml_diff>

<commit_message>
feat: Esboço do slide 2 melhorado
</commit_message>
<xml_diff>
--- a/docs/Template - Fase 2 - Apresentação Executiva - Projeto em Business Intelligence e Analytics.pptx
+++ b/docs/Template - Fase 2 - Apresentação Executiva - Projeto em Business Intelligence e Analytics.pptx
@@ -6948,8 +6948,8 @@
         </p:nvSpPr>
         <p:spPr>
           <a:xfrm>
-            <a:off x="6162992" y="4425158"/>
-            <a:ext cx="7506971" cy="4233939"/>
+            <a:off x="6162992" y="6031149"/>
+            <a:ext cx="7506971" cy="2627948"/>
           </a:xfrm>
           <a:prstGeom prst="rect">
             <a:avLst/>
@@ -7148,11 +7148,41 @@
                 <a:latin typeface="Arial" panose="020B0604020202020204" pitchFamily="34" charset="0"/>
                 <a:cs typeface="Arial" panose="020B0604020202020204" pitchFamily="34" charset="0"/>
               </a:rPr>
-              <a:t>Algum texto vai vir aqui</a:t>
+              <a:t>Links vai vir aqui</a:t>
             </a:r>
           </a:p>
         </p:txBody>
       </p:sp>
+      <p:pic>
+        <p:nvPicPr>
+          <p:cNvPr id="8" name="Imagem 7">
+            <a:extLst>
+              <a:ext uri="{FF2B5EF4-FFF2-40B4-BE49-F238E27FC236}">
+                <a16:creationId xmlns:a16="http://schemas.microsoft.com/office/drawing/2014/main" id="{F12AC9E0-8745-86C3-F4D0-0E15AA71A1FC}"/>
+              </a:ext>
+            </a:extLst>
+          </p:cNvPr>
+          <p:cNvPicPr>
+            <a:picLocks noChangeAspect="1"/>
+          </p:cNvPicPr>
+          <p:nvPr/>
+        </p:nvPicPr>
+        <p:blipFill>
+          <a:blip r:embed="rId4"/>
+          <a:stretch>
+            <a:fillRect/>
+          </a:stretch>
+        </p:blipFill>
+        <p:spPr>
+          <a:xfrm>
+            <a:off x="6162992" y="4370466"/>
+            <a:ext cx="1375116" cy="1375116"/>
+          </a:xfrm>
+          <a:prstGeom prst="rect">
+            <a:avLst/>
+          </a:prstGeom>
+        </p:spPr>
+      </p:pic>
     </p:spTree>
     <p:extLst>
       <p:ext uri="{BB962C8B-B14F-4D97-AF65-F5344CB8AC3E}">

</xml_diff>

<commit_message>
feat: Adiçao de simbolos e link para github slide 2
</commit_message>
<xml_diff>
--- a/docs/Template - Fase 2 - Apresentação Executiva - Projeto em Business Intelligence e Analytics.pptx
+++ b/docs/Template - Fase 2 - Apresentação Executiva - Projeto em Business Intelligence e Analytics.pptx
@@ -6948,8 +6948,8 @@
         </p:nvSpPr>
         <p:spPr>
           <a:xfrm>
-            <a:off x="6162992" y="6031149"/>
-            <a:ext cx="7506971" cy="2627948"/>
+            <a:off x="6162992" y="6162102"/>
+            <a:ext cx="9310369" cy="699685"/>
           </a:xfrm>
           <a:prstGeom prst="rect">
             <a:avLst/>
@@ -6967,7 +6967,7 @@
           </a:effectLst>
         </p:spPr>
         <p:txBody>
-          <a:bodyPr lIns="72000" tIns="72000" rIns="72000" bIns="72000"/>
+          <a:bodyPr lIns="72000" tIns="72000" rIns="72000" bIns="72000" anchor="ctr"/>
           <a:lstStyle>
             <a:lvl1pPr marL="0" indent="0" algn="l" defTabSz="1280160" rtl="0" eaLnBrk="1" latinLnBrk="0" hangingPunct="1">
               <a:lnSpc>
@@ -7138,6 +7138,7 @@
             </a:lvl9pPr>
           </a:lstStyle>
           <a:p>
+            <a:pPr algn="ctr"/>
             <a:r>
               <a:rPr lang="pt-BR" sz="1600" b="1" dirty="0">
                 <a:solidFill>
@@ -7148,8 +7149,25 @@
                 <a:latin typeface="Arial" panose="020B0604020202020204" pitchFamily="34" charset="0"/>
                 <a:cs typeface="Arial" panose="020B0604020202020204" pitchFamily="34" charset="0"/>
               </a:rPr>
-              <a:t>Links vai vir aqui</a:t>
+              <a:t>Repositorio: </a:t>
             </a:r>
+            <a:r>
+              <a:rPr lang="pt-BR" sz="1600" dirty="0">
+                <a:solidFill>
+                  <a:srgbClr val="333333"/>
+                </a:solidFill>
+              </a:rPr>
+              <a:t>github.com/FelipePinheiro964/Projeto-Em-Business-Intelligence-e-Analytics</a:t>
+            </a:r>
+            <a:endParaRPr lang="pt-BR" sz="1600" b="1" dirty="0">
+              <a:solidFill>
+                <a:schemeClr val="accent1">
+                  <a:lumMod val="75000"/>
+                </a:schemeClr>
+              </a:solidFill>
+              <a:latin typeface="Arial" panose="020B0604020202020204" pitchFamily="34" charset="0"/>
+              <a:cs typeface="Arial" panose="020B0604020202020204" pitchFamily="34" charset="0"/>
+            </a:endParaRPr>
           </a:p>
         </p:txBody>
       </p:sp>
@@ -7183,6 +7201,243 @@
           </a:prstGeom>
         </p:spPr>
       </p:pic>
+      <p:pic>
+        <p:nvPicPr>
+          <p:cNvPr id="10" name="Imagem 9">
+            <a:extLst>
+              <a:ext uri="{FF2B5EF4-FFF2-40B4-BE49-F238E27FC236}">
+                <a16:creationId xmlns:a16="http://schemas.microsoft.com/office/drawing/2014/main" id="{725373C1-0109-E1BE-EA7A-614C5EDBCC74}"/>
+              </a:ext>
+            </a:extLst>
+          </p:cNvPr>
+          <p:cNvPicPr>
+            <a:picLocks noChangeAspect="1"/>
+          </p:cNvPicPr>
+          <p:nvPr/>
+        </p:nvPicPr>
+        <p:blipFill>
+          <a:blip r:embed="rId5"/>
+          <a:stretch>
+            <a:fillRect/>
+          </a:stretch>
+        </p:blipFill>
+        <p:spPr>
+          <a:xfrm>
+            <a:off x="14009583" y="4375160"/>
+            <a:ext cx="1528752" cy="1528752"/>
+          </a:xfrm>
+          <a:prstGeom prst="rect">
+            <a:avLst/>
+          </a:prstGeom>
+        </p:spPr>
+      </p:pic>
+      <p:pic>
+        <p:nvPicPr>
+          <p:cNvPr id="13" name="Imagem 12">
+            <a:extLst>
+              <a:ext uri="{FF2B5EF4-FFF2-40B4-BE49-F238E27FC236}">
+                <a16:creationId xmlns:a16="http://schemas.microsoft.com/office/drawing/2014/main" id="{D5E3CD0E-419B-53D1-37AF-D251EF6AA517}"/>
+              </a:ext>
+            </a:extLst>
+          </p:cNvPr>
+          <p:cNvPicPr>
+            <a:picLocks noChangeAspect="1"/>
+          </p:cNvPicPr>
+          <p:nvPr/>
+        </p:nvPicPr>
+        <p:blipFill>
+          <a:blip r:embed="rId6"/>
+          <a:stretch>
+            <a:fillRect/>
+          </a:stretch>
+        </p:blipFill>
+        <p:spPr>
+          <a:xfrm>
+            <a:off x="8571344" y="4370466"/>
+            <a:ext cx="585199" cy="678831"/>
+          </a:xfrm>
+          <a:prstGeom prst="rect">
+            <a:avLst/>
+          </a:prstGeom>
+        </p:spPr>
+      </p:pic>
+      <p:pic>
+        <p:nvPicPr>
+          <p:cNvPr id="15" name="Imagem 14">
+            <a:extLst>
+              <a:ext uri="{FF2B5EF4-FFF2-40B4-BE49-F238E27FC236}">
+                <a16:creationId xmlns:a16="http://schemas.microsoft.com/office/drawing/2014/main" id="{2DC6EF2B-2B87-02DF-90ED-3DC13C37CD04}"/>
+              </a:ext>
+            </a:extLst>
+          </p:cNvPr>
+          <p:cNvPicPr>
+            <a:picLocks noChangeAspect="1"/>
+          </p:cNvPicPr>
+          <p:nvPr/>
+        </p:nvPicPr>
+        <p:blipFill>
+          <a:blip r:embed="rId7"/>
+          <a:stretch>
+            <a:fillRect/>
+          </a:stretch>
+        </p:blipFill>
+        <p:spPr>
+          <a:xfrm>
+            <a:off x="9013758" y="4861270"/>
+            <a:ext cx="704079" cy="704079"/>
+          </a:xfrm>
+          <a:prstGeom prst="rect">
+            <a:avLst/>
+          </a:prstGeom>
+        </p:spPr>
+      </p:pic>
+      <p:pic>
+        <p:nvPicPr>
+          <p:cNvPr id="17" name="Imagem 16">
+            <a:extLst>
+              <a:ext uri="{FF2B5EF4-FFF2-40B4-BE49-F238E27FC236}">
+                <a16:creationId xmlns:a16="http://schemas.microsoft.com/office/drawing/2014/main" id="{96BBE995-1C79-097C-290D-266DEA251D8E}"/>
+              </a:ext>
+            </a:extLst>
+          </p:cNvPr>
+          <p:cNvPicPr>
+            <a:picLocks noChangeAspect="1"/>
+          </p:cNvPicPr>
+          <p:nvPr/>
+        </p:nvPicPr>
+        <p:blipFill>
+          <a:blip r:embed="rId8"/>
+          <a:stretch>
+            <a:fillRect/>
+          </a:stretch>
+        </p:blipFill>
+        <p:spPr>
+          <a:xfrm>
+            <a:off x="11193487" y="4709881"/>
+            <a:ext cx="1543528" cy="865882"/>
+          </a:xfrm>
+          <a:prstGeom prst="rect">
+            <a:avLst/>
+          </a:prstGeom>
+        </p:spPr>
+      </p:pic>
+      <p:cxnSp>
+        <p:nvCxnSpPr>
+          <p:cNvPr id="21" name="Conexão reta unidirecional 20">
+            <a:extLst>
+              <a:ext uri="{FF2B5EF4-FFF2-40B4-BE49-F238E27FC236}">
+                <a16:creationId xmlns:a16="http://schemas.microsoft.com/office/drawing/2014/main" id="{D1997E0B-B04D-7029-8A65-F8D7E7A670A4}"/>
+              </a:ext>
+            </a:extLst>
+          </p:cNvPr>
+          <p:cNvCxnSpPr/>
+          <p:nvPr/>
+        </p:nvCxnSpPr>
+        <p:spPr>
+          <a:xfrm>
+            <a:off x="7691790" y="5139536"/>
+            <a:ext cx="576000" cy="0"/>
+          </a:xfrm>
+          <a:prstGeom prst="straightConnector1">
+            <a:avLst/>
+          </a:prstGeom>
+          <a:ln w="63500">
+            <a:tailEnd type="triangle"/>
+          </a:ln>
+        </p:spPr>
+        <p:style>
+          <a:lnRef idx="3">
+            <a:schemeClr val="dk1"/>
+          </a:lnRef>
+          <a:fillRef idx="0">
+            <a:schemeClr val="dk1"/>
+          </a:fillRef>
+          <a:effectRef idx="2">
+            <a:schemeClr val="dk1"/>
+          </a:effectRef>
+          <a:fontRef idx="minor">
+            <a:schemeClr val="tx1"/>
+          </a:fontRef>
+        </p:style>
+      </p:cxnSp>
+      <p:cxnSp>
+        <p:nvCxnSpPr>
+          <p:cNvPr id="22" name="Conexão reta unidirecional 21">
+            <a:extLst>
+              <a:ext uri="{FF2B5EF4-FFF2-40B4-BE49-F238E27FC236}">
+                <a16:creationId xmlns:a16="http://schemas.microsoft.com/office/drawing/2014/main" id="{CFDEC7BE-093F-416E-782E-908D025FF4E0}"/>
+              </a:ext>
+            </a:extLst>
+          </p:cNvPr>
+          <p:cNvCxnSpPr/>
+          <p:nvPr/>
+        </p:nvCxnSpPr>
+        <p:spPr>
+          <a:xfrm>
+            <a:off x="10242176" y="5148272"/>
+            <a:ext cx="576000" cy="0"/>
+          </a:xfrm>
+          <a:prstGeom prst="straightConnector1">
+            <a:avLst/>
+          </a:prstGeom>
+          <a:ln w="63500">
+            <a:tailEnd type="triangle"/>
+          </a:ln>
+        </p:spPr>
+        <p:style>
+          <a:lnRef idx="3">
+            <a:schemeClr val="dk1"/>
+          </a:lnRef>
+          <a:fillRef idx="0">
+            <a:schemeClr val="dk1"/>
+          </a:fillRef>
+          <a:effectRef idx="2">
+            <a:schemeClr val="dk1"/>
+          </a:effectRef>
+          <a:fontRef idx="minor">
+            <a:schemeClr val="tx1"/>
+          </a:fontRef>
+        </p:style>
+      </p:cxnSp>
+      <p:cxnSp>
+        <p:nvCxnSpPr>
+          <p:cNvPr id="23" name="Conexão reta unidirecional 22">
+            <a:extLst>
+              <a:ext uri="{FF2B5EF4-FFF2-40B4-BE49-F238E27FC236}">
+                <a16:creationId xmlns:a16="http://schemas.microsoft.com/office/drawing/2014/main" id="{7AE804C6-E45A-72D3-3CF0-2EA935C897E4}"/>
+              </a:ext>
+            </a:extLst>
+          </p:cNvPr>
+          <p:cNvCxnSpPr/>
+          <p:nvPr/>
+        </p:nvCxnSpPr>
+        <p:spPr>
+          <a:xfrm>
+            <a:off x="13093963" y="5213309"/>
+            <a:ext cx="576000" cy="0"/>
+          </a:xfrm>
+          <a:prstGeom prst="straightConnector1">
+            <a:avLst/>
+          </a:prstGeom>
+          <a:ln w="63500">
+            <a:tailEnd type="triangle"/>
+          </a:ln>
+        </p:spPr>
+        <p:style>
+          <a:lnRef idx="3">
+            <a:schemeClr val="dk1"/>
+          </a:lnRef>
+          <a:fillRef idx="0">
+            <a:schemeClr val="dk1"/>
+          </a:fillRef>
+          <a:effectRef idx="2">
+            <a:schemeClr val="dk1"/>
+          </a:effectRef>
+          <a:fontRef idx="minor">
+            <a:schemeClr val="tx1"/>
+          </a:fontRef>
+        </p:style>
+      </p:cxnSp>
     </p:spTree>
     <p:extLst>
       <p:ext uri="{BB962C8B-B14F-4D97-AF65-F5344CB8AC3E}">

</xml_diff>

<commit_message>
feat: Adição de descrição para etapas e processos
</commit_message>
<xml_diff>
--- a/docs/Template - Fase 2 - Apresentação Executiva - Projeto em Business Intelligence e Analytics.pptx
+++ b/docs/Template - Fase 2 - Apresentação Executiva - Projeto em Business Intelligence e Analytics.pptx
@@ -6948,7 +6948,7 @@
         </p:nvSpPr>
         <p:spPr>
           <a:xfrm>
-            <a:off x="6162992" y="6162102"/>
+            <a:off x="6162991" y="7887778"/>
             <a:ext cx="9310369" cy="699685"/>
           </a:xfrm>
           <a:prstGeom prst="rect">
@@ -7438,6 +7438,225 @@
           </a:fontRef>
         </p:style>
       </p:cxnSp>
+      <p:sp>
+        <p:nvSpPr>
+          <p:cNvPr id="27" name="Espaço Reservado para Texto 1">
+            <a:extLst>
+              <a:ext uri="{FF2B5EF4-FFF2-40B4-BE49-F238E27FC236}">
+                <a16:creationId xmlns:a16="http://schemas.microsoft.com/office/drawing/2014/main" id="{CD5BAB17-3511-3C53-FBF3-51D6232CFE95}"/>
+              </a:ext>
+            </a:extLst>
+          </p:cNvPr>
+          <p:cNvSpPr txBox="1">
+            <a:spLocks/>
+          </p:cNvSpPr>
+          <p:nvPr/>
+        </p:nvSpPr>
+        <p:spPr>
+          <a:xfrm>
+            <a:off x="6227966" y="6021140"/>
+            <a:ext cx="9607347" cy="1350586"/>
+          </a:xfrm>
+          <a:prstGeom prst="rect">
+            <a:avLst/>
+          </a:prstGeom>
+          <a:noFill/>
+          <a:effectLst>
+            <a:softEdge rad="38100"/>
+          </a:effectLst>
+        </p:spPr>
+        <p:txBody>
+          <a:bodyPr lIns="72000" tIns="72000" rIns="72000" bIns="72000" anchor="ctr"/>
+          <a:lstStyle>
+            <a:lvl1pPr marL="0" indent="0" algn="l" defTabSz="1280160" rtl="0" eaLnBrk="1" latinLnBrk="0" hangingPunct="1">
+              <a:lnSpc>
+                <a:spcPct val="100000"/>
+              </a:lnSpc>
+              <a:spcBef>
+                <a:spcPts val="0"/>
+              </a:spcBef>
+              <a:spcAft>
+                <a:spcPts val="1200"/>
+              </a:spcAft>
+              <a:buFont typeface="Arial" panose="020B0604020202020204" pitchFamily="34" charset="0"/>
+              <a:buNone/>
+              <a:defRPr sz="1800" kern="1200">
+                <a:solidFill>
+                  <a:schemeClr val="tx2">
+                    <a:lumMod val="75000"/>
+                  </a:schemeClr>
+                </a:solidFill>
+                <a:latin typeface="+mn-lt"/>
+                <a:ea typeface="+mn-ea"/>
+                <a:cs typeface="+mn-cs"/>
+              </a:defRPr>
+            </a:lvl1pPr>
+            <a:lvl2pPr marL="640080" indent="0" algn="l" defTabSz="1280160" rtl="0" eaLnBrk="1" latinLnBrk="0" hangingPunct="1">
+              <a:lnSpc>
+                <a:spcPct val="90000"/>
+              </a:lnSpc>
+              <a:spcBef>
+                <a:spcPts val="700"/>
+              </a:spcBef>
+              <a:buFont typeface="Arial" panose="020B0604020202020204" pitchFamily="34" charset="0"/>
+              <a:buNone/>
+              <a:defRPr sz="1400" kern="1200">
+                <a:solidFill>
+                  <a:schemeClr val="tx1"/>
+                </a:solidFill>
+                <a:latin typeface="+mn-lt"/>
+                <a:ea typeface="+mn-ea"/>
+                <a:cs typeface="+mn-cs"/>
+              </a:defRPr>
+            </a:lvl2pPr>
+            <a:lvl3pPr marL="1280160" indent="0" algn="l" defTabSz="1280160" rtl="0" eaLnBrk="1" latinLnBrk="0" hangingPunct="1">
+              <a:lnSpc>
+                <a:spcPct val="90000"/>
+              </a:lnSpc>
+              <a:spcBef>
+                <a:spcPts val="700"/>
+              </a:spcBef>
+              <a:buFont typeface="Arial" panose="020B0604020202020204" pitchFamily="34" charset="0"/>
+              <a:buNone/>
+              <a:defRPr sz="1400" kern="1200">
+                <a:solidFill>
+                  <a:schemeClr val="tx1"/>
+                </a:solidFill>
+                <a:latin typeface="+mn-lt"/>
+                <a:ea typeface="+mn-ea"/>
+                <a:cs typeface="+mn-cs"/>
+              </a:defRPr>
+            </a:lvl3pPr>
+            <a:lvl4pPr marL="1920240" indent="0" algn="l" defTabSz="1280160" rtl="0" eaLnBrk="1" latinLnBrk="0" hangingPunct="1">
+              <a:lnSpc>
+                <a:spcPct val="90000"/>
+              </a:lnSpc>
+              <a:spcBef>
+                <a:spcPts val="700"/>
+              </a:spcBef>
+              <a:buFont typeface="Arial" panose="020B0604020202020204" pitchFamily="34" charset="0"/>
+              <a:buNone/>
+              <a:defRPr sz="1400" kern="1200">
+                <a:solidFill>
+                  <a:schemeClr val="tx1"/>
+                </a:solidFill>
+                <a:latin typeface="+mn-lt"/>
+                <a:ea typeface="+mn-ea"/>
+                <a:cs typeface="+mn-cs"/>
+              </a:defRPr>
+            </a:lvl4pPr>
+            <a:lvl5pPr marL="2560320" indent="0" algn="l" defTabSz="1280160" rtl="0" eaLnBrk="1" latinLnBrk="0" hangingPunct="1">
+              <a:lnSpc>
+                <a:spcPct val="90000"/>
+              </a:lnSpc>
+              <a:spcBef>
+                <a:spcPts val="700"/>
+              </a:spcBef>
+              <a:buFont typeface="Arial" panose="020B0604020202020204" pitchFamily="34" charset="0"/>
+              <a:buNone/>
+              <a:defRPr sz="1400" kern="1200">
+                <a:solidFill>
+                  <a:schemeClr val="tx1"/>
+                </a:solidFill>
+                <a:latin typeface="+mn-lt"/>
+                <a:ea typeface="+mn-ea"/>
+                <a:cs typeface="+mn-cs"/>
+              </a:defRPr>
+            </a:lvl5pPr>
+            <a:lvl6pPr marL="3520440" indent="-320040" algn="l" defTabSz="1280160" rtl="0" eaLnBrk="1" latinLnBrk="0" hangingPunct="1">
+              <a:lnSpc>
+                <a:spcPct val="90000"/>
+              </a:lnSpc>
+              <a:spcBef>
+                <a:spcPts val="700"/>
+              </a:spcBef>
+              <a:buFont typeface="Arial" panose="020B0604020202020204" pitchFamily="34" charset="0"/>
+              <a:buChar char="•"/>
+              <a:defRPr sz="2520" kern="1200">
+                <a:solidFill>
+                  <a:schemeClr val="tx1"/>
+                </a:solidFill>
+                <a:latin typeface="+mn-lt"/>
+                <a:ea typeface="+mn-ea"/>
+                <a:cs typeface="+mn-cs"/>
+              </a:defRPr>
+            </a:lvl6pPr>
+            <a:lvl7pPr marL="4160520" indent="-320040" algn="l" defTabSz="1280160" rtl="0" eaLnBrk="1" latinLnBrk="0" hangingPunct="1">
+              <a:lnSpc>
+                <a:spcPct val="90000"/>
+              </a:lnSpc>
+              <a:spcBef>
+                <a:spcPts val="700"/>
+              </a:spcBef>
+              <a:buFont typeface="Arial" panose="020B0604020202020204" pitchFamily="34" charset="0"/>
+              <a:buChar char="•"/>
+              <a:defRPr sz="2520" kern="1200">
+                <a:solidFill>
+                  <a:schemeClr val="tx1"/>
+                </a:solidFill>
+                <a:latin typeface="+mn-lt"/>
+                <a:ea typeface="+mn-ea"/>
+                <a:cs typeface="+mn-cs"/>
+              </a:defRPr>
+            </a:lvl7pPr>
+            <a:lvl8pPr marL="4800600" indent="-320040" algn="l" defTabSz="1280160" rtl="0" eaLnBrk="1" latinLnBrk="0" hangingPunct="1">
+              <a:lnSpc>
+                <a:spcPct val="90000"/>
+              </a:lnSpc>
+              <a:spcBef>
+                <a:spcPts val="700"/>
+              </a:spcBef>
+              <a:buFont typeface="Arial" panose="020B0604020202020204" pitchFamily="34" charset="0"/>
+              <a:buChar char="•"/>
+              <a:defRPr sz="2520" kern="1200">
+                <a:solidFill>
+                  <a:schemeClr val="tx1"/>
+                </a:solidFill>
+                <a:latin typeface="+mn-lt"/>
+                <a:ea typeface="+mn-ea"/>
+                <a:cs typeface="+mn-cs"/>
+              </a:defRPr>
+            </a:lvl8pPr>
+            <a:lvl9pPr marL="5440680" indent="-320040" algn="l" defTabSz="1280160" rtl="0" eaLnBrk="1" latinLnBrk="0" hangingPunct="1">
+              <a:lnSpc>
+                <a:spcPct val="90000"/>
+              </a:lnSpc>
+              <a:spcBef>
+                <a:spcPts val="700"/>
+              </a:spcBef>
+              <a:buFont typeface="Arial" panose="020B0604020202020204" pitchFamily="34" charset="0"/>
+              <a:buChar char="•"/>
+              <a:defRPr sz="2520" kern="1200">
+                <a:solidFill>
+                  <a:schemeClr val="tx1"/>
+                </a:solidFill>
+                <a:latin typeface="+mn-lt"/>
+                <a:ea typeface="+mn-ea"/>
+                <a:cs typeface="+mn-cs"/>
+              </a:defRPr>
+            </a:lvl9pPr>
+          </a:lstStyle>
+          <a:p>
+            <a:pPr algn="ctr"/>
+            <a:r>
+              <a:rPr lang="pt-BR" sz="1400" dirty="0">
+                <a:latin typeface="Arial" panose="020B0604020202020204" pitchFamily="34" charset="0"/>
+                <a:cs typeface="Arial" panose="020B0604020202020204" pitchFamily="34" charset="0"/>
+              </a:rPr>
+              <a:t>Os dados foram obtidos em formato CSV no Kaggle e analisados e preparados no Python/Jupyter Notebook. Com a biblioteca Scikit-learn, foi calculado o risco de rebaixamento de cada clube. Os resultados foram exportados para um novo CSV e posteriormente utilizados no Tableau para criação e publicação do dashboard no Tableau Public.</a:t>
+            </a:r>
+            <a:endParaRPr lang="pt-BR" sz="1400" b="1" dirty="0">
+              <a:solidFill>
+                <a:schemeClr val="accent1">
+                  <a:lumMod val="75000"/>
+                </a:schemeClr>
+              </a:solidFill>
+              <a:latin typeface="Arial" panose="020B0604020202020204" pitchFamily="34" charset="0"/>
+              <a:cs typeface="Arial" panose="020B0604020202020204" pitchFamily="34" charset="0"/>
+            </a:endParaRPr>
+          </a:p>
+        </p:txBody>
+      </p:sp>
     </p:spTree>
     <p:extLst>
       <p:ext uri="{BB962C8B-B14F-4D97-AF65-F5344CB8AC3E}">

</xml_diff>

<commit_message>
feat: adicionei um grafico no notebook 2, mas tive que rodar todo o codigo novamente
</commit_message>
<xml_diff>
--- a/docs/Template - Fase 2 - Apresentação Executiva - Projeto em Business Intelligence e Analytics.pptx
+++ b/docs/Template - Fase 2 - Apresentação Executiva - Projeto em Business Intelligence e Analytics.pptx
@@ -5,17 +5,18 @@
     <p:sldMasterId id="2147483665" r:id="rId4"/>
   </p:sldMasterIdLst>
   <p:notesMasterIdLst>
-    <p:notesMasterId r:id="rId10"/>
+    <p:notesMasterId r:id="rId11"/>
   </p:notesMasterIdLst>
   <p:handoutMasterIdLst>
-    <p:handoutMasterId r:id="rId11"/>
+    <p:handoutMasterId r:id="rId12"/>
   </p:handoutMasterIdLst>
   <p:sldIdLst>
     <p:sldId id="288" r:id="rId5"/>
     <p:sldId id="303" r:id="rId6"/>
     <p:sldId id="302" r:id="rId7"/>
     <p:sldId id="304" r:id="rId8"/>
-    <p:sldId id="300" r:id="rId9"/>
+    <p:sldId id="305" r:id="rId9"/>
+    <p:sldId id="300" r:id="rId10"/>
   </p:sldIdLst>
   <p:sldSz cx="16402050" cy="9601200"/>
   <p:notesSz cx="6858000" cy="9144000"/>
@@ -123,6 +124,7 @@
             <p14:sldId id="303"/>
             <p14:sldId id="302"/>
             <p14:sldId id="304"/>
+            <p14:sldId id="305"/>
             <p14:sldId id="300"/>
           </p14:sldIdLst>
         </p14:section>
@@ -1884,6 +1886,114 @@
 </p:notes>
 </file>
 
+<file path=ppt/notesSlides/notesSlide2.xml><?xml version="1.0" encoding="utf-8"?>
+<p:notes xmlns:a="http://schemas.openxmlformats.org/drawingml/2006/main" xmlns:r="http://schemas.openxmlformats.org/officeDocument/2006/relationships" xmlns:p="http://schemas.openxmlformats.org/presentationml/2006/main">
+  <p:cSld>
+    <p:spTree>
+      <p:nvGrpSpPr>
+        <p:cNvPr id="1" name="">
+          <a:extLst>
+            <a:ext uri="{FF2B5EF4-FFF2-40B4-BE49-F238E27FC236}">
+              <a16:creationId xmlns:a16="http://schemas.microsoft.com/office/drawing/2014/main" id="{1FD1205A-1E4D-2B3B-19D6-6FBCA06E5136}"/>
+            </a:ext>
+          </a:extLst>
+        </p:cNvPr>
+        <p:cNvGrpSpPr/>
+        <p:nvPr/>
+      </p:nvGrpSpPr>
+      <p:grpSpPr>
+        <a:xfrm>
+          <a:off x="0" y="0"/>
+          <a:ext cx="0" cy="0"/>
+          <a:chOff x="0" y="0"/>
+          <a:chExt cx="0" cy="0"/>
+        </a:xfrm>
+      </p:grpSpPr>
+      <p:sp>
+        <p:nvSpPr>
+          <p:cNvPr id="2" name="Marcador de Posição da Imagem do Diapositivo 1">
+            <a:extLst>
+              <a:ext uri="{FF2B5EF4-FFF2-40B4-BE49-F238E27FC236}">
+                <a16:creationId xmlns:a16="http://schemas.microsoft.com/office/drawing/2014/main" id="{3A397BE8-29A4-C3CF-4321-6D4D995AD47C}"/>
+              </a:ext>
+            </a:extLst>
+          </p:cNvPr>
+          <p:cNvSpPr>
+            <a:spLocks noGrp="1" noRot="1" noChangeAspect="1"/>
+          </p:cNvSpPr>
+          <p:nvPr>
+            <p:ph type="sldImg"/>
+          </p:nvPr>
+        </p:nvSpPr>
+        <p:spPr/>
+      </p:sp>
+      <p:sp>
+        <p:nvSpPr>
+          <p:cNvPr id="3" name="Marcador de Posição de Notas 2">
+            <a:extLst>
+              <a:ext uri="{FF2B5EF4-FFF2-40B4-BE49-F238E27FC236}">
+                <a16:creationId xmlns:a16="http://schemas.microsoft.com/office/drawing/2014/main" id="{C4B24ECB-5489-19BB-F2C5-2608144AEBEF}"/>
+              </a:ext>
+            </a:extLst>
+          </p:cNvPr>
+          <p:cNvSpPr>
+            <a:spLocks noGrp="1"/>
+          </p:cNvSpPr>
+          <p:nvPr>
+            <p:ph type="body" idx="1"/>
+          </p:nvPr>
+        </p:nvSpPr>
+        <p:spPr/>
+        <p:txBody>
+          <a:bodyPr/>
+          <a:lstStyle/>
+          <a:p>
+            <a:endParaRPr lang="pt-BR" dirty="0"/>
+          </a:p>
+        </p:txBody>
+      </p:sp>
+      <p:sp>
+        <p:nvSpPr>
+          <p:cNvPr id="4" name="Marcador de Posição do Número do Diapositivo 3">
+            <a:extLst>
+              <a:ext uri="{FF2B5EF4-FFF2-40B4-BE49-F238E27FC236}">
+                <a16:creationId xmlns:a16="http://schemas.microsoft.com/office/drawing/2014/main" id="{98E68C17-2EBF-BB24-C900-0BED949B75B5}"/>
+              </a:ext>
+            </a:extLst>
+          </p:cNvPr>
+          <p:cNvSpPr>
+            <a:spLocks noGrp="1"/>
+          </p:cNvSpPr>
+          <p:nvPr>
+            <p:ph type="sldNum" sz="quarter" idx="5"/>
+          </p:nvPr>
+        </p:nvSpPr>
+        <p:spPr/>
+        <p:txBody>
+          <a:bodyPr/>
+          <a:lstStyle/>
+          <a:p>
+            <a:fld id="{4EC3EDC0-8BE0-4B53-981B-0D2AEC565C43}" type="slidenum">
+              <a:rPr lang="pt-BR" smtClean="0"/>
+              <a:t>5</a:t>
+            </a:fld>
+            <a:endParaRPr lang="pt-BR"/>
+          </a:p>
+        </p:txBody>
+      </p:sp>
+    </p:spTree>
+    <p:extLst>
+      <p:ext uri="{BB962C8B-B14F-4D97-AF65-F5344CB8AC3E}">
+        <p14:creationId xmlns:p14="http://schemas.microsoft.com/office/powerpoint/2010/main" val="3366602549"/>
+      </p:ext>
+    </p:extLst>
+  </p:cSld>
+  <p:clrMapOvr>
+    <a:masterClrMapping/>
+  </p:clrMapOvr>
+</p:notes>
+</file>
+
 <file path=ppt/slideLayouts/slideLayout1.xml><?xml version="1.0" encoding="utf-8"?>
 <p:sldLayout xmlns:a="http://schemas.openxmlformats.org/drawingml/2006/main" xmlns:r="http://schemas.openxmlformats.org/officeDocument/2006/relationships" xmlns:p="http://schemas.openxmlformats.org/presentationml/2006/main" preserve="1" userDrawn="1">
   <p:cSld name="Layout Personalizado">
@@ -7671,6 +7781,2003 @@
 </file>
 
 <file path=ppt/slides/slide5.xml><?xml version="1.0" encoding="utf-8"?>
+<p:sld xmlns:a="http://schemas.openxmlformats.org/drawingml/2006/main" xmlns:r="http://schemas.openxmlformats.org/officeDocument/2006/relationships" xmlns:p="http://schemas.openxmlformats.org/presentationml/2006/main">
+  <p:cSld>
+    <p:spTree>
+      <p:nvGrpSpPr>
+        <p:cNvPr id="1" name="">
+          <a:extLst>
+            <a:ext uri="{FF2B5EF4-FFF2-40B4-BE49-F238E27FC236}">
+              <a16:creationId xmlns:a16="http://schemas.microsoft.com/office/drawing/2014/main" id="{2ADD4340-6EE1-4068-38AA-90BE1A33911A}"/>
+            </a:ext>
+          </a:extLst>
+        </p:cNvPr>
+        <p:cNvGrpSpPr/>
+        <p:nvPr/>
+      </p:nvGrpSpPr>
+      <p:grpSpPr>
+        <a:xfrm>
+          <a:off x="0" y="0"/>
+          <a:ext cx="0" cy="0"/>
+          <a:chOff x="0" y="0"/>
+          <a:chExt cx="0" cy="0"/>
+        </a:xfrm>
+      </p:grpSpPr>
+      <p:sp>
+        <p:nvSpPr>
+          <p:cNvPr id="2" name="Espaço Reservado para Texto 1">
+            <a:extLst>
+              <a:ext uri="{FF2B5EF4-FFF2-40B4-BE49-F238E27FC236}">
+                <a16:creationId xmlns:a16="http://schemas.microsoft.com/office/drawing/2014/main" id="{D2D51578-798C-CC7B-83A1-52FCA37E0CC0}"/>
+              </a:ext>
+            </a:extLst>
+          </p:cNvPr>
+          <p:cNvSpPr>
+            <a:spLocks noGrp="1"/>
+          </p:cNvSpPr>
+          <p:nvPr>
+            <p:ph type="body" sz="quarter" idx="10"/>
+          </p:nvPr>
+        </p:nvSpPr>
+        <p:spPr>
+          <a:xfrm>
+            <a:off x="928689" y="1416050"/>
+            <a:ext cx="14544674" cy="625401"/>
+          </a:xfrm>
+        </p:spPr>
+        <p:txBody>
+          <a:bodyPr/>
+          <a:lstStyle/>
+          <a:p>
+            <a:r>
+              <a:rPr lang="pt-BR" sz="3000" b="1" dirty="0">
+                <a:solidFill>
+                  <a:schemeClr val="accent1">
+                    <a:lumMod val="75000"/>
+                  </a:schemeClr>
+                </a:solidFill>
+                <a:latin typeface="Arial" panose="020B0604020202020204" pitchFamily="34" charset="0"/>
+                <a:cs typeface="Arial" panose="020B0604020202020204" pitchFamily="34" charset="0"/>
+              </a:rPr>
+              <a:t>Resultados do modelo</a:t>
+            </a:r>
+          </a:p>
+        </p:txBody>
+      </p:sp>
+      <p:sp>
+        <p:nvSpPr>
+          <p:cNvPr id="6" name="Espaço Reservado para Texto 1">
+            <a:extLst>
+              <a:ext uri="{FF2B5EF4-FFF2-40B4-BE49-F238E27FC236}">
+                <a16:creationId xmlns:a16="http://schemas.microsoft.com/office/drawing/2014/main" id="{C18CEF13-32EC-5EE6-0721-285AC48D6C51}"/>
+              </a:ext>
+            </a:extLst>
+          </p:cNvPr>
+          <p:cNvSpPr txBox="1">
+            <a:spLocks/>
+          </p:cNvSpPr>
+          <p:nvPr/>
+        </p:nvSpPr>
+        <p:spPr>
+          <a:xfrm>
+            <a:off x="928688" y="2270959"/>
+            <a:ext cx="4386262" cy="2109107"/>
+          </a:xfrm>
+          <a:prstGeom prst="rect">
+            <a:avLst/>
+          </a:prstGeom>
+          <a:solidFill>
+            <a:schemeClr val="bg2"/>
+          </a:solidFill>
+          <a:effectLst>
+            <a:outerShdw blurRad="215900" dist="114300" dir="2700000" algn="tl" rotWithShape="0">
+              <a:prstClr val="black">
+                <a:alpha val="30000"/>
+              </a:prstClr>
+            </a:outerShdw>
+            <a:softEdge rad="38100"/>
+          </a:effectLst>
+        </p:spPr>
+        <p:txBody>
+          <a:bodyPr lIns="72000" tIns="72000" rIns="72000" bIns="72000"/>
+          <a:lstStyle>
+            <a:lvl1pPr marL="0" indent="0" algn="l" defTabSz="1280160" rtl="0" eaLnBrk="1" latinLnBrk="0" hangingPunct="1">
+              <a:lnSpc>
+                <a:spcPct val="100000"/>
+              </a:lnSpc>
+              <a:spcBef>
+                <a:spcPts val="0"/>
+              </a:spcBef>
+              <a:spcAft>
+                <a:spcPts val="1200"/>
+              </a:spcAft>
+              <a:buFont typeface="Arial" panose="020B0604020202020204" pitchFamily="34" charset="0"/>
+              <a:buNone/>
+              <a:defRPr sz="1800" kern="1200">
+                <a:solidFill>
+                  <a:schemeClr val="tx2">
+                    <a:lumMod val="75000"/>
+                  </a:schemeClr>
+                </a:solidFill>
+                <a:latin typeface="+mn-lt"/>
+                <a:ea typeface="+mn-ea"/>
+                <a:cs typeface="+mn-cs"/>
+              </a:defRPr>
+            </a:lvl1pPr>
+            <a:lvl2pPr marL="640080" indent="0" algn="l" defTabSz="1280160" rtl="0" eaLnBrk="1" latinLnBrk="0" hangingPunct="1">
+              <a:lnSpc>
+                <a:spcPct val="90000"/>
+              </a:lnSpc>
+              <a:spcBef>
+                <a:spcPts val="700"/>
+              </a:spcBef>
+              <a:buFont typeface="Arial" panose="020B0604020202020204" pitchFamily="34" charset="0"/>
+              <a:buNone/>
+              <a:defRPr sz="1400" kern="1200">
+                <a:solidFill>
+                  <a:schemeClr val="tx1"/>
+                </a:solidFill>
+                <a:latin typeface="+mn-lt"/>
+                <a:ea typeface="+mn-ea"/>
+                <a:cs typeface="+mn-cs"/>
+              </a:defRPr>
+            </a:lvl2pPr>
+            <a:lvl3pPr marL="1280160" indent="0" algn="l" defTabSz="1280160" rtl="0" eaLnBrk="1" latinLnBrk="0" hangingPunct="1">
+              <a:lnSpc>
+                <a:spcPct val="90000"/>
+              </a:lnSpc>
+              <a:spcBef>
+                <a:spcPts val="700"/>
+              </a:spcBef>
+              <a:buFont typeface="Arial" panose="020B0604020202020204" pitchFamily="34" charset="0"/>
+              <a:buNone/>
+              <a:defRPr sz="1400" kern="1200">
+                <a:solidFill>
+                  <a:schemeClr val="tx1"/>
+                </a:solidFill>
+                <a:latin typeface="+mn-lt"/>
+                <a:ea typeface="+mn-ea"/>
+                <a:cs typeface="+mn-cs"/>
+              </a:defRPr>
+            </a:lvl3pPr>
+            <a:lvl4pPr marL="1920240" indent="0" algn="l" defTabSz="1280160" rtl="0" eaLnBrk="1" latinLnBrk="0" hangingPunct="1">
+              <a:lnSpc>
+                <a:spcPct val="90000"/>
+              </a:lnSpc>
+              <a:spcBef>
+                <a:spcPts val="700"/>
+              </a:spcBef>
+              <a:buFont typeface="Arial" panose="020B0604020202020204" pitchFamily="34" charset="0"/>
+              <a:buNone/>
+              <a:defRPr sz="1400" kern="1200">
+                <a:solidFill>
+                  <a:schemeClr val="tx1"/>
+                </a:solidFill>
+                <a:latin typeface="+mn-lt"/>
+                <a:ea typeface="+mn-ea"/>
+                <a:cs typeface="+mn-cs"/>
+              </a:defRPr>
+            </a:lvl4pPr>
+            <a:lvl5pPr marL="2560320" indent="0" algn="l" defTabSz="1280160" rtl="0" eaLnBrk="1" latinLnBrk="0" hangingPunct="1">
+              <a:lnSpc>
+                <a:spcPct val="90000"/>
+              </a:lnSpc>
+              <a:spcBef>
+                <a:spcPts val="700"/>
+              </a:spcBef>
+              <a:buFont typeface="Arial" panose="020B0604020202020204" pitchFamily="34" charset="0"/>
+              <a:buNone/>
+              <a:defRPr sz="1400" kern="1200">
+                <a:solidFill>
+                  <a:schemeClr val="tx1"/>
+                </a:solidFill>
+                <a:latin typeface="+mn-lt"/>
+                <a:ea typeface="+mn-ea"/>
+                <a:cs typeface="+mn-cs"/>
+              </a:defRPr>
+            </a:lvl5pPr>
+            <a:lvl6pPr marL="3520440" indent="-320040" algn="l" defTabSz="1280160" rtl="0" eaLnBrk="1" latinLnBrk="0" hangingPunct="1">
+              <a:lnSpc>
+                <a:spcPct val="90000"/>
+              </a:lnSpc>
+              <a:spcBef>
+                <a:spcPts val="700"/>
+              </a:spcBef>
+              <a:buFont typeface="Arial" panose="020B0604020202020204" pitchFamily="34" charset="0"/>
+              <a:buChar char="•"/>
+              <a:defRPr sz="2520" kern="1200">
+                <a:solidFill>
+                  <a:schemeClr val="tx1"/>
+                </a:solidFill>
+                <a:latin typeface="+mn-lt"/>
+                <a:ea typeface="+mn-ea"/>
+                <a:cs typeface="+mn-cs"/>
+              </a:defRPr>
+            </a:lvl6pPr>
+            <a:lvl7pPr marL="4160520" indent="-320040" algn="l" defTabSz="1280160" rtl="0" eaLnBrk="1" latinLnBrk="0" hangingPunct="1">
+              <a:lnSpc>
+                <a:spcPct val="90000"/>
+              </a:lnSpc>
+              <a:spcBef>
+                <a:spcPts val="700"/>
+              </a:spcBef>
+              <a:buFont typeface="Arial" panose="020B0604020202020204" pitchFamily="34" charset="0"/>
+              <a:buChar char="•"/>
+              <a:defRPr sz="2520" kern="1200">
+                <a:solidFill>
+                  <a:schemeClr val="tx1"/>
+                </a:solidFill>
+                <a:latin typeface="+mn-lt"/>
+                <a:ea typeface="+mn-ea"/>
+                <a:cs typeface="+mn-cs"/>
+              </a:defRPr>
+            </a:lvl7pPr>
+            <a:lvl8pPr marL="4800600" indent="-320040" algn="l" defTabSz="1280160" rtl="0" eaLnBrk="1" latinLnBrk="0" hangingPunct="1">
+              <a:lnSpc>
+                <a:spcPct val="90000"/>
+              </a:lnSpc>
+              <a:spcBef>
+                <a:spcPts val="700"/>
+              </a:spcBef>
+              <a:buFont typeface="Arial" panose="020B0604020202020204" pitchFamily="34" charset="0"/>
+              <a:buChar char="•"/>
+              <a:defRPr sz="2520" kern="1200">
+                <a:solidFill>
+                  <a:schemeClr val="tx1"/>
+                </a:solidFill>
+                <a:latin typeface="+mn-lt"/>
+                <a:ea typeface="+mn-ea"/>
+                <a:cs typeface="+mn-cs"/>
+              </a:defRPr>
+            </a:lvl8pPr>
+            <a:lvl9pPr marL="5440680" indent="-320040" algn="l" defTabSz="1280160" rtl="0" eaLnBrk="1" latinLnBrk="0" hangingPunct="1">
+              <a:lnSpc>
+                <a:spcPct val="90000"/>
+              </a:lnSpc>
+              <a:spcBef>
+                <a:spcPts val="700"/>
+              </a:spcBef>
+              <a:buFont typeface="Arial" panose="020B0604020202020204" pitchFamily="34" charset="0"/>
+              <a:buChar char="•"/>
+              <a:defRPr sz="2520" kern="1200">
+                <a:solidFill>
+                  <a:schemeClr val="tx1"/>
+                </a:solidFill>
+                <a:latin typeface="+mn-lt"/>
+                <a:ea typeface="+mn-ea"/>
+                <a:cs typeface="+mn-cs"/>
+              </a:defRPr>
+            </a:lvl9pPr>
+          </a:lstStyle>
+          <a:p>
+            <a:endParaRPr lang="pt-BR" sz="1600" b="1" dirty="0">
+              <a:solidFill>
+                <a:schemeClr val="accent1">
+                  <a:lumMod val="75000"/>
+                </a:schemeClr>
+              </a:solidFill>
+              <a:latin typeface="Arial" panose="020B0604020202020204" pitchFamily="34" charset="0"/>
+              <a:cs typeface="Arial" panose="020B0604020202020204" pitchFamily="34" charset="0"/>
+            </a:endParaRPr>
+          </a:p>
+        </p:txBody>
+      </p:sp>
+      <p:sp>
+        <p:nvSpPr>
+          <p:cNvPr id="12" name="Espaço Reservado para Texto 1">
+            <a:extLst>
+              <a:ext uri="{FF2B5EF4-FFF2-40B4-BE49-F238E27FC236}">
+                <a16:creationId xmlns:a16="http://schemas.microsoft.com/office/drawing/2014/main" id="{19F75458-0882-12B4-4915-140BADAC6903}"/>
+              </a:ext>
+            </a:extLst>
+          </p:cNvPr>
+          <p:cNvSpPr txBox="1">
+            <a:spLocks/>
+          </p:cNvSpPr>
+          <p:nvPr/>
+        </p:nvSpPr>
+        <p:spPr>
+          <a:xfrm>
+            <a:off x="6007894" y="2270959"/>
+            <a:ext cx="4386262" cy="2109107"/>
+          </a:xfrm>
+          <a:prstGeom prst="rect">
+            <a:avLst/>
+          </a:prstGeom>
+          <a:solidFill>
+            <a:schemeClr val="bg2"/>
+          </a:solidFill>
+          <a:effectLst>
+            <a:outerShdw blurRad="215900" dist="114300" dir="2700000" algn="tl" rotWithShape="0">
+              <a:prstClr val="black">
+                <a:alpha val="30000"/>
+              </a:prstClr>
+            </a:outerShdw>
+            <a:softEdge rad="38100"/>
+          </a:effectLst>
+        </p:spPr>
+        <p:txBody>
+          <a:bodyPr lIns="72000" tIns="72000" rIns="72000" bIns="72000"/>
+          <a:lstStyle>
+            <a:lvl1pPr marL="0" indent="0" algn="l" defTabSz="1280160" rtl="0" eaLnBrk="1" latinLnBrk="0" hangingPunct="1">
+              <a:lnSpc>
+                <a:spcPct val="100000"/>
+              </a:lnSpc>
+              <a:spcBef>
+                <a:spcPts val="0"/>
+              </a:spcBef>
+              <a:spcAft>
+                <a:spcPts val="1200"/>
+              </a:spcAft>
+              <a:buFont typeface="Arial" panose="020B0604020202020204" pitchFamily="34" charset="0"/>
+              <a:buNone/>
+              <a:defRPr sz="1800" kern="1200">
+                <a:solidFill>
+                  <a:schemeClr val="tx2">
+                    <a:lumMod val="75000"/>
+                  </a:schemeClr>
+                </a:solidFill>
+                <a:latin typeface="+mn-lt"/>
+                <a:ea typeface="+mn-ea"/>
+                <a:cs typeface="+mn-cs"/>
+              </a:defRPr>
+            </a:lvl1pPr>
+            <a:lvl2pPr marL="640080" indent="0" algn="l" defTabSz="1280160" rtl="0" eaLnBrk="1" latinLnBrk="0" hangingPunct="1">
+              <a:lnSpc>
+                <a:spcPct val="90000"/>
+              </a:lnSpc>
+              <a:spcBef>
+                <a:spcPts val="700"/>
+              </a:spcBef>
+              <a:buFont typeface="Arial" panose="020B0604020202020204" pitchFamily="34" charset="0"/>
+              <a:buNone/>
+              <a:defRPr sz="1400" kern="1200">
+                <a:solidFill>
+                  <a:schemeClr val="tx1"/>
+                </a:solidFill>
+                <a:latin typeface="+mn-lt"/>
+                <a:ea typeface="+mn-ea"/>
+                <a:cs typeface="+mn-cs"/>
+              </a:defRPr>
+            </a:lvl2pPr>
+            <a:lvl3pPr marL="1280160" indent="0" algn="l" defTabSz="1280160" rtl="0" eaLnBrk="1" latinLnBrk="0" hangingPunct="1">
+              <a:lnSpc>
+                <a:spcPct val="90000"/>
+              </a:lnSpc>
+              <a:spcBef>
+                <a:spcPts val="700"/>
+              </a:spcBef>
+              <a:buFont typeface="Arial" panose="020B0604020202020204" pitchFamily="34" charset="0"/>
+              <a:buNone/>
+              <a:defRPr sz="1400" kern="1200">
+                <a:solidFill>
+                  <a:schemeClr val="tx1"/>
+                </a:solidFill>
+                <a:latin typeface="+mn-lt"/>
+                <a:ea typeface="+mn-ea"/>
+                <a:cs typeface="+mn-cs"/>
+              </a:defRPr>
+            </a:lvl3pPr>
+            <a:lvl4pPr marL="1920240" indent="0" algn="l" defTabSz="1280160" rtl="0" eaLnBrk="1" latinLnBrk="0" hangingPunct="1">
+              <a:lnSpc>
+                <a:spcPct val="90000"/>
+              </a:lnSpc>
+              <a:spcBef>
+                <a:spcPts val="700"/>
+              </a:spcBef>
+              <a:buFont typeface="Arial" panose="020B0604020202020204" pitchFamily="34" charset="0"/>
+              <a:buNone/>
+              <a:defRPr sz="1400" kern="1200">
+                <a:solidFill>
+                  <a:schemeClr val="tx1"/>
+                </a:solidFill>
+                <a:latin typeface="+mn-lt"/>
+                <a:ea typeface="+mn-ea"/>
+                <a:cs typeface="+mn-cs"/>
+              </a:defRPr>
+            </a:lvl4pPr>
+            <a:lvl5pPr marL="2560320" indent="0" algn="l" defTabSz="1280160" rtl="0" eaLnBrk="1" latinLnBrk="0" hangingPunct="1">
+              <a:lnSpc>
+                <a:spcPct val="90000"/>
+              </a:lnSpc>
+              <a:spcBef>
+                <a:spcPts val="700"/>
+              </a:spcBef>
+              <a:buFont typeface="Arial" panose="020B0604020202020204" pitchFamily="34" charset="0"/>
+              <a:buNone/>
+              <a:defRPr sz="1400" kern="1200">
+                <a:solidFill>
+                  <a:schemeClr val="tx1"/>
+                </a:solidFill>
+                <a:latin typeface="+mn-lt"/>
+                <a:ea typeface="+mn-ea"/>
+                <a:cs typeface="+mn-cs"/>
+              </a:defRPr>
+            </a:lvl5pPr>
+            <a:lvl6pPr marL="3520440" indent="-320040" algn="l" defTabSz="1280160" rtl="0" eaLnBrk="1" latinLnBrk="0" hangingPunct="1">
+              <a:lnSpc>
+                <a:spcPct val="90000"/>
+              </a:lnSpc>
+              <a:spcBef>
+                <a:spcPts val="700"/>
+              </a:spcBef>
+              <a:buFont typeface="Arial" panose="020B0604020202020204" pitchFamily="34" charset="0"/>
+              <a:buChar char="•"/>
+              <a:defRPr sz="2520" kern="1200">
+                <a:solidFill>
+                  <a:schemeClr val="tx1"/>
+                </a:solidFill>
+                <a:latin typeface="+mn-lt"/>
+                <a:ea typeface="+mn-ea"/>
+                <a:cs typeface="+mn-cs"/>
+              </a:defRPr>
+            </a:lvl6pPr>
+            <a:lvl7pPr marL="4160520" indent="-320040" algn="l" defTabSz="1280160" rtl="0" eaLnBrk="1" latinLnBrk="0" hangingPunct="1">
+              <a:lnSpc>
+                <a:spcPct val="90000"/>
+              </a:lnSpc>
+              <a:spcBef>
+                <a:spcPts val="700"/>
+              </a:spcBef>
+              <a:buFont typeface="Arial" panose="020B0604020202020204" pitchFamily="34" charset="0"/>
+              <a:buChar char="•"/>
+              <a:defRPr sz="2520" kern="1200">
+                <a:solidFill>
+                  <a:schemeClr val="tx1"/>
+                </a:solidFill>
+                <a:latin typeface="+mn-lt"/>
+                <a:ea typeface="+mn-ea"/>
+                <a:cs typeface="+mn-cs"/>
+              </a:defRPr>
+            </a:lvl7pPr>
+            <a:lvl8pPr marL="4800600" indent="-320040" algn="l" defTabSz="1280160" rtl="0" eaLnBrk="1" latinLnBrk="0" hangingPunct="1">
+              <a:lnSpc>
+                <a:spcPct val="90000"/>
+              </a:lnSpc>
+              <a:spcBef>
+                <a:spcPts val="700"/>
+              </a:spcBef>
+              <a:buFont typeface="Arial" panose="020B0604020202020204" pitchFamily="34" charset="0"/>
+              <a:buChar char="•"/>
+              <a:defRPr sz="2520" kern="1200">
+                <a:solidFill>
+                  <a:schemeClr val="tx1"/>
+                </a:solidFill>
+                <a:latin typeface="+mn-lt"/>
+                <a:ea typeface="+mn-ea"/>
+                <a:cs typeface="+mn-cs"/>
+              </a:defRPr>
+            </a:lvl8pPr>
+            <a:lvl9pPr marL="5440680" indent="-320040" algn="l" defTabSz="1280160" rtl="0" eaLnBrk="1" latinLnBrk="0" hangingPunct="1">
+              <a:lnSpc>
+                <a:spcPct val="90000"/>
+              </a:lnSpc>
+              <a:spcBef>
+                <a:spcPts val="700"/>
+              </a:spcBef>
+              <a:buFont typeface="Arial" panose="020B0604020202020204" pitchFamily="34" charset="0"/>
+              <a:buChar char="•"/>
+              <a:defRPr sz="2520" kern="1200">
+                <a:solidFill>
+                  <a:schemeClr val="tx1"/>
+                </a:solidFill>
+                <a:latin typeface="+mn-lt"/>
+                <a:ea typeface="+mn-ea"/>
+                <a:cs typeface="+mn-cs"/>
+              </a:defRPr>
+            </a:lvl9pPr>
+          </a:lstStyle>
+          <a:p>
+            <a:endParaRPr lang="pt-BR" sz="1600" b="1" dirty="0">
+              <a:solidFill>
+                <a:schemeClr val="accent1">
+                  <a:lumMod val="75000"/>
+                </a:schemeClr>
+              </a:solidFill>
+              <a:latin typeface="Arial" panose="020B0604020202020204" pitchFamily="34" charset="0"/>
+              <a:cs typeface="Arial" panose="020B0604020202020204" pitchFamily="34" charset="0"/>
+            </a:endParaRPr>
+          </a:p>
+        </p:txBody>
+      </p:sp>
+      <p:sp>
+        <p:nvSpPr>
+          <p:cNvPr id="16" name="Espaço Reservado para Texto 1">
+            <a:extLst>
+              <a:ext uri="{FF2B5EF4-FFF2-40B4-BE49-F238E27FC236}">
+                <a16:creationId xmlns:a16="http://schemas.microsoft.com/office/drawing/2014/main" id="{9230BB37-AB2D-3AF0-5467-C3B221B1AF84}"/>
+              </a:ext>
+            </a:extLst>
+          </p:cNvPr>
+          <p:cNvSpPr txBox="1">
+            <a:spLocks/>
+          </p:cNvSpPr>
+          <p:nvPr/>
+        </p:nvSpPr>
+        <p:spPr>
+          <a:xfrm>
+            <a:off x="11087100" y="2270959"/>
+            <a:ext cx="4386262" cy="2109107"/>
+          </a:xfrm>
+          <a:prstGeom prst="rect">
+            <a:avLst/>
+          </a:prstGeom>
+          <a:solidFill>
+            <a:schemeClr val="bg2"/>
+          </a:solidFill>
+          <a:effectLst>
+            <a:outerShdw blurRad="215900" dist="114300" dir="2700000" algn="tl" rotWithShape="0">
+              <a:prstClr val="black">
+                <a:alpha val="30000"/>
+              </a:prstClr>
+            </a:outerShdw>
+            <a:softEdge rad="38100"/>
+          </a:effectLst>
+        </p:spPr>
+        <p:txBody>
+          <a:bodyPr lIns="72000" tIns="72000" rIns="72000" bIns="72000"/>
+          <a:lstStyle>
+            <a:lvl1pPr marL="0" indent="0" algn="l" defTabSz="1280160" rtl="0" eaLnBrk="1" latinLnBrk="0" hangingPunct="1">
+              <a:lnSpc>
+                <a:spcPct val="100000"/>
+              </a:lnSpc>
+              <a:spcBef>
+                <a:spcPts val="0"/>
+              </a:spcBef>
+              <a:spcAft>
+                <a:spcPts val="1200"/>
+              </a:spcAft>
+              <a:buFont typeface="Arial" panose="020B0604020202020204" pitchFamily="34" charset="0"/>
+              <a:buNone/>
+              <a:defRPr sz="1800" kern="1200">
+                <a:solidFill>
+                  <a:schemeClr val="tx2">
+                    <a:lumMod val="75000"/>
+                  </a:schemeClr>
+                </a:solidFill>
+                <a:latin typeface="+mn-lt"/>
+                <a:ea typeface="+mn-ea"/>
+                <a:cs typeface="+mn-cs"/>
+              </a:defRPr>
+            </a:lvl1pPr>
+            <a:lvl2pPr marL="640080" indent="0" algn="l" defTabSz="1280160" rtl="0" eaLnBrk="1" latinLnBrk="0" hangingPunct="1">
+              <a:lnSpc>
+                <a:spcPct val="90000"/>
+              </a:lnSpc>
+              <a:spcBef>
+                <a:spcPts val="700"/>
+              </a:spcBef>
+              <a:buFont typeface="Arial" panose="020B0604020202020204" pitchFamily="34" charset="0"/>
+              <a:buNone/>
+              <a:defRPr sz="1400" kern="1200">
+                <a:solidFill>
+                  <a:schemeClr val="tx1"/>
+                </a:solidFill>
+                <a:latin typeface="+mn-lt"/>
+                <a:ea typeface="+mn-ea"/>
+                <a:cs typeface="+mn-cs"/>
+              </a:defRPr>
+            </a:lvl2pPr>
+            <a:lvl3pPr marL="1280160" indent="0" algn="l" defTabSz="1280160" rtl="0" eaLnBrk="1" latinLnBrk="0" hangingPunct="1">
+              <a:lnSpc>
+                <a:spcPct val="90000"/>
+              </a:lnSpc>
+              <a:spcBef>
+                <a:spcPts val="700"/>
+              </a:spcBef>
+              <a:buFont typeface="Arial" panose="020B0604020202020204" pitchFamily="34" charset="0"/>
+              <a:buNone/>
+              <a:defRPr sz="1400" kern="1200">
+                <a:solidFill>
+                  <a:schemeClr val="tx1"/>
+                </a:solidFill>
+                <a:latin typeface="+mn-lt"/>
+                <a:ea typeface="+mn-ea"/>
+                <a:cs typeface="+mn-cs"/>
+              </a:defRPr>
+            </a:lvl3pPr>
+            <a:lvl4pPr marL="1920240" indent="0" algn="l" defTabSz="1280160" rtl="0" eaLnBrk="1" latinLnBrk="0" hangingPunct="1">
+              <a:lnSpc>
+                <a:spcPct val="90000"/>
+              </a:lnSpc>
+              <a:spcBef>
+                <a:spcPts val="700"/>
+              </a:spcBef>
+              <a:buFont typeface="Arial" panose="020B0604020202020204" pitchFamily="34" charset="0"/>
+              <a:buNone/>
+              <a:defRPr sz="1400" kern="1200">
+                <a:solidFill>
+                  <a:schemeClr val="tx1"/>
+                </a:solidFill>
+                <a:latin typeface="+mn-lt"/>
+                <a:ea typeface="+mn-ea"/>
+                <a:cs typeface="+mn-cs"/>
+              </a:defRPr>
+            </a:lvl4pPr>
+            <a:lvl5pPr marL="2560320" indent="0" algn="l" defTabSz="1280160" rtl="0" eaLnBrk="1" latinLnBrk="0" hangingPunct="1">
+              <a:lnSpc>
+                <a:spcPct val="90000"/>
+              </a:lnSpc>
+              <a:spcBef>
+                <a:spcPts val="700"/>
+              </a:spcBef>
+              <a:buFont typeface="Arial" panose="020B0604020202020204" pitchFamily="34" charset="0"/>
+              <a:buNone/>
+              <a:defRPr sz="1400" kern="1200">
+                <a:solidFill>
+                  <a:schemeClr val="tx1"/>
+                </a:solidFill>
+                <a:latin typeface="+mn-lt"/>
+                <a:ea typeface="+mn-ea"/>
+                <a:cs typeface="+mn-cs"/>
+              </a:defRPr>
+            </a:lvl5pPr>
+            <a:lvl6pPr marL="3520440" indent="-320040" algn="l" defTabSz="1280160" rtl="0" eaLnBrk="1" latinLnBrk="0" hangingPunct="1">
+              <a:lnSpc>
+                <a:spcPct val="90000"/>
+              </a:lnSpc>
+              <a:spcBef>
+                <a:spcPts val="700"/>
+              </a:spcBef>
+              <a:buFont typeface="Arial" panose="020B0604020202020204" pitchFamily="34" charset="0"/>
+              <a:buChar char="•"/>
+              <a:defRPr sz="2520" kern="1200">
+                <a:solidFill>
+                  <a:schemeClr val="tx1"/>
+                </a:solidFill>
+                <a:latin typeface="+mn-lt"/>
+                <a:ea typeface="+mn-ea"/>
+                <a:cs typeface="+mn-cs"/>
+              </a:defRPr>
+            </a:lvl6pPr>
+            <a:lvl7pPr marL="4160520" indent="-320040" algn="l" defTabSz="1280160" rtl="0" eaLnBrk="1" latinLnBrk="0" hangingPunct="1">
+              <a:lnSpc>
+                <a:spcPct val="90000"/>
+              </a:lnSpc>
+              <a:spcBef>
+                <a:spcPts val="700"/>
+              </a:spcBef>
+              <a:buFont typeface="Arial" panose="020B0604020202020204" pitchFamily="34" charset="0"/>
+              <a:buChar char="•"/>
+              <a:defRPr sz="2520" kern="1200">
+                <a:solidFill>
+                  <a:schemeClr val="tx1"/>
+                </a:solidFill>
+                <a:latin typeface="+mn-lt"/>
+                <a:ea typeface="+mn-ea"/>
+                <a:cs typeface="+mn-cs"/>
+              </a:defRPr>
+            </a:lvl7pPr>
+            <a:lvl8pPr marL="4800600" indent="-320040" algn="l" defTabSz="1280160" rtl="0" eaLnBrk="1" latinLnBrk="0" hangingPunct="1">
+              <a:lnSpc>
+                <a:spcPct val="90000"/>
+              </a:lnSpc>
+              <a:spcBef>
+                <a:spcPts val="700"/>
+              </a:spcBef>
+              <a:buFont typeface="Arial" panose="020B0604020202020204" pitchFamily="34" charset="0"/>
+              <a:buChar char="•"/>
+              <a:defRPr sz="2520" kern="1200">
+                <a:solidFill>
+                  <a:schemeClr val="tx1"/>
+                </a:solidFill>
+                <a:latin typeface="+mn-lt"/>
+                <a:ea typeface="+mn-ea"/>
+                <a:cs typeface="+mn-cs"/>
+              </a:defRPr>
+            </a:lvl8pPr>
+            <a:lvl9pPr marL="5440680" indent="-320040" algn="l" defTabSz="1280160" rtl="0" eaLnBrk="1" latinLnBrk="0" hangingPunct="1">
+              <a:lnSpc>
+                <a:spcPct val="90000"/>
+              </a:lnSpc>
+              <a:spcBef>
+                <a:spcPts val="700"/>
+              </a:spcBef>
+              <a:buFont typeface="Arial" panose="020B0604020202020204" pitchFamily="34" charset="0"/>
+              <a:buChar char="•"/>
+              <a:defRPr sz="2520" kern="1200">
+                <a:solidFill>
+                  <a:schemeClr val="tx1"/>
+                </a:solidFill>
+                <a:latin typeface="+mn-lt"/>
+                <a:ea typeface="+mn-ea"/>
+                <a:cs typeface="+mn-cs"/>
+              </a:defRPr>
+            </a:lvl9pPr>
+          </a:lstStyle>
+          <a:p>
+            <a:endParaRPr lang="pt-BR" sz="1600" b="1" dirty="0">
+              <a:solidFill>
+                <a:schemeClr val="accent1">
+                  <a:lumMod val="75000"/>
+                </a:schemeClr>
+              </a:solidFill>
+              <a:latin typeface="Arial" panose="020B0604020202020204" pitchFamily="34" charset="0"/>
+              <a:cs typeface="Arial" panose="020B0604020202020204" pitchFamily="34" charset="0"/>
+            </a:endParaRPr>
+          </a:p>
+        </p:txBody>
+      </p:sp>
+      <p:sp>
+        <p:nvSpPr>
+          <p:cNvPr id="19" name="Espaço Reservado para Texto 1">
+            <a:extLst>
+              <a:ext uri="{FF2B5EF4-FFF2-40B4-BE49-F238E27FC236}">
+                <a16:creationId xmlns:a16="http://schemas.microsoft.com/office/drawing/2014/main" id="{125C1541-4928-0AB6-D9D6-90EA778E3CBA}"/>
+              </a:ext>
+            </a:extLst>
+          </p:cNvPr>
+          <p:cNvSpPr txBox="1">
+            <a:spLocks/>
+          </p:cNvSpPr>
+          <p:nvPr/>
+        </p:nvSpPr>
+        <p:spPr>
+          <a:xfrm>
+            <a:off x="1680487" y="2444851"/>
+            <a:ext cx="2882664" cy="421714"/>
+          </a:xfrm>
+          <a:prstGeom prst="rect">
+            <a:avLst/>
+          </a:prstGeom>
+          <a:noFill/>
+        </p:spPr>
+        <p:txBody>
+          <a:bodyPr lIns="72000" tIns="72000" rIns="72000" bIns="72000"/>
+          <a:lstStyle>
+            <a:lvl1pPr marL="0" indent="0" algn="l" defTabSz="1280160" rtl="0" eaLnBrk="1" latinLnBrk="0" hangingPunct="1">
+              <a:lnSpc>
+                <a:spcPct val="100000"/>
+              </a:lnSpc>
+              <a:spcBef>
+                <a:spcPts val="0"/>
+              </a:spcBef>
+              <a:spcAft>
+                <a:spcPts val="1200"/>
+              </a:spcAft>
+              <a:buFont typeface="Arial" panose="020B0604020202020204" pitchFamily="34" charset="0"/>
+              <a:buNone/>
+              <a:defRPr sz="1800" kern="1200">
+                <a:solidFill>
+                  <a:schemeClr val="tx2">
+                    <a:lumMod val="75000"/>
+                  </a:schemeClr>
+                </a:solidFill>
+                <a:latin typeface="+mn-lt"/>
+                <a:ea typeface="+mn-ea"/>
+                <a:cs typeface="+mn-cs"/>
+              </a:defRPr>
+            </a:lvl1pPr>
+            <a:lvl2pPr marL="640080" indent="0" algn="l" defTabSz="1280160" rtl="0" eaLnBrk="1" latinLnBrk="0" hangingPunct="1">
+              <a:lnSpc>
+                <a:spcPct val="90000"/>
+              </a:lnSpc>
+              <a:spcBef>
+                <a:spcPts val="700"/>
+              </a:spcBef>
+              <a:buFont typeface="Arial" panose="020B0604020202020204" pitchFamily="34" charset="0"/>
+              <a:buNone/>
+              <a:defRPr sz="1400" kern="1200">
+                <a:solidFill>
+                  <a:schemeClr val="tx1"/>
+                </a:solidFill>
+                <a:latin typeface="+mn-lt"/>
+                <a:ea typeface="+mn-ea"/>
+                <a:cs typeface="+mn-cs"/>
+              </a:defRPr>
+            </a:lvl2pPr>
+            <a:lvl3pPr marL="1280160" indent="0" algn="l" defTabSz="1280160" rtl="0" eaLnBrk="1" latinLnBrk="0" hangingPunct="1">
+              <a:lnSpc>
+                <a:spcPct val="90000"/>
+              </a:lnSpc>
+              <a:spcBef>
+                <a:spcPts val="700"/>
+              </a:spcBef>
+              <a:buFont typeface="Arial" panose="020B0604020202020204" pitchFamily="34" charset="0"/>
+              <a:buNone/>
+              <a:defRPr sz="1400" kern="1200">
+                <a:solidFill>
+                  <a:schemeClr val="tx1"/>
+                </a:solidFill>
+                <a:latin typeface="+mn-lt"/>
+                <a:ea typeface="+mn-ea"/>
+                <a:cs typeface="+mn-cs"/>
+              </a:defRPr>
+            </a:lvl3pPr>
+            <a:lvl4pPr marL="1920240" indent="0" algn="l" defTabSz="1280160" rtl="0" eaLnBrk="1" latinLnBrk="0" hangingPunct="1">
+              <a:lnSpc>
+                <a:spcPct val="90000"/>
+              </a:lnSpc>
+              <a:spcBef>
+                <a:spcPts val="700"/>
+              </a:spcBef>
+              <a:buFont typeface="Arial" panose="020B0604020202020204" pitchFamily="34" charset="0"/>
+              <a:buNone/>
+              <a:defRPr sz="1400" kern="1200">
+                <a:solidFill>
+                  <a:schemeClr val="tx1"/>
+                </a:solidFill>
+                <a:latin typeface="+mn-lt"/>
+                <a:ea typeface="+mn-ea"/>
+                <a:cs typeface="+mn-cs"/>
+              </a:defRPr>
+            </a:lvl4pPr>
+            <a:lvl5pPr marL="2560320" indent="0" algn="l" defTabSz="1280160" rtl="0" eaLnBrk="1" latinLnBrk="0" hangingPunct="1">
+              <a:lnSpc>
+                <a:spcPct val="90000"/>
+              </a:lnSpc>
+              <a:spcBef>
+                <a:spcPts val="700"/>
+              </a:spcBef>
+              <a:buFont typeface="Arial" panose="020B0604020202020204" pitchFamily="34" charset="0"/>
+              <a:buNone/>
+              <a:defRPr sz="1400" kern="1200">
+                <a:solidFill>
+                  <a:schemeClr val="tx1"/>
+                </a:solidFill>
+                <a:latin typeface="+mn-lt"/>
+                <a:ea typeface="+mn-ea"/>
+                <a:cs typeface="+mn-cs"/>
+              </a:defRPr>
+            </a:lvl5pPr>
+            <a:lvl6pPr marL="3520440" indent="-320040" algn="l" defTabSz="1280160" rtl="0" eaLnBrk="1" latinLnBrk="0" hangingPunct="1">
+              <a:lnSpc>
+                <a:spcPct val="90000"/>
+              </a:lnSpc>
+              <a:spcBef>
+                <a:spcPts val="700"/>
+              </a:spcBef>
+              <a:buFont typeface="Arial" panose="020B0604020202020204" pitchFamily="34" charset="0"/>
+              <a:buChar char="•"/>
+              <a:defRPr sz="2520" kern="1200">
+                <a:solidFill>
+                  <a:schemeClr val="tx1"/>
+                </a:solidFill>
+                <a:latin typeface="+mn-lt"/>
+                <a:ea typeface="+mn-ea"/>
+                <a:cs typeface="+mn-cs"/>
+              </a:defRPr>
+            </a:lvl6pPr>
+            <a:lvl7pPr marL="4160520" indent="-320040" algn="l" defTabSz="1280160" rtl="0" eaLnBrk="1" latinLnBrk="0" hangingPunct="1">
+              <a:lnSpc>
+                <a:spcPct val="90000"/>
+              </a:lnSpc>
+              <a:spcBef>
+                <a:spcPts val="700"/>
+              </a:spcBef>
+              <a:buFont typeface="Arial" panose="020B0604020202020204" pitchFamily="34" charset="0"/>
+              <a:buChar char="•"/>
+              <a:defRPr sz="2520" kern="1200">
+                <a:solidFill>
+                  <a:schemeClr val="tx1"/>
+                </a:solidFill>
+                <a:latin typeface="+mn-lt"/>
+                <a:ea typeface="+mn-ea"/>
+                <a:cs typeface="+mn-cs"/>
+              </a:defRPr>
+            </a:lvl7pPr>
+            <a:lvl8pPr marL="4800600" indent="-320040" algn="l" defTabSz="1280160" rtl="0" eaLnBrk="1" latinLnBrk="0" hangingPunct="1">
+              <a:lnSpc>
+                <a:spcPct val="90000"/>
+              </a:lnSpc>
+              <a:spcBef>
+                <a:spcPts val="700"/>
+              </a:spcBef>
+              <a:buFont typeface="Arial" panose="020B0604020202020204" pitchFamily="34" charset="0"/>
+              <a:buChar char="•"/>
+              <a:defRPr sz="2520" kern="1200">
+                <a:solidFill>
+                  <a:schemeClr val="tx1"/>
+                </a:solidFill>
+                <a:latin typeface="+mn-lt"/>
+                <a:ea typeface="+mn-ea"/>
+                <a:cs typeface="+mn-cs"/>
+              </a:defRPr>
+            </a:lvl8pPr>
+            <a:lvl9pPr marL="5440680" indent="-320040" algn="l" defTabSz="1280160" rtl="0" eaLnBrk="1" latinLnBrk="0" hangingPunct="1">
+              <a:lnSpc>
+                <a:spcPct val="90000"/>
+              </a:lnSpc>
+              <a:spcBef>
+                <a:spcPts val="700"/>
+              </a:spcBef>
+              <a:buFont typeface="Arial" panose="020B0604020202020204" pitchFamily="34" charset="0"/>
+              <a:buChar char="•"/>
+              <a:defRPr sz="2520" kern="1200">
+                <a:solidFill>
+                  <a:schemeClr val="tx1"/>
+                </a:solidFill>
+                <a:latin typeface="+mn-lt"/>
+                <a:ea typeface="+mn-ea"/>
+                <a:cs typeface="+mn-cs"/>
+              </a:defRPr>
+            </a:lvl9pPr>
+          </a:lstStyle>
+          <a:p>
+            <a:pPr algn="ctr"/>
+            <a:r>
+              <a:rPr lang="pt-BR" sz="2000" b="1" dirty="0">
+                <a:solidFill>
+                  <a:schemeClr val="accent1">
+                    <a:lumMod val="75000"/>
+                  </a:schemeClr>
+                </a:solidFill>
+                <a:latin typeface="Arial" panose="020B0604020202020204" pitchFamily="34" charset="0"/>
+                <a:cs typeface="Arial" panose="020B0604020202020204" pitchFamily="34" charset="0"/>
+              </a:rPr>
+              <a:t>Precisão</a:t>
+            </a:r>
+          </a:p>
+        </p:txBody>
+      </p:sp>
+      <p:sp>
+        <p:nvSpPr>
+          <p:cNvPr id="24" name="Espaço Reservado para Texto 1">
+            <a:extLst>
+              <a:ext uri="{FF2B5EF4-FFF2-40B4-BE49-F238E27FC236}">
+                <a16:creationId xmlns:a16="http://schemas.microsoft.com/office/drawing/2014/main" id="{66324DE0-63CF-64C0-5612-103F2DDFEEC8}"/>
+              </a:ext>
+            </a:extLst>
+          </p:cNvPr>
+          <p:cNvSpPr txBox="1">
+            <a:spLocks/>
+          </p:cNvSpPr>
+          <p:nvPr/>
+        </p:nvSpPr>
+        <p:spPr>
+          <a:xfrm>
+            <a:off x="1680487" y="3040457"/>
+            <a:ext cx="2882664" cy="759206"/>
+          </a:xfrm>
+          <a:prstGeom prst="rect">
+            <a:avLst/>
+          </a:prstGeom>
+          <a:noFill/>
+        </p:spPr>
+        <p:txBody>
+          <a:bodyPr lIns="72000" tIns="72000" rIns="72000" bIns="72000" anchor="ctr"/>
+          <a:lstStyle>
+            <a:lvl1pPr marL="0" indent="0" algn="l" defTabSz="1280160" rtl="0" eaLnBrk="1" latinLnBrk="0" hangingPunct="1">
+              <a:lnSpc>
+                <a:spcPct val="100000"/>
+              </a:lnSpc>
+              <a:spcBef>
+                <a:spcPts val="0"/>
+              </a:spcBef>
+              <a:spcAft>
+                <a:spcPts val="1200"/>
+              </a:spcAft>
+              <a:buFont typeface="Arial" panose="020B0604020202020204" pitchFamily="34" charset="0"/>
+              <a:buNone/>
+              <a:defRPr sz="1800" kern="1200">
+                <a:solidFill>
+                  <a:schemeClr val="tx2">
+                    <a:lumMod val="75000"/>
+                  </a:schemeClr>
+                </a:solidFill>
+                <a:latin typeface="+mn-lt"/>
+                <a:ea typeface="+mn-ea"/>
+                <a:cs typeface="+mn-cs"/>
+              </a:defRPr>
+            </a:lvl1pPr>
+            <a:lvl2pPr marL="640080" indent="0" algn="l" defTabSz="1280160" rtl="0" eaLnBrk="1" latinLnBrk="0" hangingPunct="1">
+              <a:lnSpc>
+                <a:spcPct val="90000"/>
+              </a:lnSpc>
+              <a:spcBef>
+                <a:spcPts val="700"/>
+              </a:spcBef>
+              <a:buFont typeface="Arial" panose="020B0604020202020204" pitchFamily="34" charset="0"/>
+              <a:buNone/>
+              <a:defRPr sz="1400" kern="1200">
+                <a:solidFill>
+                  <a:schemeClr val="tx1"/>
+                </a:solidFill>
+                <a:latin typeface="+mn-lt"/>
+                <a:ea typeface="+mn-ea"/>
+                <a:cs typeface="+mn-cs"/>
+              </a:defRPr>
+            </a:lvl2pPr>
+            <a:lvl3pPr marL="1280160" indent="0" algn="l" defTabSz="1280160" rtl="0" eaLnBrk="1" latinLnBrk="0" hangingPunct="1">
+              <a:lnSpc>
+                <a:spcPct val="90000"/>
+              </a:lnSpc>
+              <a:spcBef>
+                <a:spcPts val="700"/>
+              </a:spcBef>
+              <a:buFont typeface="Arial" panose="020B0604020202020204" pitchFamily="34" charset="0"/>
+              <a:buNone/>
+              <a:defRPr sz="1400" kern="1200">
+                <a:solidFill>
+                  <a:schemeClr val="tx1"/>
+                </a:solidFill>
+                <a:latin typeface="+mn-lt"/>
+                <a:ea typeface="+mn-ea"/>
+                <a:cs typeface="+mn-cs"/>
+              </a:defRPr>
+            </a:lvl3pPr>
+            <a:lvl4pPr marL="1920240" indent="0" algn="l" defTabSz="1280160" rtl="0" eaLnBrk="1" latinLnBrk="0" hangingPunct="1">
+              <a:lnSpc>
+                <a:spcPct val="90000"/>
+              </a:lnSpc>
+              <a:spcBef>
+                <a:spcPts val="700"/>
+              </a:spcBef>
+              <a:buFont typeface="Arial" panose="020B0604020202020204" pitchFamily="34" charset="0"/>
+              <a:buNone/>
+              <a:defRPr sz="1400" kern="1200">
+                <a:solidFill>
+                  <a:schemeClr val="tx1"/>
+                </a:solidFill>
+                <a:latin typeface="+mn-lt"/>
+                <a:ea typeface="+mn-ea"/>
+                <a:cs typeface="+mn-cs"/>
+              </a:defRPr>
+            </a:lvl4pPr>
+            <a:lvl5pPr marL="2560320" indent="0" algn="l" defTabSz="1280160" rtl="0" eaLnBrk="1" latinLnBrk="0" hangingPunct="1">
+              <a:lnSpc>
+                <a:spcPct val="90000"/>
+              </a:lnSpc>
+              <a:spcBef>
+                <a:spcPts val="700"/>
+              </a:spcBef>
+              <a:buFont typeface="Arial" panose="020B0604020202020204" pitchFamily="34" charset="0"/>
+              <a:buNone/>
+              <a:defRPr sz="1400" kern="1200">
+                <a:solidFill>
+                  <a:schemeClr val="tx1"/>
+                </a:solidFill>
+                <a:latin typeface="+mn-lt"/>
+                <a:ea typeface="+mn-ea"/>
+                <a:cs typeface="+mn-cs"/>
+              </a:defRPr>
+            </a:lvl5pPr>
+            <a:lvl6pPr marL="3520440" indent="-320040" algn="l" defTabSz="1280160" rtl="0" eaLnBrk="1" latinLnBrk="0" hangingPunct="1">
+              <a:lnSpc>
+                <a:spcPct val="90000"/>
+              </a:lnSpc>
+              <a:spcBef>
+                <a:spcPts val="700"/>
+              </a:spcBef>
+              <a:buFont typeface="Arial" panose="020B0604020202020204" pitchFamily="34" charset="0"/>
+              <a:buChar char="•"/>
+              <a:defRPr sz="2520" kern="1200">
+                <a:solidFill>
+                  <a:schemeClr val="tx1"/>
+                </a:solidFill>
+                <a:latin typeface="+mn-lt"/>
+                <a:ea typeface="+mn-ea"/>
+                <a:cs typeface="+mn-cs"/>
+              </a:defRPr>
+            </a:lvl6pPr>
+            <a:lvl7pPr marL="4160520" indent="-320040" algn="l" defTabSz="1280160" rtl="0" eaLnBrk="1" latinLnBrk="0" hangingPunct="1">
+              <a:lnSpc>
+                <a:spcPct val="90000"/>
+              </a:lnSpc>
+              <a:spcBef>
+                <a:spcPts val="700"/>
+              </a:spcBef>
+              <a:buFont typeface="Arial" panose="020B0604020202020204" pitchFamily="34" charset="0"/>
+              <a:buChar char="•"/>
+              <a:defRPr sz="2520" kern="1200">
+                <a:solidFill>
+                  <a:schemeClr val="tx1"/>
+                </a:solidFill>
+                <a:latin typeface="+mn-lt"/>
+                <a:ea typeface="+mn-ea"/>
+                <a:cs typeface="+mn-cs"/>
+              </a:defRPr>
+            </a:lvl7pPr>
+            <a:lvl8pPr marL="4800600" indent="-320040" algn="l" defTabSz="1280160" rtl="0" eaLnBrk="1" latinLnBrk="0" hangingPunct="1">
+              <a:lnSpc>
+                <a:spcPct val="90000"/>
+              </a:lnSpc>
+              <a:spcBef>
+                <a:spcPts val="700"/>
+              </a:spcBef>
+              <a:buFont typeface="Arial" panose="020B0604020202020204" pitchFamily="34" charset="0"/>
+              <a:buChar char="•"/>
+              <a:defRPr sz="2520" kern="1200">
+                <a:solidFill>
+                  <a:schemeClr val="tx1"/>
+                </a:solidFill>
+                <a:latin typeface="+mn-lt"/>
+                <a:ea typeface="+mn-ea"/>
+                <a:cs typeface="+mn-cs"/>
+              </a:defRPr>
+            </a:lvl8pPr>
+            <a:lvl9pPr marL="5440680" indent="-320040" algn="l" defTabSz="1280160" rtl="0" eaLnBrk="1" latinLnBrk="0" hangingPunct="1">
+              <a:lnSpc>
+                <a:spcPct val="90000"/>
+              </a:lnSpc>
+              <a:spcBef>
+                <a:spcPts val="700"/>
+              </a:spcBef>
+              <a:buFont typeface="Arial" panose="020B0604020202020204" pitchFamily="34" charset="0"/>
+              <a:buChar char="•"/>
+              <a:defRPr sz="2520" kern="1200">
+                <a:solidFill>
+                  <a:schemeClr val="tx1"/>
+                </a:solidFill>
+                <a:latin typeface="+mn-lt"/>
+                <a:ea typeface="+mn-ea"/>
+                <a:cs typeface="+mn-cs"/>
+              </a:defRPr>
+            </a:lvl9pPr>
+          </a:lstStyle>
+          <a:p>
+            <a:pPr algn="ctr"/>
+            <a:r>
+              <a:rPr lang="pt-BR" sz="4800" dirty="0">
+                <a:solidFill>
+                  <a:srgbClr val="C00000"/>
+                </a:solidFill>
+                <a:latin typeface="Arial" panose="020B0604020202020204" pitchFamily="34" charset="0"/>
+                <a:cs typeface="Arial" panose="020B0604020202020204" pitchFamily="34" charset="0"/>
+              </a:rPr>
+              <a:t>0,26</a:t>
+            </a:r>
+          </a:p>
+        </p:txBody>
+      </p:sp>
+      <p:sp>
+        <p:nvSpPr>
+          <p:cNvPr id="35" name="Espaço Reservado para Texto 1">
+            <a:extLst>
+              <a:ext uri="{FF2B5EF4-FFF2-40B4-BE49-F238E27FC236}">
+                <a16:creationId xmlns:a16="http://schemas.microsoft.com/office/drawing/2014/main" id="{5AAE0159-863E-9A24-FE0D-FE2D63BD2B92}"/>
+              </a:ext>
+            </a:extLst>
+          </p:cNvPr>
+          <p:cNvSpPr txBox="1">
+            <a:spLocks/>
+          </p:cNvSpPr>
+          <p:nvPr/>
+        </p:nvSpPr>
+        <p:spPr>
+          <a:xfrm>
+            <a:off x="6759693" y="2444851"/>
+            <a:ext cx="2882664" cy="421714"/>
+          </a:xfrm>
+          <a:prstGeom prst="rect">
+            <a:avLst/>
+          </a:prstGeom>
+          <a:noFill/>
+        </p:spPr>
+        <p:txBody>
+          <a:bodyPr lIns="72000" tIns="72000" rIns="72000" bIns="72000"/>
+          <a:lstStyle>
+            <a:lvl1pPr marL="0" indent="0" algn="l" defTabSz="1280160" rtl="0" eaLnBrk="1" latinLnBrk="0" hangingPunct="1">
+              <a:lnSpc>
+                <a:spcPct val="100000"/>
+              </a:lnSpc>
+              <a:spcBef>
+                <a:spcPts val="0"/>
+              </a:spcBef>
+              <a:spcAft>
+                <a:spcPts val="1200"/>
+              </a:spcAft>
+              <a:buFont typeface="Arial" panose="020B0604020202020204" pitchFamily="34" charset="0"/>
+              <a:buNone/>
+              <a:defRPr sz="1800" kern="1200">
+                <a:solidFill>
+                  <a:schemeClr val="tx2">
+                    <a:lumMod val="75000"/>
+                  </a:schemeClr>
+                </a:solidFill>
+                <a:latin typeface="+mn-lt"/>
+                <a:ea typeface="+mn-ea"/>
+                <a:cs typeface="+mn-cs"/>
+              </a:defRPr>
+            </a:lvl1pPr>
+            <a:lvl2pPr marL="640080" indent="0" algn="l" defTabSz="1280160" rtl="0" eaLnBrk="1" latinLnBrk="0" hangingPunct="1">
+              <a:lnSpc>
+                <a:spcPct val="90000"/>
+              </a:lnSpc>
+              <a:spcBef>
+                <a:spcPts val="700"/>
+              </a:spcBef>
+              <a:buFont typeface="Arial" panose="020B0604020202020204" pitchFamily="34" charset="0"/>
+              <a:buNone/>
+              <a:defRPr sz="1400" kern="1200">
+                <a:solidFill>
+                  <a:schemeClr val="tx1"/>
+                </a:solidFill>
+                <a:latin typeface="+mn-lt"/>
+                <a:ea typeface="+mn-ea"/>
+                <a:cs typeface="+mn-cs"/>
+              </a:defRPr>
+            </a:lvl2pPr>
+            <a:lvl3pPr marL="1280160" indent="0" algn="l" defTabSz="1280160" rtl="0" eaLnBrk="1" latinLnBrk="0" hangingPunct="1">
+              <a:lnSpc>
+                <a:spcPct val="90000"/>
+              </a:lnSpc>
+              <a:spcBef>
+                <a:spcPts val="700"/>
+              </a:spcBef>
+              <a:buFont typeface="Arial" panose="020B0604020202020204" pitchFamily="34" charset="0"/>
+              <a:buNone/>
+              <a:defRPr sz="1400" kern="1200">
+                <a:solidFill>
+                  <a:schemeClr val="tx1"/>
+                </a:solidFill>
+                <a:latin typeface="+mn-lt"/>
+                <a:ea typeface="+mn-ea"/>
+                <a:cs typeface="+mn-cs"/>
+              </a:defRPr>
+            </a:lvl3pPr>
+            <a:lvl4pPr marL="1920240" indent="0" algn="l" defTabSz="1280160" rtl="0" eaLnBrk="1" latinLnBrk="0" hangingPunct="1">
+              <a:lnSpc>
+                <a:spcPct val="90000"/>
+              </a:lnSpc>
+              <a:spcBef>
+                <a:spcPts val="700"/>
+              </a:spcBef>
+              <a:buFont typeface="Arial" panose="020B0604020202020204" pitchFamily="34" charset="0"/>
+              <a:buNone/>
+              <a:defRPr sz="1400" kern="1200">
+                <a:solidFill>
+                  <a:schemeClr val="tx1"/>
+                </a:solidFill>
+                <a:latin typeface="+mn-lt"/>
+                <a:ea typeface="+mn-ea"/>
+                <a:cs typeface="+mn-cs"/>
+              </a:defRPr>
+            </a:lvl4pPr>
+            <a:lvl5pPr marL="2560320" indent="0" algn="l" defTabSz="1280160" rtl="0" eaLnBrk="1" latinLnBrk="0" hangingPunct="1">
+              <a:lnSpc>
+                <a:spcPct val="90000"/>
+              </a:lnSpc>
+              <a:spcBef>
+                <a:spcPts val="700"/>
+              </a:spcBef>
+              <a:buFont typeface="Arial" panose="020B0604020202020204" pitchFamily="34" charset="0"/>
+              <a:buNone/>
+              <a:defRPr sz="1400" kern="1200">
+                <a:solidFill>
+                  <a:schemeClr val="tx1"/>
+                </a:solidFill>
+                <a:latin typeface="+mn-lt"/>
+                <a:ea typeface="+mn-ea"/>
+                <a:cs typeface="+mn-cs"/>
+              </a:defRPr>
+            </a:lvl5pPr>
+            <a:lvl6pPr marL="3520440" indent="-320040" algn="l" defTabSz="1280160" rtl="0" eaLnBrk="1" latinLnBrk="0" hangingPunct="1">
+              <a:lnSpc>
+                <a:spcPct val="90000"/>
+              </a:lnSpc>
+              <a:spcBef>
+                <a:spcPts val="700"/>
+              </a:spcBef>
+              <a:buFont typeface="Arial" panose="020B0604020202020204" pitchFamily="34" charset="0"/>
+              <a:buChar char="•"/>
+              <a:defRPr sz="2520" kern="1200">
+                <a:solidFill>
+                  <a:schemeClr val="tx1"/>
+                </a:solidFill>
+                <a:latin typeface="+mn-lt"/>
+                <a:ea typeface="+mn-ea"/>
+                <a:cs typeface="+mn-cs"/>
+              </a:defRPr>
+            </a:lvl6pPr>
+            <a:lvl7pPr marL="4160520" indent="-320040" algn="l" defTabSz="1280160" rtl="0" eaLnBrk="1" latinLnBrk="0" hangingPunct="1">
+              <a:lnSpc>
+                <a:spcPct val="90000"/>
+              </a:lnSpc>
+              <a:spcBef>
+                <a:spcPts val="700"/>
+              </a:spcBef>
+              <a:buFont typeface="Arial" panose="020B0604020202020204" pitchFamily="34" charset="0"/>
+              <a:buChar char="•"/>
+              <a:defRPr sz="2520" kern="1200">
+                <a:solidFill>
+                  <a:schemeClr val="tx1"/>
+                </a:solidFill>
+                <a:latin typeface="+mn-lt"/>
+                <a:ea typeface="+mn-ea"/>
+                <a:cs typeface="+mn-cs"/>
+              </a:defRPr>
+            </a:lvl7pPr>
+            <a:lvl8pPr marL="4800600" indent="-320040" algn="l" defTabSz="1280160" rtl="0" eaLnBrk="1" latinLnBrk="0" hangingPunct="1">
+              <a:lnSpc>
+                <a:spcPct val="90000"/>
+              </a:lnSpc>
+              <a:spcBef>
+                <a:spcPts val="700"/>
+              </a:spcBef>
+              <a:buFont typeface="Arial" panose="020B0604020202020204" pitchFamily="34" charset="0"/>
+              <a:buChar char="•"/>
+              <a:defRPr sz="2520" kern="1200">
+                <a:solidFill>
+                  <a:schemeClr val="tx1"/>
+                </a:solidFill>
+                <a:latin typeface="+mn-lt"/>
+                <a:ea typeface="+mn-ea"/>
+                <a:cs typeface="+mn-cs"/>
+              </a:defRPr>
+            </a:lvl8pPr>
+            <a:lvl9pPr marL="5440680" indent="-320040" algn="l" defTabSz="1280160" rtl="0" eaLnBrk="1" latinLnBrk="0" hangingPunct="1">
+              <a:lnSpc>
+                <a:spcPct val="90000"/>
+              </a:lnSpc>
+              <a:spcBef>
+                <a:spcPts val="700"/>
+              </a:spcBef>
+              <a:buFont typeface="Arial" panose="020B0604020202020204" pitchFamily="34" charset="0"/>
+              <a:buChar char="•"/>
+              <a:defRPr sz="2520" kern="1200">
+                <a:solidFill>
+                  <a:schemeClr val="tx1"/>
+                </a:solidFill>
+                <a:latin typeface="+mn-lt"/>
+                <a:ea typeface="+mn-ea"/>
+                <a:cs typeface="+mn-cs"/>
+              </a:defRPr>
+            </a:lvl9pPr>
+          </a:lstStyle>
+          <a:p>
+            <a:pPr algn="ctr"/>
+            <a:r>
+              <a:rPr lang="pt-BR" sz="2000" b="1" dirty="0">
+                <a:solidFill>
+                  <a:schemeClr val="accent1">
+                    <a:lumMod val="75000"/>
+                  </a:schemeClr>
+                </a:solidFill>
+                <a:latin typeface="Arial" panose="020B0604020202020204" pitchFamily="34" charset="0"/>
+                <a:cs typeface="Arial" panose="020B0604020202020204" pitchFamily="34" charset="0"/>
+              </a:rPr>
+              <a:t>Recall</a:t>
+            </a:r>
+          </a:p>
+        </p:txBody>
+      </p:sp>
+      <p:sp>
+        <p:nvSpPr>
+          <p:cNvPr id="37" name="Espaço Reservado para Texto 1">
+            <a:extLst>
+              <a:ext uri="{FF2B5EF4-FFF2-40B4-BE49-F238E27FC236}">
+                <a16:creationId xmlns:a16="http://schemas.microsoft.com/office/drawing/2014/main" id="{9801C309-DE7F-A1DE-409C-4CA09CCBE777}"/>
+              </a:ext>
+            </a:extLst>
+          </p:cNvPr>
+          <p:cNvSpPr txBox="1">
+            <a:spLocks/>
+          </p:cNvSpPr>
+          <p:nvPr/>
+        </p:nvSpPr>
+        <p:spPr>
+          <a:xfrm>
+            <a:off x="6759693" y="3040457"/>
+            <a:ext cx="2882664" cy="759206"/>
+          </a:xfrm>
+          <a:prstGeom prst="rect">
+            <a:avLst/>
+          </a:prstGeom>
+          <a:noFill/>
+        </p:spPr>
+        <p:txBody>
+          <a:bodyPr lIns="72000" tIns="72000" rIns="72000" bIns="72000" anchor="ctr"/>
+          <a:lstStyle>
+            <a:lvl1pPr marL="0" indent="0" algn="l" defTabSz="1280160" rtl="0" eaLnBrk="1" latinLnBrk="0" hangingPunct="1">
+              <a:lnSpc>
+                <a:spcPct val="100000"/>
+              </a:lnSpc>
+              <a:spcBef>
+                <a:spcPts val="0"/>
+              </a:spcBef>
+              <a:spcAft>
+                <a:spcPts val="1200"/>
+              </a:spcAft>
+              <a:buFont typeface="Arial" panose="020B0604020202020204" pitchFamily="34" charset="0"/>
+              <a:buNone/>
+              <a:defRPr sz="1800" kern="1200">
+                <a:solidFill>
+                  <a:schemeClr val="tx2">
+                    <a:lumMod val="75000"/>
+                  </a:schemeClr>
+                </a:solidFill>
+                <a:latin typeface="+mn-lt"/>
+                <a:ea typeface="+mn-ea"/>
+                <a:cs typeface="+mn-cs"/>
+              </a:defRPr>
+            </a:lvl1pPr>
+            <a:lvl2pPr marL="640080" indent="0" algn="l" defTabSz="1280160" rtl="0" eaLnBrk="1" latinLnBrk="0" hangingPunct="1">
+              <a:lnSpc>
+                <a:spcPct val="90000"/>
+              </a:lnSpc>
+              <a:spcBef>
+                <a:spcPts val="700"/>
+              </a:spcBef>
+              <a:buFont typeface="Arial" panose="020B0604020202020204" pitchFamily="34" charset="0"/>
+              <a:buNone/>
+              <a:defRPr sz="1400" kern="1200">
+                <a:solidFill>
+                  <a:schemeClr val="tx1"/>
+                </a:solidFill>
+                <a:latin typeface="+mn-lt"/>
+                <a:ea typeface="+mn-ea"/>
+                <a:cs typeface="+mn-cs"/>
+              </a:defRPr>
+            </a:lvl2pPr>
+            <a:lvl3pPr marL="1280160" indent="0" algn="l" defTabSz="1280160" rtl="0" eaLnBrk="1" latinLnBrk="0" hangingPunct="1">
+              <a:lnSpc>
+                <a:spcPct val="90000"/>
+              </a:lnSpc>
+              <a:spcBef>
+                <a:spcPts val="700"/>
+              </a:spcBef>
+              <a:buFont typeface="Arial" panose="020B0604020202020204" pitchFamily="34" charset="0"/>
+              <a:buNone/>
+              <a:defRPr sz="1400" kern="1200">
+                <a:solidFill>
+                  <a:schemeClr val="tx1"/>
+                </a:solidFill>
+                <a:latin typeface="+mn-lt"/>
+                <a:ea typeface="+mn-ea"/>
+                <a:cs typeface="+mn-cs"/>
+              </a:defRPr>
+            </a:lvl3pPr>
+            <a:lvl4pPr marL="1920240" indent="0" algn="l" defTabSz="1280160" rtl="0" eaLnBrk="1" latinLnBrk="0" hangingPunct="1">
+              <a:lnSpc>
+                <a:spcPct val="90000"/>
+              </a:lnSpc>
+              <a:spcBef>
+                <a:spcPts val="700"/>
+              </a:spcBef>
+              <a:buFont typeface="Arial" panose="020B0604020202020204" pitchFamily="34" charset="0"/>
+              <a:buNone/>
+              <a:defRPr sz="1400" kern="1200">
+                <a:solidFill>
+                  <a:schemeClr val="tx1"/>
+                </a:solidFill>
+                <a:latin typeface="+mn-lt"/>
+                <a:ea typeface="+mn-ea"/>
+                <a:cs typeface="+mn-cs"/>
+              </a:defRPr>
+            </a:lvl4pPr>
+            <a:lvl5pPr marL="2560320" indent="0" algn="l" defTabSz="1280160" rtl="0" eaLnBrk="1" latinLnBrk="0" hangingPunct="1">
+              <a:lnSpc>
+                <a:spcPct val="90000"/>
+              </a:lnSpc>
+              <a:spcBef>
+                <a:spcPts val="700"/>
+              </a:spcBef>
+              <a:buFont typeface="Arial" panose="020B0604020202020204" pitchFamily="34" charset="0"/>
+              <a:buNone/>
+              <a:defRPr sz="1400" kern="1200">
+                <a:solidFill>
+                  <a:schemeClr val="tx1"/>
+                </a:solidFill>
+                <a:latin typeface="+mn-lt"/>
+                <a:ea typeface="+mn-ea"/>
+                <a:cs typeface="+mn-cs"/>
+              </a:defRPr>
+            </a:lvl5pPr>
+            <a:lvl6pPr marL="3520440" indent="-320040" algn="l" defTabSz="1280160" rtl="0" eaLnBrk="1" latinLnBrk="0" hangingPunct="1">
+              <a:lnSpc>
+                <a:spcPct val="90000"/>
+              </a:lnSpc>
+              <a:spcBef>
+                <a:spcPts val="700"/>
+              </a:spcBef>
+              <a:buFont typeface="Arial" panose="020B0604020202020204" pitchFamily="34" charset="0"/>
+              <a:buChar char="•"/>
+              <a:defRPr sz="2520" kern="1200">
+                <a:solidFill>
+                  <a:schemeClr val="tx1"/>
+                </a:solidFill>
+                <a:latin typeface="+mn-lt"/>
+                <a:ea typeface="+mn-ea"/>
+                <a:cs typeface="+mn-cs"/>
+              </a:defRPr>
+            </a:lvl6pPr>
+            <a:lvl7pPr marL="4160520" indent="-320040" algn="l" defTabSz="1280160" rtl="0" eaLnBrk="1" latinLnBrk="0" hangingPunct="1">
+              <a:lnSpc>
+                <a:spcPct val="90000"/>
+              </a:lnSpc>
+              <a:spcBef>
+                <a:spcPts val="700"/>
+              </a:spcBef>
+              <a:buFont typeface="Arial" panose="020B0604020202020204" pitchFamily="34" charset="0"/>
+              <a:buChar char="•"/>
+              <a:defRPr sz="2520" kern="1200">
+                <a:solidFill>
+                  <a:schemeClr val="tx1"/>
+                </a:solidFill>
+                <a:latin typeface="+mn-lt"/>
+                <a:ea typeface="+mn-ea"/>
+                <a:cs typeface="+mn-cs"/>
+              </a:defRPr>
+            </a:lvl7pPr>
+            <a:lvl8pPr marL="4800600" indent="-320040" algn="l" defTabSz="1280160" rtl="0" eaLnBrk="1" latinLnBrk="0" hangingPunct="1">
+              <a:lnSpc>
+                <a:spcPct val="90000"/>
+              </a:lnSpc>
+              <a:spcBef>
+                <a:spcPts val="700"/>
+              </a:spcBef>
+              <a:buFont typeface="Arial" panose="020B0604020202020204" pitchFamily="34" charset="0"/>
+              <a:buChar char="•"/>
+              <a:defRPr sz="2520" kern="1200">
+                <a:solidFill>
+                  <a:schemeClr val="tx1"/>
+                </a:solidFill>
+                <a:latin typeface="+mn-lt"/>
+                <a:ea typeface="+mn-ea"/>
+                <a:cs typeface="+mn-cs"/>
+              </a:defRPr>
+            </a:lvl8pPr>
+            <a:lvl9pPr marL="5440680" indent="-320040" algn="l" defTabSz="1280160" rtl="0" eaLnBrk="1" latinLnBrk="0" hangingPunct="1">
+              <a:lnSpc>
+                <a:spcPct val="90000"/>
+              </a:lnSpc>
+              <a:spcBef>
+                <a:spcPts val="700"/>
+              </a:spcBef>
+              <a:buFont typeface="Arial" panose="020B0604020202020204" pitchFamily="34" charset="0"/>
+              <a:buChar char="•"/>
+              <a:defRPr sz="2520" kern="1200">
+                <a:solidFill>
+                  <a:schemeClr val="tx1"/>
+                </a:solidFill>
+                <a:latin typeface="+mn-lt"/>
+                <a:ea typeface="+mn-ea"/>
+                <a:cs typeface="+mn-cs"/>
+              </a:defRPr>
+            </a:lvl9pPr>
+          </a:lstStyle>
+          <a:p>
+            <a:pPr algn="ctr"/>
+            <a:r>
+              <a:rPr lang="pt-BR" sz="4800" dirty="0">
+                <a:solidFill>
+                  <a:srgbClr val="00B050"/>
+                </a:solidFill>
+                <a:latin typeface="Arial" panose="020B0604020202020204" pitchFamily="34" charset="0"/>
+                <a:cs typeface="Arial" panose="020B0604020202020204" pitchFamily="34" charset="0"/>
+              </a:rPr>
+              <a:t>0,77</a:t>
+            </a:r>
+          </a:p>
+        </p:txBody>
+      </p:sp>
+      <p:sp>
+        <p:nvSpPr>
+          <p:cNvPr id="39" name="Espaço Reservado para Texto 1">
+            <a:extLst>
+              <a:ext uri="{FF2B5EF4-FFF2-40B4-BE49-F238E27FC236}">
+                <a16:creationId xmlns:a16="http://schemas.microsoft.com/office/drawing/2014/main" id="{D1B1FFF8-354D-FDE2-EE28-DF479D7C09F3}"/>
+              </a:ext>
+            </a:extLst>
+          </p:cNvPr>
+          <p:cNvSpPr txBox="1">
+            <a:spLocks/>
+          </p:cNvSpPr>
+          <p:nvPr/>
+        </p:nvSpPr>
+        <p:spPr>
+          <a:xfrm>
+            <a:off x="11838899" y="2444851"/>
+            <a:ext cx="2882664" cy="421714"/>
+          </a:xfrm>
+          <a:prstGeom prst="rect">
+            <a:avLst/>
+          </a:prstGeom>
+          <a:noFill/>
+        </p:spPr>
+        <p:txBody>
+          <a:bodyPr lIns="72000" tIns="72000" rIns="72000" bIns="72000"/>
+          <a:lstStyle>
+            <a:lvl1pPr marL="0" indent="0" algn="l" defTabSz="1280160" rtl="0" eaLnBrk="1" latinLnBrk="0" hangingPunct="1">
+              <a:lnSpc>
+                <a:spcPct val="100000"/>
+              </a:lnSpc>
+              <a:spcBef>
+                <a:spcPts val="0"/>
+              </a:spcBef>
+              <a:spcAft>
+                <a:spcPts val="1200"/>
+              </a:spcAft>
+              <a:buFont typeface="Arial" panose="020B0604020202020204" pitchFamily="34" charset="0"/>
+              <a:buNone/>
+              <a:defRPr sz="1800" kern="1200">
+                <a:solidFill>
+                  <a:schemeClr val="tx2">
+                    <a:lumMod val="75000"/>
+                  </a:schemeClr>
+                </a:solidFill>
+                <a:latin typeface="+mn-lt"/>
+                <a:ea typeface="+mn-ea"/>
+                <a:cs typeface="+mn-cs"/>
+              </a:defRPr>
+            </a:lvl1pPr>
+            <a:lvl2pPr marL="640080" indent="0" algn="l" defTabSz="1280160" rtl="0" eaLnBrk="1" latinLnBrk="0" hangingPunct="1">
+              <a:lnSpc>
+                <a:spcPct val="90000"/>
+              </a:lnSpc>
+              <a:spcBef>
+                <a:spcPts val="700"/>
+              </a:spcBef>
+              <a:buFont typeface="Arial" panose="020B0604020202020204" pitchFamily="34" charset="0"/>
+              <a:buNone/>
+              <a:defRPr sz="1400" kern="1200">
+                <a:solidFill>
+                  <a:schemeClr val="tx1"/>
+                </a:solidFill>
+                <a:latin typeface="+mn-lt"/>
+                <a:ea typeface="+mn-ea"/>
+                <a:cs typeface="+mn-cs"/>
+              </a:defRPr>
+            </a:lvl2pPr>
+            <a:lvl3pPr marL="1280160" indent="0" algn="l" defTabSz="1280160" rtl="0" eaLnBrk="1" latinLnBrk="0" hangingPunct="1">
+              <a:lnSpc>
+                <a:spcPct val="90000"/>
+              </a:lnSpc>
+              <a:spcBef>
+                <a:spcPts val="700"/>
+              </a:spcBef>
+              <a:buFont typeface="Arial" panose="020B0604020202020204" pitchFamily="34" charset="0"/>
+              <a:buNone/>
+              <a:defRPr sz="1400" kern="1200">
+                <a:solidFill>
+                  <a:schemeClr val="tx1"/>
+                </a:solidFill>
+                <a:latin typeface="+mn-lt"/>
+                <a:ea typeface="+mn-ea"/>
+                <a:cs typeface="+mn-cs"/>
+              </a:defRPr>
+            </a:lvl3pPr>
+            <a:lvl4pPr marL="1920240" indent="0" algn="l" defTabSz="1280160" rtl="0" eaLnBrk="1" latinLnBrk="0" hangingPunct="1">
+              <a:lnSpc>
+                <a:spcPct val="90000"/>
+              </a:lnSpc>
+              <a:spcBef>
+                <a:spcPts val="700"/>
+              </a:spcBef>
+              <a:buFont typeface="Arial" panose="020B0604020202020204" pitchFamily="34" charset="0"/>
+              <a:buNone/>
+              <a:defRPr sz="1400" kern="1200">
+                <a:solidFill>
+                  <a:schemeClr val="tx1"/>
+                </a:solidFill>
+                <a:latin typeface="+mn-lt"/>
+                <a:ea typeface="+mn-ea"/>
+                <a:cs typeface="+mn-cs"/>
+              </a:defRPr>
+            </a:lvl4pPr>
+            <a:lvl5pPr marL="2560320" indent="0" algn="l" defTabSz="1280160" rtl="0" eaLnBrk="1" latinLnBrk="0" hangingPunct="1">
+              <a:lnSpc>
+                <a:spcPct val="90000"/>
+              </a:lnSpc>
+              <a:spcBef>
+                <a:spcPts val="700"/>
+              </a:spcBef>
+              <a:buFont typeface="Arial" panose="020B0604020202020204" pitchFamily="34" charset="0"/>
+              <a:buNone/>
+              <a:defRPr sz="1400" kern="1200">
+                <a:solidFill>
+                  <a:schemeClr val="tx1"/>
+                </a:solidFill>
+                <a:latin typeface="+mn-lt"/>
+                <a:ea typeface="+mn-ea"/>
+                <a:cs typeface="+mn-cs"/>
+              </a:defRPr>
+            </a:lvl5pPr>
+            <a:lvl6pPr marL="3520440" indent="-320040" algn="l" defTabSz="1280160" rtl="0" eaLnBrk="1" latinLnBrk="0" hangingPunct="1">
+              <a:lnSpc>
+                <a:spcPct val="90000"/>
+              </a:lnSpc>
+              <a:spcBef>
+                <a:spcPts val="700"/>
+              </a:spcBef>
+              <a:buFont typeface="Arial" panose="020B0604020202020204" pitchFamily="34" charset="0"/>
+              <a:buChar char="•"/>
+              <a:defRPr sz="2520" kern="1200">
+                <a:solidFill>
+                  <a:schemeClr val="tx1"/>
+                </a:solidFill>
+                <a:latin typeface="+mn-lt"/>
+                <a:ea typeface="+mn-ea"/>
+                <a:cs typeface="+mn-cs"/>
+              </a:defRPr>
+            </a:lvl6pPr>
+            <a:lvl7pPr marL="4160520" indent="-320040" algn="l" defTabSz="1280160" rtl="0" eaLnBrk="1" latinLnBrk="0" hangingPunct="1">
+              <a:lnSpc>
+                <a:spcPct val="90000"/>
+              </a:lnSpc>
+              <a:spcBef>
+                <a:spcPts val="700"/>
+              </a:spcBef>
+              <a:buFont typeface="Arial" panose="020B0604020202020204" pitchFamily="34" charset="0"/>
+              <a:buChar char="•"/>
+              <a:defRPr sz="2520" kern="1200">
+                <a:solidFill>
+                  <a:schemeClr val="tx1"/>
+                </a:solidFill>
+                <a:latin typeface="+mn-lt"/>
+                <a:ea typeface="+mn-ea"/>
+                <a:cs typeface="+mn-cs"/>
+              </a:defRPr>
+            </a:lvl7pPr>
+            <a:lvl8pPr marL="4800600" indent="-320040" algn="l" defTabSz="1280160" rtl="0" eaLnBrk="1" latinLnBrk="0" hangingPunct="1">
+              <a:lnSpc>
+                <a:spcPct val="90000"/>
+              </a:lnSpc>
+              <a:spcBef>
+                <a:spcPts val="700"/>
+              </a:spcBef>
+              <a:buFont typeface="Arial" panose="020B0604020202020204" pitchFamily="34" charset="0"/>
+              <a:buChar char="•"/>
+              <a:defRPr sz="2520" kern="1200">
+                <a:solidFill>
+                  <a:schemeClr val="tx1"/>
+                </a:solidFill>
+                <a:latin typeface="+mn-lt"/>
+                <a:ea typeface="+mn-ea"/>
+                <a:cs typeface="+mn-cs"/>
+              </a:defRPr>
+            </a:lvl8pPr>
+            <a:lvl9pPr marL="5440680" indent="-320040" algn="l" defTabSz="1280160" rtl="0" eaLnBrk="1" latinLnBrk="0" hangingPunct="1">
+              <a:lnSpc>
+                <a:spcPct val="90000"/>
+              </a:lnSpc>
+              <a:spcBef>
+                <a:spcPts val="700"/>
+              </a:spcBef>
+              <a:buFont typeface="Arial" panose="020B0604020202020204" pitchFamily="34" charset="0"/>
+              <a:buChar char="•"/>
+              <a:defRPr sz="2520" kern="1200">
+                <a:solidFill>
+                  <a:schemeClr val="tx1"/>
+                </a:solidFill>
+                <a:latin typeface="+mn-lt"/>
+                <a:ea typeface="+mn-ea"/>
+                <a:cs typeface="+mn-cs"/>
+              </a:defRPr>
+            </a:lvl9pPr>
+          </a:lstStyle>
+          <a:p>
+            <a:pPr algn="ctr"/>
+            <a:r>
+              <a:rPr lang="pt-BR" sz="2000" b="1" dirty="0">
+                <a:solidFill>
+                  <a:schemeClr val="accent1">
+                    <a:lumMod val="75000"/>
+                  </a:schemeClr>
+                </a:solidFill>
+                <a:latin typeface="Arial" panose="020B0604020202020204" pitchFamily="34" charset="0"/>
+                <a:cs typeface="Arial" panose="020B0604020202020204" pitchFamily="34" charset="0"/>
+              </a:rPr>
+              <a:t>F1-score</a:t>
+            </a:r>
+          </a:p>
+        </p:txBody>
+      </p:sp>
+      <p:sp>
+        <p:nvSpPr>
+          <p:cNvPr id="41" name="Espaço Reservado para Texto 1">
+            <a:extLst>
+              <a:ext uri="{FF2B5EF4-FFF2-40B4-BE49-F238E27FC236}">
+                <a16:creationId xmlns:a16="http://schemas.microsoft.com/office/drawing/2014/main" id="{81D544E1-6D91-E906-0C5F-F4AF62D85998}"/>
+              </a:ext>
+            </a:extLst>
+          </p:cNvPr>
+          <p:cNvSpPr txBox="1">
+            <a:spLocks/>
+          </p:cNvSpPr>
+          <p:nvPr/>
+        </p:nvSpPr>
+        <p:spPr>
+          <a:xfrm>
+            <a:off x="11838899" y="3040457"/>
+            <a:ext cx="2882664" cy="759206"/>
+          </a:xfrm>
+          <a:prstGeom prst="rect">
+            <a:avLst/>
+          </a:prstGeom>
+          <a:noFill/>
+        </p:spPr>
+        <p:txBody>
+          <a:bodyPr lIns="72000" tIns="72000" rIns="72000" bIns="72000" anchor="ctr"/>
+          <a:lstStyle>
+            <a:lvl1pPr marL="0" indent="0" algn="l" defTabSz="1280160" rtl="0" eaLnBrk="1" latinLnBrk="0" hangingPunct="1">
+              <a:lnSpc>
+                <a:spcPct val="100000"/>
+              </a:lnSpc>
+              <a:spcBef>
+                <a:spcPts val="0"/>
+              </a:spcBef>
+              <a:spcAft>
+                <a:spcPts val="1200"/>
+              </a:spcAft>
+              <a:buFont typeface="Arial" panose="020B0604020202020204" pitchFamily="34" charset="0"/>
+              <a:buNone/>
+              <a:defRPr sz="1800" kern="1200">
+                <a:solidFill>
+                  <a:schemeClr val="tx2">
+                    <a:lumMod val="75000"/>
+                  </a:schemeClr>
+                </a:solidFill>
+                <a:latin typeface="+mn-lt"/>
+                <a:ea typeface="+mn-ea"/>
+                <a:cs typeface="+mn-cs"/>
+              </a:defRPr>
+            </a:lvl1pPr>
+            <a:lvl2pPr marL="640080" indent="0" algn="l" defTabSz="1280160" rtl="0" eaLnBrk="1" latinLnBrk="0" hangingPunct="1">
+              <a:lnSpc>
+                <a:spcPct val="90000"/>
+              </a:lnSpc>
+              <a:spcBef>
+                <a:spcPts val="700"/>
+              </a:spcBef>
+              <a:buFont typeface="Arial" panose="020B0604020202020204" pitchFamily="34" charset="0"/>
+              <a:buNone/>
+              <a:defRPr sz="1400" kern="1200">
+                <a:solidFill>
+                  <a:schemeClr val="tx1"/>
+                </a:solidFill>
+                <a:latin typeface="+mn-lt"/>
+                <a:ea typeface="+mn-ea"/>
+                <a:cs typeface="+mn-cs"/>
+              </a:defRPr>
+            </a:lvl2pPr>
+            <a:lvl3pPr marL="1280160" indent="0" algn="l" defTabSz="1280160" rtl="0" eaLnBrk="1" latinLnBrk="0" hangingPunct="1">
+              <a:lnSpc>
+                <a:spcPct val="90000"/>
+              </a:lnSpc>
+              <a:spcBef>
+                <a:spcPts val="700"/>
+              </a:spcBef>
+              <a:buFont typeface="Arial" panose="020B0604020202020204" pitchFamily="34" charset="0"/>
+              <a:buNone/>
+              <a:defRPr sz="1400" kern="1200">
+                <a:solidFill>
+                  <a:schemeClr val="tx1"/>
+                </a:solidFill>
+                <a:latin typeface="+mn-lt"/>
+                <a:ea typeface="+mn-ea"/>
+                <a:cs typeface="+mn-cs"/>
+              </a:defRPr>
+            </a:lvl3pPr>
+            <a:lvl4pPr marL="1920240" indent="0" algn="l" defTabSz="1280160" rtl="0" eaLnBrk="1" latinLnBrk="0" hangingPunct="1">
+              <a:lnSpc>
+                <a:spcPct val="90000"/>
+              </a:lnSpc>
+              <a:spcBef>
+                <a:spcPts val="700"/>
+              </a:spcBef>
+              <a:buFont typeface="Arial" panose="020B0604020202020204" pitchFamily="34" charset="0"/>
+              <a:buNone/>
+              <a:defRPr sz="1400" kern="1200">
+                <a:solidFill>
+                  <a:schemeClr val="tx1"/>
+                </a:solidFill>
+                <a:latin typeface="+mn-lt"/>
+                <a:ea typeface="+mn-ea"/>
+                <a:cs typeface="+mn-cs"/>
+              </a:defRPr>
+            </a:lvl4pPr>
+            <a:lvl5pPr marL="2560320" indent="0" algn="l" defTabSz="1280160" rtl="0" eaLnBrk="1" latinLnBrk="0" hangingPunct="1">
+              <a:lnSpc>
+                <a:spcPct val="90000"/>
+              </a:lnSpc>
+              <a:spcBef>
+                <a:spcPts val="700"/>
+              </a:spcBef>
+              <a:buFont typeface="Arial" panose="020B0604020202020204" pitchFamily="34" charset="0"/>
+              <a:buNone/>
+              <a:defRPr sz="1400" kern="1200">
+                <a:solidFill>
+                  <a:schemeClr val="tx1"/>
+                </a:solidFill>
+                <a:latin typeface="+mn-lt"/>
+                <a:ea typeface="+mn-ea"/>
+                <a:cs typeface="+mn-cs"/>
+              </a:defRPr>
+            </a:lvl5pPr>
+            <a:lvl6pPr marL="3520440" indent="-320040" algn="l" defTabSz="1280160" rtl="0" eaLnBrk="1" latinLnBrk="0" hangingPunct="1">
+              <a:lnSpc>
+                <a:spcPct val="90000"/>
+              </a:lnSpc>
+              <a:spcBef>
+                <a:spcPts val="700"/>
+              </a:spcBef>
+              <a:buFont typeface="Arial" panose="020B0604020202020204" pitchFamily="34" charset="0"/>
+              <a:buChar char="•"/>
+              <a:defRPr sz="2520" kern="1200">
+                <a:solidFill>
+                  <a:schemeClr val="tx1"/>
+                </a:solidFill>
+                <a:latin typeface="+mn-lt"/>
+                <a:ea typeface="+mn-ea"/>
+                <a:cs typeface="+mn-cs"/>
+              </a:defRPr>
+            </a:lvl6pPr>
+            <a:lvl7pPr marL="4160520" indent="-320040" algn="l" defTabSz="1280160" rtl="0" eaLnBrk="1" latinLnBrk="0" hangingPunct="1">
+              <a:lnSpc>
+                <a:spcPct val="90000"/>
+              </a:lnSpc>
+              <a:spcBef>
+                <a:spcPts val="700"/>
+              </a:spcBef>
+              <a:buFont typeface="Arial" panose="020B0604020202020204" pitchFamily="34" charset="0"/>
+              <a:buChar char="•"/>
+              <a:defRPr sz="2520" kern="1200">
+                <a:solidFill>
+                  <a:schemeClr val="tx1"/>
+                </a:solidFill>
+                <a:latin typeface="+mn-lt"/>
+                <a:ea typeface="+mn-ea"/>
+                <a:cs typeface="+mn-cs"/>
+              </a:defRPr>
+            </a:lvl7pPr>
+            <a:lvl8pPr marL="4800600" indent="-320040" algn="l" defTabSz="1280160" rtl="0" eaLnBrk="1" latinLnBrk="0" hangingPunct="1">
+              <a:lnSpc>
+                <a:spcPct val="90000"/>
+              </a:lnSpc>
+              <a:spcBef>
+                <a:spcPts val="700"/>
+              </a:spcBef>
+              <a:buFont typeface="Arial" panose="020B0604020202020204" pitchFamily="34" charset="0"/>
+              <a:buChar char="•"/>
+              <a:defRPr sz="2520" kern="1200">
+                <a:solidFill>
+                  <a:schemeClr val="tx1"/>
+                </a:solidFill>
+                <a:latin typeface="+mn-lt"/>
+                <a:ea typeface="+mn-ea"/>
+                <a:cs typeface="+mn-cs"/>
+              </a:defRPr>
+            </a:lvl8pPr>
+            <a:lvl9pPr marL="5440680" indent="-320040" algn="l" defTabSz="1280160" rtl="0" eaLnBrk="1" latinLnBrk="0" hangingPunct="1">
+              <a:lnSpc>
+                <a:spcPct val="90000"/>
+              </a:lnSpc>
+              <a:spcBef>
+                <a:spcPts val="700"/>
+              </a:spcBef>
+              <a:buFont typeface="Arial" panose="020B0604020202020204" pitchFamily="34" charset="0"/>
+              <a:buChar char="•"/>
+              <a:defRPr sz="2520" kern="1200">
+                <a:solidFill>
+                  <a:schemeClr val="tx1"/>
+                </a:solidFill>
+                <a:latin typeface="+mn-lt"/>
+                <a:ea typeface="+mn-ea"/>
+                <a:cs typeface="+mn-cs"/>
+              </a:defRPr>
+            </a:lvl9pPr>
+          </a:lstStyle>
+          <a:p>
+            <a:pPr algn="ctr"/>
+            <a:r>
+              <a:rPr lang="pt-BR" sz="4800" dirty="0">
+                <a:solidFill>
+                  <a:srgbClr val="C00000"/>
+                </a:solidFill>
+                <a:latin typeface="Arial" panose="020B0604020202020204" pitchFamily="34" charset="0"/>
+                <a:cs typeface="Arial" panose="020B0604020202020204" pitchFamily="34" charset="0"/>
+              </a:rPr>
+              <a:t>0,39</a:t>
+            </a:r>
+          </a:p>
+        </p:txBody>
+      </p:sp>
+    </p:spTree>
+    <p:extLst>
+      <p:ext uri="{BB962C8B-B14F-4D97-AF65-F5344CB8AC3E}">
+        <p14:creationId xmlns:p14="http://schemas.microsoft.com/office/powerpoint/2010/main" val="3719625301"/>
+      </p:ext>
+    </p:extLst>
+  </p:cSld>
+  <p:clrMapOvr>
+    <a:masterClrMapping/>
+  </p:clrMapOvr>
+</p:sld>
+</file>
+
+<file path=ppt/slides/slide6.xml><?xml version="1.0" encoding="utf-8"?>
 <p:sld xmlns:a="http://schemas.openxmlformats.org/drawingml/2006/main" xmlns:r="http://schemas.openxmlformats.org/officeDocument/2006/relationships" xmlns:p="http://schemas.openxmlformats.org/presentationml/2006/main">
   <p:cSld>
     <p:spTree>

</xml_diff>

<commit_message>
feat: slide 3 - resultado dos modelos
</commit_message>
<xml_diff>
--- a/docs/Template - Fase 2 - Apresentação Executiva - Projeto em Business Intelligence e Analytics.pptx
+++ b/docs/Template - Fase 2 - Apresentação Executiva - Projeto em Business Intelligence e Analytics.pptx
@@ -7821,7 +7821,7 @@
         </p:nvSpPr>
         <p:spPr>
           <a:xfrm>
-            <a:off x="928689" y="1416050"/>
+            <a:off x="928688" y="1301750"/>
             <a:ext cx="14544674" cy="625401"/>
           </a:xfrm>
         </p:spPr>
@@ -7860,7 +7860,7 @@
         </p:nvSpPr>
         <p:spPr>
           <a:xfrm>
-            <a:off x="928688" y="2270959"/>
+            <a:off x="928687" y="2156659"/>
             <a:ext cx="4386262" cy="2109107"/>
           </a:xfrm>
           <a:prstGeom prst="rect">
@@ -8078,7 +8078,7 @@
         </p:nvSpPr>
         <p:spPr>
           <a:xfrm>
-            <a:off x="6007894" y="2270959"/>
+            <a:off x="6007893" y="2156659"/>
             <a:ext cx="4386262" cy="2109107"/>
           </a:xfrm>
           <a:prstGeom prst="rect">
@@ -8296,7 +8296,7 @@
         </p:nvSpPr>
         <p:spPr>
           <a:xfrm>
-            <a:off x="11087100" y="2270959"/>
+            <a:off x="11087099" y="2156659"/>
             <a:ext cx="4386262" cy="2109107"/>
           </a:xfrm>
           <a:prstGeom prst="rect">
@@ -8514,7 +8514,7 @@
         </p:nvSpPr>
         <p:spPr>
           <a:xfrm>
-            <a:off x="1680487" y="2444851"/>
+            <a:off x="1680486" y="2330551"/>
             <a:ext cx="2882664" cy="421714"/>
           </a:xfrm>
           <a:prstGeom prst="rect">
@@ -8726,7 +8726,7 @@
         </p:nvSpPr>
         <p:spPr>
           <a:xfrm>
-            <a:off x="1680487" y="3040457"/>
+            <a:off x="1680486" y="2926157"/>
             <a:ext cx="2882664" cy="759206"/>
           </a:xfrm>
           <a:prstGeom prst="rect">
@@ -8936,7 +8936,7 @@
         </p:nvSpPr>
         <p:spPr>
           <a:xfrm>
-            <a:off x="6759693" y="2444851"/>
+            <a:off x="6759692" y="2330551"/>
             <a:ext cx="2882664" cy="421714"/>
           </a:xfrm>
           <a:prstGeom prst="rect">
@@ -9148,7 +9148,7 @@
         </p:nvSpPr>
         <p:spPr>
           <a:xfrm>
-            <a:off x="6759693" y="3040457"/>
+            <a:off x="6759692" y="2926157"/>
             <a:ext cx="2882664" cy="759206"/>
           </a:xfrm>
           <a:prstGeom prst="rect">
@@ -9358,7 +9358,7 @@
         </p:nvSpPr>
         <p:spPr>
           <a:xfrm>
-            <a:off x="11838899" y="2444851"/>
+            <a:off x="11838898" y="2330551"/>
             <a:ext cx="2882664" cy="421714"/>
           </a:xfrm>
           <a:prstGeom prst="rect">
@@ -9570,7 +9570,7 @@
         </p:nvSpPr>
         <p:spPr>
           <a:xfrm>
-            <a:off x="11838899" y="3040457"/>
+            <a:off x="11838898" y="2926157"/>
             <a:ext cx="2882664" cy="759206"/>
           </a:xfrm>
           <a:prstGeom prst="rect">
@@ -9761,6 +9761,341 @@
               </a:rPr>
               <a:t>0,39</a:t>
             </a:r>
+          </a:p>
+        </p:txBody>
+      </p:sp>
+      <p:pic>
+        <p:nvPicPr>
+          <p:cNvPr id="43" name="Imagem 42">
+            <a:extLst>
+              <a:ext uri="{FF2B5EF4-FFF2-40B4-BE49-F238E27FC236}">
+                <a16:creationId xmlns:a16="http://schemas.microsoft.com/office/drawing/2014/main" id="{0ED728D7-D035-F408-E89B-411052A6FC5C}"/>
+              </a:ext>
+            </a:extLst>
+          </p:cNvPr>
+          <p:cNvPicPr>
+            <a:picLocks noChangeAspect="1"/>
+          </p:cNvPicPr>
+          <p:nvPr/>
+        </p:nvPicPr>
+        <p:blipFill>
+          <a:blip r:embed="rId3"/>
+          <a:stretch>
+            <a:fillRect/>
+          </a:stretch>
+        </p:blipFill>
+        <p:spPr>
+          <a:xfrm>
+            <a:off x="928687" y="4800600"/>
+            <a:ext cx="5992930" cy="4769883"/>
+          </a:xfrm>
+          <a:prstGeom prst="rect">
+            <a:avLst/>
+          </a:prstGeom>
+        </p:spPr>
+      </p:pic>
+      <p:sp>
+        <p:nvSpPr>
+          <p:cNvPr id="47" name="CaixaDeTexto 46">
+            <a:extLst>
+              <a:ext uri="{FF2B5EF4-FFF2-40B4-BE49-F238E27FC236}">
+                <a16:creationId xmlns:a16="http://schemas.microsoft.com/office/drawing/2014/main" id="{73CB71A5-72D6-6067-2F92-D391552F2657}"/>
+              </a:ext>
+            </a:extLst>
+          </p:cNvPr>
+          <p:cNvSpPr txBox="1"/>
+          <p:nvPr/>
+        </p:nvSpPr>
+        <p:spPr>
+          <a:xfrm>
+            <a:off x="3925152" y="4439658"/>
+            <a:ext cx="8201024" cy="276999"/>
+          </a:xfrm>
+          <a:prstGeom prst="rect">
+            <a:avLst/>
+          </a:prstGeom>
+          <a:noFill/>
+          <a:ln w="9525">
+            <a:solidFill>
+              <a:schemeClr val="bg1"/>
+            </a:solidFill>
+          </a:ln>
+        </p:spPr>
+        <p:txBody>
+          <a:bodyPr wrap="square">
+            <a:spAutoFit/>
+          </a:bodyPr>
+          <a:lstStyle/>
+          <a:p>
+            <a:pPr algn="ctr">
+              <a:spcAft>
+                <a:spcPts val="0"/>
+              </a:spcAft>
+              <a:buNone/>
+            </a:pPr>
+            <a:r>
+              <a:rPr lang="pt-BR" sz="1200" b="0" i="1" dirty="0">
+                <a:solidFill>
+                  <a:srgbClr val="666666"/>
+                </a:solidFill>
+                <a:latin typeface="Calibri"/>
+              </a:rPr>
+              <a:t>Validação cruzada temporal, 2014–2024 (176 previsões agregadas), com class_weight="balanced"</a:t>
+            </a:r>
+          </a:p>
+        </p:txBody>
+      </p:sp>
+      <p:sp>
+        <p:nvSpPr>
+          <p:cNvPr id="53" name="Espaço Reservado para Texto 1">
+            <a:extLst>
+              <a:ext uri="{FF2B5EF4-FFF2-40B4-BE49-F238E27FC236}">
+                <a16:creationId xmlns:a16="http://schemas.microsoft.com/office/drawing/2014/main" id="{153B1ECC-44D4-FB16-2F83-1505AF732A56}"/>
+              </a:ext>
+            </a:extLst>
+          </p:cNvPr>
+          <p:cNvSpPr txBox="1">
+            <a:spLocks/>
+          </p:cNvSpPr>
+          <p:nvPr/>
+        </p:nvSpPr>
+        <p:spPr>
+          <a:xfrm>
+            <a:off x="7933987" y="5264772"/>
+            <a:ext cx="7363502" cy="3092738"/>
+          </a:xfrm>
+          <a:prstGeom prst="rect">
+            <a:avLst/>
+          </a:prstGeom>
+          <a:noFill/>
+        </p:spPr>
+        <p:txBody>
+          <a:bodyPr lIns="72000" tIns="72000" rIns="72000" bIns="72000"/>
+          <a:lstStyle>
+            <a:lvl1pPr marL="0" indent="0" algn="l" defTabSz="1280160" rtl="0" eaLnBrk="1" latinLnBrk="0" hangingPunct="1">
+              <a:lnSpc>
+                <a:spcPct val="100000"/>
+              </a:lnSpc>
+              <a:spcBef>
+                <a:spcPts val="0"/>
+              </a:spcBef>
+              <a:spcAft>
+                <a:spcPts val="1200"/>
+              </a:spcAft>
+              <a:buFont typeface="Arial" panose="020B0604020202020204" pitchFamily="34" charset="0"/>
+              <a:buNone/>
+              <a:defRPr sz="1800" kern="1200">
+                <a:solidFill>
+                  <a:schemeClr val="tx2">
+                    <a:lumMod val="75000"/>
+                  </a:schemeClr>
+                </a:solidFill>
+                <a:latin typeface="+mn-lt"/>
+                <a:ea typeface="+mn-ea"/>
+                <a:cs typeface="+mn-cs"/>
+              </a:defRPr>
+            </a:lvl1pPr>
+            <a:lvl2pPr marL="640080" indent="0" algn="l" defTabSz="1280160" rtl="0" eaLnBrk="1" latinLnBrk="0" hangingPunct="1">
+              <a:lnSpc>
+                <a:spcPct val="90000"/>
+              </a:lnSpc>
+              <a:spcBef>
+                <a:spcPts val="700"/>
+              </a:spcBef>
+              <a:buFont typeface="Arial" panose="020B0604020202020204" pitchFamily="34" charset="0"/>
+              <a:buNone/>
+              <a:defRPr sz="1400" kern="1200">
+                <a:solidFill>
+                  <a:schemeClr val="tx1"/>
+                </a:solidFill>
+                <a:latin typeface="+mn-lt"/>
+                <a:ea typeface="+mn-ea"/>
+                <a:cs typeface="+mn-cs"/>
+              </a:defRPr>
+            </a:lvl2pPr>
+            <a:lvl3pPr marL="1280160" indent="0" algn="l" defTabSz="1280160" rtl="0" eaLnBrk="1" latinLnBrk="0" hangingPunct="1">
+              <a:lnSpc>
+                <a:spcPct val="90000"/>
+              </a:lnSpc>
+              <a:spcBef>
+                <a:spcPts val="700"/>
+              </a:spcBef>
+              <a:buFont typeface="Arial" panose="020B0604020202020204" pitchFamily="34" charset="0"/>
+              <a:buNone/>
+              <a:defRPr sz="1400" kern="1200">
+                <a:solidFill>
+                  <a:schemeClr val="tx1"/>
+                </a:solidFill>
+                <a:latin typeface="+mn-lt"/>
+                <a:ea typeface="+mn-ea"/>
+                <a:cs typeface="+mn-cs"/>
+              </a:defRPr>
+            </a:lvl3pPr>
+            <a:lvl4pPr marL="1920240" indent="0" algn="l" defTabSz="1280160" rtl="0" eaLnBrk="1" latinLnBrk="0" hangingPunct="1">
+              <a:lnSpc>
+                <a:spcPct val="90000"/>
+              </a:lnSpc>
+              <a:spcBef>
+                <a:spcPts val="700"/>
+              </a:spcBef>
+              <a:buFont typeface="Arial" panose="020B0604020202020204" pitchFamily="34" charset="0"/>
+              <a:buNone/>
+              <a:defRPr sz="1400" kern="1200">
+                <a:solidFill>
+                  <a:schemeClr val="tx1"/>
+                </a:solidFill>
+                <a:latin typeface="+mn-lt"/>
+                <a:ea typeface="+mn-ea"/>
+                <a:cs typeface="+mn-cs"/>
+              </a:defRPr>
+            </a:lvl4pPr>
+            <a:lvl5pPr marL="2560320" indent="0" algn="l" defTabSz="1280160" rtl="0" eaLnBrk="1" latinLnBrk="0" hangingPunct="1">
+              <a:lnSpc>
+                <a:spcPct val="90000"/>
+              </a:lnSpc>
+              <a:spcBef>
+                <a:spcPts val="700"/>
+              </a:spcBef>
+              <a:buFont typeface="Arial" panose="020B0604020202020204" pitchFamily="34" charset="0"/>
+              <a:buNone/>
+              <a:defRPr sz="1400" kern="1200">
+                <a:solidFill>
+                  <a:schemeClr val="tx1"/>
+                </a:solidFill>
+                <a:latin typeface="+mn-lt"/>
+                <a:ea typeface="+mn-ea"/>
+                <a:cs typeface="+mn-cs"/>
+              </a:defRPr>
+            </a:lvl5pPr>
+            <a:lvl6pPr marL="3520440" indent="-320040" algn="l" defTabSz="1280160" rtl="0" eaLnBrk="1" latinLnBrk="0" hangingPunct="1">
+              <a:lnSpc>
+                <a:spcPct val="90000"/>
+              </a:lnSpc>
+              <a:spcBef>
+                <a:spcPts val="700"/>
+              </a:spcBef>
+              <a:buFont typeface="Arial" panose="020B0604020202020204" pitchFamily="34" charset="0"/>
+              <a:buChar char="•"/>
+              <a:defRPr sz="2520" kern="1200">
+                <a:solidFill>
+                  <a:schemeClr val="tx1"/>
+                </a:solidFill>
+                <a:latin typeface="+mn-lt"/>
+                <a:ea typeface="+mn-ea"/>
+                <a:cs typeface="+mn-cs"/>
+              </a:defRPr>
+            </a:lvl6pPr>
+            <a:lvl7pPr marL="4160520" indent="-320040" algn="l" defTabSz="1280160" rtl="0" eaLnBrk="1" latinLnBrk="0" hangingPunct="1">
+              <a:lnSpc>
+                <a:spcPct val="90000"/>
+              </a:lnSpc>
+              <a:spcBef>
+                <a:spcPts val="700"/>
+              </a:spcBef>
+              <a:buFont typeface="Arial" panose="020B0604020202020204" pitchFamily="34" charset="0"/>
+              <a:buChar char="•"/>
+              <a:defRPr sz="2520" kern="1200">
+                <a:solidFill>
+                  <a:schemeClr val="tx1"/>
+                </a:solidFill>
+                <a:latin typeface="+mn-lt"/>
+                <a:ea typeface="+mn-ea"/>
+                <a:cs typeface="+mn-cs"/>
+              </a:defRPr>
+            </a:lvl7pPr>
+            <a:lvl8pPr marL="4800600" indent="-320040" algn="l" defTabSz="1280160" rtl="0" eaLnBrk="1" latinLnBrk="0" hangingPunct="1">
+              <a:lnSpc>
+                <a:spcPct val="90000"/>
+              </a:lnSpc>
+              <a:spcBef>
+                <a:spcPts val="700"/>
+              </a:spcBef>
+              <a:buFont typeface="Arial" panose="020B0604020202020204" pitchFamily="34" charset="0"/>
+              <a:buChar char="•"/>
+              <a:defRPr sz="2520" kern="1200">
+                <a:solidFill>
+                  <a:schemeClr val="tx1"/>
+                </a:solidFill>
+                <a:latin typeface="+mn-lt"/>
+                <a:ea typeface="+mn-ea"/>
+                <a:cs typeface="+mn-cs"/>
+              </a:defRPr>
+            </a:lvl8pPr>
+            <a:lvl9pPr marL="5440680" indent="-320040" algn="l" defTabSz="1280160" rtl="0" eaLnBrk="1" latinLnBrk="0" hangingPunct="1">
+              <a:lnSpc>
+                <a:spcPct val="90000"/>
+              </a:lnSpc>
+              <a:spcBef>
+                <a:spcPts val="700"/>
+              </a:spcBef>
+              <a:buFont typeface="Arial" panose="020B0604020202020204" pitchFamily="34" charset="0"/>
+              <a:buChar char="•"/>
+              <a:defRPr sz="2520" kern="1200">
+                <a:solidFill>
+                  <a:schemeClr val="tx1"/>
+                </a:solidFill>
+                <a:latin typeface="+mn-lt"/>
+                <a:ea typeface="+mn-ea"/>
+                <a:cs typeface="+mn-cs"/>
+              </a:defRPr>
+            </a:lvl9pPr>
+          </a:lstStyle>
+          <a:p>
+            <a:pPr algn="ctr"/>
+            <a:r>
+              <a:rPr lang="pt-BR" sz="2000" b="1" dirty="0">
+                <a:solidFill>
+                  <a:schemeClr val="accent1">
+                    <a:lumMod val="75000"/>
+                  </a:schemeClr>
+                </a:solidFill>
+                <a:latin typeface="Arial" panose="020B0604020202020204" pitchFamily="34" charset="0"/>
+                <a:cs typeface="Arial" panose="020B0604020202020204" pitchFamily="34" charset="0"/>
+              </a:rPr>
+              <a:t>F1-score</a:t>
+            </a:r>
+          </a:p>
+          <a:p>
+            <a:pPr>
+              <a:spcAft>
+                <a:spcPts val="1000"/>
+              </a:spcAft>
+            </a:pPr>
+            <a:r>
+              <a:rPr lang="pt-BR" sz="2000" dirty="0">
+                <a:solidFill>
+                  <a:srgbClr val="333333"/>
+                </a:solidFill>
+              </a:rPr>
+              <a:t>O modelo identifica corretamente 20 dos 26 rebaixamentos reais do período (recall de 77%), ao custo de 57 falsos positivos.</a:t>
+            </a:r>
+          </a:p>
+          <a:p>
+            <a:pPr>
+              <a:spcAft>
+                <a:spcPts val="0"/>
+              </a:spcAft>
+            </a:pPr>
+            <a:r>
+              <a:rPr lang="pt-BR" sz="2000" dirty="0">
+                <a:solidFill>
+                  <a:srgbClr val="333333"/>
+                </a:solidFill>
+              </a:rPr>
+              <a:t>Essa configuração foi escolhida por priorizar a utilidade do KPI como sistema de alerta: para o negócio, é preferível superestimar o risco em times seguros do que deixar de sinalizar um time que de fato será rebaixado.</a:t>
+            </a:r>
+          </a:p>
+          <a:p>
+            <a:pPr algn="ctr"/>
+            <a:endParaRPr lang="pt-BR" sz="2000" b="1" dirty="0">
+              <a:solidFill>
+                <a:schemeClr val="accent1">
+                  <a:lumMod val="75000"/>
+                </a:schemeClr>
+              </a:solidFill>
+              <a:latin typeface="Arial" panose="020B0604020202020204" pitchFamily="34" charset="0"/>
+              <a:cs typeface="Arial" panose="020B0604020202020204" pitchFamily="34" charset="0"/>
+            </a:endParaRPr>
           </a:p>
         </p:txBody>
       </p:sp>

</xml_diff>

<commit_message>
feat: slide 4 - KPIs
</commit_message>
<xml_diff>
--- a/docs/Template - Fase 2 - Apresentação Executiva - Projeto em Business Intelligence e Analytics.pptx
+++ b/docs/Template - Fase 2 - Apresentação Executiva - Projeto em Business Intelligence e Analytics.pptx
@@ -12,10 +12,10 @@
   </p:handoutMasterIdLst>
   <p:sldIdLst>
     <p:sldId id="288" r:id="rId5"/>
-    <p:sldId id="303" r:id="rId6"/>
-    <p:sldId id="302" r:id="rId7"/>
-    <p:sldId id="304" r:id="rId8"/>
-    <p:sldId id="305" r:id="rId9"/>
+    <p:sldId id="302" r:id="rId6"/>
+    <p:sldId id="304" r:id="rId7"/>
+    <p:sldId id="305" r:id="rId8"/>
+    <p:sldId id="306" r:id="rId9"/>
     <p:sldId id="300" r:id="rId10"/>
   </p:sldIdLst>
   <p:sldSz cx="16402050" cy="9601200"/>
@@ -121,10 +121,10 @@
         <p14:section name="Seção Padrão" id="{DB409441-E25A-462F-9A2D-B5D2AB63FBF8}">
           <p14:sldIdLst>
             <p14:sldId id="288"/>
-            <p14:sldId id="303"/>
             <p14:sldId id="302"/>
             <p14:sldId id="304"/>
             <p14:sldId id="305"/>
+            <p14:sldId id="306"/>
             <p14:sldId id="300"/>
           </p14:sldIdLst>
         </p14:section>
@@ -1867,7 +1867,7 @@
           <a:p>
             <a:fld id="{4EC3EDC0-8BE0-4B53-981B-0D2AEC565C43}" type="slidenum">
               <a:rPr lang="pt-BR" smtClean="0"/>
-              <a:t>4</a:t>
+              <a:t>3</a:t>
             </a:fld>
             <a:endParaRPr lang="pt-BR"/>
           </a:p>
@@ -1975,6 +1975,114 @@
           <a:p>
             <a:fld id="{4EC3EDC0-8BE0-4B53-981B-0D2AEC565C43}" type="slidenum">
               <a:rPr lang="pt-BR" smtClean="0"/>
+              <a:t>4</a:t>
+            </a:fld>
+            <a:endParaRPr lang="pt-BR"/>
+          </a:p>
+        </p:txBody>
+      </p:sp>
+    </p:spTree>
+    <p:extLst>
+      <p:ext uri="{BB962C8B-B14F-4D97-AF65-F5344CB8AC3E}">
+        <p14:creationId xmlns:p14="http://schemas.microsoft.com/office/powerpoint/2010/main" val="3366602549"/>
+      </p:ext>
+    </p:extLst>
+  </p:cSld>
+  <p:clrMapOvr>
+    <a:masterClrMapping/>
+  </p:clrMapOvr>
+</p:notes>
+</file>
+
+<file path=ppt/notesSlides/notesSlide3.xml><?xml version="1.0" encoding="utf-8"?>
+<p:notes xmlns:a="http://schemas.openxmlformats.org/drawingml/2006/main" xmlns:r="http://schemas.openxmlformats.org/officeDocument/2006/relationships" xmlns:p="http://schemas.openxmlformats.org/presentationml/2006/main">
+  <p:cSld>
+    <p:spTree>
+      <p:nvGrpSpPr>
+        <p:cNvPr id="1" name="">
+          <a:extLst>
+            <a:ext uri="{FF2B5EF4-FFF2-40B4-BE49-F238E27FC236}">
+              <a16:creationId xmlns:a16="http://schemas.microsoft.com/office/drawing/2014/main" id="{719196F0-2F01-ED90-67D5-2D6C8F9F4EF8}"/>
+            </a:ext>
+          </a:extLst>
+        </p:cNvPr>
+        <p:cNvGrpSpPr/>
+        <p:nvPr/>
+      </p:nvGrpSpPr>
+      <p:grpSpPr>
+        <a:xfrm>
+          <a:off x="0" y="0"/>
+          <a:ext cx="0" cy="0"/>
+          <a:chOff x="0" y="0"/>
+          <a:chExt cx="0" cy="0"/>
+        </a:xfrm>
+      </p:grpSpPr>
+      <p:sp>
+        <p:nvSpPr>
+          <p:cNvPr id="2" name="Marcador de Posição da Imagem do Diapositivo 1">
+            <a:extLst>
+              <a:ext uri="{FF2B5EF4-FFF2-40B4-BE49-F238E27FC236}">
+                <a16:creationId xmlns:a16="http://schemas.microsoft.com/office/drawing/2014/main" id="{EF99737B-A502-64D8-E789-81775FA00BC2}"/>
+              </a:ext>
+            </a:extLst>
+          </p:cNvPr>
+          <p:cNvSpPr>
+            <a:spLocks noGrp="1" noRot="1" noChangeAspect="1"/>
+          </p:cNvSpPr>
+          <p:nvPr>
+            <p:ph type="sldImg"/>
+          </p:nvPr>
+        </p:nvSpPr>
+        <p:spPr/>
+      </p:sp>
+      <p:sp>
+        <p:nvSpPr>
+          <p:cNvPr id="3" name="Marcador de Posição de Notas 2">
+            <a:extLst>
+              <a:ext uri="{FF2B5EF4-FFF2-40B4-BE49-F238E27FC236}">
+                <a16:creationId xmlns:a16="http://schemas.microsoft.com/office/drawing/2014/main" id="{A53398ED-A254-4A74-24F6-9DA356C57A13}"/>
+              </a:ext>
+            </a:extLst>
+          </p:cNvPr>
+          <p:cNvSpPr>
+            <a:spLocks noGrp="1"/>
+          </p:cNvSpPr>
+          <p:nvPr>
+            <p:ph type="body" idx="1"/>
+          </p:nvPr>
+        </p:nvSpPr>
+        <p:spPr/>
+        <p:txBody>
+          <a:bodyPr/>
+          <a:lstStyle/>
+          <a:p>
+            <a:endParaRPr lang="pt-BR" dirty="0"/>
+          </a:p>
+        </p:txBody>
+      </p:sp>
+      <p:sp>
+        <p:nvSpPr>
+          <p:cNvPr id="4" name="Marcador de Posição do Número do Diapositivo 3">
+            <a:extLst>
+              <a:ext uri="{FF2B5EF4-FFF2-40B4-BE49-F238E27FC236}">
+                <a16:creationId xmlns:a16="http://schemas.microsoft.com/office/drawing/2014/main" id="{B9957784-009F-9771-6436-D3E52494B249}"/>
+              </a:ext>
+            </a:extLst>
+          </p:cNvPr>
+          <p:cNvSpPr>
+            <a:spLocks noGrp="1"/>
+          </p:cNvSpPr>
+          <p:nvPr>
+            <p:ph type="sldNum" sz="quarter" idx="5"/>
+          </p:nvPr>
+        </p:nvSpPr>
+        <p:spPr/>
+        <p:txBody>
+          <a:bodyPr/>
+          <a:lstStyle/>
+          <a:p>
+            <a:fld id="{4EC3EDC0-8BE0-4B53-981B-0D2AEC565C43}" type="slidenum">
+              <a:rPr lang="pt-BR" smtClean="0"/>
               <a:t>5</a:t>
             </a:fld>
             <a:endParaRPr lang="pt-BR"/>
@@ -1984,7 +2092,7 @@
     </p:spTree>
     <p:extLst>
       <p:ext uri="{BB962C8B-B14F-4D97-AF65-F5344CB8AC3E}">
-        <p14:creationId xmlns:p14="http://schemas.microsoft.com/office/powerpoint/2010/main" val="3366602549"/>
+        <p14:creationId xmlns:p14="http://schemas.microsoft.com/office/powerpoint/2010/main" val="3198125928"/>
       </p:ext>
     </p:extLst>
   </p:cSld>
@@ -3882,36 +3990,6 @@
           <a:chExt cx="0" cy="0"/>
         </a:xfrm>
       </p:grpSpPr>
-    </p:spTree>
-    <p:extLst>
-      <p:ext uri="{BB962C8B-B14F-4D97-AF65-F5344CB8AC3E}">
-        <p14:creationId xmlns:p14="http://schemas.microsoft.com/office/powerpoint/2010/main" val="1508243658"/>
-      </p:ext>
-    </p:extLst>
-  </p:cSld>
-  <p:clrMapOvr>
-    <a:masterClrMapping/>
-  </p:clrMapOvr>
-</p:sld>
-</file>
-
-<file path=ppt/slides/slide3.xml><?xml version="1.0" encoding="utf-8"?>
-<p:sld xmlns:a="http://schemas.openxmlformats.org/drawingml/2006/main" xmlns:r="http://schemas.openxmlformats.org/officeDocument/2006/relationships" xmlns:p="http://schemas.openxmlformats.org/presentationml/2006/main">
-  <p:cSld>
-    <p:spTree>
-      <p:nvGrpSpPr>
-        <p:cNvPr id="1" name=""/>
-        <p:cNvGrpSpPr/>
-        <p:nvPr/>
-      </p:nvGrpSpPr>
-      <p:grpSpPr>
-        <a:xfrm>
-          <a:off x="0" y="0"/>
-          <a:ext cx="0" cy="0"/>
-          <a:chOff x="0" y="0"/>
-          <a:chExt cx="0" cy="0"/>
-        </a:xfrm>
-      </p:grpSpPr>
       <p:sp>
         <p:nvSpPr>
           <p:cNvPr id="2" name="Espaço Reservado para Texto 1">
@@ -6435,7 +6513,7 @@
 </p:sld>
 </file>
 
-<file path=ppt/slides/slide4.xml><?xml version="1.0" encoding="utf-8"?>
+<file path=ppt/slides/slide3.xml><?xml version="1.0" encoding="utf-8"?>
 <p:sld xmlns:a="http://schemas.openxmlformats.org/drawingml/2006/main" xmlns:r="http://schemas.openxmlformats.org/officeDocument/2006/relationships" xmlns:p="http://schemas.openxmlformats.org/presentationml/2006/main">
   <p:cSld>
     <p:spTree>
@@ -7780,7 +7858,7 @@
 </p:sld>
 </file>
 
-<file path=ppt/slides/slide5.xml><?xml version="1.0" encoding="utf-8"?>
+<file path=ppt/slides/slide4.xml><?xml version="1.0" encoding="utf-8"?>
 <p:sld xmlns:a="http://schemas.openxmlformats.org/drawingml/2006/main" xmlns:r="http://schemas.openxmlformats.org/officeDocument/2006/relationships" xmlns:p="http://schemas.openxmlformats.org/presentationml/2006/main">
   <p:cSld>
     <p:spTree>
@@ -10103,6 +10181,2971 @@
     <p:extLst>
       <p:ext uri="{BB962C8B-B14F-4D97-AF65-F5344CB8AC3E}">
         <p14:creationId xmlns:p14="http://schemas.microsoft.com/office/powerpoint/2010/main" val="3719625301"/>
+      </p:ext>
+    </p:extLst>
+  </p:cSld>
+  <p:clrMapOvr>
+    <a:masterClrMapping/>
+  </p:clrMapOvr>
+</p:sld>
+</file>
+
+<file path=ppt/slides/slide5.xml><?xml version="1.0" encoding="utf-8"?>
+<p:sld xmlns:a="http://schemas.openxmlformats.org/drawingml/2006/main" xmlns:r="http://schemas.openxmlformats.org/officeDocument/2006/relationships" xmlns:p="http://schemas.openxmlformats.org/presentationml/2006/main">
+  <p:cSld>
+    <p:spTree>
+      <p:nvGrpSpPr>
+        <p:cNvPr id="1" name="">
+          <a:extLst>
+            <a:ext uri="{FF2B5EF4-FFF2-40B4-BE49-F238E27FC236}">
+              <a16:creationId xmlns:a16="http://schemas.microsoft.com/office/drawing/2014/main" id="{9B5958F5-1313-0CE3-CAF2-4FD4F4D7F057}"/>
+            </a:ext>
+          </a:extLst>
+        </p:cNvPr>
+        <p:cNvGrpSpPr/>
+        <p:nvPr/>
+      </p:nvGrpSpPr>
+      <p:grpSpPr>
+        <a:xfrm>
+          <a:off x="0" y="0"/>
+          <a:ext cx="0" cy="0"/>
+          <a:chOff x="0" y="0"/>
+          <a:chExt cx="0" cy="0"/>
+        </a:xfrm>
+      </p:grpSpPr>
+      <p:sp>
+        <p:nvSpPr>
+          <p:cNvPr id="2" name="Espaço Reservado para Texto 1">
+            <a:extLst>
+              <a:ext uri="{FF2B5EF4-FFF2-40B4-BE49-F238E27FC236}">
+                <a16:creationId xmlns:a16="http://schemas.microsoft.com/office/drawing/2014/main" id="{25CE63D5-9783-23F9-A04B-17C25F806AAD}"/>
+              </a:ext>
+            </a:extLst>
+          </p:cNvPr>
+          <p:cNvSpPr>
+            <a:spLocks noGrp="1"/>
+          </p:cNvSpPr>
+          <p:nvPr>
+            <p:ph type="body" sz="quarter" idx="10"/>
+          </p:nvPr>
+        </p:nvSpPr>
+        <p:spPr>
+          <a:xfrm>
+            <a:off x="928688" y="1301750"/>
+            <a:ext cx="14544674" cy="625401"/>
+          </a:xfrm>
+        </p:spPr>
+        <p:txBody>
+          <a:bodyPr/>
+          <a:lstStyle/>
+          <a:p>
+            <a:r>
+              <a:rPr lang="pt-BR" sz="3000" b="1" dirty="0">
+                <a:solidFill>
+                  <a:schemeClr val="accent1">
+                    <a:lumMod val="75000"/>
+                  </a:schemeClr>
+                </a:solidFill>
+                <a:latin typeface="Arial" panose="020B0604020202020204" pitchFamily="34" charset="0"/>
+                <a:cs typeface="Arial" panose="020B0604020202020204" pitchFamily="34" charset="0"/>
+              </a:rPr>
+              <a:t>KPIs do Dashboard</a:t>
+            </a:r>
+          </a:p>
+        </p:txBody>
+      </p:sp>
+      <p:sp>
+        <p:nvSpPr>
+          <p:cNvPr id="6" name="Espaço Reservado para Texto 1">
+            <a:extLst>
+              <a:ext uri="{FF2B5EF4-FFF2-40B4-BE49-F238E27FC236}">
+                <a16:creationId xmlns:a16="http://schemas.microsoft.com/office/drawing/2014/main" id="{07FAB641-9AFE-F22F-6B89-7A171DDC9E61}"/>
+              </a:ext>
+            </a:extLst>
+          </p:cNvPr>
+          <p:cNvSpPr txBox="1">
+            <a:spLocks/>
+          </p:cNvSpPr>
+          <p:nvPr/>
+        </p:nvSpPr>
+        <p:spPr>
+          <a:xfrm>
+            <a:off x="317044" y="2156660"/>
+            <a:ext cx="7683956" cy="1254198"/>
+          </a:xfrm>
+          <a:prstGeom prst="rect">
+            <a:avLst/>
+          </a:prstGeom>
+          <a:solidFill>
+            <a:schemeClr val="bg2"/>
+          </a:solidFill>
+          <a:effectLst>
+            <a:outerShdw blurRad="215900" dist="114300" dir="2700000" algn="tl" rotWithShape="0">
+              <a:prstClr val="black">
+                <a:alpha val="30000"/>
+              </a:prstClr>
+            </a:outerShdw>
+            <a:softEdge rad="38100"/>
+          </a:effectLst>
+        </p:spPr>
+        <p:txBody>
+          <a:bodyPr lIns="72000" tIns="72000" rIns="72000" bIns="72000"/>
+          <a:lstStyle>
+            <a:lvl1pPr marL="0" indent="0" algn="l" defTabSz="1280160" rtl="0" eaLnBrk="1" latinLnBrk="0" hangingPunct="1">
+              <a:lnSpc>
+                <a:spcPct val="100000"/>
+              </a:lnSpc>
+              <a:spcBef>
+                <a:spcPts val="0"/>
+              </a:spcBef>
+              <a:spcAft>
+                <a:spcPts val="1200"/>
+              </a:spcAft>
+              <a:buFont typeface="Arial" panose="020B0604020202020204" pitchFamily="34" charset="0"/>
+              <a:buNone/>
+              <a:defRPr sz="1800" kern="1200">
+                <a:solidFill>
+                  <a:schemeClr val="tx2">
+                    <a:lumMod val="75000"/>
+                  </a:schemeClr>
+                </a:solidFill>
+                <a:latin typeface="+mn-lt"/>
+                <a:ea typeface="+mn-ea"/>
+                <a:cs typeface="+mn-cs"/>
+              </a:defRPr>
+            </a:lvl1pPr>
+            <a:lvl2pPr marL="640080" indent="0" algn="l" defTabSz="1280160" rtl="0" eaLnBrk="1" latinLnBrk="0" hangingPunct="1">
+              <a:lnSpc>
+                <a:spcPct val="90000"/>
+              </a:lnSpc>
+              <a:spcBef>
+                <a:spcPts val="700"/>
+              </a:spcBef>
+              <a:buFont typeface="Arial" panose="020B0604020202020204" pitchFamily="34" charset="0"/>
+              <a:buNone/>
+              <a:defRPr sz="1400" kern="1200">
+                <a:solidFill>
+                  <a:schemeClr val="tx1"/>
+                </a:solidFill>
+                <a:latin typeface="+mn-lt"/>
+                <a:ea typeface="+mn-ea"/>
+                <a:cs typeface="+mn-cs"/>
+              </a:defRPr>
+            </a:lvl2pPr>
+            <a:lvl3pPr marL="1280160" indent="0" algn="l" defTabSz="1280160" rtl="0" eaLnBrk="1" latinLnBrk="0" hangingPunct="1">
+              <a:lnSpc>
+                <a:spcPct val="90000"/>
+              </a:lnSpc>
+              <a:spcBef>
+                <a:spcPts val="700"/>
+              </a:spcBef>
+              <a:buFont typeface="Arial" panose="020B0604020202020204" pitchFamily="34" charset="0"/>
+              <a:buNone/>
+              <a:defRPr sz="1400" kern="1200">
+                <a:solidFill>
+                  <a:schemeClr val="tx1"/>
+                </a:solidFill>
+                <a:latin typeface="+mn-lt"/>
+                <a:ea typeface="+mn-ea"/>
+                <a:cs typeface="+mn-cs"/>
+              </a:defRPr>
+            </a:lvl3pPr>
+            <a:lvl4pPr marL="1920240" indent="0" algn="l" defTabSz="1280160" rtl="0" eaLnBrk="1" latinLnBrk="0" hangingPunct="1">
+              <a:lnSpc>
+                <a:spcPct val="90000"/>
+              </a:lnSpc>
+              <a:spcBef>
+                <a:spcPts val="700"/>
+              </a:spcBef>
+              <a:buFont typeface="Arial" panose="020B0604020202020204" pitchFamily="34" charset="0"/>
+              <a:buNone/>
+              <a:defRPr sz="1400" kern="1200">
+                <a:solidFill>
+                  <a:schemeClr val="tx1"/>
+                </a:solidFill>
+                <a:latin typeface="+mn-lt"/>
+                <a:ea typeface="+mn-ea"/>
+                <a:cs typeface="+mn-cs"/>
+              </a:defRPr>
+            </a:lvl4pPr>
+            <a:lvl5pPr marL="2560320" indent="0" algn="l" defTabSz="1280160" rtl="0" eaLnBrk="1" latinLnBrk="0" hangingPunct="1">
+              <a:lnSpc>
+                <a:spcPct val="90000"/>
+              </a:lnSpc>
+              <a:spcBef>
+                <a:spcPts val="700"/>
+              </a:spcBef>
+              <a:buFont typeface="Arial" panose="020B0604020202020204" pitchFamily="34" charset="0"/>
+              <a:buNone/>
+              <a:defRPr sz="1400" kern="1200">
+                <a:solidFill>
+                  <a:schemeClr val="tx1"/>
+                </a:solidFill>
+                <a:latin typeface="+mn-lt"/>
+                <a:ea typeface="+mn-ea"/>
+                <a:cs typeface="+mn-cs"/>
+              </a:defRPr>
+            </a:lvl5pPr>
+            <a:lvl6pPr marL="3520440" indent="-320040" algn="l" defTabSz="1280160" rtl="0" eaLnBrk="1" latinLnBrk="0" hangingPunct="1">
+              <a:lnSpc>
+                <a:spcPct val="90000"/>
+              </a:lnSpc>
+              <a:spcBef>
+                <a:spcPts val="700"/>
+              </a:spcBef>
+              <a:buFont typeface="Arial" panose="020B0604020202020204" pitchFamily="34" charset="0"/>
+              <a:buChar char="•"/>
+              <a:defRPr sz="2520" kern="1200">
+                <a:solidFill>
+                  <a:schemeClr val="tx1"/>
+                </a:solidFill>
+                <a:latin typeface="+mn-lt"/>
+                <a:ea typeface="+mn-ea"/>
+                <a:cs typeface="+mn-cs"/>
+              </a:defRPr>
+            </a:lvl6pPr>
+            <a:lvl7pPr marL="4160520" indent="-320040" algn="l" defTabSz="1280160" rtl="0" eaLnBrk="1" latinLnBrk="0" hangingPunct="1">
+              <a:lnSpc>
+                <a:spcPct val="90000"/>
+              </a:lnSpc>
+              <a:spcBef>
+                <a:spcPts val="700"/>
+              </a:spcBef>
+              <a:buFont typeface="Arial" panose="020B0604020202020204" pitchFamily="34" charset="0"/>
+              <a:buChar char="•"/>
+              <a:defRPr sz="2520" kern="1200">
+                <a:solidFill>
+                  <a:schemeClr val="tx1"/>
+                </a:solidFill>
+                <a:latin typeface="+mn-lt"/>
+                <a:ea typeface="+mn-ea"/>
+                <a:cs typeface="+mn-cs"/>
+              </a:defRPr>
+            </a:lvl7pPr>
+            <a:lvl8pPr marL="4800600" indent="-320040" algn="l" defTabSz="1280160" rtl="0" eaLnBrk="1" latinLnBrk="0" hangingPunct="1">
+              <a:lnSpc>
+                <a:spcPct val="90000"/>
+              </a:lnSpc>
+              <a:spcBef>
+                <a:spcPts val="700"/>
+              </a:spcBef>
+              <a:buFont typeface="Arial" panose="020B0604020202020204" pitchFamily="34" charset="0"/>
+              <a:buChar char="•"/>
+              <a:defRPr sz="2520" kern="1200">
+                <a:solidFill>
+                  <a:schemeClr val="tx1"/>
+                </a:solidFill>
+                <a:latin typeface="+mn-lt"/>
+                <a:ea typeface="+mn-ea"/>
+                <a:cs typeface="+mn-cs"/>
+              </a:defRPr>
+            </a:lvl8pPr>
+            <a:lvl9pPr marL="5440680" indent="-320040" algn="l" defTabSz="1280160" rtl="0" eaLnBrk="1" latinLnBrk="0" hangingPunct="1">
+              <a:lnSpc>
+                <a:spcPct val="90000"/>
+              </a:lnSpc>
+              <a:spcBef>
+                <a:spcPts val="700"/>
+              </a:spcBef>
+              <a:buFont typeface="Arial" panose="020B0604020202020204" pitchFamily="34" charset="0"/>
+              <a:buChar char="•"/>
+              <a:defRPr sz="2520" kern="1200">
+                <a:solidFill>
+                  <a:schemeClr val="tx1"/>
+                </a:solidFill>
+                <a:latin typeface="+mn-lt"/>
+                <a:ea typeface="+mn-ea"/>
+                <a:cs typeface="+mn-cs"/>
+              </a:defRPr>
+            </a:lvl9pPr>
+          </a:lstStyle>
+          <a:p>
+            <a:endParaRPr lang="pt-BR" sz="1600" b="1" dirty="0">
+              <a:solidFill>
+                <a:schemeClr val="accent1">
+                  <a:lumMod val="75000"/>
+                </a:schemeClr>
+              </a:solidFill>
+              <a:latin typeface="Arial" panose="020B0604020202020204" pitchFamily="34" charset="0"/>
+              <a:cs typeface="Arial" panose="020B0604020202020204" pitchFamily="34" charset="0"/>
+            </a:endParaRPr>
+          </a:p>
+        </p:txBody>
+      </p:sp>
+      <p:sp>
+        <p:nvSpPr>
+          <p:cNvPr id="19" name="Espaço Reservado para Texto 1">
+            <a:extLst>
+              <a:ext uri="{FF2B5EF4-FFF2-40B4-BE49-F238E27FC236}">
+                <a16:creationId xmlns:a16="http://schemas.microsoft.com/office/drawing/2014/main" id="{6CDB8DC1-37B3-D4AB-F779-439DF76C84AC}"/>
+              </a:ext>
+            </a:extLst>
+          </p:cNvPr>
+          <p:cNvSpPr txBox="1">
+            <a:spLocks/>
+          </p:cNvSpPr>
+          <p:nvPr/>
+        </p:nvSpPr>
+        <p:spPr>
+          <a:xfrm>
+            <a:off x="505730" y="2330551"/>
+            <a:ext cx="6620786" cy="793649"/>
+          </a:xfrm>
+          <a:prstGeom prst="rect">
+            <a:avLst/>
+          </a:prstGeom>
+          <a:noFill/>
+        </p:spPr>
+        <p:txBody>
+          <a:bodyPr lIns="72000" tIns="72000" rIns="72000" bIns="72000"/>
+          <a:lstStyle>
+            <a:lvl1pPr marL="0" indent="0" algn="l" defTabSz="1280160" rtl="0" eaLnBrk="1" latinLnBrk="0" hangingPunct="1">
+              <a:lnSpc>
+                <a:spcPct val="100000"/>
+              </a:lnSpc>
+              <a:spcBef>
+                <a:spcPts val="0"/>
+              </a:spcBef>
+              <a:spcAft>
+                <a:spcPts val="1200"/>
+              </a:spcAft>
+              <a:buFont typeface="Arial" panose="020B0604020202020204" pitchFamily="34" charset="0"/>
+              <a:buNone/>
+              <a:defRPr sz="1800" kern="1200">
+                <a:solidFill>
+                  <a:schemeClr val="tx2">
+                    <a:lumMod val="75000"/>
+                  </a:schemeClr>
+                </a:solidFill>
+                <a:latin typeface="+mn-lt"/>
+                <a:ea typeface="+mn-ea"/>
+                <a:cs typeface="+mn-cs"/>
+              </a:defRPr>
+            </a:lvl1pPr>
+            <a:lvl2pPr marL="640080" indent="0" algn="l" defTabSz="1280160" rtl="0" eaLnBrk="1" latinLnBrk="0" hangingPunct="1">
+              <a:lnSpc>
+                <a:spcPct val="90000"/>
+              </a:lnSpc>
+              <a:spcBef>
+                <a:spcPts val="700"/>
+              </a:spcBef>
+              <a:buFont typeface="Arial" panose="020B0604020202020204" pitchFamily="34" charset="0"/>
+              <a:buNone/>
+              <a:defRPr sz="1400" kern="1200">
+                <a:solidFill>
+                  <a:schemeClr val="tx1"/>
+                </a:solidFill>
+                <a:latin typeface="+mn-lt"/>
+                <a:ea typeface="+mn-ea"/>
+                <a:cs typeface="+mn-cs"/>
+              </a:defRPr>
+            </a:lvl2pPr>
+            <a:lvl3pPr marL="1280160" indent="0" algn="l" defTabSz="1280160" rtl="0" eaLnBrk="1" latinLnBrk="0" hangingPunct="1">
+              <a:lnSpc>
+                <a:spcPct val="90000"/>
+              </a:lnSpc>
+              <a:spcBef>
+                <a:spcPts val="700"/>
+              </a:spcBef>
+              <a:buFont typeface="Arial" panose="020B0604020202020204" pitchFamily="34" charset="0"/>
+              <a:buNone/>
+              <a:defRPr sz="1400" kern="1200">
+                <a:solidFill>
+                  <a:schemeClr val="tx1"/>
+                </a:solidFill>
+                <a:latin typeface="+mn-lt"/>
+                <a:ea typeface="+mn-ea"/>
+                <a:cs typeface="+mn-cs"/>
+              </a:defRPr>
+            </a:lvl3pPr>
+            <a:lvl4pPr marL="1920240" indent="0" algn="l" defTabSz="1280160" rtl="0" eaLnBrk="1" latinLnBrk="0" hangingPunct="1">
+              <a:lnSpc>
+                <a:spcPct val="90000"/>
+              </a:lnSpc>
+              <a:spcBef>
+                <a:spcPts val="700"/>
+              </a:spcBef>
+              <a:buFont typeface="Arial" panose="020B0604020202020204" pitchFamily="34" charset="0"/>
+              <a:buNone/>
+              <a:defRPr sz="1400" kern="1200">
+                <a:solidFill>
+                  <a:schemeClr val="tx1"/>
+                </a:solidFill>
+                <a:latin typeface="+mn-lt"/>
+                <a:ea typeface="+mn-ea"/>
+                <a:cs typeface="+mn-cs"/>
+              </a:defRPr>
+            </a:lvl4pPr>
+            <a:lvl5pPr marL="2560320" indent="0" algn="l" defTabSz="1280160" rtl="0" eaLnBrk="1" latinLnBrk="0" hangingPunct="1">
+              <a:lnSpc>
+                <a:spcPct val="90000"/>
+              </a:lnSpc>
+              <a:spcBef>
+                <a:spcPts val="700"/>
+              </a:spcBef>
+              <a:buFont typeface="Arial" panose="020B0604020202020204" pitchFamily="34" charset="0"/>
+              <a:buNone/>
+              <a:defRPr sz="1400" kern="1200">
+                <a:solidFill>
+                  <a:schemeClr val="tx1"/>
+                </a:solidFill>
+                <a:latin typeface="+mn-lt"/>
+                <a:ea typeface="+mn-ea"/>
+                <a:cs typeface="+mn-cs"/>
+              </a:defRPr>
+            </a:lvl5pPr>
+            <a:lvl6pPr marL="3520440" indent="-320040" algn="l" defTabSz="1280160" rtl="0" eaLnBrk="1" latinLnBrk="0" hangingPunct="1">
+              <a:lnSpc>
+                <a:spcPct val="90000"/>
+              </a:lnSpc>
+              <a:spcBef>
+                <a:spcPts val="700"/>
+              </a:spcBef>
+              <a:buFont typeface="Arial" panose="020B0604020202020204" pitchFamily="34" charset="0"/>
+              <a:buChar char="•"/>
+              <a:defRPr sz="2520" kern="1200">
+                <a:solidFill>
+                  <a:schemeClr val="tx1"/>
+                </a:solidFill>
+                <a:latin typeface="+mn-lt"/>
+                <a:ea typeface="+mn-ea"/>
+                <a:cs typeface="+mn-cs"/>
+              </a:defRPr>
+            </a:lvl6pPr>
+            <a:lvl7pPr marL="4160520" indent="-320040" algn="l" defTabSz="1280160" rtl="0" eaLnBrk="1" latinLnBrk="0" hangingPunct="1">
+              <a:lnSpc>
+                <a:spcPct val="90000"/>
+              </a:lnSpc>
+              <a:spcBef>
+                <a:spcPts val="700"/>
+              </a:spcBef>
+              <a:buFont typeface="Arial" panose="020B0604020202020204" pitchFamily="34" charset="0"/>
+              <a:buChar char="•"/>
+              <a:defRPr sz="2520" kern="1200">
+                <a:solidFill>
+                  <a:schemeClr val="tx1"/>
+                </a:solidFill>
+                <a:latin typeface="+mn-lt"/>
+                <a:ea typeface="+mn-ea"/>
+                <a:cs typeface="+mn-cs"/>
+              </a:defRPr>
+            </a:lvl7pPr>
+            <a:lvl8pPr marL="4800600" indent="-320040" algn="l" defTabSz="1280160" rtl="0" eaLnBrk="1" latinLnBrk="0" hangingPunct="1">
+              <a:lnSpc>
+                <a:spcPct val="90000"/>
+              </a:lnSpc>
+              <a:spcBef>
+                <a:spcPts val="700"/>
+              </a:spcBef>
+              <a:buFont typeface="Arial" panose="020B0604020202020204" pitchFamily="34" charset="0"/>
+              <a:buChar char="•"/>
+              <a:defRPr sz="2520" kern="1200">
+                <a:solidFill>
+                  <a:schemeClr val="tx1"/>
+                </a:solidFill>
+                <a:latin typeface="+mn-lt"/>
+                <a:ea typeface="+mn-ea"/>
+                <a:cs typeface="+mn-cs"/>
+              </a:defRPr>
+            </a:lvl8pPr>
+            <a:lvl9pPr marL="5440680" indent="-320040" algn="l" defTabSz="1280160" rtl="0" eaLnBrk="1" latinLnBrk="0" hangingPunct="1">
+              <a:lnSpc>
+                <a:spcPct val="90000"/>
+              </a:lnSpc>
+              <a:spcBef>
+                <a:spcPts val="700"/>
+              </a:spcBef>
+              <a:buFont typeface="Arial" panose="020B0604020202020204" pitchFamily="34" charset="0"/>
+              <a:buChar char="•"/>
+              <a:defRPr sz="2520" kern="1200">
+                <a:solidFill>
+                  <a:schemeClr val="tx1"/>
+                </a:solidFill>
+                <a:latin typeface="+mn-lt"/>
+                <a:ea typeface="+mn-ea"/>
+                <a:cs typeface="+mn-cs"/>
+              </a:defRPr>
+            </a:lvl9pPr>
+          </a:lstStyle>
+          <a:p>
+            <a:r>
+              <a:rPr lang="pt-BR" sz="2000" b="1" dirty="0">
+                <a:solidFill>
+                  <a:schemeClr val="accent1">
+                    <a:lumMod val="75000"/>
+                  </a:schemeClr>
+                </a:solidFill>
+                <a:latin typeface="Arial" panose="020B0604020202020204" pitchFamily="34" charset="0"/>
+                <a:cs typeface="Arial" panose="020B0604020202020204" pitchFamily="34" charset="0"/>
+              </a:rPr>
+              <a:t>KPI 1 – Divisão de risco dos clubes</a:t>
+            </a:r>
+          </a:p>
+          <a:p>
+            <a:r>
+              <a:rPr lang="pt-BR" sz="1200" dirty="0">
+                <a:solidFill>
+                  <a:schemeClr val="tx1"/>
+                </a:solidFill>
+                <a:latin typeface="Arial" panose="020B0604020202020204" pitchFamily="34" charset="0"/>
+                <a:cs typeface="Arial" panose="020B0604020202020204" pitchFamily="34" charset="0"/>
+              </a:rPr>
+              <a:t>Classifica os clubes conforme o risco previsto nas categorias Baixo, Medio, Alto e Muito alto.</a:t>
+            </a:r>
+          </a:p>
+        </p:txBody>
+      </p:sp>
+      <p:sp>
+        <p:nvSpPr>
+          <p:cNvPr id="20" name="Espaço Reservado para Texto 1">
+            <a:extLst>
+              <a:ext uri="{FF2B5EF4-FFF2-40B4-BE49-F238E27FC236}">
+                <a16:creationId xmlns:a16="http://schemas.microsoft.com/office/drawing/2014/main" id="{40C22DA8-04A9-7F05-1E77-85966597C8A4}"/>
+              </a:ext>
+            </a:extLst>
+          </p:cNvPr>
+          <p:cNvSpPr txBox="1">
+            <a:spLocks/>
+          </p:cNvSpPr>
+          <p:nvPr/>
+        </p:nvSpPr>
+        <p:spPr>
+          <a:xfrm>
+            <a:off x="8401050" y="2156660"/>
+            <a:ext cx="7683956" cy="1254198"/>
+          </a:xfrm>
+          <a:prstGeom prst="rect">
+            <a:avLst/>
+          </a:prstGeom>
+          <a:solidFill>
+            <a:schemeClr val="bg2"/>
+          </a:solidFill>
+          <a:effectLst>
+            <a:outerShdw blurRad="215900" dist="114300" dir="2700000" algn="tl" rotWithShape="0">
+              <a:prstClr val="black">
+                <a:alpha val="30000"/>
+              </a:prstClr>
+            </a:outerShdw>
+            <a:softEdge rad="38100"/>
+          </a:effectLst>
+        </p:spPr>
+        <p:txBody>
+          <a:bodyPr lIns="72000" tIns="72000" rIns="72000" bIns="72000"/>
+          <a:lstStyle>
+            <a:lvl1pPr marL="0" indent="0" algn="l" defTabSz="1280160" rtl="0" eaLnBrk="1" latinLnBrk="0" hangingPunct="1">
+              <a:lnSpc>
+                <a:spcPct val="100000"/>
+              </a:lnSpc>
+              <a:spcBef>
+                <a:spcPts val="0"/>
+              </a:spcBef>
+              <a:spcAft>
+                <a:spcPts val="1200"/>
+              </a:spcAft>
+              <a:buFont typeface="Arial" panose="020B0604020202020204" pitchFamily="34" charset="0"/>
+              <a:buNone/>
+              <a:defRPr sz="1800" kern="1200">
+                <a:solidFill>
+                  <a:schemeClr val="tx2">
+                    <a:lumMod val="75000"/>
+                  </a:schemeClr>
+                </a:solidFill>
+                <a:latin typeface="+mn-lt"/>
+                <a:ea typeface="+mn-ea"/>
+                <a:cs typeface="+mn-cs"/>
+              </a:defRPr>
+            </a:lvl1pPr>
+            <a:lvl2pPr marL="640080" indent="0" algn="l" defTabSz="1280160" rtl="0" eaLnBrk="1" latinLnBrk="0" hangingPunct="1">
+              <a:lnSpc>
+                <a:spcPct val="90000"/>
+              </a:lnSpc>
+              <a:spcBef>
+                <a:spcPts val="700"/>
+              </a:spcBef>
+              <a:buFont typeface="Arial" panose="020B0604020202020204" pitchFamily="34" charset="0"/>
+              <a:buNone/>
+              <a:defRPr sz="1400" kern="1200">
+                <a:solidFill>
+                  <a:schemeClr val="tx1"/>
+                </a:solidFill>
+                <a:latin typeface="+mn-lt"/>
+                <a:ea typeface="+mn-ea"/>
+                <a:cs typeface="+mn-cs"/>
+              </a:defRPr>
+            </a:lvl2pPr>
+            <a:lvl3pPr marL="1280160" indent="0" algn="l" defTabSz="1280160" rtl="0" eaLnBrk="1" latinLnBrk="0" hangingPunct="1">
+              <a:lnSpc>
+                <a:spcPct val="90000"/>
+              </a:lnSpc>
+              <a:spcBef>
+                <a:spcPts val="700"/>
+              </a:spcBef>
+              <a:buFont typeface="Arial" panose="020B0604020202020204" pitchFamily="34" charset="0"/>
+              <a:buNone/>
+              <a:defRPr sz="1400" kern="1200">
+                <a:solidFill>
+                  <a:schemeClr val="tx1"/>
+                </a:solidFill>
+                <a:latin typeface="+mn-lt"/>
+                <a:ea typeface="+mn-ea"/>
+                <a:cs typeface="+mn-cs"/>
+              </a:defRPr>
+            </a:lvl3pPr>
+            <a:lvl4pPr marL="1920240" indent="0" algn="l" defTabSz="1280160" rtl="0" eaLnBrk="1" latinLnBrk="0" hangingPunct="1">
+              <a:lnSpc>
+                <a:spcPct val="90000"/>
+              </a:lnSpc>
+              <a:spcBef>
+                <a:spcPts val="700"/>
+              </a:spcBef>
+              <a:buFont typeface="Arial" panose="020B0604020202020204" pitchFamily="34" charset="0"/>
+              <a:buNone/>
+              <a:defRPr sz="1400" kern="1200">
+                <a:solidFill>
+                  <a:schemeClr val="tx1"/>
+                </a:solidFill>
+                <a:latin typeface="+mn-lt"/>
+                <a:ea typeface="+mn-ea"/>
+                <a:cs typeface="+mn-cs"/>
+              </a:defRPr>
+            </a:lvl4pPr>
+            <a:lvl5pPr marL="2560320" indent="0" algn="l" defTabSz="1280160" rtl="0" eaLnBrk="1" latinLnBrk="0" hangingPunct="1">
+              <a:lnSpc>
+                <a:spcPct val="90000"/>
+              </a:lnSpc>
+              <a:spcBef>
+                <a:spcPts val="700"/>
+              </a:spcBef>
+              <a:buFont typeface="Arial" panose="020B0604020202020204" pitchFamily="34" charset="0"/>
+              <a:buNone/>
+              <a:defRPr sz="1400" kern="1200">
+                <a:solidFill>
+                  <a:schemeClr val="tx1"/>
+                </a:solidFill>
+                <a:latin typeface="+mn-lt"/>
+                <a:ea typeface="+mn-ea"/>
+                <a:cs typeface="+mn-cs"/>
+              </a:defRPr>
+            </a:lvl5pPr>
+            <a:lvl6pPr marL="3520440" indent="-320040" algn="l" defTabSz="1280160" rtl="0" eaLnBrk="1" latinLnBrk="0" hangingPunct="1">
+              <a:lnSpc>
+                <a:spcPct val="90000"/>
+              </a:lnSpc>
+              <a:spcBef>
+                <a:spcPts val="700"/>
+              </a:spcBef>
+              <a:buFont typeface="Arial" panose="020B0604020202020204" pitchFamily="34" charset="0"/>
+              <a:buChar char="•"/>
+              <a:defRPr sz="2520" kern="1200">
+                <a:solidFill>
+                  <a:schemeClr val="tx1"/>
+                </a:solidFill>
+                <a:latin typeface="+mn-lt"/>
+                <a:ea typeface="+mn-ea"/>
+                <a:cs typeface="+mn-cs"/>
+              </a:defRPr>
+            </a:lvl6pPr>
+            <a:lvl7pPr marL="4160520" indent="-320040" algn="l" defTabSz="1280160" rtl="0" eaLnBrk="1" latinLnBrk="0" hangingPunct="1">
+              <a:lnSpc>
+                <a:spcPct val="90000"/>
+              </a:lnSpc>
+              <a:spcBef>
+                <a:spcPts val="700"/>
+              </a:spcBef>
+              <a:buFont typeface="Arial" panose="020B0604020202020204" pitchFamily="34" charset="0"/>
+              <a:buChar char="•"/>
+              <a:defRPr sz="2520" kern="1200">
+                <a:solidFill>
+                  <a:schemeClr val="tx1"/>
+                </a:solidFill>
+                <a:latin typeface="+mn-lt"/>
+                <a:ea typeface="+mn-ea"/>
+                <a:cs typeface="+mn-cs"/>
+              </a:defRPr>
+            </a:lvl7pPr>
+            <a:lvl8pPr marL="4800600" indent="-320040" algn="l" defTabSz="1280160" rtl="0" eaLnBrk="1" latinLnBrk="0" hangingPunct="1">
+              <a:lnSpc>
+                <a:spcPct val="90000"/>
+              </a:lnSpc>
+              <a:spcBef>
+                <a:spcPts val="700"/>
+              </a:spcBef>
+              <a:buFont typeface="Arial" panose="020B0604020202020204" pitchFamily="34" charset="0"/>
+              <a:buChar char="•"/>
+              <a:defRPr sz="2520" kern="1200">
+                <a:solidFill>
+                  <a:schemeClr val="tx1"/>
+                </a:solidFill>
+                <a:latin typeface="+mn-lt"/>
+                <a:ea typeface="+mn-ea"/>
+                <a:cs typeface="+mn-cs"/>
+              </a:defRPr>
+            </a:lvl8pPr>
+            <a:lvl9pPr marL="5440680" indent="-320040" algn="l" defTabSz="1280160" rtl="0" eaLnBrk="1" latinLnBrk="0" hangingPunct="1">
+              <a:lnSpc>
+                <a:spcPct val="90000"/>
+              </a:lnSpc>
+              <a:spcBef>
+                <a:spcPts val="700"/>
+              </a:spcBef>
+              <a:buFont typeface="Arial" panose="020B0604020202020204" pitchFamily="34" charset="0"/>
+              <a:buChar char="•"/>
+              <a:defRPr sz="2520" kern="1200">
+                <a:solidFill>
+                  <a:schemeClr val="tx1"/>
+                </a:solidFill>
+                <a:latin typeface="+mn-lt"/>
+                <a:ea typeface="+mn-ea"/>
+                <a:cs typeface="+mn-cs"/>
+              </a:defRPr>
+            </a:lvl9pPr>
+          </a:lstStyle>
+          <a:p>
+            <a:endParaRPr lang="pt-BR" sz="1600" b="1" dirty="0">
+              <a:solidFill>
+                <a:schemeClr val="accent1">
+                  <a:lumMod val="75000"/>
+                </a:schemeClr>
+              </a:solidFill>
+              <a:latin typeface="Arial" panose="020B0604020202020204" pitchFamily="34" charset="0"/>
+              <a:cs typeface="Arial" panose="020B0604020202020204" pitchFamily="34" charset="0"/>
+            </a:endParaRPr>
+          </a:p>
+        </p:txBody>
+      </p:sp>
+      <p:sp>
+        <p:nvSpPr>
+          <p:cNvPr id="22" name="Espaço Reservado para Texto 1">
+            <a:extLst>
+              <a:ext uri="{FF2B5EF4-FFF2-40B4-BE49-F238E27FC236}">
+                <a16:creationId xmlns:a16="http://schemas.microsoft.com/office/drawing/2014/main" id="{5DD33A01-0674-351E-87A7-49E10712ED80}"/>
+              </a:ext>
+            </a:extLst>
+          </p:cNvPr>
+          <p:cNvSpPr txBox="1">
+            <a:spLocks/>
+          </p:cNvSpPr>
+          <p:nvPr/>
+        </p:nvSpPr>
+        <p:spPr>
+          <a:xfrm>
+            <a:off x="8589736" y="2330551"/>
+            <a:ext cx="6620786" cy="793649"/>
+          </a:xfrm>
+          <a:prstGeom prst="rect">
+            <a:avLst/>
+          </a:prstGeom>
+          <a:noFill/>
+        </p:spPr>
+        <p:txBody>
+          <a:bodyPr lIns="72000" tIns="72000" rIns="72000" bIns="72000"/>
+          <a:lstStyle>
+            <a:lvl1pPr marL="0" indent="0" algn="l" defTabSz="1280160" rtl="0" eaLnBrk="1" latinLnBrk="0" hangingPunct="1">
+              <a:lnSpc>
+                <a:spcPct val="100000"/>
+              </a:lnSpc>
+              <a:spcBef>
+                <a:spcPts val="0"/>
+              </a:spcBef>
+              <a:spcAft>
+                <a:spcPts val="1200"/>
+              </a:spcAft>
+              <a:buFont typeface="Arial" panose="020B0604020202020204" pitchFamily="34" charset="0"/>
+              <a:buNone/>
+              <a:defRPr sz="1800" kern="1200">
+                <a:solidFill>
+                  <a:schemeClr val="tx2">
+                    <a:lumMod val="75000"/>
+                  </a:schemeClr>
+                </a:solidFill>
+                <a:latin typeface="+mn-lt"/>
+                <a:ea typeface="+mn-ea"/>
+                <a:cs typeface="+mn-cs"/>
+              </a:defRPr>
+            </a:lvl1pPr>
+            <a:lvl2pPr marL="640080" indent="0" algn="l" defTabSz="1280160" rtl="0" eaLnBrk="1" latinLnBrk="0" hangingPunct="1">
+              <a:lnSpc>
+                <a:spcPct val="90000"/>
+              </a:lnSpc>
+              <a:spcBef>
+                <a:spcPts val="700"/>
+              </a:spcBef>
+              <a:buFont typeface="Arial" panose="020B0604020202020204" pitchFamily="34" charset="0"/>
+              <a:buNone/>
+              <a:defRPr sz="1400" kern="1200">
+                <a:solidFill>
+                  <a:schemeClr val="tx1"/>
+                </a:solidFill>
+                <a:latin typeface="+mn-lt"/>
+                <a:ea typeface="+mn-ea"/>
+                <a:cs typeface="+mn-cs"/>
+              </a:defRPr>
+            </a:lvl2pPr>
+            <a:lvl3pPr marL="1280160" indent="0" algn="l" defTabSz="1280160" rtl="0" eaLnBrk="1" latinLnBrk="0" hangingPunct="1">
+              <a:lnSpc>
+                <a:spcPct val="90000"/>
+              </a:lnSpc>
+              <a:spcBef>
+                <a:spcPts val="700"/>
+              </a:spcBef>
+              <a:buFont typeface="Arial" panose="020B0604020202020204" pitchFamily="34" charset="0"/>
+              <a:buNone/>
+              <a:defRPr sz="1400" kern="1200">
+                <a:solidFill>
+                  <a:schemeClr val="tx1"/>
+                </a:solidFill>
+                <a:latin typeface="+mn-lt"/>
+                <a:ea typeface="+mn-ea"/>
+                <a:cs typeface="+mn-cs"/>
+              </a:defRPr>
+            </a:lvl3pPr>
+            <a:lvl4pPr marL="1920240" indent="0" algn="l" defTabSz="1280160" rtl="0" eaLnBrk="1" latinLnBrk="0" hangingPunct="1">
+              <a:lnSpc>
+                <a:spcPct val="90000"/>
+              </a:lnSpc>
+              <a:spcBef>
+                <a:spcPts val="700"/>
+              </a:spcBef>
+              <a:buFont typeface="Arial" panose="020B0604020202020204" pitchFamily="34" charset="0"/>
+              <a:buNone/>
+              <a:defRPr sz="1400" kern="1200">
+                <a:solidFill>
+                  <a:schemeClr val="tx1"/>
+                </a:solidFill>
+                <a:latin typeface="+mn-lt"/>
+                <a:ea typeface="+mn-ea"/>
+                <a:cs typeface="+mn-cs"/>
+              </a:defRPr>
+            </a:lvl4pPr>
+            <a:lvl5pPr marL="2560320" indent="0" algn="l" defTabSz="1280160" rtl="0" eaLnBrk="1" latinLnBrk="0" hangingPunct="1">
+              <a:lnSpc>
+                <a:spcPct val="90000"/>
+              </a:lnSpc>
+              <a:spcBef>
+                <a:spcPts val="700"/>
+              </a:spcBef>
+              <a:buFont typeface="Arial" panose="020B0604020202020204" pitchFamily="34" charset="0"/>
+              <a:buNone/>
+              <a:defRPr sz="1400" kern="1200">
+                <a:solidFill>
+                  <a:schemeClr val="tx1"/>
+                </a:solidFill>
+                <a:latin typeface="+mn-lt"/>
+                <a:ea typeface="+mn-ea"/>
+                <a:cs typeface="+mn-cs"/>
+              </a:defRPr>
+            </a:lvl5pPr>
+            <a:lvl6pPr marL="3520440" indent="-320040" algn="l" defTabSz="1280160" rtl="0" eaLnBrk="1" latinLnBrk="0" hangingPunct="1">
+              <a:lnSpc>
+                <a:spcPct val="90000"/>
+              </a:lnSpc>
+              <a:spcBef>
+                <a:spcPts val="700"/>
+              </a:spcBef>
+              <a:buFont typeface="Arial" panose="020B0604020202020204" pitchFamily="34" charset="0"/>
+              <a:buChar char="•"/>
+              <a:defRPr sz="2520" kern="1200">
+                <a:solidFill>
+                  <a:schemeClr val="tx1"/>
+                </a:solidFill>
+                <a:latin typeface="+mn-lt"/>
+                <a:ea typeface="+mn-ea"/>
+                <a:cs typeface="+mn-cs"/>
+              </a:defRPr>
+            </a:lvl6pPr>
+            <a:lvl7pPr marL="4160520" indent="-320040" algn="l" defTabSz="1280160" rtl="0" eaLnBrk="1" latinLnBrk="0" hangingPunct="1">
+              <a:lnSpc>
+                <a:spcPct val="90000"/>
+              </a:lnSpc>
+              <a:spcBef>
+                <a:spcPts val="700"/>
+              </a:spcBef>
+              <a:buFont typeface="Arial" panose="020B0604020202020204" pitchFamily="34" charset="0"/>
+              <a:buChar char="•"/>
+              <a:defRPr sz="2520" kern="1200">
+                <a:solidFill>
+                  <a:schemeClr val="tx1"/>
+                </a:solidFill>
+                <a:latin typeface="+mn-lt"/>
+                <a:ea typeface="+mn-ea"/>
+                <a:cs typeface="+mn-cs"/>
+              </a:defRPr>
+            </a:lvl7pPr>
+            <a:lvl8pPr marL="4800600" indent="-320040" algn="l" defTabSz="1280160" rtl="0" eaLnBrk="1" latinLnBrk="0" hangingPunct="1">
+              <a:lnSpc>
+                <a:spcPct val="90000"/>
+              </a:lnSpc>
+              <a:spcBef>
+                <a:spcPts val="700"/>
+              </a:spcBef>
+              <a:buFont typeface="Arial" panose="020B0604020202020204" pitchFamily="34" charset="0"/>
+              <a:buChar char="•"/>
+              <a:defRPr sz="2520" kern="1200">
+                <a:solidFill>
+                  <a:schemeClr val="tx1"/>
+                </a:solidFill>
+                <a:latin typeface="+mn-lt"/>
+                <a:ea typeface="+mn-ea"/>
+                <a:cs typeface="+mn-cs"/>
+              </a:defRPr>
+            </a:lvl8pPr>
+            <a:lvl9pPr marL="5440680" indent="-320040" algn="l" defTabSz="1280160" rtl="0" eaLnBrk="1" latinLnBrk="0" hangingPunct="1">
+              <a:lnSpc>
+                <a:spcPct val="90000"/>
+              </a:lnSpc>
+              <a:spcBef>
+                <a:spcPts val="700"/>
+              </a:spcBef>
+              <a:buFont typeface="Arial" panose="020B0604020202020204" pitchFamily="34" charset="0"/>
+              <a:buChar char="•"/>
+              <a:defRPr sz="2520" kern="1200">
+                <a:solidFill>
+                  <a:schemeClr val="tx1"/>
+                </a:solidFill>
+                <a:latin typeface="+mn-lt"/>
+                <a:ea typeface="+mn-ea"/>
+                <a:cs typeface="+mn-cs"/>
+              </a:defRPr>
+            </a:lvl9pPr>
+          </a:lstStyle>
+          <a:p>
+            <a:r>
+              <a:rPr lang="pt-BR" sz="2000" b="1" dirty="0">
+                <a:solidFill>
+                  <a:schemeClr val="accent1">
+                    <a:lumMod val="75000"/>
+                  </a:schemeClr>
+                </a:solidFill>
+                <a:latin typeface="Arial" panose="020B0604020202020204" pitchFamily="34" charset="0"/>
+                <a:cs typeface="Arial" panose="020B0604020202020204" pitchFamily="34" charset="0"/>
+              </a:rPr>
+              <a:t>KPI 2 – Média de risco</a:t>
+            </a:r>
+          </a:p>
+          <a:p>
+            <a:r>
+              <a:rPr lang="pt-BR" sz="1200" dirty="0">
+                <a:solidFill>
+                  <a:schemeClr val="tx1"/>
+                </a:solidFill>
+                <a:latin typeface="Arial" panose="020B0604020202020204" pitchFamily="34" charset="0"/>
+                <a:cs typeface="Arial" panose="020B0604020202020204" pitchFamily="34" charset="0"/>
+              </a:rPr>
+              <a:t>Apresenta a média de risco previsto entre os clubes analisados.</a:t>
+            </a:r>
+          </a:p>
+        </p:txBody>
+      </p:sp>
+      <p:sp>
+        <p:nvSpPr>
+          <p:cNvPr id="25" name="Espaço Reservado para Texto 1">
+            <a:extLst>
+              <a:ext uri="{FF2B5EF4-FFF2-40B4-BE49-F238E27FC236}">
+                <a16:creationId xmlns:a16="http://schemas.microsoft.com/office/drawing/2014/main" id="{2114B58A-7B6C-8A51-A372-CFD809F1038E}"/>
+              </a:ext>
+            </a:extLst>
+          </p:cNvPr>
+          <p:cNvSpPr txBox="1">
+            <a:spLocks/>
+          </p:cNvSpPr>
+          <p:nvPr/>
+        </p:nvSpPr>
+        <p:spPr>
+          <a:xfrm>
+            <a:off x="317044" y="3757109"/>
+            <a:ext cx="7683956" cy="1254198"/>
+          </a:xfrm>
+          <a:prstGeom prst="rect">
+            <a:avLst/>
+          </a:prstGeom>
+          <a:solidFill>
+            <a:schemeClr val="bg2"/>
+          </a:solidFill>
+          <a:effectLst>
+            <a:outerShdw blurRad="215900" dist="114300" dir="2700000" algn="tl" rotWithShape="0">
+              <a:prstClr val="black">
+                <a:alpha val="30000"/>
+              </a:prstClr>
+            </a:outerShdw>
+            <a:softEdge rad="38100"/>
+          </a:effectLst>
+        </p:spPr>
+        <p:txBody>
+          <a:bodyPr lIns="72000" tIns="72000" rIns="72000" bIns="72000"/>
+          <a:lstStyle>
+            <a:lvl1pPr marL="0" indent="0" algn="l" defTabSz="1280160" rtl="0" eaLnBrk="1" latinLnBrk="0" hangingPunct="1">
+              <a:lnSpc>
+                <a:spcPct val="100000"/>
+              </a:lnSpc>
+              <a:spcBef>
+                <a:spcPts val="0"/>
+              </a:spcBef>
+              <a:spcAft>
+                <a:spcPts val="1200"/>
+              </a:spcAft>
+              <a:buFont typeface="Arial" panose="020B0604020202020204" pitchFamily="34" charset="0"/>
+              <a:buNone/>
+              <a:defRPr sz="1800" kern="1200">
+                <a:solidFill>
+                  <a:schemeClr val="tx2">
+                    <a:lumMod val="75000"/>
+                  </a:schemeClr>
+                </a:solidFill>
+                <a:latin typeface="+mn-lt"/>
+                <a:ea typeface="+mn-ea"/>
+                <a:cs typeface="+mn-cs"/>
+              </a:defRPr>
+            </a:lvl1pPr>
+            <a:lvl2pPr marL="640080" indent="0" algn="l" defTabSz="1280160" rtl="0" eaLnBrk="1" latinLnBrk="0" hangingPunct="1">
+              <a:lnSpc>
+                <a:spcPct val="90000"/>
+              </a:lnSpc>
+              <a:spcBef>
+                <a:spcPts val="700"/>
+              </a:spcBef>
+              <a:buFont typeface="Arial" panose="020B0604020202020204" pitchFamily="34" charset="0"/>
+              <a:buNone/>
+              <a:defRPr sz="1400" kern="1200">
+                <a:solidFill>
+                  <a:schemeClr val="tx1"/>
+                </a:solidFill>
+                <a:latin typeface="+mn-lt"/>
+                <a:ea typeface="+mn-ea"/>
+                <a:cs typeface="+mn-cs"/>
+              </a:defRPr>
+            </a:lvl2pPr>
+            <a:lvl3pPr marL="1280160" indent="0" algn="l" defTabSz="1280160" rtl="0" eaLnBrk="1" latinLnBrk="0" hangingPunct="1">
+              <a:lnSpc>
+                <a:spcPct val="90000"/>
+              </a:lnSpc>
+              <a:spcBef>
+                <a:spcPts val="700"/>
+              </a:spcBef>
+              <a:buFont typeface="Arial" panose="020B0604020202020204" pitchFamily="34" charset="0"/>
+              <a:buNone/>
+              <a:defRPr sz="1400" kern="1200">
+                <a:solidFill>
+                  <a:schemeClr val="tx1"/>
+                </a:solidFill>
+                <a:latin typeface="+mn-lt"/>
+                <a:ea typeface="+mn-ea"/>
+                <a:cs typeface="+mn-cs"/>
+              </a:defRPr>
+            </a:lvl3pPr>
+            <a:lvl4pPr marL="1920240" indent="0" algn="l" defTabSz="1280160" rtl="0" eaLnBrk="1" latinLnBrk="0" hangingPunct="1">
+              <a:lnSpc>
+                <a:spcPct val="90000"/>
+              </a:lnSpc>
+              <a:spcBef>
+                <a:spcPts val="700"/>
+              </a:spcBef>
+              <a:buFont typeface="Arial" panose="020B0604020202020204" pitchFamily="34" charset="0"/>
+              <a:buNone/>
+              <a:defRPr sz="1400" kern="1200">
+                <a:solidFill>
+                  <a:schemeClr val="tx1"/>
+                </a:solidFill>
+                <a:latin typeface="+mn-lt"/>
+                <a:ea typeface="+mn-ea"/>
+                <a:cs typeface="+mn-cs"/>
+              </a:defRPr>
+            </a:lvl4pPr>
+            <a:lvl5pPr marL="2560320" indent="0" algn="l" defTabSz="1280160" rtl="0" eaLnBrk="1" latinLnBrk="0" hangingPunct="1">
+              <a:lnSpc>
+                <a:spcPct val="90000"/>
+              </a:lnSpc>
+              <a:spcBef>
+                <a:spcPts val="700"/>
+              </a:spcBef>
+              <a:buFont typeface="Arial" panose="020B0604020202020204" pitchFamily="34" charset="0"/>
+              <a:buNone/>
+              <a:defRPr sz="1400" kern="1200">
+                <a:solidFill>
+                  <a:schemeClr val="tx1"/>
+                </a:solidFill>
+                <a:latin typeface="+mn-lt"/>
+                <a:ea typeface="+mn-ea"/>
+                <a:cs typeface="+mn-cs"/>
+              </a:defRPr>
+            </a:lvl5pPr>
+            <a:lvl6pPr marL="3520440" indent="-320040" algn="l" defTabSz="1280160" rtl="0" eaLnBrk="1" latinLnBrk="0" hangingPunct="1">
+              <a:lnSpc>
+                <a:spcPct val="90000"/>
+              </a:lnSpc>
+              <a:spcBef>
+                <a:spcPts val="700"/>
+              </a:spcBef>
+              <a:buFont typeface="Arial" panose="020B0604020202020204" pitchFamily="34" charset="0"/>
+              <a:buChar char="•"/>
+              <a:defRPr sz="2520" kern="1200">
+                <a:solidFill>
+                  <a:schemeClr val="tx1"/>
+                </a:solidFill>
+                <a:latin typeface="+mn-lt"/>
+                <a:ea typeface="+mn-ea"/>
+                <a:cs typeface="+mn-cs"/>
+              </a:defRPr>
+            </a:lvl6pPr>
+            <a:lvl7pPr marL="4160520" indent="-320040" algn="l" defTabSz="1280160" rtl="0" eaLnBrk="1" latinLnBrk="0" hangingPunct="1">
+              <a:lnSpc>
+                <a:spcPct val="90000"/>
+              </a:lnSpc>
+              <a:spcBef>
+                <a:spcPts val="700"/>
+              </a:spcBef>
+              <a:buFont typeface="Arial" panose="020B0604020202020204" pitchFamily="34" charset="0"/>
+              <a:buChar char="•"/>
+              <a:defRPr sz="2520" kern="1200">
+                <a:solidFill>
+                  <a:schemeClr val="tx1"/>
+                </a:solidFill>
+                <a:latin typeface="+mn-lt"/>
+                <a:ea typeface="+mn-ea"/>
+                <a:cs typeface="+mn-cs"/>
+              </a:defRPr>
+            </a:lvl7pPr>
+            <a:lvl8pPr marL="4800600" indent="-320040" algn="l" defTabSz="1280160" rtl="0" eaLnBrk="1" latinLnBrk="0" hangingPunct="1">
+              <a:lnSpc>
+                <a:spcPct val="90000"/>
+              </a:lnSpc>
+              <a:spcBef>
+                <a:spcPts val="700"/>
+              </a:spcBef>
+              <a:buFont typeface="Arial" panose="020B0604020202020204" pitchFamily="34" charset="0"/>
+              <a:buChar char="•"/>
+              <a:defRPr sz="2520" kern="1200">
+                <a:solidFill>
+                  <a:schemeClr val="tx1"/>
+                </a:solidFill>
+                <a:latin typeface="+mn-lt"/>
+                <a:ea typeface="+mn-ea"/>
+                <a:cs typeface="+mn-cs"/>
+              </a:defRPr>
+            </a:lvl8pPr>
+            <a:lvl9pPr marL="5440680" indent="-320040" algn="l" defTabSz="1280160" rtl="0" eaLnBrk="1" latinLnBrk="0" hangingPunct="1">
+              <a:lnSpc>
+                <a:spcPct val="90000"/>
+              </a:lnSpc>
+              <a:spcBef>
+                <a:spcPts val="700"/>
+              </a:spcBef>
+              <a:buFont typeface="Arial" panose="020B0604020202020204" pitchFamily="34" charset="0"/>
+              <a:buChar char="•"/>
+              <a:defRPr sz="2520" kern="1200">
+                <a:solidFill>
+                  <a:schemeClr val="tx1"/>
+                </a:solidFill>
+                <a:latin typeface="+mn-lt"/>
+                <a:ea typeface="+mn-ea"/>
+                <a:cs typeface="+mn-cs"/>
+              </a:defRPr>
+            </a:lvl9pPr>
+          </a:lstStyle>
+          <a:p>
+            <a:endParaRPr lang="pt-BR" sz="1600" b="1" dirty="0">
+              <a:solidFill>
+                <a:schemeClr val="accent1">
+                  <a:lumMod val="75000"/>
+                </a:schemeClr>
+              </a:solidFill>
+              <a:latin typeface="Arial" panose="020B0604020202020204" pitchFamily="34" charset="0"/>
+              <a:cs typeface="Arial" panose="020B0604020202020204" pitchFamily="34" charset="0"/>
+            </a:endParaRPr>
+          </a:p>
+        </p:txBody>
+      </p:sp>
+      <p:sp>
+        <p:nvSpPr>
+          <p:cNvPr id="27" name="Espaço Reservado para Texto 1">
+            <a:extLst>
+              <a:ext uri="{FF2B5EF4-FFF2-40B4-BE49-F238E27FC236}">
+                <a16:creationId xmlns:a16="http://schemas.microsoft.com/office/drawing/2014/main" id="{9E807486-C73E-900F-B9BE-D66C04A8780E}"/>
+              </a:ext>
+            </a:extLst>
+          </p:cNvPr>
+          <p:cNvSpPr txBox="1">
+            <a:spLocks/>
+          </p:cNvSpPr>
+          <p:nvPr/>
+        </p:nvSpPr>
+        <p:spPr>
+          <a:xfrm>
+            <a:off x="505730" y="3931000"/>
+            <a:ext cx="6620786" cy="793649"/>
+          </a:xfrm>
+          <a:prstGeom prst="rect">
+            <a:avLst/>
+          </a:prstGeom>
+          <a:noFill/>
+        </p:spPr>
+        <p:txBody>
+          <a:bodyPr lIns="72000" tIns="72000" rIns="72000" bIns="72000"/>
+          <a:lstStyle>
+            <a:lvl1pPr marL="0" indent="0" algn="l" defTabSz="1280160" rtl="0" eaLnBrk="1" latinLnBrk="0" hangingPunct="1">
+              <a:lnSpc>
+                <a:spcPct val="100000"/>
+              </a:lnSpc>
+              <a:spcBef>
+                <a:spcPts val="0"/>
+              </a:spcBef>
+              <a:spcAft>
+                <a:spcPts val="1200"/>
+              </a:spcAft>
+              <a:buFont typeface="Arial" panose="020B0604020202020204" pitchFamily="34" charset="0"/>
+              <a:buNone/>
+              <a:defRPr sz="1800" kern="1200">
+                <a:solidFill>
+                  <a:schemeClr val="tx2">
+                    <a:lumMod val="75000"/>
+                  </a:schemeClr>
+                </a:solidFill>
+                <a:latin typeface="+mn-lt"/>
+                <a:ea typeface="+mn-ea"/>
+                <a:cs typeface="+mn-cs"/>
+              </a:defRPr>
+            </a:lvl1pPr>
+            <a:lvl2pPr marL="640080" indent="0" algn="l" defTabSz="1280160" rtl="0" eaLnBrk="1" latinLnBrk="0" hangingPunct="1">
+              <a:lnSpc>
+                <a:spcPct val="90000"/>
+              </a:lnSpc>
+              <a:spcBef>
+                <a:spcPts val="700"/>
+              </a:spcBef>
+              <a:buFont typeface="Arial" panose="020B0604020202020204" pitchFamily="34" charset="0"/>
+              <a:buNone/>
+              <a:defRPr sz="1400" kern="1200">
+                <a:solidFill>
+                  <a:schemeClr val="tx1"/>
+                </a:solidFill>
+                <a:latin typeface="+mn-lt"/>
+                <a:ea typeface="+mn-ea"/>
+                <a:cs typeface="+mn-cs"/>
+              </a:defRPr>
+            </a:lvl2pPr>
+            <a:lvl3pPr marL="1280160" indent="0" algn="l" defTabSz="1280160" rtl="0" eaLnBrk="1" latinLnBrk="0" hangingPunct="1">
+              <a:lnSpc>
+                <a:spcPct val="90000"/>
+              </a:lnSpc>
+              <a:spcBef>
+                <a:spcPts val="700"/>
+              </a:spcBef>
+              <a:buFont typeface="Arial" panose="020B0604020202020204" pitchFamily="34" charset="0"/>
+              <a:buNone/>
+              <a:defRPr sz="1400" kern="1200">
+                <a:solidFill>
+                  <a:schemeClr val="tx1"/>
+                </a:solidFill>
+                <a:latin typeface="+mn-lt"/>
+                <a:ea typeface="+mn-ea"/>
+                <a:cs typeface="+mn-cs"/>
+              </a:defRPr>
+            </a:lvl3pPr>
+            <a:lvl4pPr marL="1920240" indent="0" algn="l" defTabSz="1280160" rtl="0" eaLnBrk="1" latinLnBrk="0" hangingPunct="1">
+              <a:lnSpc>
+                <a:spcPct val="90000"/>
+              </a:lnSpc>
+              <a:spcBef>
+                <a:spcPts val="700"/>
+              </a:spcBef>
+              <a:buFont typeface="Arial" panose="020B0604020202020204" pitchFamily="34" charset="0"/>
+              <a:buNone/>
+              <a:defRPr sz="1400" kern="1200">
+                <a:solidFill>
+                  <a:schemeClr val="tx1"/>
+                </a:solidFill>
+                <a:latin typeface="+mn-lt"/>
+                <a:ea typeface="+mn-ea"/>
+                <a:cs typeface="+mn-cs"/>
+              </a:defRPr>
+            </a:lvl4pPr>
+            <a:lvl5pPr marL="2560320" indent="0" algn="l" defTabSz="1280160" rtl="0" eaLnBrk="1" latinLnBrk="0" hangingPunct="1">
+              <a:lnSpc>
+                <a:spcPct val="90000"/>
+              </a:lnSpc>
+              <a:spcBef>
+                <a:spcPts val="700"/>
+              </a:spcBef>
+              <a:buFont typeface="Arial" panose="020B0604020202020204" pitchFamily="34" charset="0"/>
+              <a:buNone/>
+              <a:defRPr sz="1400" kern="1200">
+                <a:solidFill>
+                  <a:schemeClr val="tx1"/>
+                </a:solidFill>
+                <a:latin typeface="+mn-lt"/>
+                <a:ea typeface="+mn-ea"/>
+                <a:cs typeface="+mn-cs"/>
+              </a:defRPr>
+            </a:lvl5pPr>
+            <a:lvl6pPr marL="3520440" indent="-320040" algn="l" defTabSz="1280160" rtl="0" eaLnBrk="1" latinLnBrk="0" hangingPunct="1">
+              <a:lnSpc>
+                <a:spcPct val="90000"/>
+              </a:lnSpc>
+              <a:spcBef>
+                <a:spcPts val="700"/>
+              </a:spcBef>
+              <a:buFont typeface="Arial" panose="020B0604020202020204" pitchFamily="34" charset="0"/>
+              <a:buChar char="•"/>
+              <a:defRPr sz="2520" kern="1200">
+                <a:solidFill>
+                  <a:schemeClr val="tx1"/>
+                </a:solidFill>
+                <a:latin typeface="+mn-lt"/>
+                <a:ea typeface="+mn-ea"/>
+                <a:cs typeface="+mn-cs"/>
+              </a:defRPr>
+            </a:lvl6pPr>
+            <a:lvl7pPr marL="4160520" indent="-320040" algn="l" defTabSz="1280160" rtl="0" eaLnBrk="1" latinLnBrk="0" hangingPunct="1">
+              <a:lnSpc>
+                <a:spcPct val="90000"/>
+              </a:lnSpc>
+              <a:spcBef>
+                <a:spcPts val="700"/>
+              </a:spcBef>
+              <a:buFont typeface="Arial" panose="020B0604020202020204" pitchFamily="34" charset="0"/>
+              <a:buChar char="•"/>
+              <a:defRPr sz="2520" kern="1200">
+                <a:solidFill>
+                  <a:schemeClr val="tx1"/>
+                </a:solidFill>
+                <a:latin typeface="+mn-lt"/>
+                <a:ea typeface="+mn-ea"/>
+                <a:cs typeface="+mn-cs"/>
+              </a:defRPr>
+            </a:lvl7pPr>
+            <a:lvl8pPr marL="4800600" indent="-320040" algn="l" defTabSz="1280160" rtl="0" eaLnBrk="1" latinLnBrk="0" hangingPunct="1">
+              <a:lnSpc>
+                <a:spcPct val="90000"/>
+              </a:lnSpc>
+              <a:spcBef>
+                <a:spcPts val="700"/>
+              </a:spcBef>
+              <a:buFont typeface="Arial" panose="020B0604020202020204" pitchFamily="34" charset="0"/>
+              <a:buChar char="•"/>
+              <a:defRPr sz="2520" kern="1200">
+                <a:solidFill>
+                  <a:schemeClr val="tx1"/>
+                </a:solidFill>
+                <a:latin typeface="+mn-lt"/>
+                <a:ea typeface="+mn-ea"/>
+                <a:cs typeface="+mn-cs"/>
+              </a:defRPr>
+            </a:lvl8pPr>
+            <a:lvl9pPr marL="5440680" indent="-320040" algn="l" defTabSz="1280160" rtl="0" eaLnBrk="1" latinLnBrk="0" hangingPunct="1">
+              <a:lnSpc>
+                <a:spcPct val="90000"/>
+              </a:lnSpc>
+              <a:spcBef>
+                <a:spcPts val="700"/>
+              </a:spcBef>
+              <a:buFont typeface="Arial" panose="020B0604020202020204" pitchFamily="34" charset="0"/>
+              <a:buChar char="•"/>
+              <a:defRPr sz="2520" kern="1200">
+                <a:solidFill>
+                  <a:schemeClr val="tx1"/>
+                </a:solidFill>
+                <a:latin typeface="+mn-lt"/>
+                <a:ea typeface="+mn-ea"/>
+                <a:cs typeface="+mn-cs"/>
+              </a:defRPr>
+            </a:lvl9pPr>
+          </a:lstStyle>
+          <a:p>
+            <a:r>
+              <a:rPr lang="pt-BR" sz="2000" b="1" dirty="0">
+                <a:solidFill>
+                  <a:schemeClr val="accent1">
+                    <a:lumMod val="75000"/>
+                  </a:schemeClr>
+                </a:solidFill>
+                <a:latin typeface="Arial" panose="020B0604020202020204" pitchFamily="34" charset="0"/>
+                <a:cs typeface="Arial" panose="020B0604020202020204" pitchFamily="34" charset="0"/>
+              </a:rPr>
+              <a:t>KPI 3 – Maior risco de rebaixamento</a:t>
+            </a:r>
+          </a:p>
+          <a:p>
+            <a:r>
+              <a:rPr lang="pt-BR" sz="1200" dirty="0">
+                <a:solidFill>
+                  <a:schemeClr val="tx1"/>
+                </a:solidFill>
+                <a:latin typeface="Arial" panose="020B0604020202020204" pitchFamily="34" charset="0"/>
+                <a:cs typeface="Arial" panose="020B0604020202020204" pitchFamily="34" charset="0"/>
+              </a:rPr>
+              <a:t>Identifica o clube com maior risco previsto na temporada analisada.</a:t>
+            </a:r>
+          </a:p>
+        </p:txBody>
+      </p:sp>
+      <p:sp>
+        <p:nvSpPr>
+          <p:cNvPr id="29" name="Espaço Reservado para Texto 1">
+            <a:extLst>
+              <a:ext uri="{FF2B5EF4-FFF2-40B4-BE49-F238E27FC236}">
+                <a16:creationId xmlns:a16="http://schemas.microsoft.com/office/drawing/2014/main" id="{C6ECB8DB-5348-3C77-33FF-CAB922DF014D}"/>
+              </a:ext>
+            </a:extLst>
+          </p:cNvPr>
+          <p:cNvSpPr txBox="1">
+            <a:spLocks/>
+          </p:cNvSpPr>
+          <p:nvPr/>
+        </p:nvSpPr>
+        <p:spPr>
+          <a:xfrm>
+            <a:off x="8401050" y="3757109"/>
+            <a:ext cx="7683956" cy="1254198"/>
+          </a:xfrm>
+          <a:prstGeom prst="rect">
+            <a:avLst/>
+          </a:prstGeom>
+          <a:solidFill>
+            <a:schemeClr val="bg2"/>
+          </a:solidFill>
+          <a:effectLst>
+            <a:outerShdw blurRad="215900" dist="114300" dir="2700000" algn="tl" rotWithShape="0">
+              <a:prstClr val="black">
+                <a:alpha val="30000"/>
+              </a:prstClr>
+            </a:outerShdw>
+            <a:softEdge rad="38100"/>
+          </a:effectLst>
+        </p:spPr>
+        <p:txBody>
+          <a:bodyPr lIns="72000" tIns="72000" rIns="72000" bIns="72000"/>
+          <a:lstStyle>
+            <a:lvl1pPr marL="0" indent="0" algn="l" defTabSz="1280160" rtl="0" eaLnBrk="1" latinLnBrk="0" hangingPunct="1">
+              <a:lnSpc>
+                <a:spcPct val="100000"/>
+              </a:lnSpc>
+              <a:spcBef>
+                <a:spcPts val="0"/>
+              </a:spcBef>
+              <a:spcAft>
+                <a:spcPts val="1200"/>
+              </a:spcAft>
+              <a:buFont typeface="Arial" panose="020B0604020202020204" pitchFamily="34" charset="0"/>
+              <a:buNone/>
+              <a:defRPr sz="1800" kern="1200">
+                <a:solidFill>
+                  <a:schemeClr val="tx2">
+                    <a:lumMod val="75000"/>
+                  </a:schemeClr>
+                </a:solidFill>
+                <a:latin typeface="+mn-lt"/>
+                <a:ea typeface="+mn-ea"/>
+                <a:cs typeface="+mn-cs"/>
+              </a:defRPr>
+            </a:lvl1pPr>
+            <a:lvl2pPr marL="640080" indent="0" algn="l" defTabSz="1280160" rtl="0" eaLnBrk="1" latinLnBrk="0" hangingPunct="1">
+              <a:lnSpc>
+                <a:spcPct val="90000"/>
+              </a:lnSpc>
+              <a:spcBef>
+                <a:spcPts val="700"/>
+              </a:spcBef>
+              <a:buFont typeface="Arial" panose="020B0604020202020204" pitchFamily="34" charset="0"/>
+              <a:buNone/>
+              <a:defRPr sz="1400" kern="1200">
+                <a:solidFill>
+                  <a:schemeClr val="tx1"/>
+                </a:solidFill>
+                <a:latin typeface="+mn-lt"/>
+                <a:ea typeface="+mn-ea"/>
+                <a:cs typeface="+mn-cs"/>
+              </a:defRPr>
+            </a:lvl2pPr>
+            <a:lvl3pPr marL="1280160" indent="0" algn="l" defTabSz="1280160" rtl="0" eaLnBrk="1" latinLnBrk="0" hangingPunct="1">
+              <a:lnSpc>
+                <a:spcPct val="90000"/>
+              </a:lnSpc>
+              <a:spcBef>
+                <a:spcPts val="700"/>
+              </a:spcBef>
+              <a:buFont typeface="Arial" panose="020B0604020202020204" pitchFamily="34" charset="0"/>
+              <a:buNone/>
+              <a:defRPr sz="1400" kern="1200">
+                <a:solidFill>
+                  <a:schemeClr val="tx1"/>
+                </a:solidFill>
+                <a:latin typeface="+mn-lt"/>
+                <a:ea typeface="+mn-ea"/>
+                <a:cs typeface="+mn-cs"/>
+              </a:defRPr>
+            </a:lvl3pPr>
+            <a:lvl4pPr marL="1920240" indent="0" algn="l" defTabSz="1280160" rtl="0" eaLnBrk="1" latinLnBrk="0" hangingPunct="1">
+              <a:lnSpc>
+                <a:spcPct val="90000"/>
+              </a:lnSpc>
+              <a:spcBef>
+                <a:spcPts val="700"/>
+              </a:spcBef>
+              <a:buFont typeface="Arial" panose="020B0604020202020204" pitchFamily="34" charset="0"/>
+              <a:buNone/>
+              <a:defRPr sz="1400" kern="1200">
+                <a:solidFill>
+                  <a:schemeClr val="tx1"/>
+                </a:solidFill>
+                <a:latin typeface="+mn-lt"/>
+                <a:ea typeface="+mn-ea"/>
+                <a:cs typeface="+mn-cs"/>
+              </a:defRPr>
+            </a:lvl4pPr>
+            <a:lvl5pPr marL="2560320" indent="0" algn="l" defTabSz="1280160" rtl="0" eaLnBrk="1" latinLnBrk="0" hangingPunct="1">
+              <a:lnSpc>
+                <a:spcPct val="90000"/>
+              </a:lnSpc>
+              <a:spcBef>
+                <a:spcPts val="700"/>
+              </a:spcBef>
+              <a:buFont typeface="Arial" panose="020B0604020202020204" pitchFamily="34" charset="0"/>
+              <a:buNone/>
+              <a:defRPr sz="1400" kern="1200">
+                <a:solidFill>
+                  <a:schemeClr val="tx1"/>
+                </a:solidFill>
+                <a:latin typeface="+mn-lt"/>
+                <a:ea typeface="+mn-ea"/>
+                <a:cs typeface="+mn-cs"/>
+              </a:defRPr>
+            </a:lvl5pPr>
+            <a:lvl6pPr marL="3520440" indent="-320040" algn="l" defTabSz="1280160" rtl="0" eaLnBrk="1" latinLnBrk="0" hangingPunct="1">
+              <a:lnSpc>
+                <a:spcPct val="90000"/>
+              </a:lnSpc>
+              <a:spcBef>
+                <a:spcPts val="700"/>
+              </a:spcBef>
+              <a:buFont typeface="Arial" panose="020B0604020202020204" pitchFamily="34" charset="0"/>
+              <a:buChar char="•"/>
+              <a:defRPr sz="2520" kern="1200">
+                <a:solidFill>
+                  <a:schemeClr val="tx1"/>
+                </a:solidFill>
+                <a:latin typeface="+mn-lt"/>
+                <a:ea typeface="+mn-ea"/>
+                <a:cs typeface="+mn-cs"/>
+              </a:defRPr>
+            </a:lvl6pPr>
+            <a:lvl7pPr marL="4160520" indent="-320040" algn="l" defTabSz="1280160" rtl="0" eaLnBrk="1" latinLnBrk="0" hangingPunct="1">
+              <a:lnSpc>
+                <a:spcPct val="90000"/>
+              </a:lnSpc>
+              <a:spcBef>
+                <a:spcPts val="700"/>
+              </a:spcBef>
+              <a:buFont typeface="Arial" panose="020B0604020202020204" pitchFamily="34" charset="0"/>
+              <a:buChar char="•"/>
+              <a:defRPr sz="2520" kern="1200">
+                <a:solidFill>
+                  <a:schemeClr val="tx1"/>
+                </a:solidFill>
+                <a:latin typeface="+mn-lt"/>
+                <a:ea typeface="+mn-ea"/>
+                <a:cs typeface="+mn-cs"/>
+              </a:defRPr>
+            </a:lvl7pPr>
+            <a:lvl8pPr marL="4800600" indent="-320040" algn="l" defTabSz="1280160" rtl="0" eaLnBrk="1" latinLnBrk="0" hangingPunct="1">
+              <a:lnSpc>
+                <a:spcPct val="90000"/>
+              </a:lnSpc>
+              <a:spcBef>
+                <a:spcPts val="700"/>
+              </a:spcBef>
+              <a:buFont typeface="Arial" panose="020B0604020202020204" pitchFamily="34" charset="0"/>
+              <a:buChar char="•"/>
+              <a:defRPr sz="2520" kern="1200">
+                <a:solidFill>
+                  <a:schemeClr val="tx1"/>
+                </a:solidFill>
+                <a:latin typeface="+mn-lt"/>
+                <a:ea typeface="+mn-ea"/>
+                <a:cs typeface="+mn-cs"/>
+              </a:defRPr>
+            </a:lvl8pPr>
+            <a:lvl9pPr marL="5440680" indent="-320040" algn="l" defTabSz="1280160" rtl="0" eaLnBrk="1" latinLnBrk="0" hangingPunct="1">
+              <a:lnSpc>
+                <a:spcPct val="90000"/>
+              </a:lnSpc>
+              <a:spcBef>
+                <a:spcPts val="700"/>
+              </a:spcBef>
+              <a:buFont typeface="Arial" panose="020B0604020202020204" pitchFamily="34" charset="0"/>
+              <a:buChar char="•"/>
+              <a:defRPr sz="2520" kern="1200">
+                <a:solidFill>
+                  <a:schemeClr val="tx1"/>
+                </a:solidFill>
+                <a:latin typeface="+mn-lt"/>
+                <a:ea typeface="+mn-ea"/>
+                <a:cs typeface="+mn-cs"/>
+              </a:defRPr>
+            </a:lvl9pPr>
+          </a:lstStyle>
+          <a:p>
+            <a:endParaRPr lang="pt-BR" sz="1600" b="1" dirty="0">
+              <a:solidFill>
+                <a:schemeClr val="accent1">
+                  <a:lumMod val="75000"/>
+                </a:schemeClr>
+              </a:solidFill>
+              <a:latin typeface="Arial" panose="020B0604020202020204" pitchFamily="34" charset="0"/>
+              <a:cs typeface="Arial" panose="020B0604020202020204" pitchFamily="34" charset="0"/>
+            </a:endParaRPr>
+          </a:p>
+        </p:txBody>
+      </p:sp>
+      <p:sp>
+        <p:nvSpPr>
+          <p:cNvPr id="31" name="Espaço Reservado para Texto 1">
+            <a:extLst>
+              <a:ext uri="{FF2B5EF4-FFF2-40B4-BE49-F238E27FC236}">
+                <a16:creationId xmlns:a16="http://schemas.microsoft.com/office/drawing/2014/main" id="{B22B410E-0F7C-7A10-F2A9-7FE4DD3D781C}"/>
+              </a:ext>
+            </a:extLst>
+          </p:cNvPr>
+          <p:cNvSpPr txBox="1">
+            <a:spLocks/>
+          </p:cNvSpPr>
+          <p:nvPr/>
+        </p:nvSpPr>
+        <p:spPr>
+          <a:xfrm>
+            <a:off x="8589736" y="3931000"/>
+            <a:ext cx="6620786" cy="793649"/>
+          </a:xfrm>
+          <a:prstGeom prst="rect">
+            <a:avLst/>
+          </a:prstGeom>
+          <a:noFill/>
+        </p:spPr>
+        <p:txBody>
+          <a:bodyPr lIns="72000" tIns="72000" rIns="72000" bIns="72000"/>
+          <a:lstStyle>
+            <a:lvl1pPr marL="0" indent="0" algn="l" defTabSz="1280160" rtl="0" eaLnBrk="1" latinLnBrk="0" hangingPunct="1">
+              <a:lnSpc>
+                <a:spcPct val="100000"/>
+              </a:lnSpc>
+              <a:spcBef>
+                <a:spcPts val="0"/>
+              </a:spcBef>
+              <a:spcAft>
+                <a:spcPts val="1200"/>
+              </a:spcAft>
+              <a:buFont typeface="Arial" panose="020B0604020202020204" pitchFamily="34" charset="0"/>
+              <a:buNone/>
+              <a:defRPr sz="1800" kern="1200">
+                <a:solidFill>
+                  <a:schemeClr val="tx2">
+                    <a:lumMod val="75000"/>
+                  </a:schemeClr>
+                </a:solidFill>
+                <a:latin typeface="+mn-lt"/>
+                <a:ea typeface="+mn-ea"/>
+                <a:cs typeface="+mn-cs"/>
+              </a:defRPr>
+            </a:lvl1pPr>
+            <a:lvl2pPr marL="640080" indent="0" algn="l" defTabSz="1280160" rtl="0" eaLnBrk="1" latinLnBrk="0" hangingPunct="1">
+              <a:lnSpc>
+                <a:spcPct val="90000"/>
+              </a:lnSpc>
+              <a:spcBef>
+                <a:spcPts val="700"/>
+              </a:spcBef>
+              <a:buFont typeface="Arial" panose="020B0604020202020204" pitchFamily="34" charset="0"/>
+              <a:buNone/>
+              <a:defRPr sz="1400" kern="1200">
+                <a:solidFill>
+                  <a:schemeClr val="tx1"/>
+                </a:solidFill>
+                <a:latin typeface="+mn-lt"/>
+                <a:ea typeface="+mn-ea"/>
+                <a:cs typeface="+mn-cs"/>
+              </a:defRPr>
+            </a:lvl2pPr>
+            <a:lvl3pPr marL="1280160" indent="0" algn="l" defTabSz="1280160" rtl="0" eaLnBrk="1" latinLnBrk="0" hangingPunct="1">
+              <a:lnSpc>
+                <a:spcPct val="90000"/>
+              </a:lnSpc>
+              <a:spcBef>
+                <a:spcPts val="700"/>
+              </a:spcBef>
+              <a:buFont typeface="Arial" panose="020B0604020202020204" pitchFamily="34" charset="0"/>
+              <a:buNone/>
+              <a:defRPr sz="1400" kern="1200">
+                <a:solidFill>
+                  <a:schemeClr val="tx1"/>
+                </a:solidFill>
+                <a:latin typeface="+mn-lt"/>
+                <a:ea typeface="+mn-ea"/>
+                <a:cs typeface="+mn-cs"/>
+              </a:defRPr>
+            </a:lvl3pPr>
+            <a:lvl4pPr marL="1920240" indent="0" algn="l" defTabSz="1280160" rtl="0" eaLnBrk="1" latinLnBrk="0" hangingPunct="1">
+              <a:lnSpc>
+                <a:spcPct val="90000"/>
+              </a:lnSpc>
+              <a:spcBef>
+                <a:spcPts val="700"/>
+              </a:spcBef>
+              <a:buFont typeface="Arial" panose="020B0604020202020204" pitchFamily="34" charset="0"/>
+              <a:buNone/>
+              <a:defRPr sz="1400" kern="1200">
+                <a:solidFill>
+                  <a:schemeClr val="tx1"/>
+                </a:solidFill>
+                <a:latin typeface="+mn-lt"/>
+                <a:ea typeface="+mn-ea"/>
+                <a:cs typeface="+mn-cs"/>
+              </a:defRPr>
+            </a:lvl4pPr>
+            <a:lvl5pPr marL="2560320" indent="0" algn="l" defTabSz="1280160" rtl="0" eaLnBrk="1" latinLnBrk="0" hangingPunct="1">
+              <a:lnSpc>
+                <a:spcPct val="90000"/>
+              </a:lnSpc>
+              <a:spcBef>
+                <a:spcPts val="700"/>
+              </a:spcBef>
+              <a:buFont typeface="Arial" panose="020B0604020202020204" pitchFamily="34" charset="0"/>
+              <a:buNone/>
+              <a:defRPr sz="1400" kern="1200">
+                <a:solidFill>
+                  <a:schemeClr val="tx1"/>
+                </a:solidFill>
+                <a:latin typeface="+mn-lt"/>
+                <a:ea typeface="+mn-ea"/>
+                <a:cs typeface="+mn-cs"/>
+              </a:defRPr>
+            </a:lvl5pPr>
+            <a:lvl6pPr marL="3520440" indent="-320040" algn="l" defTabSz="1280160" rtl="0" eaLnBrk="1" latinLnBrk="0" hangingPunct="1">
+              <a:lnSpc>
+                <a:spcPct val="90000"/>
+              </a:lnSpc>
+              <a:spcBef>
+                <a:spcPts val="700"/>
+              </a:spcBef>
+              <a:buFont typeface="Arial" panose="020B0604020202020204" pitchFamily="34" charset="0"/>
+              <a:buChar char="•"/>
+              <a:defRPr sz="2520" kern="1200">
+                <a:solidFill>
+                  <a:schemeClr val="tx1"/>
+                </a:solidFill>
+                <a:latin typeface="+mn-lt"/>
+                <a:ea typeface="+mn-ea"/>
+                <a:cs typeface="+mn-cs"/>
+              </a:defRPr>
+            </a:lvl6pPr>
+            <a:lvl7pPr marL="4160520" indent="-320040" algn="l" defTabSz="1280160" rtl="0" eaLnBrk="1" latinLnBrk="0" hangingPunct="1">
+              <a:lnSpc>
+                <a:spcPct val="90000"/>
+              </a:lnSpc>
+              <a:spcBef>
+                <a:spcPts val="700"/>
+              </a:spcBef>
+              <a:buFont typeface="Arial" panose="020B0604020202020204" pitchFamily="34" charset="0"/>
+              <a:buChar char="•"/>
+              <a:defRPr sz="2520" kern="1200">
+                <a:solidFill>
+                  <a:schemeClr val="tx1"/>
+                </a:solidFill>
+                <a:latin typeface="+mn-lt"/>
+                <a:ea typeface="+mn-ea"/>
+                <a:cs typeface="+mn-cs"/>
+              </a:defRPr>
+            </a:lvl7pPr>
+            <a:lvl8pPr marL="4800600" indent="-320040" algn="l" defTabSz="1280160" rtl="0" eaLnBrk="1" latinLnBrk="0" hangingPunct="1">
+              <a:lnSpc>
+                <a:spcPct val="90000"/>
+              </a:lnSpc>
+              <a:spcBef>
+                <a:spcPts val="700"/>
+              </a:spcBef>
+              <a:buFont typeface="Arial" panose="020B0604020202020204" pitchFamily="34" charset="0"/>
+              <a:buChar char="•"/>
+              <a:defRPr sz="2520" kern="1200">
+                <a:solidFill>
+                  <a:schemeClr val="tx1"/>
+                </a:solidFill>
+                <a:latin typeface="+mn-lt"/>
+                <a:ea typeface="+mn-ea"/>
+                <a:cs typeface="+mn-cs"/>
+              </a:defRPr>
+            </a:lvl8pPr>
+            <a:lvl9pPr marL="5440680" indent="-320040" algn="l" defTabSz="1280160" rtl="0" eaLnBrk="1" latinLnBrk="0" hangingPunct="1">
+              <a:lnSpc>
+                <a:spcPct val="90000"/>
+              </a:lnSpc>
+              <a:spcBef>
+                <a:spcPts val="700"/>
+              </a:spcBef>
+              <a:buFont typeface="Arial" panose="020B0604020202020204" pitchFamily="34" charset="0"/>
+              <a:buChar char="•"/>
+              <a:defRPr sz="2520" kern="1200">
+                <a:solidFill>
+                  <a:schemeClr val="tx1"/>
+                </a:solidFill>
+                <a:latin typeface="+mn-lt"/>
+                <a:ea typeface="+mn-ea"/>
+                <a:cs typeface="+mn-cs"/>
+              </a:defRPr>
+            </a:lvl9pPr>
+          </a:lstStyle>
+          <a:p>
+            <a:r>
+              <a:rPr lang="pt-BR" sz="2000" b="1" dirty="0">
+                <a:solidFill>
+                  <a:schemeClr val="accent1">
+                    <a:lumMod val="75000"/>
+                  </a:schemeClr>
+                </a:solidFill>
+                <a:latin typeface="Arial" panose="020B0604020202020204" pitchFamily="34" charset="0"/>
+                <a:cs typeface="Arial" panose="020B0604020202020204" pitchFamily="34" charset="0"/>
+              </a:rPr>
+              <a:t>KPI 4 – Menor Risco de rebaixamento</a:t>
+            </a:r>
+            <a:endParaRPr lang="pt-BR" sz="1200" dirty="0">
+              <a:solidFill>
+                <a:schemeClr val="tx1"/>
+              </a:solidFill>
+              <a:latin typeface="Arial" panose="020B0604020202020204" pitchFamily="34" charset="0"/>
+              <a:cs typeface="Arial" panose="020B0604020202020204" pitchFamily="34" charset="0"/>
+            </a:endParaRPr>
+          </a:p>
+          <a:p>
+            <a:r>
+              <a:rPr lang="pt-BR" sz="1200" dirty="0">
+                <a:solidFill>
+                  <a:schemeClr val="tx1"/>
+                </a:solidFill>
+                <a:latin typeface="Arial" panose="020B0604020202020204" pitchFamily="34" charset="0"/>
+                <a:cs typeface="Arial" panose="020B0604020202020204" pitchFamily="34" charset="0"/>
+              </a:rPr>
+              <a:t>Identifica o clube com menor risco previsto na temporada analisada.</a:t>
+            </a:r>
+          </a:p>
+        </p:txBody>
+      </p:sp>
+      <p:sp>
+        <p:nvSpPr>
+          <p:cNvPr id="33" name="Espaço Reservado para Texto 1">
+            <a:extLst>
+              <a:ext uri="{FF2B5EF4-FFF2-40B4-BE49-F238E27FC236}">
+                <a16:creationId xmlns:a16="http://schemas.microsoft.com/office/drawing/2014/main" id="{A0FC9110-E7BE-86A5-71B1-F4E35A37B9AB}"/>
+              </a:ext>
+            </a:extLst>
+          </p:cNvPr>
+          <p:cNvSpPr txBox="1">
+            <a:spLocks/>
+          </p:cNvSpPr>
+          <p:nvPr/>
+        </p:nvSpPr>
+        <p:spPr>
+          <a:xfrm>
+            <a:off x="317044" y="5357558"/>
+            <a:ext cx="7683956" cy="1254198"/>
+          </a:xfrm>
+          <a:prstGeom prst="rect">
+            <a:avLst/>
+          </a:prstGeom>
+          <a:solidFill>
+            <a:schemeClr val="bg2"/>
+          </a:solidFill>
+          <a:effectLst>
+            <a:outerShdw blurRad="215900" dist="114300" dir="2700000" algn="tl" rotWithShape="0">
+              <a:prstClr val="black">
+                <a:alpha val="30000"/>
+              </a:prstClr>
+            </a:outerShdw>
+            <a:softEdge rad="38100"/>
+          </a:effectLst>
+        </p:spPr>
+        <p:txBody>
+          <a:bodyPr lIns="72000" tIns="72000" rIns="72000" bIns="72000"/>
+          <a:lstStyle>
+            <a:lvl1pPr marL="0" indent="0" algn="l" defTabSz="1280160" rtl="0" eaLnBrk="1" latinLnBrk="0" hangingPunct="1">
+              <a:lnSpc>
+                <a:spcPct val="100000"/>
+              </a:lnSpc>
+              <a:spcBef>
+                <a:spcPts val="0"/>
+              </a:spcBef>
+              <a:spcAft>
+                <a:spcPts val="1200"/>
+              </a:spcAft>
+              <a:buFont typeface="Arial" panose="020B0604020202020204" pitchFamily="34" charset="0"/>
+              <a:buNone/>
+              <a:defRPr sz="1800" kern="1200">
+                <a:solidFill>
+                  <a:schemeClr val="tx2">
+                    <a:lumMod val="75000"/>
+                  </a:schemeClr>
+                </a:solidFill>
+                <a:latin typeface="+mn-lt"/>
+                <a:ea typeface="+mn-ea"/>
+                <a:cs typeface="+mn-cs"/>
+              </a:defRPr>
+            </a:lvl1pPr>
+            <a:lvl2pPr marL="640080" indent="0" algn="l" defTabSz="1280160" rtl="0" eaLnBrk="1" latinLnBrk="0" hangingPunct="1">
+              <a:lnSpc>
+                <a:spcPct val="90000"/>
+              </a:lnSpc>
+              <a:spcBef>
+                <a:spcPts val="700"/>
+              </a:spcBef>
+              <a:buFont typeface="Arial" panose="020B0604020202020204" pitchFamily="34" charset="0"/>
+              <a:buNone/>
+              <a:defRPr sz="1400" kern="1200">
+                <a:solidFill>
+                  <a:schemeClr val="tx1"/>
+                </a:solidFill>
+                <a:latin typeface="+mn-lt"/>
+                <a:ea typeface="+mn-ea"/>
+                <a:cs typeface="+mn-cs"/>
+              </a:defRPr>
+            </a:lvl2pPr>
+            <a:lvl3pPr marL="1280160" indent="0" algn="l" defTabSz="1280160" rtl="0" eaLnBrk="1" latinLnBrk="0" hangingPunct="1">
+              <a:lnSpc>
+                <a:spcPct val="90000"/>
+              </a:lnSpc>
+              <a:spcBef>
+                <a:spcPts val="700"/>
+              </a:spcBef>
+              <a:buFont typeface="Arial" panose="020B0604020202020204" pitchFamily="34" charset="0"/>
+              <a:buNone/>
+              <a:defRPr sz="1400" kern="1200">
+                <a:solidFill>
+                  <a:schemeClr val="tx1"/>
+                </a:solidFill>
+                <a:latin typeface="+mn-lt"/>
+                <a:ea typeface="+mn-ea"/>
+                <a:cs typeface="+mn-cs"/>
+              </a:defRPr>
+            </a:lvl3pPr>
+            <a:lvl4pPr marL="1920240" indent="0" algn="l" defTabSz="1280160" rtl="0" eaLnBrk="1" latinLnBrk="0" hangingPunct="1">
+              <a:lnSpc>
+                <a:spcPct val="90000"/>
+              </a:lnSpc>
+              <a:spcBef>
+                <a:spcPts val="700"/>
+              </a:spcBef>
+              <a:buFont typeface="Arial" panose="020B0604020202020204" pitchFamily="34" charset="0"/>
+              <a:buNone/>
+              <a:defRPr sz="1400" kern="1200">
+                <a:solidFill>
+                  <a:schemeClr val="tx1"/>
+                </a:solidFill>
+                <a:latin typeface="+mn-lt"/>
+                <a:ea typeface="+mn-ea"/>
+                <a:cs typeface="+mn-cs"/>
+              </a:defRPr>
+            </a:lvl4pPr>
+            <a:lvl5pPr marL="2560320" indent="0" algn="l" defTabSz="1280160" rtl="0" eaLnBrk="1" latinLnBrk="0" hangingPunct="1">
+              <a:lnSpc>
+                <a:spcPct val="90000"/>
+              </a:lnSpc>
+              <a:spcBef>
+                <a:spcPts val="700"/>
+              </a:spcBef>
+              <a:buFont typeface="Arial" panose="020B0604020202020204" pitchFamily="34" charset="0"/>
+              <a:buNone/>
+              <a:defRPr sz="1400" kern="1200">
+                <a:solidFill>
+                  <a:schemeClr val="tx1"/>
+                </a:solidFill>
+                <a:latin typeface="+mn-lt"/>
+                <a:ea typeface="+mn-ea"/>
+                <a:cs typeface="+mn-cs"/>
+              </a:defRPr>
+            </a:lvl5pPr>
+            <a:lvl6pPr marL="3520440" indent="-320040" algn="l" defTabSz="1280160" rtl="0" eaLnBrk="1" latinLnBrk="0" hangingPunct="1">
+              <a:lnSpc>
+                <a:spcPct val="90000"/>
+              </a:lnSpc>
+              <a:spcBef>
+                <a:spcPts val="700"/>
+              </a:spcBef>
+              <a:buFont typeface="Arial" panose="020B0604020202020204" pitchFamily="34" charset="0"/>
+              <a:buChar char="•"/>
+              <a:defRPr sz="2520" kern="1200">
+                <a:solidFill>
+                  <a:schemeClr val="tx1"/>
+                </a:solidFill>
+                <a:latin typeface="+mn-lt"/>
+                <a:ea typeface="+mn-ea"/>
+                <a:cs typeface="+mn-cs"/>
+              </a:defRPr>
+            </a:lvl6pPr>
+            <a:lvl7pPr marL="4160520" indent="-320040" algn="l" defTabSz="1280160" rtl="0" eaLnBrk="1" latinLnBrk="0" hangingPunct="1">
+              <a:lnSpc>
+                <a:spcPct val="90000"/>
+              </a:lnSpc>
+              <a:spcBef>
+                <a:spcPts val="700"/>
+              </a:spcBef>
+              <a:buFont typeface="Arial" panose="020B0604020202020204" pitchFamily="34" charset="0"/>
+              <a:buChar char="•"/>
+              <a:defRPr sz="2520" kern="1200">
+                <a:solidFill>
+                  <a:schemeClr val="tx1"/>
+                </a:solidFill>
+                <a:latin typeface="+mn-lt"/>
+                <a:ea typeface="+mn-ea"/>
+                <a:cs typeface="+mn-cs"/>
+              </a:defRPr>
+            </a:lvl7pPr>
+            <a:lvl8pPr marL="4800600" indent="-320040" algn="l" defTabSz="1280160" rtl="0" eaLnBrk="1" latinLnBrk="0" hangingPunct="1">
+              <a:lnSpc>
+                <a:spcPct val="90000"/>
+              </a:lnSpc>
+              <a:spcBef>
+                <a:spcPts val="700"/>
+              </a:spcBef>
+              <a:buFont typeface="Arial" panose="020B0604020202020204" pitchFamily="34" charset="0"/>
+              <a:buChar char="•"/>
+              <a:defRPr sz="2520" kern="1200">
+                <a:solidFill>
+                  <a:schemeClr val="tx1"/>
+                </a:solidFill>
+                <a:latin typeface="+mn-lt"/>
+                <a:ea typeface="+mn-ea"/>
+                <a:cs typeface="+mn-cs"/>
+              </a:defRPr>
+            </a:lvl8pPr>
+            <a:lvl9pPr marL="5440680" indent="-320040" algn="l" defTabSz="1280160" rtl="0" eaLnBrk="1" latinLnBrk="0" hangingPunct="1">
+              <a:lnSpc>
+                <a:spcPct val="90000"/>
+              </a:lnSpc>
+              <a:spcBef>
+                <a:spcPts val="700"/>
+              </a:spcBef>
+              <a:buFont typeface="Arial" panose="020B0604020202020204" pitchFamily="34" charset="0"/>
+              <a:buChar char="•"/>
+              <a:defRPr sz="2520" kern="1200">
+                <a:solidFill>
+                  <a:schemeClr val="tx1"/>
+                </a:solidFill>
+                <a:latin typeface="+mn-lt"/>
+                <a:ea typeface="+mn-ea"/>
+                <a:cs typeface="+mn-cs"/>
+              </a:defRPr>
+            </a:lvl9pPr>
+          </a:lstStyle>
+          <a:p>
+            <a:endParaRPr lang="pt-BR" sz="1600" b="1" dirty="0">
+              <a:solidFill>
+                <a:schemeClr val="accent1">
+                  <a:lumMod val="75000"/>
+                </a:schemeClr>
+              </a:solidFill>
+              <a:latin typeface="Arial" panose="020B0604020202020204" pitchFamily="34" charset="0"/>
+              <a:cs typeface="Arial" panose="020B0604020202020204" pitchFamily="34" charset="0"/>
+            </a:endParaRPr>
+          </a:p>
+        </p:txBody>
+      </p:sp>
+      <p:sp>
+        <p:nvSpPr>
+          <p:cNvPr id="36" name="Espaço Reservado para Texto 1">
+            <a:extLst>
+              <a:ext uri="{FF2B5EF4-FFF2-40B4-BE49-F238E27FC236}">
+                <a16:creationId xmlns:a16="http://schemas.microsoft.com/office/drawing/2014/main" id="{9B3A136E-25E5-48E8-6D9A-F528983D6735}"/>
+              </a:ext>
+            </a:extLst>
+          </p:cNvPr>
+          <p:cNvSpPr txBox="1">
+            <a:spLocks/>
+          </p:cNvSpPr>
+          <p:nvPr/>
+        </p:nvSpPr>
+        <p:spPr>
+          <a:xfrm>
+            <a:off x="505730" y="5531449"/>
+            <a:ext cx="6620786" cy="793649"/>
+          </a:xfrm>
+          <a:prstGeom prst="rect">
+            <a:avLst/>
+          </a:prstGeom>
+          <a:noFill/>
+        </p:spPr>
+        <p:txBody>
+          <a:bodyPr lIns="72000" tIns="72000" rIns="72000" bIns="72000"/>
+          <a:lstStyle>
+            <a:lvl1pPr marL="0" indent="0" algn="l" defTabSz="1280160" rtl="0" eaLnBrk="1" latinLnBrk="0" hangingPunct="1">
+              <a:lnSpc>
+                <a:spcPct val="100000"/>
+              </a:lnSpc>
+              <a:spcBef>
+                <a:spcPts val="0"/>
+              </a:spcBef>
+              <a:spcAft>
+                <a:spcPts val="1200"/>
+              </a:spcAft>
+              <a:buFont typeface="Arial" panose="020B0604020202020204" pitchFamily="34" charset="0"/>
+              <a:buNone/>
+              <a:defRPr sz="1800" kern="1200">
+                <a:solidFill>
+                  <a:schemeClr val="tx2">
+                    <a:lumMod val="75000"/>
+                  </a:schemeClr>
+                </a:solidFill>
+                <a:latin typeface="+mn-lt"/>
+                <a:ea typeface="+mn-ea"/>
+                <a:cs typeface="+mn-cs"/>
+              </a:defRPr>
+            </a:lvl1pPr>
+            <a:lvl2pPr marL="640080" indent="0" algn="l" defTabSz="1280160" rtl="0" eaLnBrk="1" latinLnBrk="0" hangingPunct="1">
+              <a:lnSpc>
+                <a:spcPct val="90000"/>
+              </a:lnSpc>
+              <a:spcBef>
+                <a:spcPts val="700"/>
+              </a:spcBef>
+              <a:buFont typeface="Arial" panose="020B0604020202020204" pitchFamily="34" charset="0"/>
+              <a:buNone/>
+              <a:defRPr sz="1400" kern="1200">
+                <a:solidFill>
+                  <a:schemeClr val="tx1"/>
+                </a:solidFill>
+                <a:latin typeface="+mn-lt"/>
+                <a:ea typeface="+mn-ea"/>
+                <a:cs typeface="+mn-cs"/>
+              </a:defRPr>
+            </a:lvl2pPr>
+            <a:lvl3pPr marL="1280160" indent="0" algn="l" defTabSz="1280160" rtl="0" eaLnBrk="1" latinLnBrk="0" hangingPunct="1">
+              <a:lnSpc>
+                <a:spcPct val="90000"/>
+              </a:lnSpc>
+              <a:spcBef>
+                <a:spcPts val="700"/>
+              </a:spcBef>
+              <a:buFont typeface="Arial" panose="020B0604020202020204" pitchFamily="34" charset="0"/>
+              <a:buNone/>
+              <a:defRPr sz="1400" kern="1200">
+                <a:solidFill>
+                  <a:schemeClr val="tx1"/>
+                </a:solidFill>
+                <a:latin typeface="+mn-lt"/>
+                <a:ea typeface="+mn-ea"/>
+                <a:cs typeface="+mn-cs"/>
+              </a:defRPr>
+            </a:lvl3pPr>
+            <a:lvl4pPr marL="1920240" indent="0" algn="l" defTabSz="1280160" rtl="0" eaLnBrk="1" latinLnBrk="0" hangingPunct="1">
+              <a:lnSpc>
+                <a:spcPct val="90000"/>
+              </a:lnSpc>
+              <a:spcBef>
+                <a:spcPts val="700"/>
+              </a:spcBef>
+              <a:buFont typeface="Arial" panose="020B0604020202020204" pitchFamily="34" charset="0"/>
+              <a:buNone/>
+              <a:defRPr sz="1400" kern="1200">
+                <a:solidFill>
+                  <a:schemeClr val="tx1"/>
+                </a:solidFill>
+                <a:latin typeface="+mn-lt"/>
+                <a:ea typeface="+mn-ea"/>
+                <a:cs typeface="+mn-cs"/>
+              </a:defRPr>
+            </a:lvl4pPr>
+            <a:lvl5pPr marL="2560320" indent="0" algn="l" defTabSz="1280160" rtl="0" eaLnBrk="1" latinLnBrk="0" hangingPunct="1">
+              <a:lnSpc>
+                <a:spcPct val="90000"/>
+              </a:lnSpc>
+              <a:spcBef>
+                <a:spcPts val="700"/>
+              </a:spcBef>
+              <a:buFont typeface="Arial" panose="020B0604020202020204" pitchFamily="34" charset="0"/>
+              <a:buNone/>
+              <a:defRPr sz="1400" kern="1200">
+                <a:solidFill>
+                  <a:schemeClr val="tx1"/>
+                </a:solidFill>
+                <a:latin typeface="+mn-lt"/>
+                <a:ea typeface="+mn-ea"/>
+                <a:cs typeface="+mn-cs"/>
+              </a:defRPr>
+            </a:lvl5pPr>
+            <a:lvl6pPr marL="3520440" indent="-320040" algn="l" defTabSz="1280160" rtl="0" eaLnBrk="1" latinLnBrk="0" hangingPunct="1">
+              <a:lnSpc>
+                <a:spcPct val="90000"/>
+              </a:lnSpc>
+              <a:spcBef>
+                <a:spcPts val="700"/>
+              </a:spcBef>
+              <a:buFont typeface="Arial" panose="020B0604020202020204" pitchFamily="34" charset="0"/>
+              <a:buChar char="•"/>
+              <a:defRPr sz="2520" kern="1200">
+                <a:solidFill>
+                  <a:schemeClr val="tx1"/>
+                </a:solidFill>
+                <a:latin typeface="+mn-lt"/>
+                <a:ea typeface="+mn-ea"/>
+                <a:cs typeface="+mn-cs"/>
+              </a:defRPr>
+            </a:lvl6pPr>
+            <a:lvl7pPr marL="4160520" indent="-320040" algn="l" defTabSz="1280160" rtl="0" eaLnBrk="1" latinLnBrk="0" hangingPunct="1">
+              <a:lnSpc>
+                <a:spcPct val="90000"/>
+              </a:lnSpc>
+              <a:spcBef>
+                <a:spcPts val="700"/>
+              </a:spcBef>
+              <a:buFont typeface="Arial" panose="020B0604020202020204" pitchFamily="34" charset="0"/>
+              <a:buChar char="•"/>
+              <a:defRPr sz="2520" kern="1200">
+                <a:solidFill>
+                  <a:schemeClr val="tx1"/>
+                </a:solidFill>
+                <a:latin typeface="+mn-lt"/>
+                <a:ea typeface="+mn-ea"/>
+                <a:cs typeface="+mn-cs"/>
+              </a:defRPr>
+            </a:lvl7pPr>
+            <a:lvl8pPr marL="4800600" indent="-320040" algn="l" defTabSz="1280160" rtl="0" eaLnBrk="1" latinLnBrk="0" hangingPunct="1">
+              <a:lnSpc>
+                <a:spcPct val="90000"/>
+              </a:lnSpc>
+              <a:spcBef>
+                <a:spcPts val="700"/>
+              </a:spcBef>
+              <a:buFont typeface="Arial" panose="020B0604020202020204" pitchFamily="34" charset="0"/>
+              <a:buChar char="•"/>
+              <a:defRPr sz="2520" kern="1200">
+                <a:solidFill>
+                  <a:schemeClr val="tx1"/>
+                </a:solidFill>
+                <a:latin typeface="+mn-lt"/>
+                <a:ea typeface="+mn-ea"/>
+                <a:cs typeface="+mn-cs"/>
+              </a:defRPr>
+            </a:lvl8pPr>
+            <a:lvl9pPr marL="5440680" indent="-320040" algn="l" defTabSz="1280160" rtl="0" eaLnBrk="1" latinLnBrk="0" hangingPunct="1">
+              <a:lnSpc>
+                <a:spcPct val="90000"/>
+              </a:lnSpc>
+              <a:spcBef>
+                <a:spcPts val="700"/>
+              </a:spcBef>
+              <a:buFont typeface="Arial" panose="020B0604020202020204" pitchFamily="34" charset="0"/>
+              <a:buChar char="•"/>
+              <a:defRPr sz="2520" kern="1200">
+                <a:solidFill>
+                  <a:schemeClr val="tx1"/>
+                </a:solidFill>
+                <a:latin typeface="+mn-lt"/>
+                <a:ea typeface="+mn-ea"/>
+                <a:cs typeface="+mn-cs"/>
+              </a:defRPr>
+            </a:lvl9pPr>
+          </a:lstStyle>
+          <a:p>
+            <a:r>
+              <a:rPr lang="pt-BR" sz="2000" b="1" dirty="0">
+                <a:solidFill>
+                  <a:schemeClr val="accent1">
+                    <a:lumMod val="75000"/>
+                  </a:schemeClr>
+                </a:solidFill>
+                <a:latin typeface="Arial" panose="020B0604020202020204" pitchFamily="34" charset="0"/>
+                <a:cs typeface="Arial" panose="020B0604020202020204" pitchFamily="34" charset="0"/>
+              </a:rPr>
+              <a:t>KPI 5 – Risco de rebaixamento por clube</a:t>
+            </a:r>
+          </a:p>
+          <a:p>
+            <a:r>
+              <a:rPr lang="pt-BR" sz="1200" dirty="0">
+                <a:solidFill>
+                  <a:schemeClr val="tx1"/>
+                </a:solidFill>
+                <a:latin typeface="Arial" panose="020B0604020202020204" pitchFamily="34" charset="0"/>
+                <a:cs typeface="Arial" panose="020B0604020202020204" pitchFamily="34" charset="0"/>
+              </a:rPr>
+              <a:t>Gráfico de barras com risco previsto de cada clube, permitindo comparação entre eles.</a:t>
+            </a:r>
+          </a:p>
+        </p:txBody>
+      </p:sp>
+      <p:sp>
+        <p:nvSpPr>
+          <p:cNvPr id="40" name="Espaço Reservado para Texto 1">
+            <a:extLst>
+              <a:ext uri="{FF2B5EF4-FFF2-40B4-BE49-F238E27FC236}">
+                <a16:creationId xmlns:a16="http://schemas.microsoft.com/office/drawing/2014/main" id="{ACAC470C-CC8A-7985-ACDB-40BC4C1ADE4E}"/>
+              </a:ext>
+            </a:extLst>
+          </p:cNvPr>
+          <p:cNvSpPr txBox="1">
+            <a:spLocks/>
+          </p:cNvSpPr>
+          <p:nvPr/>
+        </p:nvSpPr>
+        <p:spPr>
+          <a:xfrm>
+            <a:off x="8401050" y="5357558"/>
+            <a:ext cx="7683956" cy="1254198"/>
+          </a:xfrm>
+          <a:prstGeom prst="rect">
+            <a:avLst/>
+          </a:prstGeom>
+          <a:solidFill>
+            <a:schemeClr val="bg2"/>
+          </a:solidFill>
+          <a:effectLst>
+            <a:outerShdw blurRad="215900" dist="114300" dir="2700000" algn="tl" rotWithShape="0">
+              <a:prstClr val="black">
+                <a:alpha val="30000"/>
+              </a:prstClr>
+            </a:outerShdw>
+            <a:softEdge rad="38100"/>
+          </a:effectLst>
+        </p:spPr>
+        <p:txBody>
+          <a:bodyPr lIns="72000" tIns="72000" rIns="72000" bIns="72000"/>
+          <a:lstStyle>
+            <a:lvl1pPr marL="0" indent="0" algn="l" defTabSz="1280160" rtl="0" eaLnBrk="1" latinLnBrk="0" hangingPunct="1">
+              <a:lnSpc>
+                <a:spcPct val="100000"/>
+              </a:lnSpc>
+              <a:spcBef>
+                <a:spcPts val="0"/>
+              </a:spcBef>
+              <a:spcAft>
+                <a:spcPts val="1200"/>
+              </a:spcAft>
+              <a:buFont typeface="Arial" panose="020B0604020202020204" pitchFamily="34" charset="0"/>
+              <a:buNone/>
+              <a:defRPr sz="1800" kern="1200">
+                <a:solidFill>
+                  <a:schemeClr val="tx2">
+                    <a:lumMod val="75000"/>
+                  </a:schemeClr>
+                </a:solidFill>
+                <a:latin typeface="+mn-lt"/>
+                <a:ea typeface="+mn-ea"/>
+                <a:cs typeface="+mn-cs"/>
+              </a:defRPr>
+            </a:lvl1pPr>
+            <a:lvl2pPr marL="640080" indent="0" algn="l" defTabSz="1280160" rtl="0" eaLnBrk="1" latinLnBrk="0" hangingPunct="1">
+              <a:lnSpc>
+                <a:spcPct val="90000"/>
+              </a:lnSpc>
+              <a:spcBef>
+                <a:spcPts val="700"/>
+              </a:spcBef>
+              <a:buFont typeface="Arial" panose="020B0604020202020204" pitchFamily="34" charset="0"/>
+              <a:buNone/>
+              <a:defRPr sz="1400" kern="1200">
+                <a:solidFill>
+                  <a:schemeClr val="tx1"/>
+                </a:solidFill>
+                <a:latin typeface="+mn-lt"/>
+                <a:ea typeface="+mn-ea"/>
+                <a:cs typeface="+mn-cs"/>
+              </a:defRPr>
+            </a:lvl2pPr>
+            <a:lvl3pPr marL="1280160" indent="0" algn="l" defTabSz="1280160" rtl="0" eaLnBrk="1" latinLnBrk="0" hangingPunct="1">
+              <a:lnSpc>
+                <a:spcPct val="90000"/>
+              </a:lnSpc>
+              <a:spcBef>
+                <a:spcPts val="700"/>
+              </a:spcBef>
+              <a:buFont typeface="Arial" panose="020B0604020202020204" pitchFamily="34" charset="0"/>
+              <a:buNone/>
+              <a:defRPr sz="1400" kern="1200">
+                <a:solidFill>
+                  <a:schemeClr val="tx1"/>
+                </a:solidFill>
+                <a:latin typeface="+mn-lt"/>
+                <a:ea typeface="+mn-ea"/>
+                <a:cs typeface="+mn-cs"/>
+              </a:defRPr>
+            </a:lvl3pPr>
+            <a:lvl4pPr marL="1920240" indent="0" algn="l" defTabSz="1280160" rtl="0" eaLnBrk="1" latinLnBrk="0" hangingPunct="1">
+              <a:lnSpc>
+                <a:spcPct val="90000"/>
+              </a:lnSpc>
+              <a:spcBef>
+                <a:spcPts val="700"/>
+              </a:spcBef>
+              <a:buFont typeface="Arial" panose="020B0604020202020204" pitchFamily="34" charset="0"/>
+              <a:buNone/>
+              <a:defRPr sz="1400" kern="1200">
+                <a:solidFill>
+                  <a:schemeClr val="tx1"/>
+                </a:solidFill>
+                <a:latin typeface="+mn-lt"/>
+                <a:ea typeface="+mn-ea"/>
+                <a:cs typeface="+mn-cs"/>
+              </a:defRPr>
+            </a:lvl4pPr>
+            <a:lvl5pPr marL="2560320" indent="0" algn="l" defTabSz="1280160" rtl="0" eaLnBrk="1" latinLnBrk="0" hangingPunct="1">
+              <a:lnSpc>
+                <a:spcPct val="90000"/>
+              </a:lnSpc>
+              <a:spcBef>
+                <a:spcPts val="700"/>
+              </a:spcBef>
+              <a:buFont typeface="Arial" panose="020B0604020202020204" pitchFamily="34" charset="0"/>
+              <a:buNone/>
+              <a:defRPr sz="1400" kern="1200">
+                <a:solidFill>
+                  <a:schemeClr val="tx1"/>
+                </a:solidFill>
+                <a:latin typeface="+mn-lt"/>
+                <a:ea typeface="+mn-ea"/>
+                <a:cs typeface="+mn-cs"/>
+              </a:defRPr>
+            </a:lvl5pPr>
+            <a:lvl6pPr marL="3520440" indent="-320040" algn="l" defTabSz="1280160" rtl="0" eaLnBrk="1" latinLnBrk="0" hangingPunct="1">
+              <a:lnSpc>
+                <a:spcPct val="90000"/>
+              </a:lnSpc>
+              <a:spcBef>
+                <a:spcPts val="700"/>
+              </a:spcBef>
+              <a:buFont typeface="Arial" panose="020B0604020202020204" pitchFamily="34" charset="0"/>
+              <a:buChar char="•"/>
+              <a:defRPr sz="2520" kern="1200">
+                <a:solidFill>
+                  <a:schemeClr val="tx1"/>
+                </a:solidFill>
+                <a:latin typeface="+mn-lt"/>
+                <a:ea typeface="+mn-ea"/>
+                <a:cs typeface="+mn-cs"/>
+              </a:defRPr>
+            </a:lvl6pPr>
+            <a:lvl7pPr marL="4160520" indent="-320040" algn="l" defTabSz="1280160" rtl="0" eaLnBrk="1" latinLnBrk="0" hangingPunct="1">
+              <a:lnSpc>
+                <a:spcPct val="90000"/>
+              </a:lnSpc>
+              <a:spcBef>
+                <a:spcPts val="700"/>
+              </a:spcBef>
+              <a:buFont typeface="Arial" panose="020B0604020202020204" pitchFamily="34" charset="0"/>
+              <a:buChar char="•"/>
+              <a:defRPr sz="2520" kern="1200">
+                <a:solidFill>
+                  <a:schemeClr val="tx1"/>
+                </a:solidFill>
+                <a:latin typeface="+mn-lt"/>
+                <a:ea typeface="+mn-ea"/>
+                <a:cs typeface="+mn-cs"/>
+              </a:defRPr>
+            </a:lvl7pPr>
+            <a:lvl8pPr marL="4800600" indent="-320040" algn="l" defTabSz="1280160" rtl="0" eaLnBrk="1" latinLnBrk="0" hangingPunct="1">
+              <a:lnSpc>
+                <a:spcPct val="90000"/>
+              </a:lnSpc>
+              <a:spcBef>
+                <a:spcPts val="700"/>
+              </a:spcBef>
+              <a:buFont typeface="Arial" panose="020B0604020202020204" pitchFamily="34" charset="0"/>
+              <a:buChar char="•"/>
+              <a:defRPr sz="2520" kern="1200">
+                <a:solidFill>
+                  <a:schemeClr val="tx1"/>
+                </a:solidFill>
+                <a:latin typeface="+mn-lt"/>
+                <a:ea typeface="+mn-ea"/>
+                <a:cs typeface="+mn-cs"/>
+              </a:defRPr>
+            </a:lvl8pPr>
+            <a:lvl9pPr marL="5440680" indent="-320040" algn="l" defTabSz="1280160" rtl="0" eaLnBrk="1" latinLnBrk="0" hangingPunct="1">
+              <a:lnSpc>
+                <a:spcPct val="90000"/>
+              </a:lnSpc>
+              <a:spcBef>
+                <a:spcPts val="700"/>
+              </a:spcBef>
+              <a:buFont typeface="Arial" panose="020B0604020202020204" pitchFamily="34" charset="0"/>
+              <a:buChar char="•"/>
+              <a:defRPr sz="2520" kern="1200">
+                <a:solidFill>
+                  <a:schemeClr val="tx1"/>
+                </a:solidFill>
+                <a:latin typeface="+mn-lt"/>
+                <a:ea typeface="+mn-ea"/>
+                <a:cs typeface="+mn-cs"/>
+              </a:defRPr>
+            </a:lvl9pPr>
+          </a:lstStyle>
+          <a:p>
+            <a:endParaRPr lang="pt-BR" sz="1600" b="1" dirty="0">
+              <a:solidFill>
+                <a:schemeClr val="accent1">
+                  <a:lumMod val="75000"/>
+                </a:schemeClr>
+              </a:solidFill>
+              <a:latin typeface="Arial" panose="020B0604020202020204" pitchFamily="34" charset="0"/>
+              <a:cs typeface="Arial" panose="020B0604020202020204" pitchFamily="34" charset="0"/>
+            </a:endParaRPr>
+          </a:p>
+        </p:txBody>
+      </p:sp>
+      <p:sp>
+        <p:nvSpPr>
+          <p:cNvPr id="44" name="Espaço Reservado para Texto 1">
+            <a:extLst>
+              <a:ext uri="{FF2B5EF4-FFF2-40B4-BE49-F238E27FC236}">
+                <a16:creationId xmlns:a16="http://schemas.microsoft.com/office/drawing/2014/main" id="{8D0A85B0-C545-D8AA-47E7-3F983AA2A6B1}"/>
+              </a:ext>
+            </a:extLst>
+          </p:cNvPr>
+          <p:cNvSpPr txBox="1">
+            <a:spLocks/>
+          </p:cNvSpPr>
+          <p:nvPr/>
+        </p:nvSpPr>
+        <p:spPr>
+          <a:xfrm>
+            <a:off x="8589736" y="5531449"/>
+            <a:ext cx="6883626" cy="793649"/>
+          </a:xfrm>
+          <a:prstGeom prst="rect">
+            <a:avLst/>
+          </a:prstGeom>
+          <a:noFill/>
+        </p:spPr>
+        <p:txBody>
+          <a:bodyPr lIns="72000" tIns="72000" rIns="72000" bIns="72000"/>
+          <a:lstStyle>
+            <a:lvl1pPr marL="0" indent="0" algn="l" defTabSz="1280160" rtl="0" eaLnBrk="1" latinLnBrk="0" hangingPunct="1">
+              <a:lnSpc>
+                <a:spcPct val="100000"/>
+              </a:lnSpc>
+              <a:spcBef>
+                <a:spcPts val="0"/>
+              </a:spcBef>
+              <a:spcAft>
+                <a:spcPts val="1200"/>
+              </a:spcAft>
+              <a:buFont typeface="Arial" panose="020B0604020202020204" pitchFamily="34" charset="0"/>
+              <a:buNone/>
+              <a:defRPr sz="1800" kern="1200">
+                <a:solidFill>
+                  <a:schemeClr val="tx2">
+                    <a:lumMod val="75000"/>
+                  </a:schemeClr>
+                </a:solidFill>
+                <a:latin typeface="+mn-lt"/>
+                <a:ea typeface="+mn-ea"/>
+                <a:cs typeface="+mn-cs"/>
+              </a:defRPr>
+            </a:lvl1pPr>
+            <a:lvl2pPr marL="640080" indent="0" algn="l" defTabSz="1280160" rtl="0" eaLnBrk="1" latinLnBrk="0" hangingPunct="1">
+              <a:lnSpc>
+                <a:spcPct val="90000"/>
+              </a:lnSpc>
+              <a:spcBef>
+                <a:spcPts val="700"/>
+              </a:spcBef>
+              <a:buFont typeface="Arial" panose="020B0604020202020204" pitchFamily="34" charset="0"/>
+              <a:buNone/>
+              <a:defRPr sz="1400" kern="1200">
+                <a:solidFill>
+                  <a:schemeClr val="tx1"/>
+                </a:solidFill>
+                <a:latin typeface="+mn-lt"/>
+                <a:ea typeface="+mn-ea"/>
+                <a:cs typeface="+mn-cs"/>
+              </a:defRPr>
+            </a:lvl2pPr>
+            <a:lvl3pPr marL="1280160" indent="0" algn="l" defTabSz="1280160" rtl="0" eaLnBrk="1" latinLnBrk="0" hangingPunct="1">
+              <a:lnSpc>
+                <a:spcPct val="90000"/>
+              </a:lnSpc>
+              <a:spcBef>
+                <a:spcPts val="700"/>
+              </a:spcBef>
+              <a:buFont typeface="Arial" panose="020B0604020202020204" pitchFamily="34" charset="0"/>
+              <a:buNone/>
+              <a:defRPr sz="1400" kern="1200">
+                <a:solidFill>
+                  <a:schemeClr val="tx1"/>
+                </a:solidFill>
+                <a:latin typeface="+mn-lt"/>
+                <a:ea typeface="+mn-ea"/>
+                <a:cs typeface="+mn-cs"/>
+              </a:defRPr>
+            </a:lvl3pPr>
+            <a:lvl4pPr marL="1920240" indent="0" algn="l" defTabSz="1280160" rtl="0" eaLnBrk="1" latinLnBrk="0" hangingPunct="1">
+              <a:lnSpc>
+                <a:spcPct val="90000"/>
+              </a:lnSpc>
+              <a:spcBef>
+                <a:spcPts val="700"/>
+              </a:spcBef>
+              <a:buFont typeface="Arial" panose="020B0604020202020204" pitchFamily="34" charset="0"/>
+              <a:buNone/>
+              <a:defRPr sz="1400" kern="1200">
+                <a:solidFill>
+                  <a:schemeClr val="tx1"/>
+                </a:solidFill>
+                <a:latin typeface="+mn-lt"/>
+                <a:ea typeface="+mn-ea"/>
+                <a:cs typeface="+mn-cs"/>
+              </a:defRPr>
+            </a:lvl4pPr>
+            <a:lvl5pPr marL="2560320" indent="0" algn="l" defTabSz="1280160" rtl="0" eaLnBrk="1" latinLnBrk="0" hangingPunct="1">
+              <a:lnSpc>
+                <a:spcPct val="90000"/>
+              </a:lnSpc>
+              <a:spcBef>
+                <a:spcPts val="700"/>
+              </a:spcBef>
+              <a:buFont typeface="Arial" panose="020B0604020202020204" pitchFamily="34" charset="0"/>
+              <a:buNone/>
+              <a:defRPr sz="1400" kern="1200">
+                <a:solidFill>
+                  <a:schemeClr val="tx1"/>
+                </a:solidFill>
+                <a:latin typeface="+mn-lt"/>
+                <a:ea typeface="+mn-ea"/>
+                <a:cs typeface="+mn-cs"/>
+              </a:defRPr>
+            </a:lvl5pPr>
+            <a:lvl6pPr marL="3520440" indent="-320040" algn="l" defTabSz="1280160" rtl="0" eaLnBrk="1" latinLnBrk="0" hangingPunct="1">
+              <a:lnSpc>
+                <a:spcPct val="90000"/>
+              </a:lnSpc>
+              <a:spcBef>
+                <a:spcPts val="700"/>
+              </a:spcBef>
+              <a:buFont typeface="Arial" panose="020B0604020202020204" pitchFamily="34" charset="0"/>
+              <a:buChar char="•"/>
+              <a:defRPr sz="2520" kern="1200">
+                <a:solidFill>
+                  <a:schemeClr val="tx1"/>
+                </a:solidFill>
+                <a:latin typeface="+mn-lt"/>
+                <a:ea typeface="+mn-ea"/>
+                <a:cs typeface="+mn-cs"/>
+              </a:defRPr>
+            </a:lvl6pPr>
+            <a:lvl7pPr marL="4160520" indent="-320040" algn="l" defTabSz="1280160" rtl="0" eaLnBrk="1" latinLnBrk="0" hangingPunct="1">
+              <a:lnSpc>
+                <a:spcPct val="90000"/>
+              </a:lnSpc>
+              <a:spcBef>
+                <a:spcPts val="700"/>
+              </a:spcBef>
+              <a:buFont typeface="Arial" panose="020B0604020202020204" pitchFamily="34" charset="0"/>
+              <a:buChar char="•"/>
+              <a:defRPr sz="2520" kern="1200">
+                <a:solidFill>
+                  <a:schemeClr val="tx1"/>
+                </a:solidFill>
+                <a:latin typeface="+mn-lt"/>
+                <a:ea typeface="+mn-ea"/>
+                <a:cs typeface="+mn-cs"/>
+              </a:defRPr>
+            </a:lvl7pPr>
+            <a:lvl8pPr marL="4800600" indent="-320040" algn="l" defTabSz="1280160" rtl="0" eaLnBrk="1" latinLnBrk="0" hangingPunct="1">
+              <a:lnSpc>
+                <a:spcPct val="90000"/>
+              </a:lnSpc>
+              <a:spcBef>
+                <a:spcPts val="700"/>
+              </a:spcBef>
+              <a:buFont typeface="Arial" panose="020B0604020202020204" pitchFamily="34" charset="0"/>
+              <a:buChar char="•"/>
+              <a:defRPr sz="2520" kern="1200">
+                <a:solidFill>
+                  <a:schemeClr val="tx1"/>
+                </a:solidFill>
+                <a:latin typeface="+mn-lt"/>
+                <a:ea typeface="+mn-ea"/>
+                <a:cs typeface="+mn-cs"/>
+              </a:defRPr>
+            </a:lvl8pPr>
+            <a:lvl9pPr marL="5440680" indent="-320040" algn="l" defTabSz="1280160" rtl="0" eaLnBrk="1" latinLnBrk="0" hangingPunct="1">
+              <a:lnSpc>
+                <a:spcPct val="90000"/>
+              </a:lnSpc>
+              <a:spcBef>
+                <a:spcPts val="700"/>
+              </a:spcBef>
+              <a:buFont typeface="Arial" panose="020B0604020202020204" pitchFamily="34" charset="0"/>
+              <a:buChar char="•"/>
+              <a:defRPr sz="2520" kern="1200">
+                <a:solidFill>
+                  <a:schemeClr val="tx1"/>
+                </a:solidFill>
+                <a:latin typeface="+mn-lt"/>
+                <a:ea typeface="+mn-ea"/>
+                <a:cs typeface="+mn-cs"/>
+              </a:defRPr>
+            </a:lvl9pPr>
+          </a:lstStyle>
+          <a:p>
+            <a:r>
+              <a:rPr lang="pt-BR" sz="2000" b="1" dirty="0">
+                <a:solidFill>
+                  <a:schemeClr val="accent1">
+                    <a:lumMod val="75000"/>
+                  </a:schemeClr>
+                </a:solidFill>
+                <a:latin typeface="Arial" panose="020B0604020202020204" pitchFamily="34" charset="0"/>
+                <a:cs typeface="Arial" panose="020B0604020202020204" pitchFamily="34" charset="0"/>
+              </a:rPr>
+              <a:t>KPI 1 – Risco ao longo das temporada (2014 – 2025)</a:t>
+            </a:r>
+          </a:p>
+          <a:p>
+            <a:r>
+              <a:rPr lang="pt-BR" sz="1200" dirty="0">
+                <a:solidFill>
+                  <a:schemeClr val="tx1"/>
+                </a:solidFill>
+                <a:latin typeface="Arial" panose="020B0604020202020204" pitchFamily="34" charset="0"/>
+                <a:cs typeface="Arial" panose="020B0604020202020204" pitchFamily="34" charset="0"/>
+              </a:rPr>
+              <a:t>Evolução histórica do risco previsto, mostrando o comportamento dos clubes ao longo do tempo..</a:t>
+            </a:r>
+          </a:p>
+        </p:txBody>
+      </p:sp>
+      <p:sp>
+        <p:nvSpPr>
+          <p:cNvPr id="46" name="Espaço Reservado para Texto 1">
+            <a:extLst>
+              <a:ext uri="{FF2B5EF4-FFF2-40B4-BE49-F238E27FC236}">
+                <a16:creationId xmlns:a16="http://schemas.microsoft.com/office/drawing/2014/main" id="{74C12E54-5CF2-971E-7FAE-ED161C26FEBD}"/>
+              </a:ext>
+            </a:extLst>
+          </p:cNvPr>
+          <p:cNvSpPr txBox="1">
+            <a:spLocks/>
+          </p:cNvSpPr>
+          <p:nvPr/>
+        </p:nvSpPr>
+        <p:spPr>
+          <a:xfrm>
+            <a:off x="2775477" y="7809956"/>
+            <a:ext cx="10851096" cy="699685"/>
+          </a:xfrm>
+          <a:prstGeom prst="rect">
+            <a:avLst/>
+          </a:prstGeom>
+          <a:solidFill>
+            <a:schemeClr val="bg2"/>
+          </a:solidFill>
+          <a:effectLst>
+            <a:outerShdw blurRad="215900" dist="114300" dir="2700000" algn="tl" rotWithShape="0">
+              <a:prstClr val="black">
+                <a:alpha val="30000"/>
+              </a:prstClr>
+            </a:outerShdw>
+            <a:softEdge rad="38100"/>
+          </a:effectLst>
+        </p:spPr>
+        <p:txBody>
+          <a:bodyPr lIns="72000" tIns="72000" rIns="72000" bIns="72000" anchor="ctr"/>
+          <a:lstStyle>
+            <a:lvl1pPr marL="0" indent="0" algn="l" defTabSz="1280160" rtl="0" eaLnBrk="1" latinLnBrk="0" hangingPunct="1">
+              <a:lnSpc>
+                <a:spcPct val="100000"/>
+              </a:lnSpc>
+              <a:spcBef>
+                <a:spcPts val="0"/>
+              </a:spcBef>
+              <a:spcAft>
+                <a:spcPts val="1200"/>
+              </a:spcAft>
+              <a:buFont typeface="Arial" panose="020B0604020202020204" pitchFamily="34" charset="0"/>
+              <a:buNone/>
+              <a:defRPr sz="1800" kern="1200">
+                <a:solidFill>
+                  <a:schemeClr val="tx2">
+                    <a:lumMod val="75000"/>
+                  </a:schemeClr>
+                </a:solidFill>
+                <a:latin typeface="+mn-lt"/>
+                <a:ea typeface="+mn-ea"/>
+                <a:cs typeface="+mn-cs"/>
+              </a:defRPr>
+            </a:lvl1pPr>
+            <a:lvl2pPr marL="640080" indent="0" algn="l" defTabSz="1280160" rtl="0" eaLnBrk="1" latinLnBrk="0" hangingPunct="1">
+              <a:lnSpc>
+                <a:spcPct val="90000"/>
+              </a:lnSpc>
+              <a:spcBef>
+                <a:spcPts val="700"/>
+              </a:spcBef>
+              <a:buFont typeface="Arial" panose="020B0604020202020204" pitchFamily="34" charset="0"/>
+              <a:buNone/>
+              <a:defRPr sz="1400" kern="1200">
+                <a:solidFill>
+                  <a:schemeClr val="tx1"/>
+                </a:solidFill>
+                <a:latin typeface="+mn-lt"/>
+                <a:ea typeface="+mn-ea"/>
+                <a:cs typeface="+mn-cs"/>
+              </a:defRPr>
+            </a:lvl2pPr>
+            <a:lvl3pPr marL="1280160" indent="0" algn="l" defTabSz="1280160" rtl="0" eaLnBrk="1" latinLnBrk="0" hangingPunct="1">
+              <a:lnSpc>
+                <a:spcPct val="90000"/>
+              </a:lnSpc>
+              <a:spcBef>
+                <a:spcPts val="700"/>
+              </a:spcBef>
+              <a:buFont typeface="Arial" panose="020B0604020202020204" pitchFamily="34" charset="0"/>
+              <a:buNone/>
+              <a:defRPr sz="1400" kern="1200">
+                <a:solidFill>
+                  <a:schemeClr val="tx1"/>
+                </a:solidFill>
+                <a:latin typeface="+mn-lt"/>
+                <a:ea typeface="+mn-ea"/>
+                <a:cs typeface="+mn-cs"/>
+              </a:defRPr>
+            </a:lvl3pPr>
+            <a:lvl4pPr marL="1920240" indent="0" algn="l" defTabSz="1280160" rtl="0" eaLnBrk="1" latinLnBrk="0" hangingPunct="1">
+              <a:lnSpc>
+                <a:spcPct val="90000"/>
+              </a:lnSpc>
+              <a:spcBef>
+                <a:spcPts val="700"/>
+              </a:spcBef>
+              <a:buFont typeface="Arial" panose="020B0604020202020204" pitchFamily="34" charset="0"/>
+              <a:buNone/>
+              <a:defRPr sz="1400" kern="1200">
+                <a:solidFill>
+                  <a:schemeClr val="tx1"/>
+                </a:solidFill>
+                <a:latin typeface="+mn-lt"/>
+                <a:ea typeface="+mn-ea"/>
+                <a:cs typeface="+mn-cs"/>
+              </a:defRPr>
+            </a:lvl4pPr>
+            <a:lvl5pPr marL="2560320" indent="0" algn="l" defTabSz="1280160" rtl="0" eaLnBrk="1" latinLnBrk="0" hangingPunct="1">
+              <a:lnSpc>
+                <a:spcPct val="90000"/>
+              </a:lnSpc>
+              <a:spcBef>
+                <a:spcPts val="700"/>
+              </a:spcBef>
+              <a:buFont typeface="Arial" panose="020B0604020202020204" pitchFamily="34" charset="0"/>
+              <a:buNone/>
+              <a:defRPr sz="1400" kern="1200">
+                <a:solidFill>
+                  <a:schemeClr val="tx1"/>
+                </a:solidFill>
+                <a:latin typeface="+mn-lt"/>
+                <a:ea typeface="+mn-ea"/>
+                <a:cs typeface="+mn-cs"/>
+              </a:defRPr>
+            </a:lvl5pPr>
+            <a:lvl6pPr marL="3520440" indent="-320040" algn="l" defTabSz="1280160" rtl="0" eaLnBrk="1" latinLnBrk="0" hangingPunct="1">
+              <a:lnSpc>
+                <a:spcPct val="90000"/>
+              </a:lnSpc>
+              <a:spcBef>
+                <a:spcPts val="700"/>
+              </a:spcBef>
+              <a:buFont typeface="Arial" panose="020B0604020202020204" pitchFamily="34" charset="0"/>
+              <a:buChar char="•"/>
+              <a:defRPr sz="2520" kern="1200">
+                <a:solidFill>
+                  <a:schemeClr val="tx1"/>
+                </a:solidFill>
+                <a:latin typeface="+mn-lt"/>
+                <a:ea typeface="+mn-ea"/>
+                <a:cs typeface="+mn-cs"/>
+              </a:defRPr>
+            </a:lvl6pPr>
+            <a:lvl7pPr marL="4160520" indent="-320040" algn="l" defTabSz="1280160" rtl="0" eaLnBrk="1" latinLnBrk="0" hangingPunct="1">
+              <a:lnSpc>
+                <a:spcPct val="90000"/>
+              </a:lnSpc>
+              <a:spcBef>
+                <a:spcPts val="700"/>
+              </a:spcBef>
+              <a:buFont typeface="Arial" panose="020B0604020202020204" pitchFamily="34" charset="0"/>
+              <a:buChar char="•"/>
+              <a:defRPr sz="2520" kern="1200">
+                <a:solidFill>
+                  <a:schemeClr val="tx1"/>
+                </a:solidFill>
+                <a:latin typeface="+mn-lt"/>
+                <a:ea typeface="+mn-ea"/>
+                <a:cs typeface="+mn-cs"/>
+              </a:defRPr>
+            </a:lvl7pPr>
+            <a:lvl8pPr marL="4800600" indent="-320040" algn="l" defTabSz="1280160" rtl="0" eaLnBrk="1" latinLnBrk="0" hangingPunct="1">
+              <a:lnSpc>
+                <a:spcPct val="90000"/>
+              </a:lnSpc>
+              <a:spcBef>
+                <a:spcPts val="700"/>
+              </a:spcBef>
+              <a:buFont typeface="Arial" panose="020B0604020202020204" pitchFamily="34" charset="0"/>
+              <a:buChar char="•"/>
+              <a:defRPr sz="2520" kern="1200">
+                <a:solidFill>
+                  <a:schemeClr val="tx1"/>
+                </a:solidFill>
+                <a:latin typeface="+mn-lt"/>
+                <a:ea typeface="+mn-ea"/>
+                <a:cs typeface="+mn-cs"/>
+              </a:defRPr>
+            </a:lvl8pPr>
+            <a:lvl9pPr marL="5440680" indent="-320040" algn="l" defTabSz="1280160" rtl="0" eaLnBrk="1" latinLnBrk="0" hangingPunct="1">
+              <a:lnSpc>
+                <a:spcPct val="90000"/>
+              </a:lnSpc>
+              <a:spcBef>
+                <a:spcPts val="700"/>
+              </a:spcBef>
+              <a:buFont typeface="Arial" panose="020B0604020202020204" pitchFamily="34" charset="0"/>
+              <a:buChar char="•"/>
+              <a:defRPr sz="2520" kern="1200">
+                <a:solidFill>
+                  <a:schemeClr val="tx1"/>
+                </a:solidFill>
+                <a:latin typeface="+mn-lt"/>
+                <a:ea typeface="+mn-ea"/>
+                <a:cs typeface="+mn-cs"/>
+              </a:defRPr>
+            </a:lvl9pPr>
+          </a:lstStyle>
+          <a:p>
+            <a:pPr algn="ctr"/>
+            <a:r>
+              <a:rPr lang="pt-BR" sz="1600" b="1" dirty="0">
+                <a:solidFill>
+                  <a:schemeClr val="accent1">
+                    <a:lumMod val="75000"/>
+                  </a:schemeClr>
+                </a:solidFill>
+                <a:latin typeface="Arial" panose="020B0604020202020204" pitchFamily="34" charset="0"/>
+                <a:cs typeface="Arial" panose="020B0604020202020204" pitchFamily="34" charset="0"/>
+              </a:rPr>
+              <a:t>Dashboard: </a:t>
+            </a:r>
+            <a:r>
+              <a:rPr lang="pt-BR" dirty="0"/>
+              <a:t>https://public.tableau.com/app/profile/felipe.pinheiro.foss./viz/Projeto-em-bi-analytics/Dashboard</a:t>
+            </a:r>
+            <a:endParaRPr lang="pt-BR" sz="1600" b="1" dirty="0">
+              <a:solidFill>
+                <a:schemeClr val="accent1">
+                  <a:lumMod val="75000"/>
+                </a:schemeClr>
+              </a:solidFill>
+              <a:latin typeface="Arial" panose="020B0604020202020204" pitchFamily="34" charset="0"/>
+              <a:cs typeface="Arial" panose="020B0604020202020204" pitchFamily="34" charset="0"/>
+            </a:endParaRPr>
+          </a:p>
+        </p:txBody>
+      </p:sp>
+    </p:spTree>
+    <p:extLst>
+      <p:ext uri="{BB962C8B-B14F-4D97-AF65-F5344CB8AC3E}">
+        <p14:creationId xmlns:p14="http://schemas.microsoft.com/office/powerpoint/2010/main" val="2254749336"/>
       </p:ext>
     </p:extLst>
   </p:cSld>

</xml_diff>

<commit_message>
feat: slide 6, principais insights
</commit_message>
<xml_diff>
--- a/docs/Template - Fase 2 - Apresentação Executiva - Projeto em Business Intelligence e Analytics.pptx
+++ b/docs/Template - Fase 2 - Apresentação Executiva - Projeto em Business Intelligence e Analytics.pptx
@@ -5,10 +5,10 @@
     <p:sldMasterId id="2147483665" r:id="rId4"/>
   </p:sldMasterIdLst>
   <p:notesMasterIdLst>
-    <p:notesMasterId r:id="rId11"/>
+    <p:notesMasterId r:id="rId12"/>
   </p:notesMasterIdLst>
   <p:handoutMasterIdLst>
-    <p:handoutMasterId r:id="rId12"/>
+    <p:handoutMasterId r:id="rId13"/>
   </p:handoutMasterIdLst>
   <p:sldIdLst>
     <p:sldId id="288" r:id="rId5"/>
@@ -16,7 +16,8 @@
     <p:sldId id="304" r:id="rId7"/>
     <p:sldId id="305" r:id="rId8"/>
     <p:sldId id="306" r:id="rId9"/>
-    <p:sldId id="300" r:id="rId10"/>
+    <p:sldId id="307" r:id="rId10"/>
+    <p:sldId id="300" r:id="rId11"/>
   </p:sldIdLst>
   <p:sldSz cx="16402050" cy="9601200"/>
   <p:notesSz cx="6858000" cy="9144000"/>
@@ -125,6 +126,7 @@
             <p14:sldId id="304"/>
             <p14:sldId id="305"/>
             <p14:sldId id="306"/>
+            <p14:sldId id="307"/>
             <p14:sldId id="300"/>
           </p14:sldIdLst>
         </p14:section>
@@ -2102,6 +2104,114 @@
 </p:notes>
 </file>
 
+<file path=ppt/notesSlides/notesSlide4.xml><?xml version="1.0" encoding="utf-8"?>
+<p:notes xmlns:a="http://schemas.openxmlformats.org/drawingml/2006/main" xmlns:r="http://schemas.openxmlformats.org/officeDocument/2006/relationships" xmlns:p="http://schemas.openxmlformats.org/presentationml/2006/main">
+  <p:cSld>
+    <p:spTree>
+      <p:nvGrpSpPr>
+        <p:cNvPr id="1" name="">
+          <a:extLst>
+            <a:ext uri="{FF2B5EF4-FFF2-40B4-BE49-F238E27FC236}">
+              <a16:creationId xmlns:a16="http://schemas.microsoft.com/office/drawing/2014/main" id="{792B6844-09D4-A5EB-BE27-E078DFF16501}"/>
+            </a:ext>
+          </a:extLst>
+        </p:cNvPr>
+        <p:cNvGrpSpPr/>
+        <p:nvPr/>
+      </p:nvGrpSpPr>
+      <p:grpSpPr>
+        <a:xfrm>
+          <a:off x="0" y="0"/>
+          <a:ext cx="0" cy="0"/>
+          <a:chOff x="0" y="0"/>
+          <a:chExt cx="0" cy="0"/>
+        </a:xfrm>
+      </p:grpSpPr>
+      <p:sp>
+        <p:nvSpPr>
+          <p:cNvPr id="2" name="Marcador de Posição da Imagem do Diapositivo 1">
+            <a:extLst>
+              <a:ext uri="{FF2B5EF4-FFF2-40B4-BE49-F238E27FC236}">
+                <a16:creationId xmlns:a16="http://schemas.microsoft.com/office/drawing/2014/main" id="{447FADB8-16B0-43FC-86E3-5779E73B2E05}"/>
+              </a:ext>
+            </a:extLst>
+          </p:cNvPr>
+          <p:cNvSpPr>
+            <a:spLocks noGrp="1" noRot="1" noChangeAspect="1"/>
+          </p:cNvSpPr>
+          <p:nvPr>
+            <p:ph type="sldImg"/>
+          </p:nvPr>
+        </p:nvSpPr>
+        <p:spPr/>
+      </p:sp>
+      <p:sp>
+        <p:nvSpPr>
+          <p:cNvPr id="3" name="Marcador de Posição de Notas 2">
+            <a:extLst>
+              <a:ext uri="{FF2B5EF4-FFF2-40B4-BE49-F238E27FC236}">
+                <a16:creationId xmlns:a16="http://schemas.microsoft.com/office/drawing/2014/main" id="{0FE0F885-91A8-6C47-10FF-E3C309253CDC}"/>
+              </a:ext>
+            </a:extLst>
+          </p:cNvPr>
+          <p:cNvSpPr>
+            <a:spLocks noGrp="1"/>
+          </p:cNvSpPr>
+          <p:nvPr>
+            <p:ph type="body" idx="1"/>
+          </p:nvPr>
+        </p:nvSpPr>
+        <p:spPr/>
+        <p:txBody>
+          <a:bodyPr/>
+          <a:lstStyle/>
+          <a:p>
+            <a:endParaRPr lang="pt-BR" dirty="0"/>
+          </a:p>
+        </p:txBody>
+      </p:sp>
+      <p:sp>
+        <p:nvSpPr>
+          <p:cNvPr id="4" name="Marcador de Posição do Número do Diapositivo 3">
+            <a:extLst>
+              <a:ext uri="{FF2B5EF4-FFF2-40B4-BE49-F238E27FC236}">
+                <a16:creationId xmlns:a16="http://schemas.microsoft.com/office/drawing/2014/main" id="{AB6F42A3-36F9-4E24-A8D4-A06B9765DE09}"/>
+              </a:ext>
+            </a:extLst>
+          </p:cNvPr>
+          <p:cNvSpPr>
+            <a:spLocks noGrp="1"/>
+          </p:cNvSpPr>
+          <p:nvPr>
+            <p:ph type="sldNum" sz="quarter" idx="5"/>
+          </p:nvPr>
+        </p:nvSpPr>
+        <p:spPr/>
+        <p:txBody>
+          <a:bodyPr/>
+          <a:lstStyle/>
+          <a:p>
+            <a:fld id="{4EC3EDC0-8BE0-4B53-981B-0D2AEC565C43}" type="slidenum">
+              <a:rPr lang="pt-BR" smtClean="0"/>
+              <a:t>6</a:t>
+            </a:fld>
+            <a:endParaRPr lang="pt-BR"/>
+          </a:p>
+        </p:txBody>
+      </p:sp>
+    </p:spTree>
+    <p:extLst>
+      <p:ext uri="{BB962C8B-B14F-4D97-AF65-F5344CB8AC3E}">
+        <p14:creationId xmlns:p14="http://schemas.microsoft.com/office/powerpoint/2010/main" val="382819383"/>
+      </p:ext>
+    </p:extLst>
+  </p:cSld>
+  <p:clrMapOvr>
+    <a:masterClrMapping/>
+  </p:clrMapOvr>
+</p:notes>
+</file>
+
 <file path=ppt/slideLayouts/slideLayout1.xml><?xml version="1.0" encoding="utf-8"?>
 <p:sldLayout xmlns:a="http://schemas.openxmlformats.org/drawingml/2006/main" xmlns:r="http://schemas.openxmlformats.org/officeDocument/2006/relationships" xmlns:p="http://schemas.openxmlformats.org/presentationml/2006/main" preserve="1" userDrawn="1">
   <p:cSld name="Layout Personalizado">
@@ -13156,6 +13266,1458 @@
 </file>
 
 <file path=ppt/slides/slide6.xml><?xml version="1.0" encoding="utf-8"?>
+<p:sld xmlns:a="http://schemas.openxmlformats.org/drawingml/2006/main" xmlns:r="http://schemas.openxmlformats.org/officeDocument/2006/relationships" xmlns:p="http://schemas.openxmlformats.org/presentationml/2006/main">
+  <p:cSld>
+    <p:spTree>
+      <p:nvGrpSpPr>
+        <p:cNvPr id="1" name="">
+          <a:extLst>
+            <a:ext uri="{FF2B5EF4-FFF2-40B4-BE49-F238E27FC236}">
+              <a16:creationId xmlns:a16="http://schemas.microsoft.com/office/drawing/2014/main" id="{A8D47FDC-CD9C-315D-5BF0-4195DB50C14F}"/>
+            </a:ext>
+          </a:extLst>
+        </p:cNvPr>
+        <p:cNvGrpSpPr/>
+        <p:nvPr/>
+      </p:nvGrpSpPr>
+      <p:grpSpPr>
+        <a:xfrm>
+          <a:off x="0" y="0"/>
+          <a:ext cx="0" cy="0"/>
+          <a:chOff x="0" y="0"/>
+          <a:chExt cx="0" cy="0"/>
+        </a:xfrm>
+      </p:grpSpPr>
+      <p:sp>
+        <p:nvSpPr>
+          <p:cNvPr id="2" name="Espaço Reservado para Texto 1">
+            <a:extLst>
+              <a:ext uri="{FF2B5EF4-FFF2-40B4-BE49-F238E27FC236}">
+                <a16:creationId xmlns:a16="http://schemas.microsoft.com/office/drawing/2014/main" id="{F8B34A84-B5F1-7A4A-F608-FA691A51652E}"/>
+              </a:ext>
+            </a:extLst>
+          </p:cNvPr>
+          <p:cNvSpPr>
+            <a:spLocks noGrp="1"/>
+          </p:cNvSpPr>
+          <p:nvPr>
+            <p:ph type="body" sz="quarter" idx="10"/>
+          </p:nvPr>
+        </p:nvSpPr>
+        <p:spPr>
+          <a:xfrm>
+            <a:off x="928688" y="1301750"/>
+            <a:ext cx="14544674" cy="625401"/>
+          </a:xfrm>
+        </p:spPr>
+        <p:txBody>
+          <a:bodyPr/>
+          <a:lstStyle/>
+          <a:p>
+            <a:r>
+              <a:rPr lang="pt-BR" sz="3000" b="1" dirty="0">
+                <a:solidFill>
+                  <a:schemeClr val="accent1">
+                    <a:lumMod val="75000"/>
+                  </a:schemeClr>
+                </a:solidFill>
+                <a:latin typeface="Arial" panose="020B0604020202020204" pitchFamily="34" charset="0"/>
+                <a:cs typeface="Arial" panose="020B0604020202020204" pitchFamily="34" charset="0"/>
+              </a:rPr>
+              <a:t>Principais insights – Temporada 2025</a:t>
+            </a:r>
+          </a:p>
+        </p:txBody>
+      </p:sp>
+      <p:sp>
+        <p:nvSpPr>
+          <p:cNvPr id="20" name="Espaço Reservado para Texto 1">
+            <a:extLst>
+              <a:ext uri="{FF2B5EF4-FFF2-40B4-BE49-F238E27FC236}">
+                <a16:creationId xmlns:a16="http://schemas.microsoft.com/office/drawing/2014/main" id="{CEA9DCD1-8701-DC18-FD80-B8A8FEE276D2}"/>
+              </a:ext>
+            </a:extLst>
+          </p:cNvPr>
+          <p:cNvSpPr txBox="1">
+            <a:spLocks/>
+          </p:cNvSpPr>
+          <p:nvPr/>
+        </p:nvSpPr>
+        <p:spPr>
+          <a:xfrm>
+            <a:off x="8401050" y="2156660"/>
+            <a:ext cx="7683956" cy="1254198"/>
+          </a:xfrm>
+          <a:prstGeom prst="rect">
+            <a:avLst/>
+          </a:prstGeom>
+          <a:solidFill>
+            <a:schemeClr val="bg2"/>
+          </a:solidFill>
+          <a:effectLst>
+            <a:outerShdw blurRad="215900" dist="114300" dir="2700000" algn="tl" rotWithShape="0">
+              <a:prstClr val="black">
+                <a:alpha val="30000"/>
+              </a:prstClr>
+            </a:outerShdw>
+            <a:softEdge rad="38100"/>
+          </a:effectLst>
+        </p:spPr>
+        <p:txBody>
+          <a:bodyPr lIns="72000" tIns="72000" rIns="72000" bIns="72000"/>
+          <a:lstStyle>
+            <a:lvl1pPr marL="0" indent="0" algn="l" defTabSz="1280160" rtl="0" eaLnBrk="1" latinLnBrk="0" hangingPunct="1">
+              <a:lnSpc>
+                <a:spcPct val="100000"/>
+              </a:lnSpc>
+              <a:spcBef>
+                <a:spcPts val="0"/>
+              </a:spcBef>
+              <a:spcAft>
+                <a:spcPts val="1200"/>
+              </a:spcAft>
+              <a:buFont typeface="Arial" panose="020B0604020202020204" pitchFamily="34" charset="0"/>
+              <a:buNone/>
+              <a:defRPr sz="1800" kern="1200">
+                <a:solidFill>
+                  <a:schemeClr val="tx2">
+                    <a:lumMod val="75000"/>
+                  </a:schemeClr>
+                </a:solidFill>
+                <a:latin typeface="+mn-lt"/>
+                <a:ea typeface="+mn-ea"/>
+                <a:cs typeface="+mn-cs"/>
+              </a:defRPr>
+            </a:lvl1pPr>
+            <a:lvl2pPr marL="640080" indent="0" algn="l" defTabSz="1280160" rtl="0" eaLnBrk="1" latinLnBrk="0" hangingPunct="1">
+              <a:lnSpc>
+                <a:spcPct val="90000"/>
+              </a:lnSpc>
+              <a:spcBef>
+                <a:spcPts val="700"/>
+              </a:spcBef>
+              <a:buFont typeface="Arial" panose="020B0604020202020204" pitchFamily="34" charset="0"/>
+              <a:buNone/>
+              <a:defRPr sz="1400" kern="1200">
+                <a:solidFill>
+                  <a:schemeClr val="tx1"/>
+                </a:solidFill>
+                <a:latin typeface="+mn-lt"/>
+                <a:ea typeface="+mn-ea"/>
+                <a:cs typeface="+mn-cs"/>
+              </a:defRPr>
+            </a:lvl2pPr>
+            <a:lvl3pPr marL="1280160" indent="0" algn="l" defTabSz="1280160" rtl="0" eaLnBrk="1" latinLnBrk="0" hangingPunct="1">
+              <a:lnSpc>
+                <a:spcPct val="90000"/>
+              </a:lnSpc>
+              <a:spcBef>
+                <a:spcPts val="700"/>
+              </a:spcBef>
+              <a:buFont typeface="Arial" panose="020B0604020202020204" pitchFamily="34" charset="0"/>
+              <a:buNone/>
+              <a:defRPr sz="1400" kern="1200">
+                <a:solidFill>
+                  <a:schemeClr val="tx1"/>
+                </a:solidFill>
+                <a:latin typeface="+mn-lt"/>
+                <a:ea typeface="+mn-ea"/>
+                <a:cs typeface="+mn-cs"/>
+              </a:defRPr>
+            </a:lvl3pPr>
+            <a:lvl4pPr marL="1920240" indent="0" algn="l" defTabSz="1280160" rtl="0" eaLnBrk="1" latinLnBrk="0" hangingPunct="1">
+              <a:lnSpc>
+                <a:spcPct val="90000"/>
+              </a:lnSpc>
+              <a:spcBef>
+                <a:spcPts val="700"/>
+              </a:spcBef>
+              <a:buFont typeface="Arial" panose="020B0604020202020204" pitchFamily="34" charset="0"/>
+              <a:buNone/>
+              <a:defRPr sz="1400" kern="1200">
+                <a:solidFill>
+                  <a:schemeClr val="tx1"/>
+                </a:solidFill>
+                <a:latin typeface="+mn-lt"/>
+                <a:ea typeface="+mn-ea"/>
+                <a:cs typeface="+mn-cs"/>
+              </a:defRPr>
+            </a:lvl4pPr>
+            <a:lvl5pPr marL="2560320" indent="0" algn="l" defTabSz="1280160" rtl="0" eaLnBrk="1" latinLnBrk="0" hangingPunct="1">
+              <a:lnSpc>
+                <a:spcPct val="90000"/>
+              </a:lnSpc>
+              <a:spcBef>
+                <a:spcPts val="700"/>
+              </a:spcBef>
+              <a:buFont typeface="Arial" panose="020B0604020202020204" pitchFamily="34" charset="0"/>
+              <a:buNone/>
+              <a:defRPr sz="1400" kern="1200">
+                <a:solidFill>
+                  <a:schemeClr val="tx1"/>
+                </a:solidFill>
+                <a:latin typeface="+mn-lt"/>
+                <a:ea typeface="+mn-ea"/>
+                <a:cs typeface="+mn-cs"/>
+              </a:defRPr>
+            </a:lvl5pPr>
+            <a:lvl6pPr marL="3520440" indent="-320040" algn="l" defTabSz="1280160" rtl="0" eaLnBrk="1" latinLnBrk="0" hangingPunct="1">
+              <a:lnSpc>
+                <a:spcPct val="90000"/>
+              </a:lnSpc>
+              <a:spcBef>
+                <a:spcPts val="700"/>
+              </a:spcBef>
+              <a:buFont typeface="Arial" panose="020B0604020202020204" pitchFamily="34" charset="0"/>
+              <a:buChar char="•"/>
+              <a:defRPr sz="2520" kern="1200">
+                <a:solidFill>
+                  <a:schemeClr val="tx1"/>
+                </a:solidFill>
+                <a:latin typeface="+mn-lt"/>
+                <a:ea typeface="+mn-ea"/>
+                <a:cs typeface="+mn-cs"/>
+              </a:defRPr>
+            </a:lvl6pPr>
+            <a:lvl7pPr marL="4160520" indent="-320040" algn="l" defTabSz="1280160" rtl="0" eaLnBrk="1" latinLnBrk="0" hangingPunct="1">
+              <a:lnSpc>
+                <a:spcPct val="90000"/>
+              </a:lnSpc>
+              <a:spcBef>
+                <a:spcPts val="700"/>
+              </a:spcBef>
+              <a:buFont typeface="Arial" panose="020B0604020202020204" pitchFamily="34" charset="0"/>
+              <a:buChar char="•"/>
+              <a:defRPr sz="2520" kern="1200">
+                <a:solidFill>
+                  <a:schemeClr val="tx1"/>
+                </a:solidFill>
+                <a:latin typeface="+mn-lt"/>
+                <a:ea typeface="+mn-ea"/>
+                <a:cs typeface="+mn-cs"/>
+              </a:defRPr>
+            </a:lvl7pPr>
+            <a:lvl8pPr marL="4800600" indent="-320040" algn="l" defTabSz="1280160" rtl="0" eaLnBrk="1" latinLnBrk="0" hangingPunct="1">
+              <a:lnSpc>
+                <a:spcPct val="90000"/>
+              </a:lnSpc>
+              <a:spcBef>
+                <a:spcPts val="700"/>
+              </a:spcBef>
+              <a:buFont typeface="Arial" panose="020B0604020202020204" pitchFamily="34" charset="0"/>
+              <a:buChar char="•"/>
+              <a:defRPr sz="2520" kern="1200">
+                <a:solidFill>
+                  <a:schemeClr val="tx1"/>
+                </a:solidFill>
+                <a:latin typeface="+mn-lt"/>
+                <a:ea typeface="+mn-ea"/>
+                <a:cs typeface="+mn-cs"/>
+              </a:defRPr>
+            </a:lvl8pPr>
+            <a:lvl9pPr marL="5440680" indent="-320040" algn="l" defTabSz="1280160" rtl="0" eaLnBrk="1" latinLnBrk="0" hangingPunct="1">
+              <a:lnSpc>
+                <a:spcPct val="90000"/>
+              </a:lnSpc>
+              <a:spcBef>
+                <a:spcPts val="700"/>
+              </a:spcBef>
+              <a:buFont typeface="Arial" panose="020B0604020202020204" pitchFamily="34" charset="0"/>
+              <a:buChar char="•"/>
+              <a:defRPr sz="2520" kern="1200">
+                <a:solidFill>
+                  <a:schemeClr val="tx1"/>
+                </a:solidFill>
+                <a:latin typeface="+mn-lt"/>
+                <a:ea typeface="+mn-ea"/>
+                <a:cs typeface="+mn-cs"/>
+              </a:defRPr>
+            </a:lvl9pPr>
+          </a:lstStyle>
+          <a:p>
+            <a:endParaRPr lang="pt-BR" sz="1600" b="1" dirty="0">
+              <a:solidFill>
+                <a:schemeClr val="accent1">
+                  <a:lumMod val="75000"/>
+                </a:schemeClr>
+              </a:solidFill>
+              <a:latin typeface="Arial" panose="020B0604020202020204" pitchFamily="34" charset="0"/>
+              <a:cs typeface="Arial" panose="020B0604020202020204" pitchFamily="34" charset="0"/>
+            </a:endParaRPr>
+          </a:p>
+        </p:txBody>
+      </p:sp>
+      <p:sp>
+        <p:nvSpPr>
+          <p:cNvPr id="22" name="Espaço Reservado para Texto 1">
+            <a:extLst>
+              <a:ext uri="{FF2B5EF4-FFF2-40B4-BE49-F238E27FC236}">
+                <a16:creationId xmlns:a16="http://schemas.microsoft.com/office/drawing/2014/main" id="{546106AF-6736-EB8A-0303-2A64AEA157EB}"/>
+              </a:ext>
+            </a:extLst>
+          </p:cNvPr>
+          <p:cNvSpPr txBox="1">
+            <a:spLocks/>
+          </p:cNvSpPr>
+          <p:nvPr/>
+        </p:nvSpPr>
+        <p:spPr>
+          <a:xfrm>
+            <a:off x="8589736" y="2330551"/>
+            <a:ext cx="7324714" cy="793649"/>
+          </a:xfrm>
+          <a:prstGeom prst="rect">
+            <a:avLst/>
+          </a:prstGeom>
+          <a:noFill/>
+        </p:spPr>
+        <p:txBody>
+          <a:bodyPr lIns="72000" tIns="72000" rIns="72000" bIns="72000"/>
+          <a:lstStyle>
+            <a:lvl1pPr marL="0" indent="0" algn="l" defTabSz="1280160" rtl="0" eaLnBrk="1" latinLnBrk="0" hangingPunct="1">
+              <a:lnSpc>
+                <a:spcPct val="100000"/>
+              </a:lnSpc>
+              <a:spcBef>
+                <a:spcPts val="0"/>
+              </a:spcBef>
+              <a:spcAft>
+                <a:spcPts val="1200"/>
+              </a:spcAft>
+              <a:buFont typeface="Arial" panose="020B0604020202020204" pitchFamily="34" charset="0"/>
+              <a:buNone/>
+              <a:defRPr sz="1800" kern="1200">
+                <a:solidFill>
+                  <a:schemeClr val="tx2">
+                    <a:lumMod val="75000"/>
+                  </a:schemeClr>
+                </a:solidFill>
+                <a:latin typeface="+mn-lt"/>
+                <a:ea typeface="+mn-ea"/>
+                <a:cs typeface="+mn-cs"/>
+              </a:defRPr>
+            </a:lvl1pPr>
+            <a:lvl2pPr marL="640080" indent="0" algn="l" defTabSz="1280160" rtl="0" eaLnBrk="1" latinLnBrk="0" hangingPunct="1">
+              <a:lnSpc>
+                <a:spcPct val="90000"/>
+              </a:lnSpc>
+              <a:spcBef>
+                <a:spcPts val="700"/>
+              </a:spcBef>
+              <a:buFont typeface="Arial" panose="020B0604020202020204" pitchFamily="34" charset="0"/>
+              <a:buNone/>
+              <a:defRPr sz="1400" kern="1200">
+                <a:solidFill>
+                  <a:schemeClr val="tx1"/>
+                </a:solidFill>
+                <a:latin typeface="+mn-lt"/>
+                <a:ea typeface="+mn-ea"/>
+                <a:cs typeface="+mn-cs"/>
+              </a:defRPr>
+            </a:lvl2pPr>
+            <a:lvl3pPr marL="1280160" indent="0" algn="l" defTabSz="1280160" rtl="0" eaLnBrk="1" latinLnBrk="0" hangingPunct="1">
+              <a:lnSpc>
+                <a:spcPct val="90000"/>
+              </a:lnSpc>
+              <a:spcBef>
+                <a:spcPts val="700"/>
+              </a:spcBef>
+              <a:buFont typeface="Arial" panose="020B0604020202020204" pitchFamily="34" charset="0"/>
+              <a:buNone/>
+              <a:defRPr sz="1400" kern="1200">
+                <a:solidFill>
+                  <a:schemeClr val="tx1"/>
+                </a:solidFill>
+                <a:latin typeface="+mn-lt"/>
+                <a:ea typeface="+mn-ea"/>
+                <a:cs typeface="+mn-cs"/>
+              </a:defRPr>
+            </a:lvl3pPr>
+            <a:lvl4pPr marL="1920240" indent="0" algn="l" defTabSz="1280160" rtl="0" eaLnBrk="1" latinLnBrk="0" hangingPunct="1">
+              <a:lnSpc>
+                <a:spcPct val="90000"/>
+              </a:lnSpc>
+              <a:spcBef>
+                <a:spcPts val="700"/>
+              </a:spcBef>
+              <a:buFont typeface="Arial" panose="020B0604020202020204" pitchFamily="34" charset="0"/>
+              <a:buNone/>
+              <a:defRPr sz="1400" kern="1200">
+                <a:solidFill>
+                  <a:schemeClr val="tx1"/>
+                </a:solidFill>
+                <a:latin typeface="+mn-lt"/>
+                <a:ea typeface="+mn-ea"/>
+                <a:cs typeface="+mn-cs"/>
+              </a:defRPr>
+            </a:lvl4pPr>
+            <a:lvl5pPr marL="2560320" indent="0" algn="l" defTabSz="1280160" rtl="0" eaLnBrk="1" latinLnBrk="0" hangingPunct="1">
+              <a:lnSpc>
+                <a:spcPct val="90000"/>
+              </a:lnSpc>
+              <a:spcBef>
+                <a:spcPts val="700"/>
+              </a:spcBef>
+              <a:buFont typeface="Arial" panose="020B0604020202020204" pitchFamily="34" charset="0"/>
+              <a:buNone/>
+              <a:defRPr sz="1400" kern="1200">
+                <a:solidFill>
+                  <a:schemeClr val="tx1"/>
+                </a:solidFill>
+                <a:latin typeface="+mn-lt"/>
+                <a:ea typeface="+mn-ea"/>
+                <a:cs typeface="+mn-cs"/>
+              </a:defRPr>
+            </a:lvl5pPr>
+            <a:lvl6pPr marL="3520440" indent="-320040" algn="l" defTabSz="1280160" rtl="0" eaLnBrk="1" latinLnBrk="0" hangingPunct="1">
+              <a:lnSpc>
+                <a:spcPct val="90000"/>
+              </a:lnSpc>
+              <a:spcBef>
+                <a:spcPts val="700"/>
+              </a:spcBef>
+              <a:buFont typeface="Arial" panose="020B0604020202020204" pitchFamily="34" charset="0"/>
+              <a:buChar char="•"/>
+              <a:defRPr sz="2520" kern="1200">
+                <a:solidFill>
+                  <a:schemeClr val="tx1"/>
+                </a:solidFill>
+                <a:latin typeface="+mn-lt"/>
+                <a:ea typeface="+mn-ea"/>
+                <a:cs typeface="+mn-cs"/>
+              </a:defRPr>
+            </a:lvl6pPr>
+            <a:lvl7pPr marL="4160520" indent="-320040" algn="l" defTabSz="1280160" rtl="0" eaLnBrk="1" latinLnBrk="0" hangingPunct="1">
+              <a:lnSpc>
+                <a:spcPct val="90000"/>
+              </a:lnSpc>
+              <a:spcBef>
+                <a:spcPts val="700"/>
+              </a:spcBef>
+              <a:buFont typeface="Arial" panose="020B0604020202020204" pitchFamily="34" charset="0"/>
+              <a:buChar char="•"/>
+              <a:defRPr sz="2520" kern="1200">
+                <a:solidFill>
+                  <a:schemeClr val="tx1"/>
+                </a:solidFill>
+                <a:latin typeface="+mn-lt"/>
+                <a:ea typeface="+mn-ea"/>
+                <a:cs typeface="+mn-cs"/>
+              </a:defRPr>
+            </a:lvl7pPr>
+            <a:lvl8pPr marL="4800600" indent="-320040" algn="l" defTabSz="1280160" rtl="0" eaLnBrk="1" latinLnBrk="0" hangingPunct="1">
+              <a:lnSpc>
+                <a:spcPct val="90000"/>
+              </a:lnSpc>
+              <a:spcBef>
+                <a:spcPts val="700"/>
+              </a:spcBef>
+              <a:buFont typeface="Arial" panose="020B0604020202020204" pitchFamily="34" charset="0"/>
+              <a:buChar char="•"/>
+              <a:defRPr sz="2520" kern="1200">
+                <a:solidFill>
+                  <a:schemeClr val="tx1"/>
+                </a:solidFill>
+                <a:latin typeface="+mn-lt"/>
+                <a:ea typeface="+mn-ea"/>
+                <a:cs typeface="+mn-cs"/>
+              </a:defRPr>
+            </a:lvl8pPr>
+            <a:lvl9pPr marL="5440680" indent="-320040" algn="l" defTabSz="1280160" rtl="0" eaLnBrk="1" latinLnBrk="0" hangingPunct="1">
+              <a:lnSpc>
+                <a:spcPct val="90000"/>
+              </a:lnSpc>
+              <a:spcBef>
+                <a:spcPts val="700"/>
+              </a:spcBef>
+              <a:buFont typeface="Arial" panose="020B0604020202020204" pitchFamily="34" charset="0"/>
+              <a:buChar char="•"/>
+              <a:defRPr sz="2520" kern="1200">
+                <a:solidFill>
+                  <a:schemeClr val="tx1"/>
+                </a:solidFill>
+                <a:latin typeface="+mn-lt"/>
+                <a:ea typeface="+mn-ea"/>
+                <a:cs typeface="+mn-cs"/>
+              </a:defRPr>
+            </a:lvl9pPr>
+          </a:lstStyle>
+          <a:p>
+            <a:pPr algn="ctr"/>
+            <a:r>
+              <a:rPr lang="pt-BR" sz="2800" b="1" dirty="0">
+                <a:solidFill>
+                  <a:srgbClr val="C00000"/>
+                </a:solidFill>
+                <a:latin typeface="Arial" panose="020B0604020202020204" pitchFamily="34" charset="0"/>
+                <a:cs typeface="Arial" panose="020B0604020202020204" pitchFamily="34" charset="0"/>
+              </a:rPr>
+              <a:t>Sport - 83,49%</a:t>
+            </a:r>
+          </a:p>
+          <a:p>
+            <a:pPr algn="ctr"/>
+            <a:r>
+              <a:rPr lang="pt-BR" sz="1200" dirty="0">
+                <a:solidFill>
+                  <a:schemeClr val="tx1"/>
+                </a:solidFill>
+                <a:latin typeface="Arial" panose="020B0604020202020204" pitchFamily="34" charset="0"/>
+                <a:cs typeface="Arial" panose="020B0604020202020204" pitchFamily="34" charset="0"/>
+              </a:rPr>
+              <a:t>Apresenta a média de risco previsto entre os clubes analisados.</a:t>
+            </a:r>
+          </a:p>
+        </p:txBody>
+      </p:sp>
+      <p:sp>
+        <p:nvSpPr>
+          <p:cNvPr id="29" name="Espaço Reservado para Texto 1">
+            <a:extLst>
+              <a:ext uri="{FF2B5EF4-FFF2-40B4-BE49-F238E27FC236}">
+                <a16:creationId xmlns:a16="http://schemas.microsoft.com/office/drawing/2014/main" id="{57CC3FDE-824A-3037-27DE-C838FA5FDFAF}"/>
+              </a:ext>
+            </a:extLst>
+          </p:cNvPr>
+          <p:cNvSpPr txBox="1">
+            <a:spLocks/>
+          </p:cNvSpPr>
+          <p:nvPr/>
+        </p:nvSpPr>
+        <p:spPr>
+          <a:xfrm>
+            <a:off x="8401050" y="3757109"/>
+            <a:ext cx="7683956" cy="1254198"/>
+          </a:xfrm>
+          <a:prstGeom prst="rect">
+            <a:avLst/>
+          </a:prstGeom>
+          <a:solidFill>
+            <a:schemeClr val="bg2"/>
+          </a:solidFill>
+          <a:effectLst>
+            <a:outerShdw blurRad="215900" dist="114300" dir="2700000" algn="tl" rotWithShape="0">
+              <a:prstClr val="black">
+                <a:alpha val="30000"/>
+              </a:prstClr>
+            </a:outerShdw>
+            <a:softEdge rad="38100"/>
+          </a:effectLst>
+        </p:spPr>
+        <p:txBody>
+          <a:bodyPr lIns="72000" tIns="72000" rIns="72000" bIns="72000"/>
+          <a:lstStyle>
+            <a:lvl1pPr marL="0" indent="0" algn="l" defTabSz="1280160" rtl="0" eaLnBrk="1" latinLnBrk="0" hangingPunct="1">
+              <a:lnSpc>
+                <a:spcPct val="100000"/>
+              </a:lnSpc>
+              <a:spcBef>
+                <a:spcPts val="0"/>
+              </a:spcBef>
+              <a:spcAft>
+                <a:spcPts val="1200"/>
+              </a:spcAft>
+              <a:buFont typeface="Arial" panose="020B0604020202020204" pitchFamily="34" charset="0"/>
+              <a:buNone/>
+              <a:defRPr sz="1800" kern="1200">
+                <a:solidFill>
+                  <a:schemeClr val="tx2">
+                    <a:lumMod val="75000"/>
+                  </a:schemeClr>
+                </a:solidFill>
+                <a:latin typeface="+mn-lt"/>
+                <a:ea typeface="+mn-ea"/>
+                <a:cs typeface="+mn-cs"/>
+              </a:defRPr>
+            </a:lvl1pPr>
+            <a:lvl2pPr marL="640080" indent="0" algn="l" defTabSz="1280160" rtl="0" eaLnBrk="1" latinLnBrk="0" hangingPunct="1">
+              <a:lnSpc>
+                <a:spcPct val="90000"/>
+              </a:lnSpc>
+              <a:spcBef>
+                <a:spcPts val="700"/>
+              </a:spcBef>
+              <a:buFont typeface="Arial" panose="020B0604020202020204" pitchFamily="34" charset="0"/>
+              <a:buNone/>
+              <a:defRPr sz="1400" kern="1200">
+                <a:solidFill>
+                  <a:schemeClr val="tx1"/>
+                </a:solidFill>
+                <a:latin typeface="+mn-lt"/>
+                <a:ea typeface="+mn-ea"/>
+                <a:cs typeface="+mn-cs"/>
+              </a:defRPr>
+            </a:lvl2pPr>
+            <a:lvl3pPr marL="1280160" indent="0" algn="l" defTabSz="1280160" rtl="0" eaLnBrk="1" latinLnBrk="0" hangingPunct="1">
+              <a:lnSpc>
+                <a:spcPct val="90000"/>
+              </a:lnSpc>
+              <a:spcBef>
+                <a:spcPts val="700"/>
+              </a:spcBef>
+              <a:buFont typeface="Arial" panose="020B0604020202020204" pitchFamily="34" charset="0"/>
+              <a:buNone/>
+              <a:defRPr sz="1400" kern="1200">
+                <a:solidFill>
+                  <a:schemeClr val="tx1"/>
+                </a:solidFill>
+                <a:latin typeface="+mn-lt"/>
+                <a:ea typeface="+mn-ea"/>
+                <a:cs typeface="+mn-cs"/>
+              </a:defRPr>
+            </a:lvl3pPr>
+            <a:lvl4pPr marL="1920240" indent="0" algn="l" defTabSz="1280160" rtl="0" eaLnBrk="1" latinLnBrk="0" hangingPunct="1">
+              <a:lnSpc>
+                <a:spcPct val="90000"/>
+              </a:lnSpc>
+              <a:spcBef>
+                <a:spcPts val="700"/>
+              </a:spcBef>
+              <a:buFont typeface="Arial" panose="020B0604020202020204" pitchFamily="34" charset="0"/>
+              <a:buNone/>
+              <a:defRPr sz="1400" kern="1200">
+                <a:solidFill>
+                  <a:schemeClr val="tx1"/>
+                </a:solidFill>
+                <a:latin typeface="+mn-lt"/>
+                <a:ea typeface="+mn-ea"/>
+                <a:cs typeface="+mn-cs"/>
+              </a:defRPr>
+            </a:lvl4pPr>
+            <a:lvl5pPr marL="2560320" indent="0" algn="l" defTabSz="1280160" rtl="0" eaLnBrk="1" latinLnBrk="0" hangingPunct="1">
+              <a:lnSpc>
+                <a:spcPct val="90000"/>
+              </a:lnSpc>
+              <a:spcBef>
+                <a:spcPts val="700"/>
+              </a:spcBef>
+              <a:buFont typeface="Arial" panose="020B0604020202020204" pitchFamily="34" charset="0"/>
+              <a:buNone/>
+              <a:defRPr sz="1400" kern="1200">
+                <a:solidFill>
+                  <a:schemeClr val="tx1"/>
+                </a:solidFill>
+                <a:latin typeface="+mn-lt"/>
+                <a:ea typeface="+mn-ea"/>
+                <a:cs typeface="+mn-cs"/>
+              </a:defRPr>
+            </a:lvl5pPr>
+            <a:lvl6pPr marL="3520440" indent="-320040" algn="l" defTabSz="1280160" rtl="0" eaLnBrk="1" latinLnBrk="0" hangingPunct="1">
+              <a:lnSpc>
+                <a:spcPct val="90000"/>
+              </a:lnSpc>
+              <a:spcBef>
+                <a:spcPts val="700"/>
+              </a:spcBef>
+              <a:buFont typeface="Arial" panose="020B0604020202020204" pitchFamily="34" charset="0"/>
+              <a:buChar char="•"/>
+              <a:defRPr sz="2520" kern="1200">
+                <a:solidFill>
+                  <a:schemeClr val="tx1"/>
+                </a:solidFill>
+                <a:latin typeface="+mn-lt"/>
+                <a:ea typeface="+mn-ea"/>
+                <a:cs typeface="+mn-cs"/>
+              </a:defRPr>
+            </a:lvl6pPr>
+            <a:lvl7pPr marL="4160520" indent="-320040" algn="l" defTabSz="1280160" rtl="0" eaLnBrk="1" latinLnBrk="0" hangingPunct="1">
+              <a:lnSpc>
+                <a:spcPct val="90000"/>
+              </a:lnSpc>
+              <a:spcBef>
+                <a:spcPts val="700"/>
+              </a:spcBef>
+              <a:buFont typeface="Arial" panose="020B0604020202020204" pitchFamily="34" charset="0"/>
+              <a:buChar char="•"/>
+              <a:defRPr sz="2520" kern="1200">
+                <a:solidFill>
+                  <a:schemeClr val="tx1"/>
+                </a:solidFill>
+                <a:latin typeface="+mn-lt"/>
+                <a:ea typeface="+mn-ea"/>
+                <a:cs typeface="+mn-cs"/>
+              </a:defRPr>
+            </a:lvl7pPr>
+            <a:lvl8pPr marL="4800600" indent="-320040" algn="l" defTabSz="1280160" rtl="0" eaLnBrk="1" latinLnBrk="0" hangingPunct="1">
+              <a:lnSpc>
+                <a:spcPct val="90000"/>
+              </a:lnSpc>
+              <a:spcBef>
+                <a:spcPts val="700"/>
+              </a:spcBef>
+              <a:buFont typeface="Arial" panose="020B0604020202020204" pitchFamily="34" charset="0"/>
+              <a:buChar char="•"/>
+              <a:defRPr sz="2520" kern="1200">
+                <a:solidFill>
+                  <a:schemeClr val="tx1"/>
+                </a:solidFill>
+                <a:latin typeface="+mn-lt"/>
+                <a:ea typeface="+mn-ea"/>
+                <a:cs typeface="+mn-cs"/>
+              </a:defRPr>
+            </a:lvl8pPr>
+            <a:lvl9pPr marL="5440680" indent="-320040" algn="l" defTabSz="1280160" rtl="0" eaLnBrk="1" latinLnBrk="0" hangingPunct="1">
+              <a:lnSpc>
+                <a:spcPct val="90000"/>
+              </a:lnSpc>
+              <a:spcBef>
+                <a:spcPts val="700"/>
+              </a:spcBef>
+              <a:buFont typeface="Arial" panose="020B0604020202020204" pitchFamily="34" charset="0"/>
+              <a:buChar char="•"/>
+              <a:defRPr sz="2520" kern="1200">
+                <a:solidFill>
+                  <a:schemeClr val="tx1"/>
+                </a:solidFill>
+                <a:latin typeface="+mn-lt"/>
+                <a:ea typeface="+mn-ea"/>
+                <a:cs typeface="+mn-cs"/>
+              </a:defRPr>
+            </a:lvl9pPr>
+          </a:lstStyle>
+          <a:p>
+            <a:endParaRPr lang="pt-BR" sz="1600" b="1" dirty="0">
+              <a:solidFill>
+                <a:schemeClr val="accent1">
+                  <a:lumMod val="75000"/>
+                </a:schemeClr>
+              </a:solidFill>
+              <a:latin typeface="Arial" panose="020B0604020202020204" pitchFamily="34" charset="0"/>
+              <a:cs typeface="Arial" panose="020B0604020202020204" pitchFamily="34" charset="0"/>
+            </a:endParaRPr>
+          </a:p>
+        </p:txBody>
+      </p:sp>
+      <p:sp>
+        <p:nvSpPr>
+          <p:cNvPr id="31" name="Espaço Reservado para Texto 1">
+            <a:extLst>
+              <a:ext uri="{FF2B5EF4-FFF2-40B4-BE49-F238E27FC236}">
+                <a16:creationId xmlns:a16="http://schemas.microsoft.com/office/drawing/2014/main" id="{4A0D9C4D-F27D-BA70-45F0-396B418C87A2}"/>
+              </a:ext>
+            </a:extLst>
+          </p:cNvPr>
+          <p:cNvSpPr txBox="1">
+            <a:spLocks/>
+          </p:cNvSpPr>
+          <p:nvPr/>
+        </p:nvSpPr>
+        <p:spPr>
+          <a:xfrm>
+            <a:off x="8589736" y="3931000"/>
+            <a:ext cx="7324714" cy="793649"/>
+          </a:xfrm>
+          <a:prstGeom prst="rect">
+            <a:avLst/>
+          </a:prstGeom>
+          <a:noFill/>
+        </p:spPr>
+        <p:txBody>
+          <a:bodyPr lIns="72000" tIns="72000" rIns="72000" bIns="72000"/>
+          <a:lstStyle>
+            <a:lvl1pPr marL="0" indent="0" algn="l" defTabSz="1280160" rtl="0" eaLnBrk="1" latinLnBrk="0" hangingPunct="1">
+              <a:lnSpc>
+                <a:spcPct val="100000"/>
+              </a:lnSpc>
+              <a:spcBef>
+                <a:spcPts val="0"/>
+              </a:spcBef>
+              <a:spcAft>
+                <a:spcPts val="1200"/>
+              </a:spcAft>
+              <a:buFont typeface="Arial" panose="020B0604020202020204" pitchFamily="34" charset="0"/>
+              <a:buNone/>
+              <a:defRPr sz="1800" kern="1200">
+                <a:solidFill>
+                  <a:schemeClr val="tx2">
+                    <a:lumMod val="75000"/>
+                  </a:schemeClr>
+                </a:solidFill>
+                <a:latin typeface="+mn-lt"/>
+                <a:ea typeface="+mn-ea"/>
+                <a:cs typeface="+mn-cs"/>
+              </a:defRPr>
+            </a:lvl1pPr>
+            <a:lvl2pPr marL="640080" indent="0" algn="l" defTabSz="1280160" rtl="0" eaLnBrk="1" latinLnBrk="0" hangingPunct="1">
+              <a:lnSpc>
+                <a:spcPct val="90000"/>
+              </a:lnSpc>
+              <a:spcBef>
+                <a:spcPts val="700"/>
+              </a:spcBef>
+              <a:buFont typeface="Arial" panose="020B0604020202020204" pitchFamily="34" charset="0"/>
+              <a:buNone/>
+              <a:defRPr sz="1400" kern="1200">
+                <a:solidFill>
+                  <a:schemeClr val="tx1"/>
+                </a:solidFill>
+                <a:latin typeface="+mn-lt"/>
+                <a:ea typeface="+mn-ea"/>
+                <a:cs typeface="+mn-cs"/>
+              </a:defRPr>
+            </a:lvl2pPr>
+            <a:lvl3pPr marL="1280160" indent="0" algn="l" defTabSz="1280160" rtl="0" eaLnBrk="1" latinLnBrk="0" hangingPunct="1">
+              <a:lnSpc>
+                <a:spcPct val="90000"/>
+              </a:lnSpc>
+              <a:spcBef>
+                <a:spcPts val="700"/>
+              </a:spcBef>
+              <a:buFont typeface="Arial" panose="020B0604020202020204" pitchFamily="34" charset="0"/>
+              <a:buNone/>
+              <a:defRPr sz="1400" kern="1200">
+                <a:solidFill>
+                  <a:schemeClr val="tx1"/>
+                </a:solidFill>
+                <a:latin typeface="+mn-lt"/>
+                <a:ea typeface="+mn-ea"/>
+                <a:cs typeface="+mn-cs"/>
+              </a:defRPr>
+            </a:lvl3pPr>
+            <a:lvl4pPr marL="1920240" indent="0" algn="l" defTabSz="1280160" rtl="0" eaLnBrk="1" latinLnBrk="0" hangingPunct="1">
+              <a:lnSpc>
+                <a:spcPct val="90000"/>
+              </a:lnSpc>
+              <a:spcBef>
+                <a:spcPts val="700"/>
+              </a:spcBef>
+              <a:buFont typeface="Arial" panose="020B0604020202020204" pitchFamily="34" charset="0"/>
+              <a:buNone/>
+              <a:defRPr sz="1400" kern="1200">
+                <a:solidFill>
+                  <a:schemeClr val="tx1"/>
+                </a:solidFill>
+                <a:latin typeface="+mn-lt"/>
+                <a:ea typeface="+mn-ea"/>
+                <a:cs typeface="+mn-cs"/>
+              </a:defRPr>
+            </a:lvl4pPr>
+            <a:lvl5pPr marL="2560320" indent="0" algn="l" defTabSz="1280160" rtl="0" eaLnBrk="1" latinLnBrk="0" hangingPunct="1">
+              <a:lnSpc>
+                <a:spcPct val="90000"/>
+              </a:lnSpc>
+              <a:spcBef>
+                <a:spcPts val="700"/>
+              </a:spcBef>
+              <a:buFont typeface="Arial" panose="020B0604020202020204" pitchFamily="34" charset="0"/>
+              <a:buNone/>
+              <a:defRPr sz="1400" kern="1200">
+                <a:solidFill>
+                  <a:schemeClr val="tx1"/>
+                </a:solidFill>
+                <a:latin typeface="+mn-lt"/>
+                <a:ea typeface="+mn-ea"/>
+                <a:cs typeface="+mn-cs"/>
+              </a:defRPr>
+            </a:lvl5pPr>
+            <a:lvl6pPr marL="3520440" indent="-320040" algn="l" defTabSz="1280160" rtl="0" eaLnBrk="1" latinLnBrk="0" hangingPunct="1">
+              <a:lnSpc>
+                <a:spcPct val="90000"/>
+              </a:lnSpc>
+              <a:spcBef>
+                <a:spcPts val="700"/>
+              </a:spcBef>
+              <a:buFont typeface="Arial" panose="020B0604020202020204" pitchFamily="34" charset="0"/>
+              <a:buChar char="•"/>
+              <a:defRPr sz="2520" kern="1200">
+                <a:solidFill>
+                  <a:schemeClr val="tx1"/>
+                </a:solidFill>
+                <a:latin typeface="+mn-lt"/>
+                <a:ea typeface="+mn-ea"/>
+                <a:cs typeface="+mn-cs"/>
+              </a:defRPr>
+            </a:lvl6pPr>
+            <a:lvl7pPr marL="4160520" indent="-320040" algn="l" defTabSz="1280160" rtl="0" eaLnBrk="1" latinLnBrk="0" hangingPunct="1">
+              <a:lnSpc>
+                <a:spcPct val="90000"/>
+              </a:lnSpc>
+              <a:spcBef>
+                <a:spcPts val="700"/>
+              </a:spcBef>
+              <a:buFont typeface="Arial" panose="020B0604020202020204" pitchFamily="34" charset="0"/>
+              <a:buChar char="•"/>
+              <a:defRPr sz="2520" kern="1200">
+                <a:solidFill>
+                  <a:schemeClr val="tx1"/>
+                </a:solidFill>
+                <a:latin typeface="+mn-lt"/>
+                <a:ea typeface="+mn-ea"/>
+                <a:cs typeface="+mn-cs"/>
+              </a:defRPr>
+            </a:lvl7pPr>
+            <a:lvl8pPr marL="4800600" indent="-320040" algn="l" defTabSz="1280160" rtl="0" eaLnBrk="1" latinLnBrk="0" hangingPunct="1">
+              <a:lnSpc>
+                <a:spcPct val="90000"/>
+              </a:lnSpc>
+              <a:spcBef>
+                <a:spcPts val="700"/>
+              </a:spcBef>
+              <a:buFont typeface="Arial" panose="020B0604020202020204" pitchFamily="34" charset="0"/>
+              <a:buChar char="•"/>
+              <a:defRPr sz="2520" kern="1200">
+                <a:solidFill>
+                  <a:schemeClr val="tx1"/>
+                </a:solidFill>
+                <a:latin typeface="+mn-lt"/>
+                <a:ea typeface="+mn-ea"/>
+                <a:cs typeface="+mn-cs"/>
+              </a:defRPr>
+            </a:lvl8pPr>
+            <a:lvl9pPr marL="5440680" indent="-320040" algn="l" defTabSz="1280160" rtl="0" eaLnBrk="1" latinLnBrk="0" hangingPunct="1">
+              <a:lnSpc>
+                <a:spcPct val="90000"/>
+              </a:lnSpc>
+              <a:spcBef>
+                <a:spcPts val="700"/>
+              </a:spcBef>
+              <a:buFont typeface="Arial" panose="020B0604020202020204" pitchFamily="34" charset="0"/>
+              <a:buChar char="•"/>
+              <a:defRPr sz="2520" kern="1200">
+                <a:solidFill>
+                  <a:schemeClr val="tx1"/>
+                </a:solidFill>
+                <a:latin typeface="+mn-lt"/>
+                <a:ea typeface="+mn-ea"/>
+                <a:cs typeface="+mn-cs"/>
+              </a:defRPr>
+            </a:lvl9pPr>
+          </a:lstStyle>
+          <a:p>
+            <a:pPr algn="ctr"/>
+            <a:r>
+              <a:rPr lang="pt-BR" sz="2800" b="1" dirty="0">
+                <a:solidFill>
+                  <a:srgbClr val="00B050"/>
+                </a:solidFill>
+                <a:latin typeface="Arial" panose="020B0604020202020204" pitchFamily="34" charset="0"/>
+                <a:cs typeface="Arial" panose="020B0604020202020204" pitchFamily="34" charset="0"/>
+              </a:rPr>
+              <a:t>Flamengo - 21%</a:t>
+            </a:r>
+            <a:endParaRPr lang="pt-BR" sz="2800" dirty="0">
+              <a:solidFill>
+                <a:srgbClr val="00B050"/>
+              </a:solidFill>
+              <a:latin typeface="Arial" panose="020B0604020202020204" pitchFamily="34" charset="0"/>
+              <a:cs typeface="Arial" panose="020B0604020202020204" pitchFamily="34" charset="0"/>
+            </a:endParaRPr>
+          </a:p>
+          <a:p>
+            <a:pPr algn="ctr"/>
+            <a:r>
+              <a:rPr lang="pt-BR" sz="1200" dirty="0">
+                <a:solidFill>
+                  <a:schemeClr val="tx1"/>
+                </a:solidFill>
+                <a:latin typeface="Arial" panose="020B0604020202020204" pitchFamily="34" charset="0"/>
+                <a:cs typeface="Arial" panose="020B0604020202020204" pitchFamily="34" charset="0"/>
+              </a:rPr>
+              <a:t>Identifica o clube com menor risco previsto na temporada analisada.</a:t>
+            </a:r>
+          </a:p>
+        </p:txBody>
+      </p:sp>
+      <p:sp>
+        <p:nvSpPr>
+          <p:cNvPr id="40" name="Espaço Reservado para Texto 1">
+            <a:extLst>
+              <a:ext uri="{FF2B5EF4-FFF2-40B4-BE49-F238E27FC236}">
+                <a16:creationId xmlns:a16="http://schemas.microsoft.com/office/drawing/2014/main" id="{F158F3D1-4D42-F89D-E4FE-ADD597594433}"/>
+              </a:ext>
+            </a:extLst>
+          </p:cNvPr>
+          <p:cNvSpPr txBox="1">
+            <a:spLocks/>
+          </p:cNvSpPr>
+          <p:nvPr/>
+        </p:nvSpPr>
+        <p:spPr>
+          <a:xfrm>
+            <a:off x="8401050" y="5357558"/>
+            <a:ext cx="7683956" cy="2941892"/>
+          </a:xfrm>
+          <a:prstGeom prst="rect">
+            <a:avLst/>
+          </a:prstGeom>
+          <a:solidFill>
+            <a:schemeClr val="bg2"/>
+          </a:solidFill>
+          <a:effectLst>
+            <a:outerShdw blurRad="215900" dist="114300" dir="2700000" algn="tl" rotWithShape="0">
+              <a:prstClr val="black">
+                <a:alpha val="30000"/>
+              </a:prstClr>
+            </a:outerShdw>
+            <a:softEdge rad="38100"/>
+          </a:effectLst>
+        </p:spPr>
+        <p:txBody>
+          <a:bodyPr lIns="72000" tIns="72000" rIns="72000" bIns="72000"/>
+          <a:lstStyle>
+            <a:lvl1pPr marL="0" indent="0" algn="l" defTabSz="1280160" rtl="0" eaLnBrk="1" latinLnBrk="0" hangingPunct="1">
+              <a:lnSpc>
+                <a:spcPct val="100000"/>
+              </a:lnSpc>
+              <a:spcBef>
+                <a:spcPts val="0"/>
+              </a:spcBef>
+              <a:spcAft>
+                <a:spcPts val="1200"/>
+              </a:spcAft>
+              <a:buFont typeface="Arial" panose="020B0604020202020204" pitchFamily="34" charset="0"/>
+              <a:buNone/>
+              <a:defRPr sz="1800" kern="1200">
+                <a:solidFill>
+                  <a:schemeClr val="tx2">
+                    <a:lumMod val="75000"/>
+                  </a:schemeClr>
+                </a:solidFill>
+                <a:latin typeface="+mn-lt"/>
+                <a:ea typeface="+mn-ea"/>
+                <a:cs typeface="+mn-cs"/>
+              </a:defRPr>
+            </a:lvl1pPr>
+            <a:lvl2pPr marL="640080" indent="0" algn="l" defTabSz="1280160" rtl="0" eaLnBrk="1" latinLnBrk="0" hangingPunct="1">
+              <a:lnSpc>
+                <a:spcPct val="90000"/>
+              </a:lnSpc>
+              <a:spcBef>
+                <a:spcPts val="700"/>
+              </a:spcBef>
+              <a:buFont typeface="Arial" panose="020B0604020202020204" pitchFamily="34" charset="0"/>
+              <a:buNone/>
+              <a:defRPr sz="1400" kern="1200">
+                <a:solidFill>
+                  <a:schemeClr val="tx1"/>
+                </a:solidFill>
+                <a:latin typeface="+mn-lt"/>
+                <a:ea typeface="+mn-ea"/>
+                <a:cs typeface="+mn-cs"/>
+              </a:defRPr>
+            </a:lvl2pPr>
+            <a:lvl3pPr marL="1280160" indent="0" algn="l" defTabSz="1280160" rtl="0" eaLnBrk="1" latinLnBrk="0" hangingPunct="1">
+              <a:lnSpc>
+                <a:spcPct val="90000"/>
+              </a:lnSpc>
+              <a:spcBef>
+                <a:spcPts val="700"/>
+              </a:spcBef>
+              <a:buFont typeface="Arial" panose="020B0604020202020204" pitchFamily="34" charset="0"/>
+              <a:buNone/>
+              <a:defRPr sz="1400" kern="1200">
+                <a:solidFill>
+                  <a:schemeClr val="tx1"/>
+                </a:solidFill>
+                <a:latin typeface="+mn-lt"/>
+                <a:ea typeface="+mn-ea"/>
+                <a:cs typeface="+mn-cs"/>
+              </a:defRPr>
+            </a:lvl3pPr>
+            <a:lvl4pPr marL="1920240" indent="0" algn="l" defTabSz="1280160" rtl="0" eaLnBrk="1" latinLnBrk="0" hangingPunct="1">
+              <a:lnSpc>
+                <a:spcPct val="90000"/>
+              </a:lnSpc>
+              <a:spcBef>
+                <a:spcPts val="700"/>
+              </a:spcBef>
+              <a:buFont typeface="Arial" panose="020B0604020202020204" pitchFamily="34" charset="0"/>
+              <a:buNone/>
+              <a:defRPr sz="1400" kern="1200">
+                <a:solidFill>
+                  <a:schemeClr val="tx1"/>
+                </a:solidFill>
+                <a:latin typeface="+mn-lt"/>
+                <a:ea typeface="+mn-ea"/>
+                <a:cs typeface="+mn-cs"/>
+              </a:defRPr>
+            </a:lvl4pPr>
+            <a:lvl5pPr marL="2560320" indent="0" algn="l" defTabSz="1280160" rtl="0" eaLnBrk="1" latinLnBrk="0" hangingPunct="1">
+              <a:lnSpc>
+                <a:spcPct val="90000"/>
+              </a:lnSpc>
+              <a:spcBef>
+                <a:spcPts val="700"/>
+              </a:spcBef>
+              <a:buFont typeface="Arial" panose="020B0604020202020204" pitchFamily="34" charset="0"/>
+              <a:buNone/>
+              <a:defRPr sz="1400" kern="1200">
+                <a:solidFill>
+                  <a:schemeClr val="tx1"/>
+                </a:solidFill>
+                <a:latin typeface="+mn-lt"/>
+                <a:ea typeface="+mn-ea"/>
+                <a:cs typeface="+mn-cs"/>
+              </a:defRPr>
+            </a:lvl5pPr>
+            <a:lvl6pPr marL="3520440" indent="-320040" algn="l" defTabSz="1280160" rtl="0" eaLnBrk="1" latinLnBrk="0" hangingPunct="1">
+              <a:lnSpc>
+                <a:spcPct val="90000"/>
+              </a:lnSpc>
+              <a:spcBef>
+                <a:spcPts val="700"/>
+              </a:spcBef>
+              <a:buFont typeface="Arial" panose="020B0604020202020204" pitchFamily="34" charset="0"/>
+              <a:buChar char="•"/>
+              <a:defRPr sz="2520" kern="1200">
+                <a:solidFill>
+                  <a:schemeClr val="tx1"/>
+                </a:solidFill>
+                <a:latin typeface="+mn-lt"/>
+                <a:ea typeface="+mn-ea"/>
+                <a:cs typeface="+mn-cs"/>
+              </a:defRPr>
+            </a:lvl6pPr>
+            <a:lvl7pPr marL="4160520" indent="-320040" algn="l" defTabSz="1280160" rtl="0" eaLnBrk="1" latinLnBrk="0" hangingPunct="1">
+              <a:lnSpc>
+                <a:spcPct val="90000"/>
+              </a:lnSpc>
+              <a:spcBef>
+                <a:spcPts val="700"/>
+              </a:spcBef>
+              <a:buFont typeface="Arial" panose="020B0604020202020204" pitchFamily="34" charset="0"/>
+              <a:buChar char="•"/>
+              <a:defRPr sz="2520" kern="1200">
+                <a:solidFill>
+                  <a:schemeClr val="tx1"/>
+                </a:solidFill>
+                <a:latin typeface="+mn-lt"/>
+                <a:ea typeface="+mn-ea"/>
+                <a:cs typeface="+mn-cs"/>
+              </a:defRPr>
+            </a:lvl7pPr>
+            <a:lvl8pPr marL="4800600" indent="-320040" algn="l" defTabSz="1280160" rtl="0" eaLnBrk="1" latinLnBrk="0" hangingPunct="1">
+              <a:lnSpc>
+                <a:spcPct val="90000"/>
+              </a:lnSpc>
+              <a:spcBef>
+                <a:spcPts val="700"/>
+              </a:spcBef>
+              <a:buFont typeface="Arial" panose="020B0604020202020204" pitchFamily="34" charset="0"/>
+              <a:buChar char="•"/>
+              <a:defRPr sz="2520" kern="1200">
+                <a:solidFill>
+                  <a:schemeClr val="tx1"/>
+                </a:solidFill>
+                <a:latin typeface="+mn-lt"/>
+                <a:ea typeface="+mn-ea"/>
+                <a:cs typeface="+mn-cs"/>
+              </a:defRPr>
+            </a:lvl8pPr>
+            <a:lvl9pPr marL="5440680" indent="-320040" algn="l" defTabSz="1280160" rtl="0" eaLnBrk="1" latinLnBrk="0" hangingPunct="1">
+              <a:lnSpc>
+                <a:spcPct val="90000"/>
+              </a:lnSpc>
+              <a:spcBef>
+                <a:spcPts val="700"/>
+              </a:spcBef>
+              <a:buFont typeface="Arial" panose="020B0604020202020204" pitchFamily="34" charset="0"/>
+              <a:buChar char="•"/>
+              <a:defRPr sz="2520" kern="1200">
+                <a:solidFill>
+                  <a:schemeClr val="tx1"/>
+                </a:solidFill>
+                <a:latin typeface="+mn-lt"/>
+                <a:ea typeface="+mn-ea"/>
+                <a:cs typeface="+mn-cs"/>
+              </a:defRPr>
+            </a:lvl9pPr>
+          </a:lstStyle>
+          <a:p>
+            <a:endParaRPr lang="pt-BR" sz="1600" b="1" dirty="0">
+              <a:solidFill>
+                <a:schemeClr val="accent1">
+                  <a:lumMod val="75000"/>
+                </a:schemeClr>
+              </a:solidFill>
+              <a:latin typeface="Arial" panose="020B0604020202020204" pitchFamily="34" charset="0"/>
+              <a:cs typeface="Arial" panose="020B0604020202020204" pitchFamily="34" charset="0"/>
+            </a:endParaRPr>
+          </a:p>
+        </p:txBody>
+      </p:sp>
+      <p:sp>
+        <p:nvSpPr>
+          <p:cNvPr id="44" name="Espaço Reservado para Texto 1">
+            <a:extLst>
+              <a:ext uri="{FF2B5EF4-FFF2-40B4-BE49-F238E27FC236}">
+                <a16:creationId xmlns:a16="http://schemas.microsoft.com/office/drawing/2014/main" id="{3F23FADD-12EC-A2F3-2447-EAEA113A04FC}"/>
+              </a:ext>
+            </a:extLst>
+          </p:cNvPr>
+          <p:cNvSpPr txBox="1">
+            <a:spLocks/>
+          </p:cNvSpPr>
+          <p:nvPr/>
+        </p:nvSpPr>
+        <p:spPr>
+          <a:xfrm>
+            <a:off x="8589735" y="5531449"/>
+            <a:ext cx="7324715" cy="2367411"/>
+          </a:xfrm>
+          <a:prstGeom prst="rect">
+            <a:avLst/>
+          </a:prstGeom>
+          <a:noFill/>
+        </p:spPr>
+        <p:txBody>
+          <a:bodyPr lIns="72000" tIns="72000" rIns="72000" bIns="72000"/>
+          <a:lstStyle>
+            <a:lvl1pPr marL="0" indent="0" algn="l" defTabSz="1280160" rtl="0" eaLnBrk="1" latinLnBrk="0" hangingPunct="1">
+              <a:lnSpc>
+                <a:spcPct val="100000"/>
+              </a:lnSpc>
+              <a:spcBef>
+                <a:spcPts val="0"/>
+              </a:spcBef>
+              <a:spcAft>
+                <a:spcPts val="1200"/>
+              </a:spcAft>
+              <a:buFont typeface="Arial" panose="020B0604020202020204" pitchFamily="34" charset="0"/>
+              <a:buNone/>
+              <a:defRPr sz="1800" kern="1200">
+                <a:solidFill>
+                  <a:schemeClr val="tx2">
+                    <a:lumMod val="75000"/>
+                  </a:schemeClr>
+                </a:solidFill>
+                <a:latin typeface="+mn-lt"/>
+                <a:ea typeface="+mn-ea"/>
+                <a:cs typeface="+mn-cs"/>
+              </a:defRPr>
+            </a:lvl1pPr>
+            <a:lvl2pPr marL="640080" indent="0" algn="l" defTabSz="1280160" rtl="0" eaLnBrk="1" latinLnBrk="0" hangingPunct="1">
+              <a:lnSpc>
+                <a:spcPct val="90000"/>
+              </a:lnSpc>
+              <a:spcBef>
+                <a:spcPts val="700"/>
+              </a:spcBef>
+              <a:buFont typeface="Arial" panose="020B0604020202020204" pitchFamily="34" charset="0"/>
+              <a:buNone/>
+              <a:defRPr sz="1400" kern="1200">
+                <a:solidFill>
+                  <a:schemeClr val="tx1"/>
+                </a:solidFill>
+                <a:latin typeface="+mn-lt"/>
+                <a:ea typeface="+mn-ea"/>
+                <a:cs typeface="+mn-cs"/>
+              </a:defRPr>
+            </a:lvl2pPr>
+            <a:lvl3pPr marL="1280160" indent="0" algn="l" defTabSz="1280160" rtl="0" eaLnBrk="1" latinLnBrk="0" hangingPunct="1">
+              <a:lnSpc>
+                <a:spcPct val="90000"/>
+              </a:lnSpc>
+              <a:spcBef>
+                <a:spcPts val="700"/>
+              </a:spcBef>
+              <a:buFont typeface="Arial" panose="020B0604020202020204" pitchFamily="34" charset="0"/>
+              <a:buNone/>
+              <a:defRPr sz="1400" kern="1200">
+                <a:solidFill>
+                  <a:schemeClr val="tx1"/>
+                </a:solidFill>
+                <a:latin typeface="+mn-lt"/>
+                <a:ea typeface="+mn-ea"/>
+                <a:cs typeface="+mn-cs"/>
+              </a:defRPr>
+            </a:lvl3pPr>
+            <a:lvl4pPr marL="1920240" indent="0" algn="l" defTabSz="1280160" rtl="0" eaLnBrk="1" latinLnBrk="0" hangingPunct="1">
+              <a:lnSpc>
+                <a:spcPct val="90000"/>
+              </a:lnSpc>
+              <a:spcBef>
+                <a:spcPts val="700"/>
+              </a:spcBef>
+              <a:buFont typeface="Arial" panose="020B0604020202020204" pitchFamily="34" charset="0"/>
+              <a:buNone/>
+              <a:defRPr sz="1400" kern="1200">
+                <a:solidFill>
+                  <a:schemeClr val="tx1"/>
+                </a:solidFill>
+                <a:latin typeface="+mn-lt"/>
+                <a:ea typeface="+mn-ea"/>
+                <a:cs typeface="+mn-cs"/>
+              </a:defRPr>
+            </a:lvl4pPr>
+            <a:lvl5pPr marL="2560320" indent="0" algn="l" defTabSz="1280160" rtl="0" eaLnBrk="1" latinLnBrk="0" hangingPunct="1">
+              <a:lnSpc>
+                <a:spcPct val="90000"/>
+              </a:lnSpc>
+              <a:spcBef>
+                <a:spcPts val="700"/>
+              </a:spcBef>
+              <a:buFont typeface="Arial" panose="020B0604020202020204" pitchFamily="34" charset="0"/>
+              <a:buNone/>
+              <a:defRPr sz="1400" kern="1200">
+                <a:solidFill>
+                  <a:schemeClr val="tx1"/>
+                </a:solidFill>
+                <a:latin typeface="+mn-lt"/>
+                <a:ea typeface="+mn-ea"/>
+                <a:cs typeface="+mn-cs"/>
+              </a:defRPr>
+            </a:lvl5pPr>
+            <a:lvl6pPr marL="3520440" indent="-320040" algn="l" defTabSz="1280160" rtl="0" eaLnBrk="1" latinLnBrk="0" hangingPunct="1">
+              <a:lnSpc>
+                <a:spcPct val="90000"/>
+              </a:lnSpc>
+              <a:spcBef>
+                <a:spcPts val="700"/>
+              </a:spcBef>
+              <a:buFont typeface="Arial" panose="020B0604020202020204" pitchFamily="34" charset="0"/>
+              <a:buChar char="•"/>
+              <a:defRPr sz="2520" kern="1200">
+                <a:solidFill>
+                  <a:schemeClr val="tx1"/>
+                </a:solidFill>
+                <a:latin typeface="+mn-lt"/>
+                <a:ea typeface="+mn-ea"/>
+                <a:cs typeface="+mn-cs"/>
+              </a:defRPr>
+            </a:lvl6pPr>
+            <a:lvl7pPr marL="4160520" indent="-320040" algn="l" defTabSz="1280160" rtl="0" eaLnBrk="1" latinLnBrk="0" hangingPunct="1">
+              <a:lnSpc>
+                <a:spcPct val="90000"/>
+              </a:lnSpc>
+              <a:spcBef>
+                <a:spcPts val="700"/>
+              </a:spcBef>
+              <a:buFont typeface="Arial" panose="020B0604020202020204" pitchFamily="34" charset="0"/>
+              <a:buChar char="•"/>
+              <a:defRPr sz="2520" kern="1200">
+                <a:solidFill>
+                  <a:schemeClr val="tx1"/>
+                </a:solidFill>
+                <a:latin typeface="+mn-lt"/>
+                <a:ea typeface="+mn-ea"/>
+                <a:cs typeface="+mn-cs"/>
+              </a:defRPr>
+            </a:lvl7pPr>
+            <a:lvl8pPr marL="4800600" indent="-320040" algn="l" defTabSz="1280160" rtl="0" eaLnBrk="1" latinLnBrk="0" hangingPunct="1">
+              <a:lnSpc>
+                <a:spcPct val="90000"/>
+              </a:lnSpc>
+              <a:spcBef>
+                <a:spcPts val="700"/>
+              </a:spcBef>
+              <a:buFont typeface="Arial" panose="020B0604020202020204" pitchFamily="34" charset="0"/>
+              <a:buChar char="•"/>
+              <a:defRPr sz="2520" kern="1200">
+                <a:solidFill>
+                  <a:schemeClr val="tx1"/>
+                </a:solidFill>
+                <a:latin typeface="+mn-lt"/>
+                <a:ea typeface="+mn-ea"/>
+                <a:cs typeface="+mn-cs"/>
+              </a:defRPr>
+            </a:lvl8pPr>
+            <a:lvl9pPr marL="5440680" indent="-320040" algn="l" defTabSz="1280160" rtl="0" eaLnBrk="1" latinLnBrk="0" hangingPunct="1">
+              <a:lnSpc>
+                <a:spcPct val="90000"/>
+              </a:lnSpc>
+              <a:spcBef>
+                <a:spcPts val="700"/>
+              </a:spcBef>
+              <a:buFont typeface="Arial" panose="020B0604020202020204" pitchFamily="34" charset="0"/>
+              <a:buChar char="•"/>
+              <a:defRPr sz="2520" kern="1200">
+                <a:solidFill>
+                  <a:schemeClr val="tx1"/>
+                </a:solidFill>
+                <a:latin typeface="+mn-lt"/>
+                <a:ea typeface="+mn-ea"/>
+                <a:cs typeface="+mn-cs"/>
+              </a:defRPr>
+            </a:lvl9pPr>
+          </a:lstStyle>
+          <a:p>
+            <a:pPr algn="ctr"/>
+            <a:r>
+              <a:rPr lang="pt-BR" sz="2000" b="1" dirty="0">
+                <a:solidFill>
+                  <a:schemeClr val="accent1">
+                    <a:lumMod val="75000"/>
+                  </a:schemeClr>
+                </a:solidFill>
+                <a:latin typeface="Arial" panose="020B0604020202020204" pitchFamily="34" charset="0"/>
+                <a:cs typeface="Arial" panose="020B0604020202020204" pitchFamily="34" charset="0"/>
+              </a:rPr>
+              <a:t>8 dos 20 clubes correm risco</a:t>
+            </a:r>
+          </a:p>
+          <a:p>
+            <a:pPr algn="ctr"/>
+            <a:endParaRPr lang="pt-BR" dirty="0">
+              <a:solidFill>
+                <a:srgbClr val="333333"/>
+              </a:solidFill>
+            </a:endParaRPr>
+          </a:p>
+          <a:p>
+            <a:pPr algn="ctr"/>
+            <a:r>
+              <a:rPr lang="pt-BR" dirty="0">
+                <a:solidFill>
+                  <a:srgbClr val="333333"/>
+                </a:solidFill>
+              </a:rPr>
+              <a:t>(40%) estão na faixa de risco Muito alto (≥ 60%) na temporada de 2025, concentrados nas últimas colocações da tabela - refletindo a forte relação entre posição final e risco de queda captada pelo modelo.</a:t>
+            </a:r>
+            <a:endParaRPr lang="pt-BR" dirty="0">
+              <a:solidFill>
+                <a:schemeClr val="tx1"/>
+              </a:solidFill>
+              <a:latin typeface="Arial" panose="020B0604020202020204" pitchFamily="34" charset="0"/>
+              <a:cs typeface="Arial" panose="020B0604020202020204" pitchFamily="34" charset="0"/>
+            </a:endParaRPr>
+          </a:p>
+        </p:txBody>
+      </p:sp>
+      <p:pic>
+        <p:nvPicPr>
+          <p:cNvPr id="11" name="Imagem 10">
+            <a:extLst>
+              <a:ext uri="{FF2B5EF4-FFF2-40B4-BE49-F238E27FC236}">
+                <a16:creationId xmlns:a16="http://schemas.microsoft.com/office/drawing/2014/main" id="{1E3BDD09-7B06-3D3D-2607-275DF7BF47F7}"/>
+              </a:ext>
+            </a:extLst>
+          </p:cNvPr>
+          <p:cNvPicPr>
+            <a:picLocks noChangeAspect="1"/>
+          </p:cNvPicPr>
+          <p:nvPr/>
+        </p:nvPicPr>
+        <p:blipFill>
+          <a:blip r:embed="rId3"/>
+          <a:stretch>
+            <a:fillRect/>
+          </a:stretch>
+        </p:blipFill>
+        <p:spPr>
+          <a:xfrm>
+            <a:off x="928688" y="2056092"/>
+            <a:ext cx="6860718" cy="6950714"/>
+          </a:xfrm>
+          <a:prstGeom prst="rect">
+            <a:avLst/>
+          </a:prstGeom>
+        </p:spPr>
+      </p:pic>
+    </p:spTree>
+    <p:extLst>
+      <p:ext uri="{BB962C8B-B14F-4D97-AF65-F5344CB8AC3E}">
+        <p14:creationId xmlns:p14="http://schemas.microsoft.com/office/powerpoint/2010/main" val="1092634859"/>
+      </p:ext>
+    </p:extLst>
+  </p:cSld>
+  <p:clrMapOvr>
+    <a:masterClrMapping/>
+  </p:clrMapOvr>
+</p:sld>
+</file>
+
+<file path=ppt/slides/slide7.xml><?xml version="1.0" encoding="utf-8"?>
 <p:sld xmlns:a="http://schemas.openxmlformats.org/drawingml/2006/main" xmlns:r="http://schemas.openxmlformats.org/officeDocument/2006/relationships" xmlns:p="http://schemas.openxmlformats.org/presentationml/2006/main">
   <p:cSld>
     <p:spTree>

</xml_diff>

<commit_message>
feat: slide 7 - evolução de risco
</commit_message>
<xml_diff>
--- a/docs/Template - Fase 2 - Apresentação Executiva - Projeto em Business Intelligence e Analytics.pptx
+++ b/docs/Template - Fase 2 - Apresentação Executiva - Projeto em Business Intelligence e Analytics.pptx
@@ -5,10 +5,10 @@
     <p:sldMasterId id="2147483665" r:id="rId4"/>
   </p:sldMasterIdLst>
   <p:notesMasterIdLst>
-    <p:notesMasterId r:id="rId12"/>
+    <p:notesMasterId r:id="rId13"/>
   </p:notesMasterIdLst>
   <p:handoutMasterIdLst>
-    <p:handoutMasterId r:id="rId13"/>
+    <p:handoutMasterId r:id="rId14"/>
   </p:handoutMasterIdLst>
   <p:sldIdLst>
     <p:sldId id="288" r:id="rId5"/>
@@ -17,7 +17,8 @@
     <p:sldId id="305" r:id="rId8"/>
     <p:sldId id="306" r:id="rId9"/>
     <p:sldId id="307" r:id="rId10"/>
-    <p:sldId id="300" r:id="rId11"/>
+    <p:sldId id="308" r:id="rId11"/>
+    <p:sldId id="300" r:id="rId12"/>
   </p:sldIdLst>
   <p:sldSz cx="16402050" cy="9601200"/>
   <p:notesSz cx="6858000" cy="9144000"/>
@@ -127,6 +128,7 @@
             <p14:sldId id="305"/>
             <p14:sldId id="306"/>
             <p14:sldId id="307"/>
+            <p14:sldId id="308"/>
             <p14:sldId id="300"/>
           </p14:sldIdLst>
         </p14:section>
@@ -2212,6 +2214,114 @@
 </p:notes>
 </file>
 
+<file path=ppt/notesSlides/notesSlide5.xml><?xml version="1.0" encoding="utf-8"?>
+<p:notes xmlns:a="http://schemas.openxmlformats.org/drawingml/2006/main" xmlns:r="http://schemas.openxmlformats.org/officeDocument/2006/relationships" xmlns:p="http://schemas.openxmlformats.org/presentationml/2006/main">
+  <p:cSld>
+    <p:spTree>
+      <p:nvGrpSpPr>
+        <p:cNvPr id="1" name="">
+          <a:extLst>
+            <a:ext uri="{FF2B5EF4-FFF2-40B4-BE49-F238E27FC236}">
+              <a16:creationId xmlns:a16="http://schemas.microsoft.com/office/drawing/2014/main" id="{B3AA5603-97A0-449B-8893-18D03A826991}"/>
+            </a:ext>
+          </a:extLst>
+        </p:cNvPr>
+        <p:cNvGrpSpPr/>
+        <p:nvPr/>
+      </p:nvGrpSpPr>
+      <p:grpSpPr>
+        <a:xfrm>
+          <a:off x="0" y="0"/>
+          <a:ext cx="0" cy="0"/>
+          <a:chOff x="0" y="0"/>
+          <a:chExt cx="0" cy="0"/>
+        </a:xfrm>
+      </p:grpSpPr>
+      <p:sp>
+        <p:nvSpPr>
+          <p:cNvPr id="2" name="Marcador de Posição da Imagem do Diapositivo 1">
+            <a:extLst>
+              <a:ext uri="{FF2B5EF4-FFF2-40B4-BE49-F238E27FC236}">
+                <a16:creationId xmlns:a16="http://schemas.microsoft.com/office/drawing/2014/main" id="{1DDAA018-A431-A5F4-A0C5-3CEDCEEB4A06}"/>
+              </a:ext>
+            </a:extLst>
+          </p:cNvPr>
+          <p:cNvSpPr>
+            <a:spLocks noGrp="1" noRot="1" noChangeAspect="1"/>
+          </p:cNvSpPr>
+          <p:nvPr>
+            <p:ph type="sldImg"/>
+          </p:nvPr>
+        </p:nvSpPr>
+        <p:spPr/>
+      </p:sp>
+      <p:sp>
+        <p:nvSpPr>
+          <p:cNvPr id="3" name="Marcador de Posição de Notas 2">
+            <a:extLst>
+              <a:ext uri="{FF2B5EF4-FFF2-40B4-BE49-F238E27FC236}">
+                <a16:creationId xmlns:a16="http://schemas.microsoft.com/office/drawing/2014/main" id="{030772D9-644D-8B45-C344-4B562CF63414}"/>
+              </a:ext>
+            </a:extLst>
+          </p:cNvPr>
+          <p:cNvSpPr>
+            <a:spLocks noGrp="1"/>
+          </p:cNvSpPr>
+          <p:nvPr>
+            <p:ph type="body" idx="1"/>
+          </p:nvPr>
+        </p:nvSpPr>
+        <p:spPr/>
+        <p:txBody>
+          <a:bodyPr/>
+          <a:lstStyle/>
+          <a:p>
+            <a:endParaRPr lang="pt-BR" dirty="0"/>
+          </a:p>
+        </p:txBody>
+      </p:sp>
+      <p:sp>
+        <p:nvSpPr>
+          <p:cNvPr id="4" name="Marcador de Posição do Número do Diapositivo 3">
+            <a:extLst>
+              <a:ext uri="{FF2B5EF4-FFF2-40B4-BE49-F238E27FC236}">
+                <a16:creationId xmlns:a16="http://schemas.microsoft.com/office/drawing/2014/main" id="{5C004FD4-DA99-69CE-67D2-0DA81574A0DD}"/>
+              </a:ext>
+            </a:extLst>
+          </p:cNvPr>
+          <p:cNvSpPr>
+            <a:spLocks noGrp="1"/>
+          </p:cNvSpPr>
+          <p:nvPr>
+            <p:ph type="sldNum" sz="quarter" idx="5"/>
+          </p:nvPr>
+        </p:nvSpPr>
+        <p:spPr/>
+        <p:txBody>
+          <a:bodyPr/>
+          <a:lstStyle/>
+          <a:p>
+            <a:fld id="{4EC3EDC0-8BE0-4B53-981B-0D2AEC565C43}" type="slidenum">
+              <a:rPr lang="pt-BR" smtClean="0"/>
+              <a:t>7</a:t>
+            </a:fld>
+            <a:endParaRPr lang="pt-BR"/>
+          </a:p>
+        </p:txBody>
+      </p:sp>
+    </p:spTree>
+    <p:extLst>
+      <p:ext uri="{BB962C8B-B14F-4D97-AF65-F5344CB8AC3E}">
+        <p14:creationId xmlns:p14="http://schemas.microsoft.com/office/powerpoint/2010/main" val="2811967338"/>
+      </p:ext>
+    </p:extLst>
+  </p:cSld>
+  <p:clrMapOvr>
+    <a:masterClrMapping/>
+  </p:clrMapOvr>
+</p:notes>
+</file>
+
 <file path=ppt/slideLayouts/slideLayout1.xml><?xml version="1.0" encoding="utf-8"?>
 <p:sldLayout xmlns:a="http://schemas.openxmlformats.org/drawingml/2006/main" xmlns:r="http://schemas.openxmlformats.org/officeDocument/2006/relationships" xmlns:p="http://schemas.openxmlformats.org/presentationml/2006/main" preserve="1" userDrawn="1">
   <p:cSld name="Layout Personalizado">
@@ -14005,7 +14115,7 @@
         <p:spPr>
           <a:xfrm>
             <a:off x="8589736" y="3931000"/>
-            <a:ext cx="7324714" cy="793649"/>
+            <a:ext cx="7324714" cy="1025968"/>
           </a:xfrm>
           <a:prstGeom prst="rect">
             <a:avLst/>
@@ -14718,6 +14828,369 @@
 </file>
 
 <file path=ppt/slides/slide7.xml><?xml version="1.0" encoding="utf-8"?>
+<p:sld xmlns:a="http://schemas.openxmlformats.org/drawingml/2006/main" xmlns:r="http://schemas.openxmlformats.org/officeDocument/2006/relationships" xmlns:p="http://schemas.openxmlformats.org/presentationml/2006/main">
+  <p:cSld>
+    <p:spTree>
+      <p:nvGrpSpPr>
+        <p:cNvPr id="1" name="">
+          <a:extLst>
+            <a:ext uri="{FF2B5EF4-FFF2-40B4-BE49-F238E27FC236}">
+              <a16:creationId xmlns:a16="http://schemas.microsoft.com/office/drawing/2014/main" id="{B4FBBF56-47A1-5C4A-FB24-E812BC9282B5}"/>
+            </a:ext>
+          </a:extLst>
+        </p:cNvPr>
+        <p:cNvGrpSpPr/>
+        <p:nvPr/>
+      </p:nvGrpSpPr>
+      <p:grpSpPr>
+        <a:xfrm>
+          <a:off x="0" y="0"/>
+          <a:ext cx="0" cy="0"/>
+          <a:chOff x="0" y="0"/>
+          <a:chExt cx="0" cy="0"/>
+        </a:xfrm>
+      </p:grpSpPr>
+      <p:sp>
+        <p:nvSpPr>
+          <p:cNvPr id="2" name="Espaço Reservado para Texto 1">
+            <a:extLst>
+              <a:ext uri="{FF2B5EF4-FFF2-40B4-BE49-F238E27FC236}">
+                <a16:creationId xmlns:a16="http://schemas.microsoft.com/office/drawing/2014/main" id="{C120A62E-236E-574F-047E-B753A0F22AB1}"/>
+              </a:ext>
+            </a:extLst>
+          </p:cNvPr>
+          <p:cNvSpPr>
+            <a:spLocks noGrp="1"/>
+          </p:cNvSpPr>
+          <p:nvPr>
+            <p:ph type="body" sz="quarter" idx="10"/>
+          </p:nvPr>
+        </p:nvSpPr>
+        <p:spPr>
+          <a:xfrm>
+            <a:off x="928688" y="1301750"/>
+            <a:ext cx="14544674" cy="625401"/>
+          </a:xfrm>
+        </p:spPr>
+        <p:txBody>
+          <a:bodyPr/>
+          <a:lstStyle/>
+          <a:p>
+            <a:r>
+              <a:rPr lang="pt-BR" sz="3000" b="1" dirty="0">
+                <a:solidFill>
+                  <a:schemeClr val="accent1">
+                    <a:lumMod val="75000"/>
+                  </a:schemeClr>
+                </a:solidFill>
+                <a:latin typeface="Arial" panose="020B0604020202020204" pitchFamily="34" charset="0"/>
+                <a:cs typeface="Arial" panose="020B0604020202020204" pitchFamily="34" charset="0"/>
+              </a:rPr>
+              <a:t>Evolução do Risco Previsto (2014 - 2025</a:t>
+            </a:r>
+          </a:p>
+        </p:txBody>
+      </p:sp>
+      <p:sp>
+        <p:nvSpPr>
+          <p:cNvPr id="40" name="Espaço Reservado para Texto 1">
+            <a:extLst>
+              <a:ext uri="{FF2B5EF4-FFF2-40B4-BE49-F238E27FC236}">
+                <a16:creationId xmlns:a16="http://schemas.microsoft.com/office/drawing/2014/main" id="{F4309906-2840-9421-C9A6-0FF839D3557E}"/>
+              </a:ext>
+            </a:extLst>
+          </p:cNvPr>
+          <p:cNvSpPr txBox="1">
+            <a:spLocks/>
+          </p:cNvSpPr>
+          <p:nvPr/>
+        </p:nvSpPr>
+        <p:spPr>
+          <a:xfrm>
+            <a:off x="622866" y="7674047"/>
+            <a:ext cx="15156318" cy="1568985"/>
+          </a:xfrm>
+          <a:prstGeom prst="rect">
+            <a:avLst/>
+          </a:prstGeom>
+          <a:solidFill>
+            <a:schemeClr val="bg2"/>
+          </a:solidFill>
+          <a:effectLst>
+            <a:outerShdw blurRad="215900" dist="114300" dir="2700000" algn="tl" rotWithShape="0">
+              <a:prstClr val="black">
+                <a:alpha val="30000"/>
+              </a:prstClr>
+            </a:outerShdw>
+            <a:softEdge rad="38100"/>
+          </a:effectLst>
+        </p:spPr>
+        <p:txBody>
+          <a:bodyPr lIns="72000" tIns="72000" rIns="72000" bIns="72000" anchor="ctr"/>
+          <a:lstStyle>
+            <a:lvl1pPr marL="0" indent="0" algn="l" defTabSz="1280160" rtl="0" eaLnBrk="1" latinLnBrk="0" hangingPunct="1">
+              <a:lnSpc>
+                <a:spcPct val="100000"/>
+              </a:lnSpc>
+              <a:spcBef>
+                <a:spcPts val="0"/>
+              </a:spcBef>
+              <a:spcAft>
+                <a:spcPts val="1200"/>
+              </a:spcAft>
+              <a:buFont typeface="Arial" panose="020B0604020202020204" pitchFamily="34" charset="0"/>
+              <a:buNone/>
+              <a:defRPr sz="1800" kern="1200">
+                <a:solidFill>
+                  <a:schemeClr val="tx2">
+                    <a:lumMod val="75000"/>
+                  </a:schemeClr>
+                </a:solidFill>
+                <a:latin typeface="+mn-lt"/>
+                <a:ea typeface="+mn-ea"/>
+                <a:cs typeface="+mn-cs"/>
+              </a:defRPr>
+            </a:lvl1pPr>
+            <a:lvl2pPr marL="640080" indent="0" algn="l" defTabSz="1280160" rtl="0" eaLnBrk="1" latinLnBrk="0" hangingPunct="1">
+              <a:lnSpc>
+                <a:spcPct val="90000"/>
+              </a:lnSpc>
+              <a:spcBef>
+                <a:spcPts val="700"/>
+              </a:spcBef>
+              <a:buFont typeface="Arial" panose="020B0604020202020204" pitchFamily="34" charset="0"/>
+              <a:buNone/>
+              <a:defRPr sz="1400" kern="1200">
+                <a:solidFill>
+                  <a:schemeClr val="tx1"/>
+                </a:solidFill>
+                <a:latin typeface="+mn-lt"/>
+                <a:ea typeface="+mn-ea"/>
+                <a:cs typeface="+mn-cs"/>
+              </a:defRPr>
+            </a:lvl2pPr>
+            <a:lvl3pPr marL="1280160" indent="0" algn="l" defTabSz="1280160" rtl="0" eaLnBrk="1" latinLnBrk="0" hangingPunct="1">
+              <a:lnSpc>
+                <a:spcPct val="90000"/>
+              </a:lnSpc>
+              <a:spcBef>
+                <a:spcPts val="700"/>
+              </a:spcBef>
+              <a:buFont typeface="Arial" panose="020B0604020202020204" pitchFamily="34" charset="0"/>
+              <a:buNone/>
+              <a:defRPr sz="1400" kern="1200">
+                <a:solidFill>
+                  <a:schemeClr val="tx1"/>
+                </a:solidFill>
+                <a:latin typeface="+mn-lt"/>
+                <a:ea typeface="+mn-ea"/>
+                <a:cs typeface="+mn-cs"/>
+              </a:defRPr>
+            </a:lvl3pPr>
+            <a:lvl4pPr marL="1920240" indent="0" algn="l" defTabSz="1280160" rtl="0" eaLnBrk="1" latinLnBrk="0" hangingPunct="1">
+              <a:lnSpc>
+                <a:spcPct val="90000"/>
+              </a:lnSpc>
+              <a:spcBef>
+                <a:spcPts val="700"/>
+              </a:spcBef>
+              <a:buFont typeface="Arial" panose="020B0604020202020204" pitchFamily="34" charset="0"/>
+              <a:buNone/>
+              <a:defRPr sz="1400" kern="1200">
+                <a:solidFill>
+                  <a:schemeClr val="tx1"/>
+                </a:solidFill>
+                <a:latin typeface="+mn-lt"/>
+                <a:ea typeface="+mn-ea"/>
+                <a:cs typeface="+mn-cs"/>
+              </a:defRPr>
+            </a:lvl4pPr>
+            <a:lvl5pPr marL="2560320" indent="0" algn="l" defTabSz="1280160" rtl="0" eaLnBrk="1" latinLnBrk="0" hangingPunct="1">
+              <a:lnSpc>
+                <a:spcPct val="90000"/>
+              </a:lnSpc>
+              <a:spcBef>
+                <a:spcPts val="700"/>
+              </a:spcBef>
+              <a:buFont typeface="Arial" panose="020B0604020202020204" pitchFamily="34" charset="0"/>
+              <a:buNone/>
+              <a:defRPr sz="1400" kern="1200">
+                <a:solidFill>
+                  <a:schemeClr val="tx1"/>
+                </a:solidFill>
+                <a:latin typeface="+mn-lt"/>
+                <a:ea typeface="+mn-ea"/>
+                <a:cs typeface="+mn-cs"/>
+              </a:defRPr>
+            </a:lvl5pPr>
+            <a:lvl6pPr marL="3520440" indent="-320040" algn="l" defTabSz="1280160" rtl="0" eaLnBrk="1" latinLnBrk="0" hangingPunct="1">
+              <a:lnSpc>
+                <a:spcPct val="90000"/>
+              </a:lnSpc>
+              <a:spcBef>
+                <a:spcPts val="700"/>
+              </a:spcBef>
+              <a:buFont typeface="Arial" panose="020B0604020202020204" pitchFamily="34" charset="0"/>
+              <a:buChar char="•"/>
+              <a:defRPr sz="2520" kern="1200">
+                <a:solidFill>
+                  <a:schemeClr val="tx1"/>
+                </a:solidFill>
+                <a:latin typeface="+mn-lt"/>
+                <a:ea typeface="+mn-ea"/>
+                <a:cs typeface="+mn-cs"/>
+              </a:defRPr>
+            </a:lvl6pPr>
+            <a:lvl7pPr marL="4160520" indent="-320040" algn="l" defTabSz="1280160" rtl="0" eaLnBrk="1" latinLnBrk="0" hangingPunct="1">
+              <a:lnSpc>
+                <a:spcPct val="90000"/>
+              </a:lnSpc>
+              <a:spcBef>
+                <a:spcPts val="700"/>
+              </a:spcBef>
+              <a:buFont typeface="Arial" panose="020B0604020202020204" pitchFamily="34" charset="0"/>
+              <a:buChar char="•"/>
+              <a:defRPr sz="2520" kern="1200">
+                <a:solidFill>
+                  <a:schemeClr val="tx1"/>
+                </a:solidFill>
+                <a:latin typeface="+mn-lt"/>
+                <a:ea typeface="+mn-ea"/>
+                <a:cs typeface="+mn-cs"/>
+              </a:defRPr>
+            </a:lvl7pPr>
+            <a:lvl8pPr marL="4800600" indent="-320040" algn="l" defTabSz="1280160" rtl="0" eaLnBrk="1" latinLnBrk="0" hangingPunct="1">
+              <a:lnSpc>
+                <a:spcPct val="90000"/>
+              </a:lnSpc>
+              <a:spcBef>
+                <a:spcPts val="700"/>
+              </a:spcBef>
+              <a:buFont typeface="Arial" panose="020B0604020202020204" pitchFamily="34" charset="0"/>
+              <a:buChar char="•"/>
+              <a:defRPr sz="2520" kern="1200">
+                <a:solidFill>
+                  <a:schemeClr val="tx1"/>
+                </a:solidFill>
+                <a:latin typeface="+mn-lt"/>
+                <a:ea typeface="+mn-ea"/>
+                <a:cs typeface="+mn-cs"/>
+              </a:defRPr>
+            </a:lvl8pPr>
+            <a:lvl9pPr marL="5440680" indent="-320040" algn="l" defTabSz="1280160" rtl="0" eaLnBrk="1" latinLnBrk="0" hangingPunct="1">
+              <a:lnSpc>
+                <a:spcPct val="90000"/>
+              </a:lnSpc>
+              <a:spcBef>
+                <a:spcPts val="700"/>
+              </a:spcBef>
+              <a:buFont typeface="Arial" panose="020B0604020202020204" pitchFamily="34" charset="0"/>
+              <a:buChar char="•"/>
+              <a:defRPr sz="2520" kern="1200">
+                <a:solidFill>
+                  <a:schemeClr val="tx1"/>
+                </a:solidFill>
+                <a:latin typeface="+mn-lt"/>
+                <a:ea typeface="+mn-ea"/>
+                <a:cs typeface="+mn-cs"/>
+              </a:defRPr>
+            </a:lvl9pPr>
+          </a:lstStyle>
+          <a:p>
+            <a:pPr algn="ctr"/>
+            <a:r>
+              <a:rPr lang="pt-BR" dirty="0">
+                <a:latin typeface="Arial" panose="020B0604020202020204" pitchFamily="34" charset="0"/>
+                <a:cs typeface="Arial" panose="020B0604020202020204" pitchFamily="34" charset="0"/>
+              </a:rPr>
+              <a:t>O gráfico de evolução permite acompanhar as variações do risco previsto dos clubes ao longo das temporadas, enquanto o gráfico de divisão apresenta a distribuição dos clubes nas faixas de risco em 2025. Juntos, os indicadores permitem comparar o comportamento histórico e identificar a concentração atual dos clubes nas diferentes categorias de risco.</a:t>
+            </a:r>
+            <a:endParaRPr lang="pt-BR" b="1" dirty="0">
+              <a:solidFill>
+                <a:schemeClr val="accent1">
+                  <a:lumMod val="75000"/>
+                </a:schemeClr>
+              </a:solidFill>
+              <a:latin typeface="Arial" panose="020B0604020202020204" pitchFamily="34" charset="0"/>
+              <a:cs typeface="Arial" panose="020B0604020202020204" pitchFamily="34" charset="0"/>
+            </a:endParaRPr>
+          </a:p>
+        </p:txBody>
+      </p:sp>
+      <p:pic>
+        <p:nvPicPr>
+          <p:cNvPr id="8" name="Imagem 7">
+            <a:extLst>
+              <a:ext uri="{FF2B5EF4-FFF2-40B4-BE49-F238E27FC236}">
+                <a16:creationId xmlns:a16="http://schemas.microsoft.com/office/drawing/2014/main" id="{230A1173-4021-1C55-7FBD-6A1572A4DF7C}"/>
+              </a:ext>
+            </a:extLst>
+          </p:cNvPr>
+          <p:cNvPicPr>
+            <a:picLocks noChangeAspect="1"/>
+          </p:cNvPicPr>
+          <p:nvPr/>
+        </p:nvPicPr>
+        <p:blipFill>
+          <a:blip r:embed="rId3"/>
+          <a:stretch>
+            <a:fillRect/>
+          </a:stretch>
+        </p:blipFill>
+        <p:spPr>
+          <a:xfrm>
+            <a:off x="622866" y="2004622"/>
+            <a:ext cx="10291568" cy="5591955"/>
+          </a:xfrm>
+          <a:prstGeom prst="rect">
+            <a:avLst/>
+          </a:prstGeom>
+        </p:spPr>
+      </p:pic>
+      <p:pic>
+        <p:nvPicPr>
+          <p:cNvPr id="13" name="Imagem 12">
+            <a:extLst>
+              <a:ext uri="{FF2B5EF4-FFF2-40B4-BE49-F238E27FC236}">
+                <a16:creationId xmlns:a16="http://schemas.microsoft.com/office/drawing/2014/main" id="{4B57B79A-2FE0-03A8-CC3C-B0E88E70F896}"/>
+              </a:ext>
+            </a:extLst>
+          </p:cNvPr>
+          <p:cNvPicPr>
+            <a:picLocks noChangeAspect="1"/>
+          </p:cNvPicPr>
+          <p:nvPr/>
+        </p:nvPicPr>
+        <p:blipFill>
+          <a:blip r:embed="rId4"/>
+          <a:stretch>
+            <a:fillRect/>
+          </a:stretch>
+        </p:blipFill>
+        <p:spPr>
+          <a:xfrm>
+            <a:off x="11169785" y="3633641"/>
+            <a:ext cx="4303577" cy="2333915"/>
+          </a:xfrm>
+          <a:prstGeom prst="rect">
+            <a:avLst/>
+          </a:prstGeom>
+        </p:spPr>
+      </p:pic>
+    </p:spTree>
+    <p:extLst>
+      <p:ext uri="{BB962C8B-B14F-4D97-AF65-F5344CB8AC3E}">
+        <p14:creationId xmlns:p14="http://schemas.microsoft.com/office/powerpoint/2010/main" val="2152788270"/>
+      </p:ext>
+    </p:extLst>
+  </p:cSld>
+  <p:clrMapOvr>
+    <a:masterClrMapping/>
+  </p:clrMapOvr>
+</p:sld>
+</file>
+
+<file path=ppt/slides/slide8.xml><?xml version="1.0" encoding="utf-8"?>
 <p:sld xmlns:a="http://schemas.openxmlformats.org/drawingml/2006/main" xmlns:r="http://schemas.openxmlformats.org/officeDocument/2006/relationships" xmlns:p="http://schemas.openxmlformats.org/presentationml/2006/main">
   <p:cSld>
     <p:spTree>

</xml_diff>

<commit_message>
feat: slide 8 - explicações sobre limitacoes do modelo
</commit_message>
<xml_diff>
--- a/docs/Template - Fase 2 - Apresentação Executiva - Projeto em Business Intelligence e Analytics.pptx
+++ b/docs/Template - Fase 2 - Apresentação Executiva - Projeto em Business Intelligence e Analytics.pptx
@@ -5,10 +5,10 @@
     <p:sldMasterId id="2147483665" r:id="rId4"/>
   </p:sldMasterIdLst>
   <p:notesMasterIdLst>
-    <p:notesMasterId r:id="rId13"/>
+    <p:notesMasterId r:id="rId14"/>
   </p:notesMasterIdLst>
   <p:handoutMasterIdLst>
-    <p:handoutMasterId r:id="rId14"/>
+    <p:handoutMasterId r:id="rId15"/>
   </p:handoutMasterIdLst>
   <p:sldIdLst>
     <p:sldId id="288" r:id="rId5"/>
@@ -18,7 +18,8 @@
     <p:sldId id="306" r:id="rId9"/>
     <p:sldId id="307" r:id="rId10"/>
     <p:sldId id="308" r:id="rId11"/>
-    <p:sldId id="300" r:id="rId12"/>
+    <p:sldId id="309" r:id="rId12"/>
+    <p:sldId id="300" r:id="rId13"/>
   </p:sldIdLst>
   <p:sldSz cx="16402050" cy="9601200"/>
   <p:notesSz cx="6858000" cy="9144000"/>
@@ -129,6 +130,7 @@
             <p14:sldId id="306"/>
             <p14:sldId id="307"/>
             <p14:sldId id="308"/>
+            <p14:sldId id="309"/>
             <p14:sldId id="300"/>
           </p14:sldIdLst>
         </p14:section>
@@ -14886,7 +14888,7 @@
                 <a:latin typeface="Arial" panose="020B0604020202020204" pitchFamily="34" charset="0"/>
                 <a:cs typeface="Arial" panose="020B0604020202020204" pitchFamily="34" charset="0"/>
               </a:rPr>
-              <a:t>Evolução do Risco Previsto (2014 - 2025</a:t>
+              <a:t>Evolução do Risco Previsto (2014 – 2025)</a:t>
             </a:r>
           </a:p>
         </p:txBody>
@@ -15191,6 +15193,991 @@
 </file>
 
 <file path=ppt/slides/slide8.xml><?xml version="1.0" encoding="utf-8"?>
+<p:sld xmlns:a="http://schemas.openxmlformats.org/drawingml/2006/main" xmlns:r="http://schemas.openxmlformats.org/officeDocument/2006/relationships" xmlns:p="http://schemas.openxmlformats.org/presentationml/2006/main">
+  <p:cSld>
+    <p:spTree>
+      <p:nvGrpSpPr>
+        <p:cNvPr id="1" name=""/>
+        <p:cNvGrpSpPr/>
+        <p:nvPr/>
+      </p:nvGrpSpPr>
+      <p:grpSpPr>
+        <a:xfrm>
+          <a:off x="0" y="0"/>
+          <a:ext cx="0" cy="0"/>
+          <a:chOff x="0" y="0"/>
+          <a:chExt cx="0" cy="0"/>
+        </a:xfrm>
+      </p:grpSpPr>
+      <p:sp>
+        <p:nvSpPr>
+          <p:cNvPr id="4" name="Espaço Reservado para Texto 1">
+            <a:extLst>
+              <a:ext uri="{FF2B5EF4-FFF2-40B4-BE49-F238E27FC236}">
+                <a16:creationId xmlns:a16="http://schemas.microsoft.com/office/drawing/2014/main" id="{390819E6-5E1F-4626-074B-893D274D0765}"/>
+              </a:ext>
+            </a:extLst>
+          </p:cNvPr>
+          <p:cNvSpPr txBox="1">
+            <a:spLocks/>
+          </p:cNvSpPr>
+          <p:nvPr/>
+        </p:nvSpPr>
+        <p:spPr>
+          <a:xfrm>
+            <a:off x="8589734" y="2198451"/>
+            <a:ext cx="6906537" cy="6673175"/>
+          </a:xfrm>
+          <a:prstGeom prst="rect">
+            <a:avLst/>
+          </a:prstGeom>
+          <a:solidFill>
+            <a:schemeClr val="bg2"/>
+          </a:solidFill>
+          <a:effectLst>
+            <a:outerShdw blurRad="215900" dist="114300" dir="2700000" algn="tl" rotWithShape="0">
+              <a:prstClr val="black">
+                <a:alpha val="30000"/>
+              </a:prstClr>
+            </a:outerShdw>
+            <a:softEdge rad="38100"/>
+          </a:effectLst>
+        </p:spPr>
+        <p:txBody>
+          <a:bodyPr lIns="72000" tIns="72000" rIns="72000" bIns="72000"/>
+          <a:lstStyle>
+            <a:lvl1pPr marL="0" indent="0" algn="l" defTabSz="1280160" rtl="0" eaLnBrk="1" latinLnBrk="0" hangingPunct="1">
+              <a:lnSpc>
+                <a:spcPct val="100000"/>
+              </a:lnSpc>
+              <a:spcBef>
+                <a:spcPts val="0"/>
+              </a:spcBef>
+              <a:spcAft>
+                <a:spcPts val="1200"/>
+              </a:spcAft>
+              <a:buFont typeface="Arial" panose="020B0604020202020204" pitchFamily="34" charset="0"/>
+              <a:buNone/>
+              <a:defRPr sz="1800" kern="1200">
+                <a:solidFill>
+                  <a:schemeClr val="tx2">
+                    <a:lumMod val="75000"/>
+                  </a:schemeClr>
+                </a:solidFill>
+                <a:latin typeface="+mn-lt"/>
+                <a:ea typeface="+mn-ea"/>
+                <a:cs typeface="+mn-cs"/>
+              </a:defRPr>
+            </a:lvl1pPr>
+            <a:lvl2pPr marL="640080" indent="0" algn="l" defTabSz="1280160" rtl="0" eaLnBrk="1" latinLnBrk="0" hangingPunct="1">
+              <a:lnSpc>
+                <a:spcPct val="90000"/>
+              </a:lnSpc>
+              <a:spcBef>
+                <a:spcPts val="700"/>
+              </a:spcBef>
+              <a:buFont typeface="Arial" panose="020B0604020202020204" pitchFamily="34" charset="0"/>
+              <a:buNone/>
+              <a:defRPr sz="1400" kern="1200">
+                <a:solidFill>
+                  <a:schemeClr val="tx1"/>
+                </a:solidFill>
+                <a:latin typeface="+mn-lt"/>
+                <a:ea typeface="+mn-ea"/>
+                <a:cs typeface="+mn-cs"/>
+              </a:defRPr>
+            </a:lvl2pPr>
+            <a:lvl3pPr marL="1280160" indent="0" algn="l" defTabSz="1280160" rtl="0" eaLnBrk="1" latinLnBrk="0" hangingPunct="1">
+              <a:lnSpc>
+                <a:spcPct val="90000"/>
+              </a:lnSpc>
+              <a:spcBef>
+                <a:spcPts val="700"/>
+              </a:spcBef>
+              <a:buFont typeface="Arial" panose="020B0604020202020204" pitchFamily="34" charset="0"/>
+              <a:buNone/>
+              <a:defRPr sz="1400" kern="1200">
+                <a:solidFill>
+                  <a:schemeClr val="tx1"/>
+                </a:solidFill>
+                <a:latin typeface="+mn-lt"/>
+                <a:ea typeface="+mn-ea"/>
+                <a:cs typeface="+mn-cs"/>
+              </a:defRPr>
+            </a:lvl3pPr>
+            <a:lvl4pPr marL="1920240" indent="0" algn="l" defTabSz="1280160" rtl="0" eaLnBrk="1" latinLnBrk="0" hangingPunct="1">
+              <a:lnSpc>
+                <a:spcPct val="90000"/>
+              </a:lnSpc>
+              <a:spcBef>
+                <a:spcPts val="700"/>
+              </a:spcBef>
+              <a:buFont typeface="Arial" panose="020B0604020202020204" pitchFamily="34" charset="0"/>
+              <a:buNone/>
+              <a:defRPr sz="1400" kern="1200">
+                <a:solidFill>
+                  <a:schemeClr val="tx1"/>
+                </a:solidFill>
+                <a:latin typeface="+mn-lt"/>
+                <a:ea typeface="+mn-ea"/>
+                <a:cs typeface="+mn-cs"/>
+              </a:defRPr>
+            </a:lvl4pPr>
+            <a:lvl5pPr marL="2560320" indent="0" algn="l" defTabSz="1280160" rtl="0" eaLnBrk="1" latinLnBrk="0" hangingPunct="1">
+              <a:lnSpc>
+                <a:spcPct val="90000"/>
+              </a:lnSpc>
+              <a:spcBef>
+                <a:spcPts val="700"/>
+              </a:spcBef>
+              <a:buFont typeface="Arial" panose="020B0604020202020204" pitchFamily="34" charset="0"/>
+              <a:buNone/>
+              <a:defRPr sz="1400" kern="1200">
+                <a:solidFill>
+                  <a:schemeClr val="tx1"/>
+                </a:solidFill>
+                <a:latin typeface="+mn-lt"/>
+                <a:ea typeface="+mn-ea"/>
+                <a:cs typeface="+mn-cs"/>
+              </a:defRPr>
+            </a:lvl5pPr>
+            <a:lvl6pPr marL="3520440" indent="-320040" algn="l" defTabSz="1280160" rtl="0" eaLnBrk="1" latinLnBrk="0" hangingPunct="1">
+              <a:lnSpc>
+                <a:spcPct val="90000"/>
+              </a:lnSpc>
+              <a:spcBef>
+                <a:spcPts val="700"/>
+              </a:spcBef>
+              <a:buFont typeface="Arial" panose="020B0604020202020204" pitchFamily="34" charset="0"/>
+              <a:buChar char="•"/>
+              <a:defRPr sz="2520" kern="1200">
+                <a:solidFill>
+                  <a:schemeClr val="tx1"/>
+                </a:solidFill>
+                <a:latin typeface="+mn-lt"/>
+                <a:ea typeface="+mn-ea"/>
+                <a:cs typeface="+mn-cs"/>
+              </a:defRPr>
+            </a:lvl6pPr>
+            <a:lvl7pPr marL="4160520" indent="-320040" algn="l" defTabSz="1280160" rtl="0" eaLnBrk="1" latinLnBrk="0" hangingPunct="1">
+              <a:lnSpc>
+                <a:spcPct val="90000"/>
+              </a:lnSpc>
+              <a:spcBef>
+                <a:spcPts val="700"/>
+              </a:spcBef>
+              <a:buFont typeface="Arial" panose="020B0604020202020204" pitchFamily="34" charset="0"/>
+              <a:buChar char="•"/>
+              <a:defRPr sz="2520" kern="1200">
+                <a:solidFill>
+                  <a:schemeClr val="tx1"/>
+                </a:solidFill>
+                <a:latin typeface="+mn-lt"/>
+                <a:ea typeface="+mn-ea"/>
+                <a:cs typeface="+mn-cs"/>
+              </a:defRPr>
+            </a:lvl7pPr>
+            <a:lvl8pPr marL="4800600" indent="-320040" algn="l" defTabSz="1280160" rtl="0" eaLnBrk="1" latinLnBrk="0" hangingPunct="1">
+              <a:lnSpc>
+                <a:spcPct val="90000"/>
+              </a:lnSpc>
+              <a:spcBef>
+                <a:spcPts val="700"/>
+              </a:spcBef>
+              <a:buFont typeface="Arial" panose="020B0604020202020204" pitchFamily="34" charset="0"/>
+              <a:buChar char="•"/>
+              <a:defRPr sz="2520" kern="1200">
+                <a:solidFill>
+                  <a:schemeClr val="tx1"/>
+                </a:solidFill>
+                <a:latin typeface="+mn-lt"/>
+                <a:ea typeface="+mn-ea"/>
+                <a:cs typeface="+mn-cs"/>
+              </a:defRPr>
+            </a:lvl8pPr>
+            <a:lvl9pPr marL="5440680" indent="-320040" algn="l" defTabSz="1280160" rtl="0" eaLnBrk="1" latinLnBrk="0" hangingPunct="1">
+              <a:lnSpc>
+                <a:spcPct val="90000"/>
+              </a:lnSpc>
+              <a:spcBef>
+                <a:spcPts val="700"/>
+              </a:spcBef>
+              <a:buFont typeface="Arial" panose="020B0604020202020204" pitchFamily="34" charset="0"/>
+              <a:buChar char="•"/>
+              <a:defRPr sz="2520" kern="1200">
+                <a:solidFill>
+                  <a:schemeClr val="tx1"/>
+                </a:solidFill>
+                <a:latin typeface="+mn-lt"/>
+                <a:ea typeface="+mn-ea"/>
+                <a:cs typeface="+mn-cs"/>
+              </a:defRPr>
+            </a:lvl9pPr>
+          </a:lstStyle>
+          <a:p>
+            <a:endParaRPr lang="pt-BR" sz="1600" b="1" dirty="0">
+              <a:solidFill>
+                <a:schemeClr val="accent1">
+                  <a:lumMod val="75000"/>
+                </a:schemeClr>
+              </a:solidFill>
+              <a:latin typeface="Arial" panose="020B0604020202020204" pitchFamily="34" charset="0"/>
+              <a:cs typeface="Arial" panose="020B0604020202020204" pitchFamily="34" charset="0"/>
+            </a:endParaRPr>
+          </a:p>
+        </p:txBody>
+      </p:sp>
+      <p:sp>
+        <p:nvSpPr>
+          <p:cNvPr id="8" name="Espaço Reservado para Texto 1">
+            <a:extLst>
+              <a:ext uri="{FF2B5EF4-FFF2-40B4-BE49-F238E27FC236}">
+                <a16:creationId xmlns:a16="http://schemas.microsoft.com/office/drawing/2014/main" id="{0FB9701F-777C-5603-7285-59CBA83B8A4A}"/>
+              </a:ext>
+            </a:extLst>
+          </p:cNvPr>
+          <p:cNvSpPr txBox="1">
+            <a:spLocks/>
+          </p:cNvSpPr>
+          <p:nvPr/>
+        </p:nvSpPr>
+        <p:spPr>
+          <a:xfrm>
+            <a:off x="905776" y="2198451"/>
+            <a:ext cx="6906537" cy="6673175"/>
+          </a:xfrm>
+          <a:prstGeom prst="rect">
+            <a:avLst/>
+          </a:prstGeom>
+          <a:solidFill>
+            <a:schemeClr val="bg2"/>
+          </a:solidFill>
+          <a:effectLst>
+            <a:outerShdw blurRad="215900" dist="114300" dir="2700000" algn="tl" rotWithShape="0">
+              <a:prstClr val="black">
+                <a:alpha val="30000"/>
+              </a:prstClr>
+            </a:outerShdw>
+            <a:softEdge rad="38100"/>
+          </a:effectLst>
+        </p:spPr>
+        <p:txBody>
+          <a:bodyPr lIns="72000" tIns="72000" rIns="72000" bIns="72000"/>
+          <a:lstStyle>
+            <a:lvl1pPr marL="0" indent="0" algn="l" defTabSz="1280160" rtl="0" eaLnBrk="1" latinLnBrk="0" hangingPunct="1">
+              <a:lnSpc>
+                <a:spcPct val="100000"/>
+              </a:lnSpc>
+              <a:spcBef>
+                <a:spcPts val="0"/>
+              </a:spcBef>
+              <a:spcAft>
+                <a:spcPts val="1200"/>
+              </a:spcAft>
+              <a:buFont typeface="Arial" panose="020B0604020202020204" pitchFamily="34" charset="0"/>
+              <a:buNone/>
+              <a:defRPr sz="1800" kern="1200">
+                <a:solidFill>
+                  <a:schemeClr val="tx2">
+                    <a:lumMod val="75000"/>
+                  </a:schemeClr>
+                </a:solidFill>
+                <a:latin typeface="+mn-lt"/>
+                <a:ea typeface="+mn-ea"/>
+                <a:cs typeface="+mn-cs"/>
+              </a:defRPr>
+            </a:lvl1pPr>
+            <a:lvl2pPr marL="640080" indent="0" algn="l" defTabSz="1280160" rtl="0" eaLnBrk="1" latinLnBrk="0" hangingPunct="1">
+              <a:lnSpc>
+                <a:spcPct val="90000"/>
+              </a:lnSpc>
+              <a:spcBef>
+                <a:spcPts val="700"/>
+              </a:spcBef>
+              <a:buFont typeface="Arial" panose="020B0604020202020204" pitchFamily="34" charset="0"/>
+              <a:buNone/>
+              <a:defRPr sz="1400" kern="1200">
+                <a:solidFill>
+                  <a:schemeClr val="tx1"/>
+                </a:solidFill>
+                <a:latin typeface="+mn-lt"/>
+                <a:ea typeface="+mn-ea"/>
+                <a:cs typeface="+mn-cs"/>
+              </a:defRPr>
+            </a:lvl2pPr>
+            <a:lvl3pPr marL="1280160" indent="0" algn="l" defTabSz="1280160" rtl="0" eaLnBrk="1" latinLnBrk="0" hangingPunct="1">
+              <a:lnSpc>
+                <a:spcPct val="90000"/>
+              </a:lnSpc>
+              <a:spcBef>
+                <a:spcPts val="700"/>
+              </a:spcBef>
+              <a:buFont typeface="Arial" panose="020B0604020202020204" pitchFamily="34" charset="0"/>
+              <a:buNone/>
+              <a:defRPr sz="1400" kern="1200">
+                <a:solidFill>
+                  <a:schemeClr val="tx1"/>
+                </a:solidFill>
+                <a:latin typeface="+mn-lt"/>
+                <a:ea typeface="+mn-ea"/>
+                <a:cs typeface="+mn-cs"/>
+              </a:defRPr>
+            </a:lvl3pPr>
+            <a:lvl4pPr marL="1920240" indent="0" algn="l" defTabSz="1280160" rtl="0" eaLnBrk="1" latinLnBrk="0" hangingPunct="1">
+              <a:lnSpc>
+                <a:spcPct val="90000"/>
+              </a:lnSpc>
+              <a:spcBef>
+                <a:spcPts val="700"/>
+              </a:spcBef>
+              <a:buFont typeface="Arial" panose="020B0604020202020204" pitchFamily="34" charset="0"/>
+              <a:buNone/>
+              <a:defRPr sz="1400" kern="1200">
+                <a:solidFill>
+                  <a:schemeClr val="tx1"/>
+                </a:solidFill>
+                <a:latin typeface="+mn-lt"/>
+                <a:ea typeface="+mn-ea"/>
+                <a:cs typeface="+mn-cs"/>
+              </a:defRPr>
+            </a:lvl4pPr>
+            <a:lvl5pPr marL="2560320" indent="0" algn="l" defTabSz="1280160" rtl="0" eaLnBrk="1" latinLnBrk="0" hangingPunct="1">
+              <a:lnSpc>
+                <a:spcPct val="90000"/>
+              </a:lnSpc>
+              <a:spcBef>
+                <a:spcPts val="700"/>
+              </a:spcBef>
+              <a:buFont typeface="Arial" panose="020B0604020202020204" pitchFamily="34" charset="0"/>
+              <a:buNone/>
+              <a:defRPr sz="1400" kern="1200">
+                <a:solidFill>
+                  <a:schemeClr val="tx1"/>
+                </a:solidFill>
+                <a:latin typeface="+mn-lt"/>
+                <a:ea typeface="+mn-ea"/>
+                <a:cs typeface="+mn-cs"/>
+              </a:defRPr>
+            </a:lvl5pPr>
+            <a:lvl6pPr marL="3520440" indent="-320040" algn="l" defTabSz="1280160" rtl="0" eaLnBrk="1" latinLnBrk="0" hangingPunct="1">
+              <a:lnSpc>
+                <a:spcPct val="90000"/>
+              </a:lnSpc>
+              <a:spcBef>
+                <a:spcPts val="700"/>
+              </a:spcBef>
+              <a:buFont typeface="Arial" panose="020B0604020202020204" pitchFamily="34" charset="0"/>
+              <a:buChar char="•"/>
+              <a:defRPr sz="2520" kern="1200">
+                <a:solidFill>
+                  <a:schemeClr val="tx1"/>
+                </a:solidFill>
+                <a:latin typeface="+mn-lt"/>
+                <a:ea typeface="+mn-ea"/>
+                <a:cs typeface="+mn-cs"/>
+              </a:defRPr>
+            </a:lvl6pPr>
+            <a:lvl7pPr marL="4160520" indent="-320040" algn="l" defTabSz="1280160" rtl="0" eaLnBrk="1" latinLnBrk="0" hangingPunct="1">
+              <a:lnSpc>
+                <a:spcPct val="90000"/>
+              </a:lnSpc>
+              <a:spcBef>
+                <a:spcPts val="700"/>
+              </a:spcBef>
+              <a:buFont typeface="Arial" panose="020B0604020202020204" pitchFamily="34" charset="0"/>
+              <a:buChar char="•"/>
+              <a:defRPr sz="2520" kern="1200">
+                <a:solidFill>
+                  <a:schemeClr val="tx1"/>
+                </a:solidFill>
+                <a:latin typeface="+mn-lt"/>
+                <a:ea typeface="+mn-ea"/>
+                <a:cs typeface="+mn-cs"/>
+              </a:defRPr>
+            </a:lvl7pPr>
+            <a:lvl8pPr marL="4800600" indent="-320040" algn="l" defTabSz="1280160" rtl="0" eaLnBrk="1" latinLnBrk="0" hangingPunct="1">
+              <a:lnSpc>
+                <a:spcPct val="90000"/>
+              </a:lnSpc>
+              <a:spcBef>
+                <a:spcPts val="700"/>
+              </a:spcBef>
+              <a:buFont typeface="Arial" panose="020B0604020202020204" pitchFamily="34" charset="0"/>
+              <a:buChar char="•"/>
+              <a:defRPr sz="2520" kern="1200">
+                <a:solidFill>
+                  <a:schemeClr val="tx1"/>
+                </a:solidFill>
+                <a:latin typeface="+mn-lt"/>
+                <a:ea typeface="+mn-ea"/>
+                <a:cs typeface="+mn-cs"/>
+              </a:defRPr>
+            </a:lvl8pPr>
+            <a:lvl9pPr marL="5440680" indent="-320040" algn="l" defTabSz="1280160" rtl="0" eaLnBrk="1" latinLnBrk="0" hangingPunct="1">
+              <a:lnSpc>
+                <a:spcPct val="90000"/>
+              </a:lnSpc>
+              <a:spcBef>
+                <a:spcPts val="700"/>
+              </a:spcBef>
+              <a:buFont typeface="Arial" panose="020B0604020202020204" pitchFamily="34" charset="0"/>
+              <a:buChar char="•"/>
+              <a:defRPr sz="2520" kern="1200">
+                <a:solidFill>
+                  <a:schemeClr val="tx1"/>
+                </a:solidFill>
+                <a:latin typeface="+mn-lt"/>
+                <a:ea typeface="+mn-ea"/>
+                <a:cs typeface="+mn-cs"/>
+              </a:defRPr>
+            </a:lvl9pPr>
+          </a:lstStyle>
+          <a:p>
+            <a:endParaRPr lang="pt-BR" sz="1600" b="1" dirty="0">
+              <a:solidFill>
+                <a:schemeClr val="accent1">
+                  <a:lumMod val="75000"/>
+                </a:schemeClr>
+              </a:solidFill>
+              <a:latin typeface="Arial" panose="020B0604020202020204" pitchFamily="34" charset="0"/>
+              <a:cs typeface="Arial" panose="020B0604020202020204" pitchFamily="34" charset="0"/>
+            </a:endParaRPr>
+          </a:p>
+        </p:txBody>
+      </p:sp>
+      <p:sp>
+        <p:nvSpPr>
+          <p:cNvPr id="10" name="Espaço Reservado para Texto 1">
+            <a:extLst>
+              <a:ext uri="{FF2B5EF4-FFF2-40B4-BE49-F238E27FC236}">
+                <a16:creationId xmlns:a16="http://schemas.microsoft.com/office/drawing/2014/main" id="{044E3BB6-511B-F4E2-C09B-CCEC0619DC7C}"/>
+              </a:ext>
+            </a:extLst>
+          </p:cNvPr>
+          <p:cNvSpPr txBox="1">
+            <a:spLocks/>
+          </p:cNvSpPr>
+          <p:nvPr/>
+        </p:nvSpPr>
+        <p:spPr>
+          <a:xfrm>
+            <a:off x="1206230" y="2431916"/>
+            <a:ext cx="6225702" cy="6050604"/>
+          </a:xfrm>
+          <a:prstGeom prst="rect">
+            <a:avLst/>
+          </a:prstGeom>
+          <a:noFill/>
+        </p:spPr>
+        <p:txBody>
+          <a:bodyPr lIns="72000" tIns="72000" rIns="72000" bIns="72000"/>
+          <a:lstStyle>
+            <a:lvl1pPr marL="0" indent="0" algn="l" defTabSz="1280160" rtl="0" eaLnBrk="1" latinLnBrk="0" hangingPunct="1">
+              <a:lnSpc>
+                <a:spcPct val="100000"/>
+              </a:lnSpc>
+              <a:spcBef>
+                <a:spcPts val="0"/>
+              </a:spcBef>
+              <a:spcAft>
+                <a:spcPts val="1200"/>
+              </a:spcAft>
+              <a:buFont typeface="Arial" panose="020B0604020202020204" pitchFamily="34" charset="0"/>
+              <a:buNone/>
+              <a:defRPr sz="1800" kern="1200">
+                <a:solidFill>
+                  <a:schemeClr val="tx2">
+                    <a:lumMod val="75000"/>
+                  </a:schemeClr>
+                </a:solidFill>
+                <a:latin typeface="+mn-lt"/>
+                <a:ea typeface="+mn-ea"/>
+                <a:cs typeface="+mn-cs"/>
+              </a:defRPr>
+            </a:lvl1pPr>
+            <a:lvl2pPr marL="640080" indent="0" algn="l" defTabSz="1280160" rtl="0" eaLnBrk="1" latinLnBrk="0" hangingPunct="1">
+              <a:lnSpc>
+                <a:spcPct val="90000"/>
+              </a:lnSpc>
+              <a:spcBef>
+                <a:spcPts val="700"/>
+              </a:spcBef>
+              <a:buFont typeface="Arial" panose="020B0604020202020204" pitchFamily="34" charset="0"/>
+              <a:buNone/>
+              <a:defRPr sz="1400" kern="1200">
+                <a:solidFill>
+                  <a:schemeClr val="tx1"/>
+                </a:solidFill>
+                <a:latin typeface="+mn-lt"/>
+                <a:ea typeface="+mn-ea"/>
+                <a:cs typeface="+mn-cs"/>
+              </a:defRPr>
+            </a:lvl2pPr>
+            <a:lvl3pPr marL="1280160" indent="0" algn="l" defTabSz="1280160" rtl="0" eaLnBrk="1" latinLnBrk="0" hangingPunct="1">
+              <a:lnSpc>
+                <a:spcPct val="90000"/>
+              </a:lnSpc>
+              <a:spcBef>
+                <a:spcPts val="700"/>
+              </a:spcBef>
+              <a:buFont typeface="Arial" panose="020B0604020202020204" pitchFamily="34" charset="0"/>
+              <a:buNone/>
+              <a:defRPr sz="1400" kern="1200">
+                <a:solidFill>
+                  <a:schemeClr val="tx1"/>
+                </a:solidFill>
+                <a:latin typeface="+mn-lt"/>
+                <a:ea typeface="+mn-ea"/>
+                <a:cs typeface="+mn-cs"/>
+              </a:defRPr>
+            </a:lvl3pPr>
+            <a:lvl4pPr marL="1920240" indent="0" algn="l" defTabSz="1280160" rtl="0" eaLnBrk="1" latinLnBrk="0" hangingPunct="1">
+              <a:lnSpc>
+                <a:spcPct val="90000"/>
+              </a:lnSpc>
+              <a:spcBef>
+                <a:spcPts val="700"/>
+              </a:spcBef>
+              <a:buFont typeface="Arial" panose="020B0604020202020204" pitchFamily="34" charset="0"/>
+              <a:buNone/>
+              <a:defRPr sz="1400" kern="1200">
+                <a:solidFill>
+                  <a:schemeClr val="tx1"/>
+                </a:solidFill>
+                <a:latin typeface="+mn-lt"/>
+                <a:ea typeface="+mn-ea"/>
+                <a:cs typeface="+mn-cs"/>
+              </a:defRPr>
+            </a:lvl4pPr>
+            <a:lvl5pPr marL="2560320" indent="0" algn="l" defTabSz="1280160" rtl="0" eaLnBrk="1" latinLnBrk="0" hangingPunct="1">
+              <a:lnSpc>
+                <a:spcPct val="90000"/>
+              </a:lnSpc>
+              <a:spcBef>
+                <a:spcPts val="700"/>
+              </a:spcBef>
+              <a:buFont typeface="Arial" panose="020B0604020202020204" pitchFamily="34" charset="0"/>
+              <a:buNone/>
+              <a:defRPr sz="1400" kern="1200">
+                <a:solidFill>
+                  <a:schemeClr val="tx1"/>
+                </a:solidFill>
+                <a:latin typeface="+mn-lt"/>
+                <a:ea typeface="+mn-ea"/>
+                <a:cs typeface="+mn-cs"/>
+              </a:defRPr>
+            </a:lvl5pPr>
+            <a:lvl6pPr marL="3520440" indent="-320040" algn="l" defTabSz="1280160" rtl="0" eaLnBrk="1" latinLnBrk="0" hangingPunct="1">
+              <a:lnSpc>
+                <a:spcPct val="90000"/>
+              </a:lnSpc>
+              <a:spcBef>
+                <a:spcPts val="700"/>
+              </a:spcBef>
+              <a:buFont typeface="Arial" panose="020B0604020202020204" pitchFamily="34" charset="0"/>
+              <a:buChar char="•"/>
+              <a:defRPr sz="2520" kern="1200">
+                <a:solidFill>
+                  <a:schemeClr val="tx1"/>
+                </a:solidFill>
+                <a:latin typeface="+mn-lt"/>
+                <a:ea typeface="+mn-ea"/>
+                <a:cs typeface="+mn-cs"/>
+              </a:defRPr>
+            </a:lvl6pPr>
+            <a:lvl7pPr marL="4160520" indent="-320040" algn="l" defTabSz="1280160" rtl="0" eaLnBrk="1" latinLnBrk="0" hangingPunct="1">
+              <a:lnSpc>
+                <a:spcPct val="90000"/>
+              </a:lnSpc>
+              <a:spcBef>
+                <a:spcPts val="700"/>
+              </a:spcBef>
+              <a:buFont typeface="Arial" panose="020B0604020202020204" pitchFamily="34" charset="0"/>
+              <a:buChar char="•"/>
+              <a:defRPr sz="2520" kern="1200">
+                <a:solidFill>
+                  <a:schemeClr val="tx1"/>
+                </a:solidFill>
+                <a:latin typeface="+mn-lt"/>
+                <a:ea typeface="+mn-ea"/>
+                <a:cs typeface="+mn-cs"/>
+              </a:defRPr>
+            </a:lvl7pPr>
+            <a:lvl8pPr marL="4800600" indent="-320040" algn="l" defTabSz="1280160" rtl="0" eaLnBrk="1" latinLnBrk="0" hangingPunct="1">
+              <a:lnSpc>
+                <a:spcPct val="90000"/>
+              </a:lnSpc>
+              <a:spcBef>
+                <a:spcPts val="700"/>
+              </a:spcBef>
+              <a:buFont typeface="Arial" panose="020B0604020202020204" pitchFamily="34" charset="0"/>
+              <a:buChar char="•"/>
+              <a:defRPr sz="2520" kern="1200">
+                <a:solidFill>
+                  <a:schemeClr val="tx1"/>
+                </a:solidFill>
+                <a:latin typeface="+mn-lt"/>
+                <a:ea typeface="+mn-ea"/>
+                <a:cs typeface="+mn-cs"/>
+              </a:defRPr>
+            </a:lvl8pPr>
+            <a:lvl9pPr marL="5440680" indent="-320040" algn="l" defTabSz="1280160" rtl="0" eaLnBrk="1" latinLnBrk="0" hangingPunct="1">
+              <a:lnSpc>
+                <a:spcPct val="90000"/>
+              </a:lnSpc>
+              <a:spcBef>
+                <a:spcPts val="700"/>
+              </a:spcBef>
+              <a:buFont typeface="Arial" panose="020B0604020202020204" pitchFamily="34" charset="0"/>
+              <a:buChar char="•"/>
+              <a:defRPr sz="2520" kern="1200">
+                <a:solidFill>
+                  <a:schemeClr val="tx1"/>
+                </a:solidFill>
+                <a:latin typeface="+mn-lt"/>
+                <a:ea typeface="+mn-ea"/>
+                <a:cs typeface="+mn-cs"/>
+              </a:defRPr>
+            </a:lvl9pPr>
+          </a:lstStyle>
+          <a:p>
+            <a:r>
+              <a:rPr lang="pt-BR" sz="2000" b="1" dirty="0">
+                <a:solidFill>
+                  <a:schemeClr val="accent1">
+                    <a:lumMod val="75000"/>
+                  </a:schemeClr>
+                </a:solidFill>
+                <a:latin typeface="Arial" panose="020B0604020202020204" pitchFamily="34" charset="0"/>
+                <a:cs typeface="Arial" panose="020B0604020202020204" pitchFamily="34" charset="0"/>
+              </a:rPr>
+              <a:t>Dados disponíveis </a:t>
+            </a:r>
+          </a:p>
+          <a:p>
+            <a:pPr marL="285750" indent="-285750">
+              <a:buFontTx/>
+              <a:buChar char="-"/>
+            </a:pPr>
+            <a:r>
+              <a:rPr lang="pt-BR" dirty="0">
+                <a:solidFill>
+                  <a:srgbClr val="333333"/>
+                </a:solidFill>
+              </a:rPr>
+              <a:t>Apenas 50 casos de rebaixamento entre 2006 e 2024 no conjunto de dados usados para treinar o modelo.</a:t>
+            </a:r>
+          </a:p>
+          <a:p>
+            <a:pPr marL="285750" indent="-285750">
+              <a:buFontTx/>
+              <a:buChar char="-"/>
+            </a:pPr>
+            <a:r>
+              <a:rPr lang="pt-BR" dirty="0">
+                <a:solidFill>
+                  <a:srgbClr val="333333"/>
+                </a:solidFill>
+              </a:rPr>
+              <a:t>Esse volume limita quantas variáveis podem ser testadas ao mesmo tempo sem perder estabilidade estatísticas.</a:t>
+            </a:r>
+          </a:p>
+        </p:txBody>
+      </p:sp>
+      <p:sp>
+        <p:nvSpPr>
+          <p:cNvPr id="11" name="Espaço Reservado para Texto 1">
+            <a:extLst>
+              <a:ext uri="{FF2B5EF4-FFF2-40B4-BE49-F238E27FC236}">
+                <a16:creationId xmlns:a16="http://schemas.microsoft.com/office/drawing/2014/main" id="{38B72914-BA7F-6A67-30B7-9FD87442BCD9}"/>
+              </a:ext>
+            </a:extLst>
+          </p:cNvPr>
+          <p:cNvSpPr>
+            <a:spLocks noGrp="1"/>
+          </p:cNvSpPr>
+          <p:nvPr>
+            <p:ph type="body" sz="quarter" idx="10"/>
+          </p:nvPr>
+        </p:nvSpPr>
+        <p:spPr>
+          <a:xfrm>
+            <a:off x="928688" y="1301750"/>
+            <a:ext cx="14544674" cy="625401"/>
+          </a:xfrm>
+        </p:spPr>
+        <p:txBody>
+          <a:bodyPr/>
+          <a:lstStyle/>
+          <a:p>
+            <a:r>
+              <a:rPr lang="pt-BR" sz="3000" b="1" dirty="0">
+                <a:solidFill>
+                  <a:schemeClr val="accent1">
+                    <a:lumMod val="75000"/>
+                  </a:schemeClr>
+                </a:solidFill>
+                <a:latin typeface="Arial" panose="020B0604020202020204" pitchFamily="34" charset="0"/>
+                <a:cs typeface="Arial" panose="020B0604020202020204" pitchFamily="34" charset="0"/>
+              </a:rPr>
+              <a:t>Limitações do Modelo</a:t>
+            </a:r>
+          </a:p>
+        </p:txBody>
+      </p:sp>
+      <p:sp>
+        <p:nvSpPr>
+          <p:cNvPr id="13" name="Espaço Reservado para Texto 1">
+            <a:extLst>
+              <a:ext uri="{FF2B5EF4-FFF2-40B4-BE49-F238E27FC236}">
+                <a16:creationId xmlns:a16="http://schemas.microsoft.com/office/drawing/2014/main" id="{F29C8B62-58D5-FB90-71CA-4D1803A8F89D}"/>
+              </a:ext>
+            </a:extLst>
+          </p:cNvPr>
+          <p:cNvSpPr txBox="1">
+            <a:spLocks/>
+          </p:cNvSpPr>
+          <p:nvPr/>
+        </p:nvSpPr>
+        <p:spPr>
+          <a:xfrm>
+            <a:off x="8930151" y="2431916"/>
+            <a:ext cx="6225702" cy="6050604"/>
+          </a:xfrm>
+          <a:prstGeom prst="rect">
+            <a:avLst/>
+          </a:prstGeom>
+          <a:noFill/>
+        </p:spPr>
+        <p:txBody>
+          <a:bodyPr lIns="72000" tIns="72000" rIns="72000" bIns="72000"/>
+          <a:lstStyle>
+            <a:lvl1pPr marL="0" indent="0" algn="l" defTabSz="1280160" rtl="0" eaLnBrk="1" latinLnBrk="0" hangingPunct="1">
+              <a:lnSpc>
+                <a:spcPct val="100000"/>
+              </a:lnSpc>
+              <a:spcBef>
+                <a:spcPts val="0"/>
+              </a:spcBef>
+              <a:spcAft>
+                <a:spcPts val="1200"/>
+              </a:spcAft>
+              <a:buFont typeface="Arial" panose="020B0604020202020204" pitchFamily="34" charset="0"/>
+              <a:buNone/>
+              <a:defRPr sz="1800" kern="1200">
+                <a:solidFill>
+                  <a:schemeClr val="tx2">
+                    <a:lumMod val="75000"/>
+                  </a:schemeClr>
+                </a:solidFill>
+                <a:latin typeface="+mn-lt"/>
+                <a:ea typeface="+mn-ea"/>
+                <a:cs typeface="+mn-cs"/>
+              </a:defRPr>
+            </a:lvl1pPr>
+            <a:lvl2pPr marL="640080" indent="0" algn="l" defTabSz="1280160" rtl="0" eaLnBrk="1" latinLnBrk="0" hangingPunct="1">
+              <a:lnSpc>
+                <a:spcPct val="90000"/>
+              </a:lnSpc>
+              <a:spcBef>
+                <a:spcPts val="700"/>
+              </a:spcBef>
+              <a:buFont typeface="Arial" panose="020B0604020202020204" pitchFamily="34" charset="0"/>
+              <a:buNone/>
+              <a:defRPr sz="1400" kern="1200">
+                <a:solidFill>
+                  <a:schemeClr val="tx1"/>
+                </a:solidFill>
+                <a:latin typeface="+mn-lt"/>
+                <a:ea typeface="+mn-ea"/>
+                <a:cs typeface="+mn-cs"/>
+              </a:defRPr>
+            </a:lvl2pPr>
+            <a:lvl3pPr marL="1280160" indent="0" algn="l" defTabSz="1280160" rtl="0" eaLnBrk="1" latinLnBrk="0" hangingPunct="1">
+              <a:lnSpc>
+                <a:spcPct val="90000"/>
+              </a:lnSpc>
+              <a:spcBef>
+                <a:spcPts val="700"/>
+              </a:spcBef>
+              <a:buFont typeface="Arial" panose="020B0604020202020204" pitchFamily="34" charset="0"/>
+              <a:buNone/>
+              <a:defRPr sz="1400" kern="1200">
+                <a:solidFill>
+                  <a:schemeClr val="tx1"/>
+                </a:solidFill>
+                <a:latin typeface="+mn-lt"/>
+                <a:ea typeface="+mn-ea"/>
+                <a:cs typeface="+mn-cs"/>
+              </a:defRPr>
+            </a:lvl3pPr>
+            <a:lvl4pPr marL="1920240" indent="0" algn="l" defTabSz="1280160" rtl="0" eaLnBrk="1" latinLnBrk="0" hangingPunct="1">
+              <a:lnSpc>
+                <a:spcPct val="90000"/>
+              </a:lnSpc>
+              <a:spcBef>
+                <a:spcPts val="700"/>
+              </a:spcBef>
+              <a:buFont typeface="Arial" panose="020B0604020202020204" pitchFamily="34" charset="0"/>
+              <a:buNone/>
+              <a:defRPr sz="1400" kern="1200">
+                <a:solidFill>
+                  <a:schemeClr val="tx1"/>
+                </a:solidFill>
+                <a:latin typeface="+mn-lt"/>
+                <a:ea typeface="+mn-ea"/>
+                <a:cs typeface="+mn-cs"/>
+              </a:defRPr>
+            </a:lvl4pPr>
+            <a:lvl5pPr marL="2560320" indent="0" algn="l" defTabSz="1280160" rtl="0" eaLnBrk="1" latinLnBrk="0" hangingPunct="1">
+              <a:lnSpc>
+                <a:spcPct val="90000"/>
+              </a:lnSpc>
+              <a:spcBef>
+                <a:spcPts val="700"/>
+              </a:spcBef>
+              <a:buFont typeface="Arial" panose="020B0604020202020204" pitchFamily="34" charset="0"/>
+              <a:buNone/>
+              <a:defRPr sz="1400" kern="1200">
+                <a:solidFill>
+                  <a:schemeClr val="tx1"/>
+                </a:solidFill>
+                <a:latin typeface="+mn-lt"/>
+                <a:ea typeface="+mn-ea"/>
+                <a:cs typeface="+mn-cs"/>
+              </a:defRPr>
+            </a:lvl5pPr>
+            <a:lvl6pPr marL="3520440" indent="-320040" algn="l" defTabSz="1280160" rtl="0" eaLnBrk="1" latinLnBrk="0" hangingPunct="1">
+              <a:lnSpc>
+                <a:spcPct val="90000"/>
+              </a:lnSpc>
+              <a:spcBef>
+                <a:spcPts val="700"/>
+              </a:spcBef>
+              <a:buFont typeface="Arial" panose="020B0604020202020204" pitchFamily="34" charset="0"/>
+              <a:buChar char="•"/>
+              <a:defRPr sz="2520" kern="1200">
+                <a:solidFill>
+                  <a:schemeClr val="tx1"/>
+                </a:solidFill>
+                <a:latin typeface="+mn-lt"/>
+                <a:ea typeface="+mn-ea"/>
+                <a:cs typeface="+mn-cs"/>
+              </a:defRPr>
+            </a:lvl6pPr>
+            <a:lvl7pPr marL="4160520" indent="-320040" algn="l" defTabSz="1280160" rtl="0" eaLnBrk="1" latinLnBrk="0" hangingPunct="1">
+              <a:lnSpc>
+                <a:spcPct val="90000"/>
+              </a:lnSpc>
+              <a:spcBef>
+                <a:spcPts val="700"/>
+              </a:spcBef>
+              <a:buFont typeface="Arial" panose="020B0604020202020204" pitchFamily="34" charset="0"/>
+              <a:buChar char="•"/>
+              <a:defRPr sz="2520" kern="1200">
+                <a:solidFill>
+                  <a:schemeClr val="tx1"/>
+                </a:solidFill>
+                <a:latin typeface="+mn-lt"/>
+                <a:ea typeface="+mn-ea"/>
+                <a:cs typeface="+mn-cs"/>
+              </a:defRPr>
+            </a:lvl7pPr>
+            <a:lvl8pPr marL="4800600" indent="-320040" algn="l" defTabSz="1280160" rtl="0" eaLnBrk="1" latinLnBrk="0" hangingPunct="1">
+              <a:lnSpc>
+                <a:spcPct val="90000"/>
+              </a:lnSpc>
+              <a:spcBef>
+                <a:spcPts val="700"/>
+              </a:spcBef>
+              <a:buFont typeface="Arial" panose="020B0604020202020204" pitchFamily="34" charset="0"/>
+              <a:buChar char="•"/>
+              <a:defRPr sz="2520" kern="1200">
+                <a:solidFill>
+                  <a:schemeClr val="tx1"/>
+                </a:solidFill>
+                <a:latin typeface="+mn-lt"/>
+                <a:ea typeface="+mn-ea"/>
+                <a:cs typeface="+mn-cs"/>
+              </a:defRPr>
+            </a:lvl8pPr>
+            <a:lvl9pPr marL="5440680" indent="-320040" algn="l" defTabSz="1280160" rtl="0" eaLnBrk="1" latinLnBrk="0" hangingPunct="1">
+              <a:lnSpc>
+                <a:spcPct val="90000"/>
+              </a:lnSpc>
+              <a:spcBef>
+                <a:spcPts val="700"/>
+              </a:spcBef>
+              <a:buFont typeface="Arial" panose="020B0604020202020204" pitchFamily="34" charset="0"/>
+              <a:buChar char="•"/>
+              <a:defRPr sz="2520" kern="1200">
+                <a:solidFill>
+                  <a:schemeClr val="tx1"/>
+                </a:solidFill>
+                <a:latin typeface="+mn-lt"/>
+                <a:ea typeface="+mn-ea"/>
+                <a:cs typeface="+mn-cs"/>
+              </a:defRPr>
+            </a:lvl9pPr>
+          </a:lstStyle>
+          <a:p>
+            <a:r>
+              <a:rPr lang="pt-BR" sz="2000" b="1" dirty="0">
+                <a:solidFill>
+                  <a:schemeClr val="accent1">
+                    <a:lumMod val="75000"/>
+                  </a:schemeClr>
+                </a:solidFill>
+                <a:latin typeface="Arial" panose="020B0604020202020204" pitchFamily="34" charset="0"/>
+                <a:cs typeface="Arial" panose="020B0604020202020204" pitchFamily="34" charset="0"/>
+              </a:rPr>
+              <a:t>Escolha do modelo final</a:t>
+            </a:r>
+          </a:p>
+          <a:p>
+            <a:pPr marL="285750" indent="-285750">
+              <a:buFontTx/>
+              <a:buChar char="-"/>
+            </a:pPr>
+            <a:r>
+              <a:rPr lang="pt-BR" dirty="0">
+                <a:solidFill>
+                  <a:srgbClr val="333333"/>
+                </a:solidFill>
+              </a:rPr>
+              <a:t>O modelo com as 8 variáveis originais apresentou coeficientes com sinal invertido, causado por colinearidade entre ponto, posição e vitórias/empates/derrotas.</a:t>
+            </a:r>
+          </a:p>
+          <a:p>
+            <a:pPr marL="285750" indent="-285750">
+              <a:buFontTx/>
+              <a:buChar char="-"/>
+            </a:pPr>
+            <a:r>
+              <a:rPr lang="pt-BR" dirty="0">
+                <a:solidFill>
+                  <a:srgbClr val="333333"/>
+                </a:solidFill>
+              </a:rPr>
+              <a:t>O modelo final usa uma única variável (posição final), que obteve o melhor f1 (0.369) e o único coeficiente com direção coerente entre as combinaçöes testadas.</a:t>
+            </a:r>
+          </a:p>
+        </p:txBody>
+      </p:sp>
+    </p:spTree>
+    <p:extLst>
+      <p:ext uri="{BB962C8B-B14F-4D97-AF65-F5344CB8AC3E}">
+        <p14:creationId xmlns:p14="http://schemas.microsoft.com/office/powerpoint/2010/main" val="3399116977"/>
+      </p:ext>
+    </p:extLst>
+  </p:cSld>
+  <p:clrMapOvr>
+    <a:masterClrMapping/>
+  </p:clrMapOvr>
+</p:sld>
+</file>
+
+<file path=ppt/slides/slide9.xml><?xml version="1.0" encoding="utf-8"?>
 <p:sld xmlns:a="http://schemas.openxmlformats.org/drawingml/2006/main" xmlns:r="http://schemas.openxmlformats.org/officeDocument/2006/relationships" xmlns:p="http://schemas.openxmlformats.org/presentationml/2006/main">
   <p:cSld>
     <p:spTree>

</xml_diff>

<commit_message>
docs: formatação do template e finalização
</commit_message>
<xml_diff>
--- a/docs/Template - Fase 2 - Apresentação Executiva - Projeto em Business Intelligence e Analytics.pptx
+++ b/docs/Template - Fase 2 - Apresentação Executiva - Projeto em Business Intelligence e Analytics.pptx
@@ -7067,13 +7067,6 @@
               </a:rPr>
               <a:t> Git/Github: documentação e histórico do projeto.</a:t>
             </a:r>
-            <a:endParaRPr lang="pt-BR" sz="3000" dirty="0">
-              <a:solidFill>
-                <a:schemeClr val="tx1"/>
-              </a:solidFill>
-              <a:latin typeface="Arial" panose="020B0604020202020204" pitchFamily="34" charset="0"/>
-              <a:cs typeface="Arial" panose="020B0604020202020204" pitchFamily="34" charset="0"/>
-            </a:endParaRPr>
           </a:p>
         </p:txBody>
       </p:sp>
@@ -7562,18 +7555,16 @@
               <a:t>Repositorio: </a:t>
             </a:r>
             <a:r>
-              <a:rPr lang="pt-BR" sz="1600" dirty="0">
-                <a:solidFill>
-                  <a:srgbClr val="333333"/>
+              <a:rPr lang="pt-BR" sz="1600" u="sng" dirty="0">
+                <a:solidFill>
+                  <a:schemeClr val="accent1"/>
                 </a:solidFill>
               </a:rPr>
               <a:t>github.com/FelipePinheiro964/Projeto-Em-Business-Intelligence-e-Analytics</a:t>
             </a:r>
-            <a:endParaRPr lang="pt-BR" sz="1600" b="1" dirty="0">
+            <a:endParaRPr lang="pt-BR" sz="1600" b="1" u="sng" dirty="0">
               <a:solidFill>
-                <a:schemeClr val="accent1">
-                  <a:lumMod val="75000"/>
-                </a:schemeClr>
+                <a:schemeClr val="accent1"/>
               </a:solidFill>
               <a:latin typeface="Arial" panose="020B0604020202020204" pitchFamily="34" charset="0"/>
               <a:cs typeface="Arial" panose="020B0604020202020204" pitchFamily="34" charset="0"/>
@@ -8050,6 +8041,9 @@
             <a:pPr algn="ctr"/>
             <a:r>
               <a:rPr lang="pt-BR" sz="1400" dirty="0">
+                <a:solidFill>
+                  <a:schemeClr val="tx1"/>
+                </a:solidFill>
                 <a:latin typeface="Arial" panose="020B0604020202020204" pitchFamily="34" charset="0"/>
                 <a:cs typeface="Arial" panose="020B0604020202020204" pitchFamily="34" charset="0"/>
               </a:rPr>
@@ -8057,9 +8051,7 @@
             </a:r>
             <a:endParaRPr lang="pt-BR" sz="1400" b="1" dirty="0">
               <a:solidFill>
-                <a:schemeClr val="accent1">
-                  <a:lumMod val="75000"/>
-                </a:schemeClr>
+                <a:schemeClr val="tx1"/>
               </a:solidFill>
               <a:latin typeface="Arial" panose="020B0604020202020204" pitchFamily="34" charset="0"/>
               <a:cs typeface="Arial" panose="020B0604020202020204" pitchFamily="34" charset="0"/>
@@ -13349,14 +13341,16 @@
               <a:t>Dashboard: </a:t>
             </a:r>
             <a:r>
-              <a:rPr lang="pt-BR" dirty="0"/>
+              <a:rPr lang="pt-BR" u="sng" dirty="0">
+                <a:solidFill>
+                  <a:schemeClr val="accent1"/>
+                </a:solidFill>
+              </a:rPr>
               <a:t>https://public.tableau.com/app/profile/felipe.pinheiro.foss./viz/Projeto-em-bi-analytics/Dashboard</a:t>
             </a:r>
-            <a:endParaRPr lang="pt-BR" sz="1600" b="1" dirty="0">
+            <a:endParaRPr lang="pt-BR" sz="1600" b="1" u="sng" dirty="0">
               <a:solidFill>
-                <a:schemeClr val="accent1">
-                  <a:lumMod val="75000"/>
-                </a:schemeClr>
+                <a:schemeClr val="accent1"/>
               </a:solidFill>
               <a:latin typeface="Arial" panose="020B0604020202020204" pitchFamily="34" charset="0"/>
               <a:cs typeface="Arial" panose="020B0604020202020204" pitchFamily="34" charset="0"/>
@@ -14771,7 +14765,7 @@
             <a:r>
               <a:rPr lang="pt-BR" dirty="0">
                 <a:solidFill>
-                  <a:srgbClr val="333333"/>
+                  <a:schemeClr val="tx1"/>
                 </a:solidFill>
               </a:rPr>
               <a:t>(40%) estão na faixa de risco Muito alto (≥ 60%) na temporada de 2025, concentrados nas últimas colocações da tabela - refletindo a forte relação entre posição final e risco de queda captada pelo modelo.</a:t>
@@ -15862,7 +15856,7 @@
             <a:r>
               <a:rPr lang="pt-BR" dirty="0">
                 <a:solidFill>
-                  <a:srgbClr val="333333"/>
+                  <a:schemeClr val="tx1"/>
                 </a:solidFill>
               </a:rPr>
               <a:t>Apenas 50 casos de rebaixamento entre 2006 e 2024 no conjunto de dados usados para treinar o modelo.</a:t>
@@ -15876,7 +15870,7 @@
             <a:r>
               <a:rPr lang="pt-BR" dirty="0">
                 <a:solidFill>
-                  <a:srgbClr val="333333"/>
+                  <a:schemeClr val="tx1"/>
                 </a:solidFill>
               </a:rPr>
               <a:t>Esse volume limita quantas variáveis podem ser testadas ao mesmo tempo sem perder estabilidade estatísticas.</a:t>
@@ -16142,7 +16136,7 @@
             <a:r>
               <a:rPr lang="pt-BR" dirty="0">
                 <a:solidFill>
-                  <a:srgbClr val="333333"/>
+                  <a:schemeClr val="tx1"/>
                 </a:solidFill>
               </a:rPr>
               <a:t>O modelo com as 8 variáveis originais apresentou coeficientes com sinal invertido, causado por colinearidade entre ponto, posição e vitórias/empates/derrotas.</a:t>
@@ -16156,7 +16150,7 @@
             <a:r>
               <a:rPr lang="pt-BR" dirty="0">
                 <a:solidFill>
-                  <a:srgbClr val="333333"/>
+                  <a:schemeClr val="tx1"/>
                 </a:solidFill>
               </a:rPr>
               <a:t>O modelo final usa uma única variável (posição final), que obteve o melhor f1 (0.369) e o único coeficiente com direção coerente entre as combinaçöes testadas.</a:t>

</xml_diff>